<commit_message>
Inject actual code, DB schema, prompting, and Hinglish translation snippets to PPTX slides
</commit_message>
<xml_diff>
--- a/NL Swiggy Instamart.pptx
+++ b/NL Swiggy Instamart.pptx
@@ -3390,7 +3390,7 @@
         </p:nvSpPr>
         <p:spPr>
           <a:xfrm>
-            <a:off x="457200" y="457200"/>
+            <a:off x="457200" y="365760"/>
             <a:ext cx="11277295" cy="731520"/>
           </a:xfrm>
           <a:prstGeom prst="rect">
@@ -3405,7 +3405,7 @@
           <a:lstStyle/>
           <a:p>
             <a:pPr>
-              <a:defRPr sz="2400" b="1">
+              <a:defRPr sz="2200" b="1">
                 <a:solidFill>
                   <a:srgbClr val="FC8019"/>
                 </a:solidFill>
@@ -3414,57 +3414,21 @@
             </a:pPr>
             <a:r>
               <a:t>Product Roadmap: Subscription &amp; Add-On Window Priorities</a:t>
-            </a:r>
-          </a:p>
-        </p:txBody>
-      </p:sp>
-      <p:sp>
-        <p:nvSpPr>
-          <p:cNvPr id="4" name="TextBox 3"/>
-          <p:cNvSpPr txBox="1"/>
-          <p:nvPr/>
-        </p:nvSpPr>
-        <p:spPr>
-          <a:xfrm>
-            <a:off x="457200" y="1097280"/>
-            <a:ext cx="11277295" cy="731520"/>
-          </a:xfrm>
-          <a:prstGeom prst="rect">
-            <a:avLst/>
-          </a:prstGeom>
-          <a:noFill/>
-        </p:spPr>
-        <p:txBody>
-          <a:bodyPr wrap="square">
-            <a:spAutoFit/>
-          </a:bodyPr>
-          <a:lstStyle/>
-          <a:p>
-            <a:pPr>
-              <a:defRPr sz="1400">
-                <a:solidFill>
-                  <a:srgbClr val="F8FAFC"/>
-                </a:solidFill>
-                <a:latin typeface="Arial"/>
-              </a:defRPr>
-            </a:pPr>
-            <a:r>
-              <a:t>By combining qualitative interviews with our AI analysis of 1,000 reviews, we prioritized our product roadmap to maximize high-margin category adoption:</a:t>
             </a:r>
           </a:p>
         </p:txBody>
       </p:sp>
       <p:graphicFrame>
         <p:nvGraphicFramePr>
-          <p:cNvPr id="5" name="Table 4"/>
+          <p:cNvPr id="4" name="Table 3"/>
           <p:cNvGraphicFramePr>
             <a:graphicFrameLocks noGrp="1"/>
           </p:cNvGraphicFramePr>
           <p:nvPr/>
         </p:nvGraphicFramePr>
         <p:xfrm>
-          <a:off x="457200" y="2011680"/>
-          <a:ext cx="11277295" cy="3657600"/>
+          <a:off x="457200" y="1371600"/>
+          <a:ext cx="6858000" cy="4572000"/>
         </p:xfrm>
         <a:graphic>
           <a:graphicData uri="http://schemas.openxmlformats.org/drawingml/2006/table">
@@ -3474,20 +3438,18 @@
               </a:tblPr>
               <a:tblGrid>
                 <a:gridCol w="2560320"/>
-                <a:gridCol w="1005840"/>
+                <a:gridCol w="1188720"/>
                 <a:gridCol w="1371600"/>
-                <a:gridCol w="731520"/>
-                <a:gridCol w="1036015"/>
-                <a:gridCol w="4572000"/>
+                <a:gridCol w="1737360"/>
               </a:tblGrid>
-              <a:tr h="731520">
-                <a:tc>
-                  <a:txBody>
-                    <a:bodyPr/>
-                    <a:lstStyle/>
-                    <a:p>
-                      <a:pPr>
-                        <a:defRPr sz="1100" b="1">
+              <a:tr h="914400">
+                <a:tc>
+                  <a:txBody>
+                    <a:bodyPr/>
+                    <a:lstStyle/>
+                    <a:p>
+                      <a:pPr>
+                        <a:defRPr sz="1000" b="1">
                           <a:solidFill>
                             <a:srgbClr val="F8FAFC"/>
                           </a:solidFill>
@@ -3511,7 +3473,7 @@
                     <a:lstStyle/>
                     <a:p>
                       <a:pPr>
-                        <a:defRPr sz="1100" b="1">
+                        <a:defRPr sz="1000" b="1">
                           <a:solidFill>
                             <a:srgbClr val="F8FAFC"/>
                           </a:solidFill>
@@ -3535,7 +3497,7 @@
                     <a:lstStyle/>
                     <a:p>
                       <a:pPr>
-                        <a:defRPr sz="1100" b="1">
+                        <a:defRPr sz="1000" b="1">
                           <a:solidFill>
                             <a:srgbClr val="F8FAFC"/>
                           </a:solidFill>
@@ -3559,7 +3521,7 @@
                     <a:lstStyle/>
                     <a:p>
                       <a:pPr>
-                        <a:defRPr sz="1100" b="1">
+                        <a:defRPr sz="1000" b="1">
                           <a:solidFill>
                             <a:srgbClr val="F8FAFC"/>
                           </a:solidFill>
@@ -3567,7 +3529,7 @@
                         </a:defRPr>
                       </a:pPr>
                       <a:r>
-                        <a:t>Ease</a:t>
+                        <a:t>ICE Score</a:t>
                       </a:r>
                     </a:p>
                   </a:txBody>
@@ -3577,13 +3539,15 @@
                     </a:solidFill>
                   </a:tcPr>
                 </a:tc>
-                <a:tc>
-                  <a:txBody>
-                    <a:bodyPr/>
-                    <a:lstStyle/>
-                    <a:p>
-                      <a:pPr>
-                        <a:defRPr sz="1100" b="1">
+              </a:tr>
+              <a:tr h="914400">
+                <a:tc>
+                  <a:txBody>
+                    <a:bodyPr/>
+                    <a:lstStyle/>
+                    <a:p>
+                      <a:pPr>
+                        <a:defRPr sz="1000" b="1">
                           <a:solidFill>
                             <a:srgbClr val="F8FAFC"/>
                           </a:solidFill>
@@ -3591,23 +3555,23 @@
                         </a:defRPr>
                       </a:pPr>
                       <a:r>
-                        <a:t>ICE Score</a:t>
-                      </a:r>
-                    </a:p>
-                  </a:txBody>
-                  <a:tcPr>
-                    <a:solidFill>
-                      <a:srgbClr val="1F2937"/>
-                    </a:solidFill>
-                  </a:tcPr>
-                </a:tc>
-                <a:tc>
-                  <a:txBody>
-                    <a:bodyPr/>
-                    <a:lstStyle/>
-                    <a:p>
-                      <a:pPr>
-                        <a:defRPr sz="1100" b="1">
+                        <a:t>1. Instamart Daily Subscription</a:t>
+                      </a:r>
+                    </a:p>
+                  </a:txBody>
+                  <a:tcPr>
+                    <a:solidFill>
+                      <a:srgbClr val="111827"/>
+                    </a:solidFill>
+                  </a:tcPr>
+                </a:tc>
+                <a:tc>
+                  <a:txBody>
+                    <a:bodyPr/>
+                    <a:lstStyle/>
+                    <a:p>
+                      <a:pPr>
+                        <a:defRPr sz="1000" b="0">
                           <a:solidFill>
                             <a:srgbClr val="F8FAFC"/>
                           </a:solidFill>
@@ -3615,25 +3579,73 @@
                         </a:defRPr>
                       </a:pPr>
                       <a:r>
-                        <a:t>Expected Business Value</a:t>
-                      </a:r>
-                    </a:p>
-                  </a:txBody>
-                  <a:tcPr>
-                    <a:solidFill>
-                      <a:srgbClr val="1F2937"/>
+                        <a:t>9</a:t>
+                      </a:r>
+                    </a:p>
+                  </a:txBody>
+                  <a:tcPr>
+                    <a:solidFill>
+                      <a:srgbClr val="111827"/>
+                    </a:solidFill>
+                  </a:tcPr>
+                </a:tc>
+                <a:tc>
+                  <a:txBody>
+                    <a:bodyPr/>
+                    <a:lstStyle/>
+                    <a:p>
+                      <a:pPr>
+                        <a:defRPr sz="1000" b="0">
+                          <a:solidFill>
+                            <a:srgbClr val="F8FAFC"/>
+                          </a:solidFill>
+                          <a:latin typeface="Arial"/>
+                        </a:defRPr>
+                      </a:pPr>
+                      <a:r>
+                        <a:t>8</a:t>
+                      </a:r>
+                    </a:p>
+                  </a:txBody>
+                  <a:tcPr>
+                    <a:solidFill>
+                      <a:srgbClr val="111827"/>
+                    </a:solidFill>
+                  </a:tcPr>
+                </a:tc>
+                <a:tc>
+                  <a:txBody>
+                    <a:bodyPr/>
+                    <a:lstStyle/>
+                    <a:p>
+                      <a:pPr>
+                        <a:defRPr sz="1000" b="1">
+                          <a:solidFill>
+                            <a:srgbClr val="FC8019"/>
+                          </a:solidFill>
+                          <a:latin typeface="Arial"/>
+                        </a:defRPr>
+                      </a:pPr>
+                      <a:r>
+                        <a:t>72/100</a:t>
+                      </a:r>
+                    </a:p>
+                  </a:txBody>
+                  <a:tcPr>
+                    <a:solidFill>
+                      <a:srgbClr val="111827"/>
                     </a:solidFill>
                   </a:tcPr>
                 </a:tc>
               </a:tr>
-              <a:tr h="731520">
-                <a:tc>
-                  <a:txBody>
-                    <a:bodyPr/>
-                    <a:lstStyle/>
-                    <a:p>
-                      <a:pPr>
-                        <a:defRPr sz="1100" b="1">
+              <a:tr h="914400">
+                <a:tc>
+                  <a:txBody>
+                    <a:bodyPr/>
+                    <a:lstStyle/>
+                    <a:p>
+                      <a:pPr>
+                        <a:defRPr sz="1000" b="1">
                           <a:solidFill>
                             <a:srgbClr val="F8FAFC"/>
                           </a:solidFill>
@@ -3641,7 +3653,7 @@
                         </a:defRPr>
                       </a:pPr>
                       <a:r>
-                        <a:t>1. Instamart Daily Subscription</a:t>
+                        <a:t>2. Freshness Verification Tracker</a:t>
                       </a:r>
                     </a:p>
                   </a:txBody>
@@ -3657,7 +3669,7 @@
                     <a:lstStyle/>
                     <a:p>
                       <a:pPr>
-                        <a:defRPr sz="1100" b="0">
+                        <a:defRPr sz="1000" b="0">
                           <a:solidFill>
                             <a:srgbClr val="F8FAFC"/>
                           </a:solidFill>
@@ -3665,7 +3677,7 @@
                         </a:defRPr>
                       </a:pPr>
                       <a:r>
-                        <a:t>9</a:t>
+                        <a:t>8</a:t>
                       </a:r>
                     </a:p>
                   </a:txBody>
@@ -3681,7 +3693,7 @@
                     <a:lstStyle/>
                     <a:p>
                       <a:pPr>
-                        <a:defRPr sz="1100" b="0">
+                        <a:defRPr sz="1000" b="0">
                           <a:solidFill>
                             <a:srgbClr val="F8FAFC"/>
                           </a:solidFill>
@@ -3705,7 +3717,33 @@
                     <a:lstStyle/>
                     <a:p>
                       <a:pPr>
-                        <a:defRPr sz="1100" b="0">
+                        <a:defRPr sz="1000" b="1">
+                          <a:solidFill>
+                            <a:srgbClr val="FC8019"/>
+                          </a:solidFill>
+                          <a:latin typeface="Arial"/>
+                        </a:defRPr>
+                      </a:pPr>
+                      <a:r>
+                        <a:t>64/100</a:t>
+                      </a:r>
+                    </a:p>
+                  </a:txBody>
+                  <a:tcPr>
+                    <a:solidFill>
+                      <a:srgbClr val="111827"/>
+                    </a:solidFill>
+                  </a:tcPr>
+                </a:tc>
+              </a:tr>
+              <a:tr h="914400">
+                <a:tc>
+                  <a:txBody>
+                    <a:bodyPr/>
+                    <a:lstStyle/>
+                    <a:p>
+                      <a:pPr>
+                        <a:defRPr sz="1000" b="1">
                           <a:solidFill>
                             <a:srgbClr val="F8FAFC"/>
                           </a:solidFill>
@@ -3713,6 +3751,54 @@
                         </a:defRPr>
                       </a:pPr>
                       <a:r>
+                        <a:t>3. 3-Min No-Fee Append Window</a:t>
+                      </a:r>
+                    </a:p>
+                  </a:txBody>
+                  <a:tcPr>
+                    <a:solidFill>
+                      <a:srgbClr val="111827"/>
+                    </a:solidFill>
+                  </a:tcPr>
+                </a:tc>
+                <a:tc>
+                  <a:txBody>
+                    <a:bodyPr/>
+                    <a:lstStyle/>
+                    <a:p>
+                      <a:pPr>
+                        <a:defRPr sz="1000" b="0">
+                          <a:solidFill>
+                            <a:srgbClr val="F8FAFC"/>
+                          </a:solidFill>
+                          <a:latin typeface="Arial"/>
+                        </a:defRPr>
+                      </a:pPr>
+                      <a:r>
+                        <a:t>7</a:t>
+                      </a:r>
+                    </a:p>
+                  </a:txBody>
+                  <a:tcPr>
+                    <a:solidFill>
+                      <a:srgbClr val="111827"/>
+                    </a:solidFill>
+                  </a:tcPr>
+                </a:tc>
+                <a:tc>
+                  <a:txBody>
+                    <a:bodyPr/>
+                    <a:lstStyle/>
+                    <a:p>
+                      <a:pPr>
+                        <a:defRPr sz="1000" b="0">
+                          <a:solidFill>
+                            <a:srgbClr val="F8FAFC"/>
+                          </a:solidFill>
+                          <a:latin typeface="Arial"/>
+                        </a:defRPr>
+                      </a:pPr>
+                      <a:r>
                         <a:t>8</a:t>
                       </a:r>
                     </a:p>
@@ -3729,7 +3815,7 @@
                     <a:lstStyle/>
                     <a:p>
                       <a:pPr>
-                        <a:defRPr sz="1100" b="1">
+                        <a:defRPr sz="1000" b="1">
                           <a:solidFill>
                             <a:srgbClr val="FC8019"/>
                           </a:solidFill>
@@ -3737,7 +3823,7 @@
                         </a:defRPr>
                       </a:pPr>
                       <a:r>
-                        <a:t>72/100</a:t>
+                        <a:t>56/100</a:t>
                       </a:r>
                     </a:p>
                   </a:txBody>
@@ -3747,13 +3833,15 @@
                     </a:solidFill>
                   </a:tcPr>
                 </a:tc>
-                <a:tc>
-                  <a:txBody>
-                    <a:bodyPr/>
-                    <a:lstStyle/>
-                    <a:p>
-                      <a:pPr>
-                        <a:defRPr sz="1100" b="0">
+              </a:tr>
+              <a:tr h="914400">
+                <a:tc>
+                  <a:txBody>
+                    <a:bodyPr/>
+                    <a:lstStyle/>
+                    <a:p>
+                      <a:pPr>
+                        <a:defRPr sz="1000" b="1">
                           <a:solidFill>
                             <a:srgbClr val="F8FAFC"/>
                           </a:solidFill>
@@ -3761,7 +3849,7 @@
                         </a:defRPr>
                       </a:pPr>
                       <a:r>
-                        <a:t>Drives daily essential repeat checkout loops.</a:t>
+                        <a:t>4. Regional Specialty Local Hub</a:t>
                       </a:r>
                     </a:p>
                   </a:txBody>
@@ -3771,15 +3859,13 @@
                     </a:solidFill>
                   </a:tcPr>
                 </a:tc>
-              </a:tr>
-              <a:tr h="731520">
-                <a:tc>
-                  <a:txBody>
-                    <a:bodyPr/>
-                    <a:lstStyle/>
-                    <a:p>
-                      <a:pPr>
-                        <a:defRPr sz="1100" b="1">
+                <a:tc>
+                  <a:txBody>
+                    <a:bodyPr/>
+                    <a:lstStyle/>
+                    <a:p>
+                      <a:pPr>
+                        <a:defRPr sz="1000" b="0">
                           <a:solidFill>
                             <a:srgbClr val="F8FAFC"/>
                           </a:solidFill>
@@ -3787,7 +3873,7 @@
                         </a:defRPr>
                       </a:pPr>
                       <a:r>
-                        <a:t>2. Freshness Verification Tracker</a:t>
+                        <a:t>8</a:t>
                       </a:r>
                     </a:p>
                   </a:txBody>
@@ -3803,7 +3889,7 @@
                     <a:lstStyle/>
                     <a:p>
                       <a:pPr>
-                        <a:defRPr sz="1100" b="0">
+                        <a:defRPr sz="1000" b="0">
                           <a:solidFill>
                             <a:srgbClr val="F8FAFC"/>
                           </a:solidFill>
@@ -3811,7 +3897,7 @@
                         </a:defRPr>
                       </a:pPr>
                       <a:r>
-                        <a:t>8</a:t>
+                        <a:t>7</a:t>
                       </a:r>
                     </a:p>
                   </a:txBody>
@@ -3827,55 +3913,7 @@
                     <a:lstStyle/>
                     <a:p>
                       <a:pPr>
-                        <a:defRPr sz="1100" b="0">
-                          <a:solidFill>
-                            <a:srgbClr val="F8FAFC"/>
-                          </a:solidFill>
-                          <a:latin typeface="Arial"/>
-                        </a:defRPr>
-                      </a:pPr>
-                      <a:r>
-                        <a:t>8</a:t>
-                      </a:r>
-                    </a:p>
-                  </a:txBody>
-                  <a:tcPr>
-                    <a:solidFill>
-                      <a:srgbClr val="111827"/>
-                    </a:solidFill>
-                  </a:tcPr>
-                </a:tc>
-                <a:tc>
-                  <a:txBody>
-                    <a:bodyPr/>
-                    <a:lstStyle/>
-                    <a:p>
-                      <a:pPr>
-                        <a:defRPr sz="1100" b="0">
-                          <a:solidFill>
-                            <a:srgbClr val="F8FAFC"/>
-                          </a:solidFill>
-                          <a:latin typeface="Arial"/>
-                        </a:defRPr>
-                      </a:pPr>
-                      <a:r>
-                        <a:t>7</a:t>
-                      </a:r>
-                    </a:p>
-                  </a:txBody>
-                  <a:tcPr>
-                    <a:solidFill>
-                      <a:srgbClr val="111827"/>
-                    </a:solidFill>
-                  </a:tcPr>
-                </a:tc>
-                <a:tc>
-                  <a:txBody>
-                    <a:bodyPr/>
-                    <a:lstStyle/>
-                    <a:p>
-                      <a:pPr>
-                        <a:defRPr sz="1100" b="1">
+                        <a:defRPr sz="1000" b="1">
                           <a:solidFill>
                             <a:srgbClr val="FC8019"/>
                           </a:solidFill>
@@ -3883,323 +3921,7 @@
                         </a:defRPr>
                       </a:pPr>
                       <a:r>
-                        <a:t>64/100</a:t>
-                      </a:r>
-                    </a:p>
-                  </a:txBody>
-                  <a:tcPr>
-                    <a:solidFill>
-                      <a:srgbClr val="111827"/>
-                    </a:solidFill>
-                  </a:tcPr>
-                </a:tc>
-                <a:tc>
-                  <a:txBody>
-                    <a:bodyPr/>
-                    <a:lstStyle/>
-                    <a:p>
-                      <a:pPr>
-                        <a:defRPr sz="1100" b="0">
-                          <a:solidFill>
-                            <a:srgbClr val="F8FAFC"/>
-                          </a:solidFill>
-                          <a:latin typeface="Arial"/>
-                        </a:defRPr>
-                      </a:pPr>
-                      <a:r>
-                        <a:t>Unlocks organic produce adoption.</a:t>
-                      </a:r>
-                    </a:p>
-                  </a:txBody>
-                  <a:tcPr>
-                    <a:solidFill>
-                      <a:srgbClr val="111827"/>
-                    </a:solidFill>
-                  </a:tcPr>
-                </a:tc>
-              </a:tr>
-              <a:tr h="731520">
-                <a:tc>
-                  <a:txBody>
-                    <a:bodyPr/>
-                    <a:lstStyle/>
-                    <a:p>
-                      <a:pPr>
-                        <a:defRPr sz="1100" b="1">
-                          <a:solidFill>
-                            <a:srgbClr val="F8FAFC"/>
-                          </a:solidFill>
-                          <a:latin typeface="Arial"/>
-                        </a:defRPr>
-                      </a:pPr>
-                      <a:r>
-                        <a:t>3. 3-Min No-Fee Append Window</a:t>
-                      </a:r>
-                    </a:p>
-                  </a:txBody>
-                  <a:tcPr>
-                    <a:solidFill>
-                      <a:srgbClr val="111827"/>
-                    </a:solidFill>
-                  </a:tcPr>
-                </a:tc>
-                <a:tc>
-                  <a:txBody>
-                    <a:bodyPr/>
-                    <a:lstStyle/>
-                    <a:p>
-                      <a:pPr>
-                        <a:defRPr sz="1100" b="0">
-                          <a:solidFill>
-                            <a:srgbClr val="F8FAFC"/>
-                          </a:solidFill>
-                          <a:latin typeface="Arial"/>
-                        </a:defRPr>
-                      </a:pPr>
-                      <a:r>
-                        <a:t>7</a:t>
-                      </a:r>
-                    </a:p>
-                  </a:txBody>
-                  <a:tcPr>
-                    <a:solidFill>
-                      <a:srgbClr val="111827"/>
-                    </a:solidFill>
-                  </a:tcPr>
-                </a:tc>
-                <a:tc>
-                  <a:txBody>
-                    <a:bodyPr/>
-                    <a:lstStyle/>
-                    <a:p>
-                      <a:pPr>
-                        <a:defRPr sz="1100" b="0">
-                          <a:solidFill>
-                            <a:srgbClr val="F8FAFC"/>
-                          </a:solidFill>
-                          <a:latin typeface="Arial"/>
-                        </a:defRPr>
-                      </a:pPr>
-                      <a:r>
-                        <a:t>8</a:t>
-                      </a:r>
-                    </a:p>
-                  </a:txBody>
-                  <a:tcPr>
-                    <a:solidFill>
-                      <a:srgbClr val="111827"/>
-                    </a:solidFill>
-                  </a:tcPr>
-                </a:tc>
-                <a:tc>
-                  <a:txBody>
-                    <a:bodyPr/>
-                    <a:lstStyle/>
-                    <a:p>
-                      <a:pPr>
-                        <a:defRPr sz="1100" b="0">
-                          <a:solidFill>
-                            <a:srgbClr val="F8FAFC"/>
-                          </a:solidFill>
-                          <a:latin typeface="Arial"/>
-                        </a:defRPr>
-                      </a:pPr>
-                      <a:r>
-                        <a:t>8</a:t>
-                      </a:r>
-                    </a:p>
-                  </a:txBody>
-                  <a:tcPr>
-                    <a:solidFill>
-                      <a:srgbClr val="111827"/>
-                    </a:solidFill>
-                  </a:tcPr>
-                </a:tc>
-                <a:tc>
-                  <a:txBody>
-                    <a:bodyPr/>
-                    <a:lstStyle/>
-                    <a:p>
-                      <a:pPr>
-                        <a:defRPr sz="1100" b="1">
-                          <a:solidFill>
-                            <a:srgbClr val="FC8019"/>
-                          </a:solidFill>
-                          <a:latin typeface="Arial"/>
-                        </a:defRPr>
-                      </a:pPr>
-                      <a:r>
                         <a:t>56/100</a:t>
-                      </a:r>
-                    </a:p>
-                  </a:txBody>
-                  <a:tcPr>
-                    <a:solidFill>
-                      <a:srgbClr val="111827"/>
-                    </a:solidFill>
-                  </a:tcPr>
-                </a:tc>
-                <a:tc>
-                  <a:txBody>
-                    <a:bodyPr/>
-                    <a:lstStyle/>
-                    <a:p>
-                      <a:pPr>
-                        <a:defRPr sz="1100" b="0">
-                          <a:solidFill>
-                            <a:srgbClr val="F8FAFC"/>
-                          </a:solidFill>
-                          <a:latin typeface="Arial"/>
-                        </a:defRPr>
-                      </a:pPr>
-                      <a:r>
-                        <a:t>Captures forgotten items, boosting AOV by 18%.</a:t>
-                      </a:r>
-                    </a:p>
-                  </a:txBody>
-                  <a:tcPr>
-                    <a:solidFill>
-                      <a:srgbClr val="111827"/>
-                    </a:solidFill>
-                  </a:tcPr>
-                </a:tc>
-              </a:tr>
-              <a:tr h="731520">
-                <a:tc>
-                  <a:txBody>
-                    <a:bodyPr/>
-                    <a:lstStyle/>
-                    <a:p>
-                      <a:pPr>
-                        <a:defRPr sz="1100" b="1">
-                          <a:solidFill>
-                            <a:srgbClr val="F8FAFC"/>
-                          </a:solidFill>
-                          <a:latin typeface="Arial"/>
-                        </a:defRPr>
-                      </a:pPr>
-                      <a:r>
-                        <a:t>4. Regional Specialty Local Hub</a:t>
-                      </a:r>
-                    </a:p>
-                  </a:txBody>
-                  <a:tcPr>
-                    <a:solidFill>
-                      <a:srgbClr val="111827"/>
-                    </a:solidFill>
-                  </a:tcPr>
-                </a:tc>
-                <a:tc>
-                  <a:txBody>
-                    <a:bodyPr/>
-                    <a:lstStyle/>
-                    <a:p>
-                      <a:pPr>
-                        <a:defRPr sz="1100" b="0">
-                          <a:solidFill>
-                            <a:srgbClr val="F8FAFC"/>
-                          </a:solidFill>
-                          <a:latin typeface="Arial"/>
-                        </a:defRPr>
-                      </a:pPr>
-                      <a:r>
-                        <a:t>8</a:t>
-                      </a:r>
-                    </a:p>
-                  </a:txBody>
-                  <a:tcPr>
-                    <a:solidFill>
-                      <a:srgbClr val="111827"/>
-                    </a:solidFill>
-                  </a:tcPr>
-                </a:tc>
-                <a:tc>
-                  <a:txBody>
-                    <a:bodyPr/>
-                    <a:lstStyle/>
-                    <a:p>
-                      <a:pPr>
-                        <a:defRPr sz="1100" b="0">
-                          <a:solidFill>
-                            <a:srgbClr val="F8FAFC"/>
-                          </a:solidFill>
-                          <a:latin typeface="Arial"/>
-                        </a:defRPr>
-                      </a:pPr>
-                      <a:r>
-                        <a:t>7</a:t>
-                      </a:r>
-                    </a:p>
-                  </a:txBody>
-                  <a:tcPr>
-                    <a:solidFill>
-                      <a:srgbClr val="111827"/>
-                    </a:solidFill>
-                  </a:tcPr>
-                </a:tc>
-                <a:tc>
-                  <a:txBody>
-                    <a:bodyPr/>
-                    <a:lstStyle/>
-                    <a:p>
-                      <a:pPr>
-                        <a:defRPr sz="1100" b="0">
-                          <a:solidFill>
-                            <a:srgbClr val="F8FAFC"/>
-                          </a:solidFill>
-                          <a:latin typeface="Arial"/>
-                        </a:defRPr>
-                      </a:pPr>
-                      <a:r>
-                        <a:t>6</a:t>
-                      </a:r>
-                    </a:p>
-                  </a:txBody>
-                  <a:tcPr>
-                    <a:solidFill>
-                      <a:srgbClr val="111827"/>
-                    </a:solidFill>
-                  </a:tcPr>
-                </a:tc>
-                <a:tc>
-                  <a:txBody>
-                    <a:bodyPr/>
-                    <a:lstStyle/>
-                    <a:p>
-                      <a:pPr>
-                        <a:defRPr sz="1100" b="1">
-                          <a:solidFill>
-                            <a:srgbClr val="FC8019"/>
-                          </a:solidFill>
-                          <a:latin typeface="Arial"/>
-                        </a:defRPr>
-                      </a:pPr>
-                      <a:r>
-                        <a:t>56/100</a:t>
-                      </a:r>
-                    </a:p>
-                  </a:txBody>
-                  <a:tcPr>
-                    <a:solidFill>
-                      <a:srgbClr val="111827"/>
-                    </a:solidFill>
-                  </a:tcPr>
-                </a:tc>
-                <a:tc>
-                  <a:txBody>
-                    <a:bodyPr/>
-                    <a:lstStyle/>
-                    <a:p>
-                      <a:pPr>
-                        <a:defRPr sz="1100" b="0">
-                          <a:solidFill>
-                            <a:srgbClr val="F8FAFC"/>
-                          </a:solidFill>
-                          <a:latin typeface="Arial"/>
-                        </a:defRPr>
-                      </a:pPr>
-                      <a:r>
-                        <a:t>Unlocks local bakery and gourmet spend.</a:t>
                       </a:r>
                     </a:p>
                   </a:txBody>
@@ -4214,6 +3936,122 @@
           </a:graphicData>
         </a:graphic>
       </p:graphicFrame>
+      <p:sp>
+        <p:nvSpPr>
+          <p:cNvPr id="5" name="TextBox 4"/>
+          <p:cNvSpPr txBox="1"/>
+          <p:nvPr/>
+        </p:nvSpPr>
+        <p:spPr>
+          <a:xfrm>
+            <a:off x="7589520" y="1280160"/>
+            <a:ext cx="4114800" cy="4754880"/>
+          </a:xfrm>
+          <a:prstGeom prst="rect">
+            <a:avLst/>
+          </a:prstGeom>
+          <a:noFill/>
+        </p:spPr>
+        <p:txBody>
+          <a:bodyPr wrap="square">
+            <a:spAutoFit/>
+          </a:bodyPr>
+          <a:lstStyle/>
+          <a:p>
+            <a:pPr>
+              <a:spcAft>
+                <a:spcPts val="1000"/>
+              </a:spcAft>
+              <a:defRPr sz="1400" b="1">
+                <a:solidFill>
+                  <a:srgbClr val="FC8019"/>
+                </a:solidFill>
+                <a:latin typeface="Arial"/>
+              </a:defRPr>
+            </a:pPr>
+            <a:r>
+              <a:t>SQLite schema.sql Snippet:</a:t>
+            </a:r>
+          </a:p>
+          <a:p>
+            <a:pPr>
+              <a:spcAft>
+                <a:spcPts val="800"/>
+              </a:spcAft>
+              <a:defRPr sz="1200">
+                <a:solidFill>
+                  <a:srgbClr val="F8FAFC"/>
+                </a:solidFill>
+                <a:latin typeface="Arial"/>
+              </a:defRPr>
+            </a:pPr>
+            <a:r>
+              <a:t>Schema structure of opportunities table:</a:t>
+            </a:r>
+          </a:p>
+          <a:p>
+            <a:pPr>
+              <a:spcAft>
+                <a:spcPts val="1000"/>
+              </a:spcAft>
+              <a:defRPr sz="950">
+                <a:solidFill>
+                  <a:srgbClr val="A855F7"/>
+                </a:solidFill>
+                <a:latin typeface="Courier New"/>
+              </a:defRPr>
+            </a:pPr>
+            <a:r>
+              <a:t>CREATE TABLE opportunities (</a:t>
+            </a:r>
+            <a:br/>
+            <a:r>
+              <a:t>  id TEXT PRIMARY KEY,</a:t>
+            </a:r>
+            <a:br/>
+            <a:r>
+              <a:t>  title TEXT NOT NULL,</a:t>
+            </a:r>
+            <a:br/>
+            <a:r>
+              <a:t>  problem TEXT NOT NULL,</a:t>
+            </a:r>
+            <a:br/>
+            <a:r>
+              <a:t>  frequency INTEGER DEFAULT 0,</a:t>
+            </a:r>
+            <a:br/>
+            <a:r>
+              <a:t>  impact INTEGER NOT NULL,</a:t>
+            </a:r>
+            <a:br/>
+            <a:r>
+              <a:t>  confidence INTEGER NOT NULL,</a:t>
+            </a:r>
+            <a:br/>
+            <a:r>
+              <a:t>  opportunity_score INTEGER NOT NULL</a:t>
+            </a:r>
+            <a:br/>
+            <a:r>
+              <a:t>);</a:t>
+            </a:r>
+          </a:p>
+          <a:p>
+            <a:pPr>
+              <a:defRPr sz="1200">
+                <a:solidFill>
+                  <a:srgbClr val="8B949E"/>
+                </a:solidFill>
+                <a:latin typeface="Arial"/>
+              </a:defRPr>
+            </a:pPr>
+            <a:r>
+              <a:t>The pipeline writes the ICE prioritization scores directly to SQLite, which are fetched by the Streamlit dashboard and API gateway.</a:t>
+            </a:r>
+          </a:p>
+        </p:txBody>
+      </p:sp>
       <p:sp>
         <p:nvSpPr>
           <p:cNvPr id="6" name="TextBox 5"/>
@@ -4365,7 +4203,7 @@
         </p:nvSpPr>
         <p:spPr>
           <a:xfrm>
-            <a:off x="457200" y="457200"/>
+            <a:off x="457200" y="365760"/>
             <a:ext cx="11277295" cy="731520"/>
           </a:xfrm>
           <a:prstGeom prst="rect">
@@ -4380,7 +4218,7 @@
           <a:lstStyle/>
           <a:p>
             <a:pPr>
-              <a:defRPr sz="2400" b="1">
+              <a:defRPr sz="2200" b="1">
                 <a:solidFill>
                   <a:srgbClr val="FC8019"/>
                 </a:solidFill>
@@ -4389,57 +4227,21 @@
             </a:pPr>
             <a:r>
               <a:t>Data Baseline: 1,000 Multi-Channel Reviews Map the Friction Points</a:t>
-            </a:r>
-          </a:p>
-        </p:txBody>
-      </p:sp>
-      <p:sp>
-        <p:nvSpPr>
-          <p:cNvPr id="4" name="TextBox 3"/>
-          <p:cNvSpPr txBox="1"/>
-          <p:nvPr/>
-        </p:nvSpPr>
-        <p:spPr>
-          <a:xfrm>
-            <a:off x="457200" y="1097280"/>
-            <a:ext cx="11277295" cy="731520"/>
-          </a:xfrm>
-          <a:prstGeom prst="rect">
-            <a:avLst/>
-          </a:prstGeom>
-          <a:noFill/>
-        </p:spPr>
-        <p:txBody>
-          <a:bodyPr wrap="square">
-            <a:spAutoFit/>
-          </a:bodyPr>
-          <a:lstStyle/>
-          <a:p>
-            <a:pPr>
-              <a:defRPr sz="1400">
-                <a:solidFill>
-                  <a:srgbClr val="F8FAFC"/>
-                </a:solidFill>
-                <a:latin typeface="Arial"/>
-              </a:defRPr>
-            </a:pPr>
-            <a:r>
-              <a:t>To capture representative customer pain points, we ingested exactly 1,000 feedback records across six diverse channels. This balances App Store ratings (bugs) with in-depth Reddit and Quora discussions.</a:t>
             </a:r>
           </a:p>
         </p:txBody>
       </p:sp>
       <p:graphicFrame>
         <p:nvGraphicFramePr>
-          <p:cNvPr id="5" name="Table 4"/>
+          <p:cNvPr id="4" name="Table 3"/>
           <p:cNvGraphicFramePr>
             <a:graphicFrameLocks noGrp="1"/>
           </p:cNvGraphicFramePr>
           <p:nvPr/>
         </p:nvGraphicFramePr>
         <p:xfrm>
-          <a:off x="457200" y="2011680"/>
-          <a:ext cx="11277295" cy="3657600"/>
+          <a:off x="457200" y="1371600"/>
+          <a:ext cx="6858000" cy="3474720"/>
         </p:xfrm>
         <a:graphic>
           <a:graphicData uri="http://schemas.openxmlformats.org/drawingml/2006/table">
@@ -4448,19 +4250,18 @@
                 <a:tableStyleId>{5C22544A-7EE6-4342-B048-85BDC9FD1C3A}</a:tableStyleId>
               </a:tblPr>
               <a:tblGrid>
-                <a:gridCol w="3200400"/>
+                <a:gridCol w="3474720"/>
+                <a:gridCol w="1554480"/>
                 <a:gridCol w="1828800"/>
-                <a:gridCol w="2286000"/>
-                <a:gridCol w="3962095"/>
               </a:tblGrid>
-              <a:tr h="522514">
-                <a:tc>
-                  <a:txBody>
-                    <a:bodyPr/>
-                    <a:lstStyle/>
-                    <a:p>
-                      <a:pPr>
-                        <a:defRPr sz="1200" b="1">
+              <a:tr h="496388">
+                <a:tc>
+                  <a:txBody>
+                    <a:bodyPr/>
+                    <a:lstStyle/>
+                    <a:p>
+                      <a:pPr>
+                        <a:defRPr sz="1000" b="1">
                           <a:solidFill>
                             <a:srgbClr val="F8FAFC"/>
                           </a:solidFill>
@@ -4468,7 +4269,7 @@
                         </a:defRPr>
                       </a:pPr>
                       <a:r>
-                        <a:t>Feedback Channel</a:t>
+                        <a:t>Feedback Channel Source</a:t>
                       </a:r>
                     </a:p>
                   </a:txBody>
@@ -4484,7 +4285,7 @@
                     <a:lstStyle/>
                     <a:p>
                       <a:pPr>
-                        <a:defRPr sz="1200" b="1">
+                        <a:defRPr sz="1000" b="1">
                           <a:solidFill>
                             <a:srgbClr val="F8FAFC"/>
                           </a:solidFill>
@@ -4492,7 +4293,7 @@
                         </a:defRPr>
                       </a:pPr>
                       <a:r>
-                        <a:t>Target Volume</a:t>
+                        <a:t>Target Vol</a:t>
                       </a:r>
                     </a:p>
                   </a:txBody>
@@ -4508,7 +4309,7 @@
                     <a:lstStyle/>
                     <a:p>
                       <a:pPr>
-                        <a:defRPr sz="1200" b="1">
+                        <a:defRPr sz="1000" b="1">
                           <a:solidFill>
                             <a:srgbClr val="F8FAFC"/>
                           </a:solidFill>
@@ -4526,13 +4327,15 @@
                     </a:solidFill>
                   </a:tcPr>
                 </a:tc>
-                <a:tc>
-                  <a:txBody>
-                    <a:bodyPr/>
-                    <a:lstStyle/>
-                    <a:p>
-                      <a:pPr>
-                        <a:defRPr sz="1200" b="1">
+              </a:tr>
+              <a:tr h="496388">
+                <a:tc>
+                  <a:txBody>
+                    <a:bodyPr/>
+                    <a:lstStyle/>
+                    <a:p>
+                      <a:pPr>
+                        <a:defRPr sz="1000" b="0">
                           <a:solidFill>
                             <a:srgbClr val="F8FAFC"/>
                           </a:solidFill>
@@ -4540,25 +4343,73 @@
                         </a:defRPr>
                       </a:pPr>
                       <a:r>
-                        <a:t>Cleaned &amp; Profiled (Spam Excluded)</a:t>
-                      </a:r>
-                    </a:p>
-                  </a:txBody>
-                  <a:tcPr>
-                    <a:solidFill>
-                      <a:srgbClr val="1F2937"/>
+                        <a:t>Google Play Store Reviews</a:t>
+                      </a:r>
+                    </a:p>
+                  </a:txBody>
+                  <a:tcPr>
+                    <a:solidFill>
+                      <a:srgbClr val="111827"/>
+                    </a:solidFill>
+                  </a:tcPr>
+                </a:tc>
+                <a:tc>
+                  <a:txBody>
+                    <a:bodyPr/>
+                    <a:lstStyle/>
+                    <a:p>
+                      <a:pPr>
+                        <a:defRPr sz="1000" b="0">
+                          <a:solidFill>
+                            <a:srgbClr val="F8FAFC"/>
+                          </a:solidFill>
+                          <a:latin typeface="Arial"/>
+                        </a:defRPr>
+                      </a:pPr>
+                      <a:r>
+                        <a:t>300</a:t>
+                      </a:r>
+                    </a:p>
+                  </a:txBody>
+                  <a:tcPr>
+                    <a:solidFill>
+                      <a:srgbClr val="111827"/>
+                    </a:solidFill>
+                  </a:tcPr>
+                </a:tc>
+                <a:tc>
+                  <a:txBody>
+                    <a:bodyPr/>
+                    <a:lstStyle/>
+                    <a:p>
+                      <a:pPr>
+                        <a:defRPr sz="1000" b="0">
+                          <a:solidFill>
+                            <a:srgbClr val="F8FAFC"/>
+                          </a:solidFill>
+                          <a:latin typeface="Arial"/>
+                        </a:defRPr>
+                      </a:pPr>
+                      <a:r>
+                        <a:t>300</a:t>
+                      </a:r>
+                    </a:p>
+                  </a:txBody>
+                  <a:tcPr>
+                    <a:solidFill>
+                      <a:srgbClr val="111827"/>
                     </a:solidFill>
                   </a:tcPr>
                 </a:tc>
               </a:tr>
-              <a:tr h="522514">
-                <a:tc>
-                  <a:txBody>
-                    <a:bodyPr/>
-                    <a:lstStyle/>
-                    <a:p>
-                      <a:pPr>
-                        <a:defRPr sz="1200" b="0">
+              <a:tr h="496388">
+                <a:tc>
+                  <a:txBody>
+                    <a:bodyPr/>
+                    <a:lstStyle/>
+                    <a:p>
+                      <a:pPr>
+                        <a:defRPr sz="1000" b="0">
                           <a:solidFill>
                             <a:srgbClr val="F8FAFC"/>
                           </a:solidFill>
@@ -4566,7 +4417,7 @@
                         </a:defRPr>
                       </a:pPr>
                       <a:r>
-                        <a:t>Google Play Store Reviews</a:t>
+                        <a:t>Reddit Retail Discussions</a:t>
                       </a:r>
                     </a:p>
                   </a:txBody>
@@ -4582,7 +4433,7 @@
                     <a:lstStyle/>
                     <a:p>
                       <a:pPr>
-                        <a:defRPr sz="1200" b="0">
+                        <a:defRPr sz="1000" b="0">
                           <a:solidFill>
                             <a:srgbClr val="F8FAFC"/>
                           </a:solidFill>
@@ -4590,7 +4441,7 @@
                         </a:defRPr>
                       </a:pPr>
                       <a:r>
-                        <a:t>300</a:t>
+                        <a:t>200</a:t>
                       </a:r>
                     </a:p>
                   </a:txBody>
@@ -4606,7 +4457,7 @@
                     <a:lstStyle/>
                     <a:p>
                       <a:pPr>
-                        <a:defRPr sz="1200" b="0">
+                        <a:defRPr sz="1000" b="0">
                           <a:solidFill>
                             <a:srgbClr val="F8FAFC"/>
                           </a:solidFill>
@@ -4614,7 +4465,7 @@
                         </a:defRPr>
                       </a:pPr>
                       <a:r>
-                        <a:t>300</a:t>
+                        <a:t>200</a:t>
                       </a:r>
                     </a:p>
                   </a:txBody>
@@ -4624,13 +4475,15 @@
                     </a:solidFill>
                   </a:tcPr>
                 </a:tc>
-                <a:tc>
-                  <a:txBody>
-                    <a:bodyPr/>
-                    <a:lstStyle/>
-                    <a:p>
-                      <a:pPr>
-                        <a:defRPr sz="1200" b="0">
+              </a:tr>
+              <a:tr h="496388">
+                <a:tc>
+                  <a:txBody>
+                    <a:bodyPr/>
+                    <a:lstStyle/>
+                    <a:p>
+                      <a:pPr>
+                        <a:defRPr sz="1000" b="0">
                           <a:solidFill>
                             <a:srgbClr val="F8FAFC"/>
                           </a:solidFill>
@@ -4638,7 +4491,7 @@
                         </a:defRPr>
                       </a:pPr>
                       <a:r>
-                        <a:t>99.8% unique entries parsed successfully.</a:t>
+                        <a:t>iOS App Store Reviews</a:t>
                       </a:r>
                     </a:p>
                   </a:txBody>
@@ -4648,15 +4501,63 @@
                     </a:solidFill>
                   </a:tcPr>
                 </a:tc>
+                <a:tc>
+                  <a:txBody>
+                    <a:bodyPr/>
+                    <a:lstStyle/>
+                    <a:p>
+                      <a:pPr>
+                        <a:defRPr sz="1000" b="0">
+                          <a:solidFill>
+                            <a:srgbClr val="F8FAFC"/>
+                          </a:solidFill>
+                          <a:latin typeface="Arial"/>
+                        </a:defRPr>
+                      </a:pPr>
+                      <a:r>
+                        <a:t>150</a:t>
+                      </a:r>
+                    </a:p>
+                  </a:txBody>
+                  <a:tcPr>
+                    <a:solidFill>
+                      <a:srgbClr val="111827"/>
+                    </a:solidFill>
+                  </a:tcPr>
+                </a:tc>
+                <a:tc>
+                  <a:txBody>
+                    <a:bodyPr/>
+                    <a:lstStyle/>
+                    <a:p>
+                      <a:pPr>
+                        <a:defRPr sz="1000" b="0">
+                          <a:solidFill>
+                            <a:srgbClr val="F8FAFC"/>
+                          </a:solidFill>
+                          <a:latin typeface="Arial"/>
+                        </a:defRPr>
+                      </a:pPr>
+                      <a:r>
+                        <a:t>150</a:t>
+                      </a:r>
+                    </a:p>
+                  </a:txBody>
+                  <a:tcPr>
+                    <a:solidFill>
+                      <a:srgbClr val="111827"/>
+                    </a:solidFill>
+                  </a:tcPr>
+                </a:tc>
               </a:tr>
-              <a:tr h="522514">
-                <a:tc>
-                  <a:txBody>
-                    <a:bodyPr/>
-                    <a:lstStyle/>
-                    <a:p>
-                      <a:pPr>
-                        <a:defRPr sz="1200" b="0">
+              <a:tr h="496388">
+                <a:tc>
+                  <a:txBody>
+                    <a:bodyPr/>
+                    <a:lstStyle/>
+                    <a:p>
+                      <a:pPr>
+                        <a:defRPr sz="1000" b="0">
                           <a:solidFill>
                             <a:srgbClr val="F8FAFC"/>
                           </a:solidFill>
@@ -4664,7 +4565,7 @@
                         </a:defRPr>
                       </a:pPr>
                       <a:r>
-                        <a:t>Reddit Retail Discussions</a:t>
+                        <a:t>YouTube Comments</a:t>
                       </a:r>
                     </a:p>
                   </a:txBody>
@@ -4680,7 +4581,7 @@
                     <a:lstStyle/>
                     <a:p>
                       <a:pPr>
-                        <a:defRPr sz="1200" b="0">
+                        <a:defRPr sz="1000" b="0">
                           <a:solidFill>
                             <a:srgbClr val="F8FAFC"/>
                           </a:solidFill>
@@ -4688,7 +4589,7 @@
                         </a:defRPr>
                       </a:pPr>
                       <a:r>
-                        <a:t>200</a:t>
+                        <a:t>150</a:t>
                       </a:r>
                     </a:p>
                   </a:txBody>
@@ -4704,7 +4605,7 @@
                     <a:lstStyle/>
                     <a:p>
                       <a:pPr>
-                        <a:defRPr sz="1200" b="0">
+                        <a:defRPr sz="1000" b="0">
                           <a:solidFill>
                             <a:srgbClr val="F8FAFC"/>
                           </a:solidFill>
@@ -4712,7 +4613,7 @@
                         </a:defRPr>
                       </a:pPr>
                       <a:r>
-                        <a:t>200</a:t>
+                        <a:t>150</a:t>
                       </a:r>
                     </a:p>
                   </a:txBody>
@@ -4722,13 +4623,15 @@
                     </a:solidFill>
                   </a:tcPr>
                 </a:tc>
-                <a:tc>
-                  <a:txBody>
-                    <a:bodyPr/>
-                    <a:lstStyle/>
-                    <a:p>
-                      <a:pPr>
-                        <a:defRPr sz="1200" b="0">
+              </a:tr>
+              <a:tr h="496388">
+                <a:tc>
+                  <a:txBody>
+                    <a:bodyPr/>
+                    <a:lstStyle/>
+                    <a:p>
+                      <a:pPr>
+                        <a:defRPr sz="1000" b="0">
                           <a:solidFill>
                             <a:srgbClr val="F8FAFC"/>
                           </a:solidFill>
@@ -4736,7 +4639,7 @@
                         </a:defRPr>
                       </a:pPr>
                       <a:r>
-                        <a:t>Identified core trust and quality themes.</a:t>
+                        <a:t>Twitter (X) Posts</a:t>
                       </a:r>
                     </a:p>
                   </a:txBody>
@@ -4746,15 +4649,63 @@
                     </a:solidFill>
                   </a:tcPr>
                 </a:tc>
+                <a:tc>
+                  <a:txBody>
+                    <a:bodyPr/>
+                    <a:lstStyle/>
+                    <a:p>
+                      <a:pPr>
+                        <a:defRPr sz="1000" b="0">
+                          <a:solidFill>
+                            <a:srgbClr val="F8FAFC"/>
+                          </a:solidFill>
+                          <a:latin typeface="Arial"/>
+                        </a:defRPr>
+                      </a:pPr>
+                      <a:r>
+                        <a:t>100</a:t>
+                      </a:r>
+                    </a:p>
+                  </a:txBody>
+                  <a:tcPr>
+                    <a:solidFill>
+                      <a:srgbClr val="111827"/>
+                    </a:solidFill>
+                  </a:tcPr>
+                </a:tc>
+                <a:tc>
+                  <a:txBody>
+                    <a:bodyPr/>
+                    <a:lstStyle/>
+                    <a:p>
+                      <a:pPr>
+                        <a:defRPr sz="1000" b="0">
+                          <a:solidFill>
+                            <a:srgbClr val="F8FAFC"/>
+                          </a:solidFill>
+                          <a:latin typeface="Arial"/>
+                        </a:defRPr>
+                      </a:pPr>
+                      <a:r>
+                        <a:t>100</a:t>
+                      </a:r>
+                    </a:p>
+                  </a:txBody>
+                  <a:tcPr>
+                    <a:solidFill>
+                      <a:srgbClr val="111827"/>
+                    </a:solidFill>
+                  </a:tcPr>
+                </a:tc>
               </a:tr>
-              <a:tr h="522514">
-                <a:tc>
-                  <a:txBody>
-                    <a:bodyPr/>
-                    <a:lstStyle/>
-                    <a:p>
-                      <a:pPr>
-                        <a:defRPr sz="1200" b="0">
+              <a:tr h="496392">
+                <a:tc>
+                  <a:txBody>
+                    <a:bodyPr/>
+                    <a:lstStyle/>
+                    <a:p>
+                      <a:pPr>
+                        <a:defRPr sz="1000" b="0">
                           <a:solidFill>
                             <a:srgbClr val="F8FAFC"/>
                           </a:solidFill>
@@ -4762,7 +4713,7 @@
                         </a:defRPr>
                       </a:pPr>
                       <a:r>
-                        <a:t>iOS App Store Reviews</a:t>
+                        <a:t>Quora Q&amp;A Discussions</a:t>
                       </a:r>
                     </a:p>
                   </a:txBody>
@@ -4778,7 +4729,7 @@
                     <a:lstStyle/>
                     <a:p>
                       <a:pPr>
-                        <a:defRPr sz="1200" b="0">
+                        <a:defRPr sz="1000" b="0">
                           <a:solidFill>
                             <a:srgbClr val="F8FAFC"/>
                           </a:solidFill>
@@ -4786,7 +4737,7 @@
                         </a:defRPr>
                       </a:pPr>
                       <a:r>
-                        <a:t>150</a:t>
+                        <a:t>100</a:t>
                       </a:r>
                     </a:p>
                   </a:txBody>
@@ -4802,7 +4753,7 @@
                     <a:lstStyle/>
                     <a:p>
                       <a:pPr>
-                        <a:defRPr sz="1200" b="0">
+                        <a:defRPr sz="1000" b="0">
                           <a:solidFill>
                             <a:srgbClr val="F8FAFC"/>
                           </a:solidFill>
@@ -4810,325 +4761,7 @@
                         </a:defRPr>
                       </a:pPr>
                       <a:r>
-                        <a:t>150</a:t>
-                      </a:r>
-                    </a:p>
-                  </a:txBody>
-                  <a:tcPr>
-                    <a:solidFill>
-                      <a:srgbClr val="111827"/>
-                    </a:solidFill>
-                  </a:tcPr>
-                </a:tc>
-                <a:tc>
-                  <a:txBody>
-                    <a:bodyPr/>
-                    <a:lstStyle/>
-                    <a:p>
-                      <a:pPr>
-                        <a:defRPr sz="1200" b="0">
-                          <a:solidFill>
-                            <a:srgbClr val="F8FAFC"/>
-                          </a:solidFill>
-                          <a:latin typeface="Arial"/>
-                        </a:defRPr>
-                      </a:pPr>
-                      <a:r>
-                        <a:t>Captured checkout UI and platform glitches.</a:t>
-                      </a:r>
-                    </a:p>
-                  </a:txBody>
-                  <a:tcPr>
-                    <a:solidFill>
-                      <a:srgbClr val="111827"/>
-                    </a:solidFill>
-                  </a:tcPr>
-                </a:tc>
-              </a:tr>
-              <a:tr h="522514">
-                <a:tc>
-                  <a:txBody>
-                    <a:bodyPr/>
-                    <a:lstStyle/>
-                    <a:p>
-                      <a:pPr>
-                        <a:defRPr sz="1200" b="0">
-                          <a:solidFill>
-                            <a:srgbClr val="F8FAFC"/>
-                          </a:solidFill>
-                          <a:latin typeface="Arial"/>
-                        </a:defRPr>
-                      </a:pPr>
-                      <a:r>
-                        <a:t>YouTube Comments</a:t>
-                      </a:r>
-                    </a:p>
-                  </a:txBody>
-                  <a:tcPr>
-                    <a:solidFill>
-                      <a:srgbClr val="111827"/>
-                    </a:solidFill>
-                  </a:tcPr>
-                </a:tc>
-                <a:tc>
-                  <a:txBody>
-                    <a:bodyPr/>
-                    <a:lstStyle/>
-                    <a:p>
-                      <a:pPr>
-                        <a:defRPr sz="1200" b="0">
-                          <a:solidFill>
-                            <a:srgbClr val="F8FAFC"/>
-                          </a:solidFill>
-                          <a:latin typeface="Arial"/>
-                        </a:defRPr>
-                      </a:pPr>
-                      <a:r>
-                        <a:t>150</a:t>
-                      </a:r>
-                    </a:p>
-                  </a:txBody>
-                  <a:tcPr>
-                    <a:solidFill>
-                      <a:srgbClr val="111827"/>
-                    </a:solidFill>
-                  </a:tcPr>
-                </a:tc>
-                <a:tc>
-                  <a:txBody>
-                    <a:bodyPr/>
-                    <a:lstStyle/>
-                    <a:p>
-                      <a:pPr>
-                        <a:defRPr sz="1200" b="0">
-                          <a:solidFill>
-                            <a:srgbClr val="F8FAFC"/>
-                          </a:solidFill>
-                          <a:latin typeface="Arial"/>
-                        </a:defRPr>
-                      </a:pPr>
-                      <a:r>
-                        <a:t>150</a:t>
-                      </a:r>
-                    </a:p>
-                  </a:txBody>
-                  <a:tcPr>
-                    <a:solidFill>
-                      <a:srgbClr val="111827"/>
-                    </a:solidFill>
-                  </a:tcPr>
-                </a:tc>
-                <a:tc>
-                  <a:txBody>
-                    <a:bodyPr/>
-                    <a:lstStyle/>
-                    <a:p>
-                      <a:pPr>
-                        <a:defRPr sz="1200" b="0">
-                          <a:solidFill>
-                            <a:srgbClr val="F8FAFC"/>
-                          </a:solidFill>
-                          <a:latin typeface="Arial"/>
-                        </a:defRPr>
-                      </a:pPr>
-                      <a:r>
-                        <a:t>2 duplicate spam items removed in cleaner.</a:t>
-                      </a:r>
-                    </a:p>
-                  </a:txBody>
-                  <a:tcPr>
-                    <a:solidFill>
-                      <a:srgbClr val="111827"/>
-                    </a:solidFill>
-                  </a:tcPr>
-                </a:tc>
-              </a:tr>
-              <a:tr h="522514">
-                <a:tc>
-                  <a:txBody>
-                    <a:bodyPr/>
-                    <a:lstStyle/>
-                    <a:p>
-                      <a:pPr>
-                        <a:defRPr sz="1200" b="0">
-                          <a:solidFill>
-                            <a:srgbClr val="F8FAFC"/>
-                          </a:solidFill>
-                          <a:latin typeface="Arial"/>
-                        </a:defRPr>
-                      </a:pPr>
-                      <a:r>
-                        <a:t>Twitter (X) Posts</a:t>
-                      </a:r>
-                    </a:p>
-                  </a:txBody>
-                  <a:tcPr>
-                    <a:solidFill>
-                      <a:srgbClr val="111827"/>
-                    </a:solidFill>
-                  </a:tcPr>
-                </a:tc>
-                <a:tc>
-                  <a:txBody>
-                    <a:bodyPr/>
-                    <a:lstStyle/>
-                    <a:p>
-                      <a:pPr>
-                        <a:defRPr sz="1200" b="0">
-                          <a:solidFill>
-                            <a:srgbClr val="F8FAFC"/>
-                          </a:solidFill>
-                          <a:latin typeface="Arial"/>
-                        </a:defRPr>
-                      </a:pPr>
-                      <a:r>
                         <a:t>100</a:t>
-                      </a:r>
-                    </a:p>
-                  </a:txBody>
-                  <a:tcPr>
-                    <a:solidFill>
-                      <a:srgbClr val="111827"/>
-                    </a:solidFill>
-                  </a:tcPr>
-                </a:tc>
-                <a:tc>
-                  <a:txBody>
-                    <a:bodyPr/>
-                    <a:lstStyle/>
-                    <a:p>
-                      <a:pPr>
-                        <a:defRPr sz="1200" b="0">
-                          <a:solidFill>
-                            <a:srgbClr val="F8FAFC"/>
-                          </a:solidFill>
-                          <a:latin typeface="Arial"/>
-                        </a:defRPr>
-                      </a:pPr>
-                      <a:r>
-                        <a:t>100</a:t>
-                      </a:r>
-                    </a:p>
-                  </a:txBody>
-                  <a:tcPr>
-                    <a:solidFill>
-                      <a:srgbClr val="111827"/>
-                    </a:solidFill>
-                  </a:tcPr>
-                </a:tc>
-                <a:tc>
-                  <a:txBody>
-                    <a:bodyPr/>
-                    <a:lstStyle/>
-                    <a:p>
-                      <a:pPr>
-                        <a:defRPr sz="1200" b="0">
-                          <a:solidFill>
-                            <a:srgbClr val="F8FAFC"/>
-                          </a:solidFill>
-                          <a:latin typeface="Arial"/>
-                        </a:defRPr>
-                      </a:pPr>
-                      <a:r>
-                        <a:t>Extracted real-time delivery fee complaints.</a:t>
-                      </a:r>
-                    </a:p>
-                  </a:txBody>
-                  <a:tcPr>
-                    <a:solidFill>
-                      <a:srgbClr val="111827"/>
-                    </a:solidFill>
-                  </a:tcPr>
-                </a:tc>
-              </a:tr>
-              <a:tr h="522516">
-                <a:tc>
-                  <a:txBody>
-                    <a:bodyPr/>
-                    <a:lstStyle/>
-                    <a:p>
-                      <a:pPr>
-                        <a:defRPr sz="1200" b="0">
-                          <a:solidFill>
-                            <a:srgbClr val="F8FAFC"/>
-                          </a:solidFill>
-                          <a:latin typeface="Arial"/>
-                        </a:defRPr>
-                      </a:pPr>
-                      <a:r>
-                        <a:t>Quora Discussions</a:t>
-                      </a:r>
-                    </a:p>
-                  </a:txBody>
-                  <a:tcPr>
-                    <a:solidFill>
-                      <a:srgbClr val="111827"/>
-                    </a:solidFill>
-                  </a:tcPr>
-                </a:tc>
-                <a:tc>
-                  <a:txBody>
-                    <a:bodyPr/>
-                    <a:lstStyle/>
-                    <a:p>
-                      <a:pPr>
-                        <a:defRPr sz="1200" b="0">
-                          <a:solidFill>
-                            <a:srgbClr val="F8FAFC"/>
-                          </a:solidFill>
-                          <a:latin typeface="Arial"/>
-                        </a:defRPr>
-                      </a:pPr>
-                      <a:r>
-                        <a:t>100</a:t>
-                      </a:r>
-                    </a:p>
-                  </a:txBody>
-                  <a:tcPr>
-                    <a:solidFill>
-                      <a:srgbClr val="111827"/>
-                    </a:solidFill>
-                  </a:tcPr>
-                </a:tc>
-                <a:tc>
-                  <a:txBody>
-                    <a:bodyPr/>
-                    <a:lstStyle/>
-                    <a:p>
-                      <a:pPr>
-                        <a:defRPr sz="1200" b="0">
-                          <a:solidFill>
-                            <a:srgbClr val="F8FAFC"/>
-                          </a:solidFill>
-                          <a:latin typeface="Arial"/>
-                        </a:defRPr>
-                      </a:pPr>
-                      <a:r>
-                        <a:t>100</a:t>
-                      </a:r>
-                    </a:p>
-                  </a:txBody>
-                  <a:tcPr>
-                    <a:solidFill>
-                      <a:srgbClr val="111827"/>
-                    </a:solidFill>
-                  </a:tcPr>
-                </a:tc>
-                <a:tc>
-                  <a:txBody>
-                    <a:bodyPr/>
-                    <a:lstStyle/>
-                    <a:p>
-                      <a:pPr>
-                        <a:defRPr sz="1200" b="0">
-                          <a:solidFill>
-                            <a:srgbClr val="F8FAFC"/>
-                          </a:solidFill>
-                          <a:latin typeface="Arial"/>
-                        </a:defRPr>
-                      </a:pPr>
-                      <a:r>
-                        <a:t>Analyzed long-tail competitor comparisons.</a:t>
                       </a:r>
                     </a:p>
                   </a:txBody>
@@ -5143,6 +4776,98 @@
           </a:graphicData>
         </a:graphic>
       </p:graphicFrame>
+      <p:sp>
+        <p:nvSpPr>
+          <p:cNvPr id="5" name="TextBox 4"/>
+          <p:cNvSpPr txBox="1"/>
+          <p:nvPr/>
+        </p:nvSpPr>
+        <p:spPr>
+          <a:xfrm>
+            <a:off x="7589520" y="1280160"/>
+            <a:ext cx="4114800" cy="4754880"/>
+          </a:xfrm>
+          <a:prstGeom prst="rect">
+            <a:avLst/>
+          </a:prstGeom>
+          <a:noFill/>
+        </p:spPr>
+        <p:txBody>
+          <a:bodyPr wrap="square">
+            <a:spAutoFit/>
+          </a:bodyPr>
+          <a:lstStyle/>
+          <a:p>
+            <a:pPr>
+              <a:spcAft>
+                <a:spcPts val="1000"/>
+              </a:spcAft>
+              <a:defRPr sz="1400" b="1">
+                <a:solidFill>
+                  <a:srgbClr val="FC8019"/>
+                </a:solidFill>
+                <a:latin typeface="Arial"/>
+              </a:defRPr>
+            </a:pPr>
+            <a:r>
+              <a:t>Ingested SQL Snippet (Proof of Work):</a:t>
+            </a:r>
+          </a:p>
+          <a:p>
+            <a:pPr>
+              <a:spcAft>
+                <a:spcPts val="1200"/>
+              </a:spcAft>
+              <a:defRPr sz="1300">
+                <a:solidFill>
+                  <a:srgbClr val="F8FAFC"/>
+                </a:solidFill>
+                <a:latin typeface="Arial"/>
+              </a:defRPr>
+            </a:pPr>
+            <a:r>
+              <a:t>Our Cleaner Agent translates retail Hinglish and sanitizes raw inputs before K-Means clustering:</a:t>
+            </a:r>
+          </a:p>
+          <a:p>
+            <a:pPr>
+              <a:spcAft>
+                <a:spcPts val="1000"/>
+              </a:spcAft>
+              <a:defRPr sz="1100">
+                <a:solidFill>
+                  <a:srgbClr val="FF9F43"/>
+                </a:solidFill>
+                <a:latin typeface="Arial-Italic"/>
+              </a:defRPr>
+            </a:pPr>
+            <a:r>
+              <a:t>Raw Review #84 (Play Store):</a:t>
+            </a:r>
+            <a:br/>
+            <a:r>
+              <a:t>"Nandini milk delivery is good but andhr-se face wash order krte hi delivery charges add ho gye. Bahut mehanga lagta hai free delivery cross krne me."</a:t>
+            </a:r>
+          </a:p>
+          <a:p>
+            <a:pPr>
+              <a:defRPr sz="1100">
+                <a:solidFill>
+                  <a:srgbClr val="22C55E"/>
+                </a:solidFill>
+                <a:latin typeface="Arial-Bold"/>
+              </a:defRPr>
+            </a:pPr>
+            <a:r>
+              <a:t>Cleaned English (Stored in DB):</a:t>
+            </a:r>
+            <a:br/>
+            <a:r>
+              <a:t>"Nandini milk delivery is good but as soon as I ordered face wash delivery charges got added. It feels very expensive to cross the free delivery threshold."</a:t>
+            </a:r>
+          </a:p>
+        </p:txBody>
+      </p:sp>
       <p:sp>
         <p:nvSpPr>
           <p:cNvPr id="6" name="TextBox 5"/>
@@ -5294,7 +5019,7 @@
         </p:nvSpPr>
         <p:spPr>
           <a:xfrm>
-            <a:off x="457200" y="457200"/>
+            <a:off x="457200" y="365760"/>
             <a:ext cx="11277295" cy="731520"/>
           </a:xfrm>
           <a:prstGeom prst="rect">
@@ -5309,7 +5034,7 @@
           <a:lstStyle/>
           <a:p>
             <a:pPr>
-              <a:defRPr sz="2400" b="1">
+              <a:defRPr sz="2200" b="1">
                 <a:solidFill>
                   <a:srgbClr val="FC8019"/>
                 </a:solidFill>
@@ -5318,57 +5043,21 @@
             </a:pPr>
             <a:r>
               <a:t>AI Ingestion Pipeline: Gathering, Translating, and Validating Feedback</a:t>
-            </a:r>
-          </a:p>
-        </p:txBody>
-      </p:sp>
-      <p:sp>
-        <p:nvSpPr>
-          <p:cNvPr id="4" name="TextBox 3"/>
-          <p:cNvSpPr txBox="1"/>
-          <p:nvPr/>
-        </p:nvSpPr>
-        <p:spPr>
-          <a:xfrm>
-            <a:off x="457200" y="1097280"/>
-            <a:ext cx="11277295" cy="731520"/>
-          </a:xfrm>
-          <a:prstGeom prst="rect">
-            <a:avLst/>
-          </a:prstGeom>
-          <a:noFill/>
-        </p:spPr>
-        <p:txBody>
-          <a:bodyPr wrap="square">
-            <a:spAutoFit/>
-          </a:bodyPr>
-          <a:lstStyle/>
-          <a:p>
-            <a:pPr>
-              <a:defRPr sz="1400">
-                <a:solidFill>
-                  <a:srgbClr val="F8FAFC"/>
-                </a:solidFill>
-                <a:latin typeface="Arial"/>
-              </a:defRPr>
-            </a:pPr>
-            <a:r>
-              <a:t>To scale qualitative analysis, we built a 7-agent pipeline. It automates Hinglish translation (e.g. mehanga -&gt; expensive, bekar -&gt; bad), clusters complaints, and validates findings against database metrics.</a:t>
             </a:r>
           </a:p>
         </p:txBody>
       </p:sp>
       <p:graphicFrame>
         <p:nvGraphicFramePr>
-          <p:cNvPr id="5" name="Table 4"/>
+          <p:cNvPr id="4" name="Table 3"/>
           <p:cNvGraphicFramePr>
             <a:graphicFrameLocks noGrp="1"/>
           </p:cNvGraphicFramePr>
           <p:nvPr/>
         </p:nvGraphicFramePr>
         <p:xfrm>
-          <a:off x="457200" y="2011680"/>
-          <a:ext cx="11277295" cy="3840480"/>
+          <a:off x="457200" y="1371600"/>
+          <a:ext cx="6858000" cy="4572000"/>
         </p:xfrm>
         <a:graphic>
           <a:graphicData uri="http://schemas.openxmlformats.org/drawingml/2006/table">
@@ -5377,17 +5066,17 @@
                 <a:tableStyleId>{5C22544A-7EE6-4342-B048-85BDC9FD1C3A}</a:tableStyleId>
               </a:tblPr>
               <a:tblGrid>
-                <a:gridCol w="2286000"/>
-                <a:gridCol w="8991295"/>
+                <a:gridCol w="1645920"/>
+                <a:gridCol w="5212080"/>
               </a:tblGrid>
-              <a:tr h="480060">
-                <a:tc>
-                  <a:txBody>
-                    <a:bodyPr/>
-                    <a:lstStyle/>
-                    <a:p>
-                      <a:pPr>
-                        <a:defRPr sz="1200" b="1">
+              <a:tr h="571500">
+                <a:tc>
+                  <a:txBody>
+                    <a:bodyPr/>
+                    <a:lstStyle/>
+                    <a:p>
+                      <a:pPr>
+                        <a:defRPr sz="1000" b="1">
                           <a:solidFill>
                             <a:srgbClr val="F8FAFC"/>
                           </a:solidFill>
@@ -5395,7 +5084,7 @@
                         </a:defRPr>
                       </a:pPr>
                       <a:r>
-                        <a:t>Pipeline Phase</a:t>
+                        <a:t>Agent</a:t>
                       </a:r>
                     </a:p>
                   </a:txBody>
@@ -5411,7 +5100,7 @@
                     <a:lstStyle/>
                     <a:p>
                       <a:pPr>
-                        <a:defRPr sz="1200" b="1">
+                        <a:defRPr sz="1000" b="1">
                           <a:solidFill>
                             <a:srgbClr val="F8FAFC"/>
                           </a:solidFill>
@@ -5419,7 +5108,7 @@
                         </a:defRPr>
                       </a:pPr>
                       <a:r>
-                        <a:t>Functional Responsibility &amp; Output</a:t>
+                        <a:t>Role &amp; Verification Code Output</a:t>
                       </a:r>
                     </a:p>
                   </a:txBody>
@@ -5430,14 +5119,14 @@
                   </a:tcPr>
                 </a:tc>
               </a:tr>
-              <a:tr h="480060">
-                <a:tc>
-                  <a:txBody>
-                    <a:bodyPr/>
-                    <a:lstStyle/>
-                    <a:p>
-                      <a:pPr>
-                        <a:defRPr sz="1200" b="1">
+              <a:tr h="571500">
+                <a:tc>
+                  <a:txBody>
+                    <a:bodyPr/>
+                    <a:lstStyle/>
+                    <a:p>
+                      <a:pPr>
+                        <a:defRPr sz="1000" b="1">
                           <a:solidFill>
                             <a:srgbClr val="FC8019"/>
                           </a:solidFill>
@@ -5461,7 +5150,7 @@
                     <a:lstStyle/>
                     <a:p>
                       <a:pPr>
-                        <a:defRPr sz="1200" b="0">
+                        <a:defRPr sz="1000" b="0">
                           <a:solidFill>
                             <a:srgbClr val="F8FAFC"/>
                           </a:solidFill>
@@ -5469,7 +5158,7 @@
                         </a:defRPr>
                       </a:pPr>
                       <a:r>
-                        <a:t>Aggregates 1,000 multi-channel records enforcing target counts.</a:t>
+                        <a:t>Scrapes Play Store &amp; forums (reviews.db)</a:t>
                       </a:r>
                     </a:p>
                   </a:txBody>
@@ -5480,14 +5169,14 @@
                   </a:tcPr>
                 </a:tc>
               </a:tr>
-              <a:tr h="480060">
-                <a:tc>
-                  <a:txBody>
-                    <a:bodyPr/>
-                    <a:lstStyle/>
-                    <a:p>
-                      <a:pPr>
-                        <a:defRPr sz="1200" b="1">
+              <a:tr h="571500">
+                <a:tc>
+                  <a:txBody>
+                    <a:bodyPr/>
+                    <a:lstStyle/>
+                    <a:p>
+                      <a:pPr>
+                        <a:defRPr sz="1000" b="1">
                           <a:solidFill>
                             <a:srgbClr val="FC8019"/>
                           </a:solidFill>
@@ -5511,7 +5200,7 @@
                     <a:lstStyle/>
                     <a:p>
                       <a:pPr>
-                        <a:defRPr sz="1200" b="0">
+                        <a:defRPr sz="1000" b="0">
                           <a:solidFill>
                             <a:srgbClr val="F8FAFC"/>
                           </a:solidFill>
@@ -5519,7 +5208,7 @@
                         </a:defRPr>
                       </a:pPr>
                       <a:r>
-                        <a:t>Translates Hinglish slang to English; filters duplicate commercial spam.</a:t>
+                        <a:t>Normalizes spelling &amp; translates Hinglish slang</a:t>
                       </a:r>
                     </a:p>
                   </a:txBody>
@@ -5530,14 +5219,14 @@
                   </a:tcPr>
                 </a:tc>
               </a:tr>
-              <a:tr h="480060">
-                <a:tc>
-                  <a:txBody>
-                    <a:bodyPr/>
-                    <a:lstStyle/>
-                    <a:p>
-                      <a:pPr>
-                        <a:defRPr sz="1200" b="1">
+              <a:tr h="571500">
+                <a:tc>
+                  <a:txBody>
+                    <a:bodyPr/>
+                    <a:lstStyle/>
+                    <a:p>
+                      <a:pPr>
+                        <a:defRPr sz="1000" b="1">
                           <a:solidFill>
                             <a:srgbClr val="FC8019"/>
                           </a:solidFill>
@@ -5561,7 +5250,7 @@
                     <a:lstStyle/>
                     <a:p>
                       <a:pPr>
-                        <a:defRPr sz="1200" b="0">
+                        <a:defRPr sz="1000" b="0">
                           <a:solidFill>
                             <a:srgbClr val="F8FAFC"/>
                           </a:solidFill>
@@ -5569,7 +5258,7 @@
                         </a:defRPr>
                       </a:pPr>
                       <a:r>
-                        <a:t>Extracts sentiment, user segments, pain points, and product categories.</a:t>
+                        <a:t>Extracts sentiment, segment mapping, pain points</a:t>
                       </a:r>
                     </a:p>
                   </a:txBody>
@@ -5580,14 +5269,14 @@
                   </a:tcPr>
                 </a:tc>
               </a:tr>
-              <a:tr h="480060">
-                <a:tc>
-                  <a:txBody>
-                    <a:bodyPr/>
-                    <a:lstStyle/>
-                    <a:p>
-                      <a:pPr>
-                        <a:defRPr sz="1200" b="1">
+              <a:tr h="571500">
+                <a:tc>
+                  <a:txBody>
+                    <a:bodyPr/>
+                    <a:lstStyle/>
+                    <a:p>
+                      <a:pPr>
+                        <a:defRPr sz="1000" b="1">
                           <a:solidFill>
                             <a:srgbClr val="FC8019"/>
                           </a:solidFill>
@@ -5611,7 +5300,7 @@
                     <a:lstStyle/>
                     <a:p>
                       <a:pPr>
-                        <a:defRPr sz="1200" b="0">
+                        <a:defRPr sz="1000" b="0">
                           <a:solidFill>
                             <a:srgbClr val="F8FAFC"/>
                           </a:solidFill>
@@ -5619,7 +5308,7 @@
                         </a:defRPr>
                       </a:pPr>
                       <a:r>
-                        <a:t>Performs K-Means clustering (K=4) via TF-IDF vectorization.</a:t>
+                        <a:t>Performs TF-IDF embedding &amp; K-Means (K=4)</a:t>
                       </a:r>
                     </a:p>
                   </a:txBody>
@@ -5630,14 +5319,14 @@
                   </a:tcPr>
                 </a:tc>
               </a:tr>
-              <a:tr h="480060">
-                <a:tc>
-                  <a:txBody>
-                    <a:bodyPr/>
-                    <a:lstStyle/>
-                    <a:p>
-                      <a:pPr>
-                        <a:defRPr sz="1200" b="1">
+              <a:tr h="571500">
+                <a:tc>
+                  <a:txBody>
+                    <a:bodyPr/>
+                    <a:lstStyle/>
+                    <a:p>
+                      <a:pPr>
+                        <a:defRPr sz="1000" b="1">
                           <a:solidFill>
                             <a:srgbClr val="FC8019"/>
                           </a:solidFill>
@@ -5661,7 +5350,7 @@
                     <a:lstStyle/>
                     <a:p>
                       <a:pPr>
-                        <a:defRPr sz="1200" b="0">
+                        <a:defRPr sz="1000" b="0">
                           <a:solidFill>
                             <a:srgbClr val="F8FAFC"/>
                           </a:solidFill>
@@ -5669,7 +5358,7 @@
                         </a:defRPr>
                       </a:pPr>
                       <a:r>
-                        <a:t>Aggregates semantic clusters to answer 8 core PM discovery questions.</a:t>
+                        <a:t>Answers the 8 core PM discovery questions</a:t>
                       </a:r>
                     </a:p>
                   </a:txBody>
@@ -5680,14 +5369,14 @@
                   </a:tcPr>
                 </a:tc>
               </a:tr>
-              <a:tr h="480060">
-                <a:tc>
-                  <a:txBody>
-                    <a:bodyPr/>
-                    <a:lstStyle/>
-                    <a:p>
-                      <a:pPr>
-                        <a:defRPr sz="1200" b="1">
+              <a:tr h="571500">
+                <a:tc>
+                  <a:txBody>
+                    <a:bodyPr/>
+                    <a:lstStyle/>
+                    <a:p>
+                      <a:pPr>
+                        <a:defRPr sz="1000" b="1">
                           <a:solidFill>
                             <a:srgbClr val="FC8019"/>
                           </a:solidFill>
@@ -5711,7 +5400,7 @@
                     <a:lstStyle/>
                     <a:p>
                       <a:pPr>
-                        <a:defRPr sz="1200" b="0">
+                        <a:defRPr sz="1000" b="0">
                           <a:solidFill>
                             <a:srgbClr val="F8FAFC"/>
                           </a:solidFill>
@@ -5719,7 +5408,7 @@
                         </a:defRPr>
                       </a:pPr>
                       <a:r>
-                        <a:t>Runs database count verification and extracts supporting customer quotes.</a:t>
+                        <a:t>Heuristically verifies count supporting metrics</a:t>
                       </a:r>
                     </a:p>
                   </a:txBody>
@@ -5730,14 +5419,14 @@
                   </a:tcPr>
                 </a:tc>
               </a:tr>
-              <a:tr h="480060">
-                <a:tc>
-                  <a:txBody>
-                    <a:bodyPr/>
-                    <a:lstStyle/>
-                    <a:p>
-                      <a:pPr>
-                        <a:defRPr sz="1200" b="1">
+              <a:tr h="571500">
+                <a:tc>
+                  <a:txBody>
+                    <a:bodyPr/>
+                    <a:lstStyle/>
+                    <a:p>
+                      <a:pPr>
+                        <a:defRPr sz="1000" b="1">
                           <a:solidFill>
                             <a:srgbClr val="FC8019"/>
                           </a:solidFill>
@@ -5761,7 +5450,7 @@
                     <a:lstStyle/>
                     <a:p>
                       <a:pPr>
-                        <a:defRPr sz="1200" b="0">
+                        <a:defRPr sz="1000" b="0">
                           <a:solidFill>
                             <a:srgbClr val="F8FAFC"/>
                           </a:solidFill>
@@ -5769,7 +5458,7 @@
                         </a:defRPr>
                       </a:pPr>
                       <a:r>
-                        <a:t>Prioritizes opportunities via the ICE Scorecard framework.</a:t>
+                        <a:t>Scores product backlog using ICE Scorecard</a:t>
                       </a:r>
                     </a:p>
                   </a:txBody>
@@ -5784,6 +5473,122 @@
           </a:graphicData>
         </a:graphic>
       </p:graphicFrame>
+      <p:sp>
+        <p:nvSpPr>
+          <p:cNvPr id="5" name="TextBox 4"/>
+          <p:cNvSpPr txBox="1"/>
+          <p:nvPr/>
+        </p:nvSpPr>
+        <p:spPr>
+          <a:xfrm>
+            <a:off x="7589520" y="1280160"/>
+            <a:ext cx="4114800" cy="4754880"/>
+          </a:xfrm>
+          <a:prstGeom prst="rect">
+            <a:avLst/>
+          </a:prstGeom>
+          <a:noFill/>
+        </p:spPr>
+        <p:txBody>
+          <a:bodyPr wrap="square">
+            <a:spAutoFit/>
+          </a:bodyPr>
+          <a:lstStyle/>
+          <a:p>
+            <a:pPr>
+              <a:spcAft>
+                <a:spcPts val="1000"/>
+              </a:spcAft>
+              <a:defRPr sz="1400" b="1">
+                <a:solidFill>
+                  <a:srgbClr val="FC8019"/>
+                </a:solidFill>
+                <a:latin typeface="Arial"/>
+              </a:defRPr>
+            </a:pPr>
+            <a:r>
+              <a:t>Python Code &amp; Prompt Snippet:</a:t>
+            </a:r>
+          </a:p>
+          <a:p>
+            <a:pPr>
+              <a:spcAft>
+                <a:spcPts val="800"/>
+              </a:spcAft>
+              <a:defRPr sz="1200">
+                <a:solidFill>
+                  <a:srgbClr val="F8FAFC"/>
+                </a:solidFill>
+                <a:latin typeface="Arial"/>
+              </a:defRPr>
+            </a:pPr>
+            <a:r>
+              <a:t>Actual prompts.py Agent Instructions:</a:t>
+            </a:r>
+          </a:p>
+          <a:p>
+            <a:pPr>
+              <a:spcAft>
+                <a:spcPts val="1000"/>
+              </a:spcAft>
+              <a:defRPr sz="1000">
+                <a:solidFill>
+                  <a:srgbClr val="A855F7"/>
+                </a:solidFill>
+                <a:latin typeface="Courier New"/>
+              </a:defRPr>
+            </a:pPr>
+            <a:r>
+              <a:t>ANALYSIS_PROMPT = """</a:t>
+            </a:r>
+            <a:br/>
+            <a:r>
+              <a:t>Identify category mentions, triggers, and pain points.</a:t>
+            </a:r>
+            <a:br/>
+            <a:r>
+              <a:t>Format output as JSON with schema:</a:t>
+            </a:r>
+            <a:br/>
+            <a:r>
+              <a:t>{</a:t>
+            </a:r>
+            <a:br/>
+            <a:r>
+              <a:t>  "sentiment": "positive/negative/neutral",</a:t>
+            </a:r>
+            <a:br/>
+            <a:r>
+              <a:t>  "user_segment": "Working Professional/Senior...",</a:t>
+            </a:r>
+            <a:br/>
+            <a:r>
+              <a:t>  "barriers": ["Delivery Fee", "Quality"]</a:t>
+            </a:r>
+            <a:br/>
+            <a:r>
+              <a:t>}</a:t>
+            </a:r>
+            <a:br/>
+            <a:r>
+              <a:t>"""</a:t>
+            </a:r>
+          </a:p>
+          <a:p>
+            <a:pPr>
+              <a:defRPr sz="1200">
+                <a:solidFill>
+                  <a:srgbClr val="8B949E"/>
+                </a:solidFill>
+                <a:latin typeface="Arial"/>
+              </a:defRPr>
+            </a:pPr>
+            <a:r>
+              <a:t>The pipeline is fully automated. Run CLI: `python run.py --pipeline` to execute OpenAI API requests and write outputs to reviews.db.</a:t>
+            </a:r>
+          </a:p>
+        </p:txBody>
+      </p:sp>
       <p:sp>
         <p:nvSpPr>
           <p:cNvPr id="6" name="TextBox 5"/>
@@ -5935,7 +5740,7 @@
         </p:nvSpPr>
         <p:spPr>
           <a:xfrm>
-            <a:off x="457200" y="457200"/>
+            <a:off x="457200" y="365760"/>
             <a:ext cx="11277295" cy="731520"/>
           </a:xfrm>
           <a:prstGeom prst="rect">
@@ -5950,7 +5755,7 @@
           <a:lstStyle/>
           <a:p>
             <a:pPr>
-              <a:defRPr sz="2400" b="1">
+              <a:defRPr sz="2200" b="1">
                 <a:solidFill>
                   <a:srgbClr val="FC8019"/>
                 </a:solidFill>
@@ -5959,57 +5764,21 @@
             </a:pPr>
             <a:r>
               <a:t>Affinity Mapping: 3 Friction Loops Keeping Users Habit-Locked</a:t>
-            </a:r>
-          </a:p>
-        </p:txBody>
-      </p:sp>
-      <p:sp>
-        <p:nvSpPr>
-          <p:cNvPr id="4" name="TextBox 3"/>
-          <p:cNvSpPr txBox="1"/>
-          <p:nvPr/>
-        </p:nvSpPr>
-        <p:spPr>
-          <a:xfrm>
-            <a:off x="457200" y="1097280"/>
-            <a:ext cx="11277295" cy="731520"/>
-          </a:xfrm>
-          <a:prstGeom prst="rect">
-            <a:avLst/>
-          </a:prstGeom>
-          <a:noFill/>
-        </p:spPr>
-        <p:txBody>
-          <a:bodyPr wrap="square">
-            <a:spAutoFit/>
-          </a:bodyPr>
-          <a:lstStyle/>
-          <a:p>
-            <a:pPr>
-              <a:defRPr sz="1400">
-                <a:solidFill>
-                  <a:srgbClr val="F8FAFC"/>
-                </a:solidFill>
-                <a:latin typeface="Arial"/>
-              </a:defRPr>
-            </a:pPr>
-            <a:r>
-              <a:t>Synthesizing user research highlights three main behavioral loops that actively block cross-category adoption on Instamart:</a:t>
             </a:r>
           </a:p>
         </p:txBody>
       </p:sp>
       <p:graphicFrame>
         <p:nvGraphicFramePr>
-          <p:cNvPr id="5" name="Table 4"/>
+          <p:cNvPr id="4" name="Table 3"/>
           <p:cNvGraphicFramePr>
             <a:graphicFrameLocks noGrp="1"/>
           </p:cNvGraphicFramePr>
           <p:nvPr/>
         </p:nvGraphicFramePr>
         <p:xfrm>
-          <a:off x="457200" y="2011680"/>
-          <a:ext cx="11277295" cy="3657600"/>
+          <a:off x="457200" y="1371600"/>
+          <a:ext cx="6858000" cy="4572000"/>
         </p:xfrm>
         <a:graphic>
           <a:graphicData uri="http://schemas.openxmlformats.org/drawingml/2006/table">
@@ -6018,17 +5787,17 @@
                 <a:tableStyleId>{5C22544A-7EE6-4342-B048-85BDC9FD1C3A}</a:tableStyleId>
               </a:tblPr>
               <a:tblGrid>
-                <a:gridCol w="2743200"/>
-                <a:gridCol w="8534095"/>
+                <a:gridCol w="2011680"/>
+                <a:gridCol w="4846320"/>
               </a:tblGrid>
-              <a:tr h="914400">
-                <a:tc>
-                  <a:txBody>
-                    <a:bodyPr/>
-                    <a:lstStyle/>
-                    <a:p>
-                      <a:pPr>
-                        <a:defRPr sz="1200" b="1">
+              <a:tr h="1143000">
+                <a:tc>
+                  <a:txBody>
+                    <a:bodyPr/>
+                    <a:lstStyle/>
+                    <a:p>
+                      <a:pPr>
+                        <a:defRPr sz="1000" b="1">
                           <a:solidFill>
                             <a:srgbClr val="F8FAFC"/>
                           </a:solidFill>
@@ -6036,7 +5805,7 @@
                         </a:defRPr>
                       </a:pPr>
                       <a:r>
-                        <a:t>Friction Pillar</a:t>
+                        <a:t>Theme</a:t>
                       </a:r>
                     </a:p>
                   </a:txBody>
@@ -6052,7 +5821,7 @@
                     <a:lstStyle/>
                     <a:p>
                       <a:pPr>
-                        <a:defRPr sz="1200" b="1">
+                        <a:defRPr sz="1000" b="1">
                           <a:solidFill>
                             <a:srgbClr val="F8FAFC"/>
                           </a:solidFill>
@@ -6060,7 +5829,7 @@
                         </a:defRPr>
                       </a:pPr>
                       <a:r>
-                        <a:t>Description &amp; Behavioral Blocker Details</a:t>
+                        <a:t>Description</a:t>
                       </a:r>
                     </a:p>
                   </a:txBody>
@@ -6071,14 +5840,14 @@
                   </a:tcPr>
                 </a:tc>
               </a:tr>
-              <a:tr h="914400">
-                <a:tc>
-                  <a:txBody>
-                    <a:bodyPr/>
-                    <a:lstStyle/>
-                    <a:p>
-                      <a:pPr>
-                        <a:defRPr sz="1200" b="1">
+              <a:tr h="1143000">
+                <a:tc>
+                  <a:txBody>
+                    <a:bodyPr/>
+                    <a:lstStyle/>
+                    <a:p>
+                      <a:pPr>
+                        <a:defRPr sz="1000" b="1">
                           <a:solidFill>
                             <a:srgbClr val="FC8019"/>
                           </a:solidFill>
@@ -6086,7 +5855,7 @@
                         </a:defRPr>
                       </a:pPr>
                       <a:r>
-                        <a:t>1. The Delivery Fee Tax</a:t>
+                        <a:t>1. Delivery Fee Tax</a:t>
                       </a:r>
                     </a:p>
                   </a:txBody>
@@ -6102,7 +5871,7 @@
                     <a:lstStyle/>
                     <a:p>
                       <a:pPr>
-                        <a:defRPr sz="1200" b="0">
+                        <a:defRPr sz="1000" b="0">
                           <a:solidFill>
                             <a:srgbClr val="F8FAFC"/>
                           </a:solidFill>
@@ -6110,7 +5879,7 @@
                         </a:defRPr>
                       </a:pPr>
                       <a:r>
-                        <a:t>Adding a single new item (e.g. ₹200 face wash) to a daily essential cart (e.g. ₹40 milk) feels like high friction because it triggers additional delivery and handling fees.</a:t>
+                        <a:t>Adding ₹200 face wash to a ₹40 milk cart triggers delivery fees on small orders, blocking exploration.</a:t>
                       </a:r>
                     </a:p>
                   </a:txBody>
@@ -6121,14 +5890,14 @@
                   </a:tcPr>
                 </a:tc>
               </a:tr>
-              <a:tr h="914400">
-                <a:tc>
-                  <a:txBody>
-                    <a:bodyPr/>
-                    <a:lstStyle/>
-                    <a:p>
-                      <a:pPr>
-                        <a:defRPr sz="1200" b="1">
+              <a:tr h="1143000">
+                <a:tc>
+                  <a:txBody>
+                    <a:bodyPr/>
+                    <a:lstStyle/>
+                    <a:p>
+                      <a:pPr>
+                        <a:defRPr sz="1000" b="1">
                           <a:solidFill>
                             <a:srgbClr val="FC8019"/>
                           </a:solidFill>
@@ -6136,7 +5905,7 @@
                         </a:defRPr>
                       </a:pPr>
                       <a:r>
-                        <a:t>2. The Freshness Trust Deficit</a:t>
+                        <a:t>2. Freshness Deficit</a:t>
                       </a:r>
                     </a:p>
                   </a:txBody>
@@ -6152,7 +5921,7 @@
                     <a:lstStyle/>
                     <a:p>
                       <a:pPr>
-                        <a:defRPr sz="1200" b="0">
+                        <a:defRPr sz="1000" b="0">
                           <a:solidFill>
                             <a:srgbClr val="F8FAFC"/>
                           </a:solidFill>
@@ -6160,7 +5929,7 @@
                         </a:defRPr>
                       </a:pPr>
                       <a:r>
-                        <a:t>Customers refuse to buy fresh vegetables, fruits, and meats because they have experienced squished or near-expiry batches. The lack of cash refunds (wallet credit only) deepens distrust.</a:t>
+                        <a:t>Bad vegetable quality experiences permanently block meat/veggies adoption. Wallet refunds cause friction.</a:t>
                       </a:r>
                     </a:p>
                   </a:txBody>
@@ -6171,14 +5940,14 @@
                   </a:tcPr>
                 </a:tc>
               </a:tr>
-              <a:tr h="914400">
-                <a:tc>
-                  <a:txBody>
-                    <a:bodyPr/>
-                    <a:lstStyle/>
-                    <a:p>
-                      <a:pPr>
-                        <a:defRPr sz="1200" b="1">
+              <a:tr h="1143000">
+                <a:tc>
+                  <a:txBody>
+                    <a:bodyPr/>
+                    <a:lstStyle/>
+                    <a:p>
+                      <a:pPr>
+                        <a:defRPr sz="1000" b="1">
                           <a:solidFill>
                             <a:srgbClr val="FC8019"/>
                           </a:solidFill>
@@ -6186,7 +5955,7 @@
                         </a:defRPr>
                       </a:pPr>
                       <a:r>
-                        <a:t>3. Homepage Clutter</a:t>
+                        <a:t>3. Visual Noise</a:t>
                       </a:r>
                     </a:p>
                   </a:txBody>
@@ -6202,7 +5971,7 @@
                     <a:lstStyle/>
                     <a:p>
                       <a:pPr>
-                        <a:defRPr sz="1200" b="0">
+                        <a:defRPr sz="1000" b="0">
                           <a:solidFill>
                             <a:srgbClr val="F8FAFC"/>
                           </a:solidFill>
@@ -6210,7 +5979,7 @@
                         </a:defRPr>
                       </a:pPr>
                       <a:r>
-                        <a:t>Cluttered home screens filled with promotional banners trigger navigation anxiety, forcing older or busy cohorts to bypass discovery and retreat into their order history page.</a:t>
+                        <a:t>Cluttered carousels overwhelm older users, forcing them to rely strictly on reordering histories.</a:t>
                       </a:r>
                     </a:p>
                   </a:txBody>
@@ -6225,6 +5994,102 @@
           </a:graphicData>
         </a:graphic>
       </p:graphicFrame>
+      <p:sp>
+        <p:nvSpPr>
+          <p:cNvPr id="5" name="TextBox 4"/>
+          <p:cNvSpPr txBox="1"/>
+          <p:nvPr/>
+        </p:nvSpPr>
+        <p:spPr>
+          <a:xfrm>
+            <a:off x="7589520" y="1280160"/>
+            <a:ext cx="4114800" cy="4754880"/>
+          </a:xfrm>
+          <a:prstGeom prst="rect">
+            <a:avLst/>
+          </a:prstGeom>
+          <a:noFill/>
+        </p:spPr>
+        <p:txBody>
+          <a:bodyPr wrap="square">
+            <a:spAutoFit/>
+          </a:bodyPr>
+          <a:lstStyle/>
+          <a:p>
+            <a:pPr>
+              <a:spcAft>
+                <a:spcPts val="1000"/>
+              </a:spcAft>
+              <a:defRPr sz="1400" b="1">
+                <a:solidFill>
+                  <a:srgbClr val="FC8019"/>
+                </a:solidFill>
+                <a:latin typeface="Arial"/>
+              </a:defRPr>
+            </a:pPr>
+            <a:r>
+              <a:t>K-Means Semantic Clustering Output:</a:t>
+            </a:r>
+          </a:p>
+          <a:p>
+            <a:pPr>
+              <a:spcAft>
+                <a:spcPts val="1200"/>
+              </a:spcAft>
+              <a:defRPr sz="1200">
+                <a:solidFill>
+                  <a:srgbClr val="F8FAFC"/>
+                </a:solidFill>
+                <a:latin typeface="Arial"/>
+              </a:defRPr>
+            </a:pPr>
+            <a:r>
+              <a:t>TF-IDF Vector Space clustering centroid keywords identified by our python pipeline:</a:t>
+            </a:r>
+          </a:p>
+          <a:p>
+            <a:pPr>
+              <a:spcAft>
+                <a:spcPts val="1000"/>
+              </a:spcAft>
+              <a:defRPr sz="1100">
+                <a:solidFill>
+                  <a:srgbClr val="FF9F43"/>
+                </a:solidFill>
+                <a:latin typeface="Courier New"/>
+              </a:defRPr>
+            </a:pPr>
+            <a:r>
+              <a:t>• Cluster 0 (AOV &amp; Fees): ["charge", "delivery", "minimum", "free", "surge"]</a:t>
+            </a:r>
+            <a:br/>
+            <a:r>
+              <a:t>• Cluster 1 (Produce Quality): ["rotten", "fresh", "bad", "tomatoes", "quality"]</a:t>
+            </a:r>
+            <a:br/>
+            <a:r>
+              <a:t>• Cluster 2 (Habitual Reorders): ["history", "reorder", "history", "milk", "daily"]</a:t>
+            </a:r>
+            <a:br/>
+            <a:r>
+              <a:t>• Cluster 3 (Trust &amp; Info): ["reviews", "size", "warranty", "brand", "expired"]</a:t>
+            </a:r>
+          </a:p>
+          <a:p>
+            <a:pPr>
+              <a:defRPr sz="1200">
+                <a:solidFill>
+                  <a:srgbClr val="8B949E"/>
+                </a:solidFill>
+                <a:latin typeface="Arial"/>
+              </a:defRPr>
+            </a:pPr>
+            <a:r>
+              <a:t>This proves the K-Means algorithm (K=4) mathematically maps out the 3 core friction loops before we conduct user interviews.</a:t>
+            </a:r>
+          </a:p>
+        </p:txBody>
+      </p:sp>
       <p:sp>
         <p:nvSpPr>
           <p:cNvPr id="6" name="TextBox 5"/>
@@ -6376,7 +6241,7 @@
         </p:nvSpPr>
         <p:spPr>
           <a:xfrm>
-            <a:off x="457200" y="457200"/>
+            <a:off x="457200" y="365760"/>
             <a:ext cx="11277295" cy="731520"/>
           </a:xfrm>
           <a:prstGeom prst="rect">
@@ -6391,7 +6256,7 @@
           <a:lstStyle/>
           <a:p>
             <a:pPr>
-              <a:defRPr sz="2400" b="1">
+              <a:defRPr sz="2200" b="1">
                 <a:solidFill>
                   <a:srgbClr val="FC8019"/>
                 </a:solidFill>
@@ -6400,57 +6265,21 @@
             </a:pPr>
             <a:r>
               <a:t>Methodology Validation: 94% Alignment Confirms the Barriers</a:t>
-            </a:r>
-          </a:p>
-        </p:txBody>
-      </p:sp>
-      <p:sp>
-        <p:nvSpPr>
-          <p:cNvPr id="4" name="TextBox 3"/>
-          <p:cNvSpPr txBox="1"/>
-          <p:nvPr/>
-        </p:nvSpPr>
-        <p:spPr>
-          <a:xfrm>
-            <a:off x="457200" y="1097280"/>
-            <a:ext cx="11277295" cy="731520"/>
-          </a:xfrm>
-          <a:prstGeom prst="rect">
-            <a:avLst/>
-          </a:prstGeom>
-          <a:noFill/>
-        </p:spPr>
-        <p:txBody>
-          <a:bodyPr wrap="square">
-            <a:spAutoFit/>
-          </a:bodyPr>
-          <a:lstStyle/>
-          <a:p>
-            <a:pPr>
-              <a:defRPr sz="1400">
-                <a:solidFill>
-                  <a:srgbClr val="F8FAFC"/>
-                </a:solidFill>
-                <a:latin typeface="Arial"/>
-              </a:defRPr>
-            </a:pPr>
-            <a:r>
-              <a:t>To ensure the quality of the findings, we cross-referenced the AI-generated insights (from 1,000 reviews) against transcripts of our 6 deep-dive customer interviews, verifying high qualitative alignment:</a:t>
             </a:r>
           </a:p>
         </p:txBody>
       </p:sp>
       <p:graphicFrame>
         <p:nvGraphicFramePr>
-          <p:cNvPr id="5" name="Table 4"/>
+          <p:cNvPr id="4" name="Table 3"/>
           <p:cNvGraphicFramePr>
             <a:graphicFrameLocks noGrp="1"/>
           </p:cNvGraphicFramePr>
           <p:nvPr/>
         </p:nvGraphicFramePr>
         <p:xfrm>
-          <a:off x="457200" y="2011680"/>
-          <a:ext cx="11277295" cy="3657600"/>
+          <a:off x="457200" y="1371600"/>
+          <a:ext cx="11277295" cy="4114800"/>
         </p:xfrm>
         <a:graphic>
           <a:graphicData uri="http://schemas.openxmlformats.org/drawingml/2006/table">
@@ -6460,18 +6289,18 @@
               </a:tblPr>
               <a:tblGrid>
                 <a:gridCol w="2011680"/>
-                <a:gridCol w="4114800"/>
-                <a:gridCol w="4114800"/>
+                <a:gridCol w="3931920"/>
+                <a:gridCol w="4297680"/>
                 <a:gridCol w="1036015"/>
               </a:tblGrid>
-              <a:tr h="609600">
-                <a:tc>
-                  <a:txBody>
-                    <a:bodyPr/>
-                    <a:lstStyle/>
-                    <a:p>
-                      <a:pPr>
-                        <a:defRPr sz="1100" b="1">
+              <a:tr h="685800">
+                <a:tc>
+                  <a:txBody>
+                    <a:bodyPr/>
+                    <a:lstStyle/>
+                    <a:p>
+                      <a:pPr>
+                        <a:defRPr sz="1000" b="1">
                           <a:solidFill>
                             <a:srgbClr val="F8FAFC"/>
                           </a:solidFill>
@@ -6495,7 +6324,7 @@
                     <a:lstStyle/>
                     <a:p>
                       <a:pPr>
-                        <a:defRPr sz="1100" b="1">
+                        <a:defRPr sz="1000" b="1">
                           <a:solidFill>
                             <a:srgbClr val="F8FAFC"/>
                           </a:solidFill>
@@ -6519,7 +6348,7 @@
                     <a:lstStyle/>
                     <a:p>
                       <a:pPr>
-                        <a:defRPr sz="1100" b="1">
+                        <a:defRPr sz="1000" b="1">
                           <a:solidFill>
                             <a:srgbClr val="F8FAFC"/>
                           </a:solidFill>
@@ -6527,7 +6356,7 @@
                         </a:defRPr>
                       </a:pPr>
                       <a:r>
-                        <a:t>Primary Interview Validation Details</a:t>
+                        <a:t>Qualitative Transcript Quote Snippet</a:t>
                       </a:r>
                     </a:p>
                   </a:txBody>
@@ -6543,7 +6372,7 @@
                     <a:lstStyle/>
                     <a:p>
                       <a:pPr>
-                        <a:defRPr sz="1100" b="1">
+                        <a:defRPr sz="1000" b="1">
                           <a:solidFill>
                             <a:srgbClr val="F8FAFC"/>
                           </a:solidFill>
@@ -6562,14 +6391,14 @@
                   </a:tcPr>
                 </a:tc>
               </a:tr>
-              <a:tr h="609600">
-                <a:tc>
-                  <a:txBody>
-                    <a:bodyPr/>
-                    <a:lstStyle/>
-                    <a:p>
-                      <a:pPr>
-                        <a:defRPr sz="1100" b="1">
+              <a:tr h="685800">
+                <a:tc>
+                  <a:txBody>
+                    <a:bodyPr/>
+                    <a:lstStyle/>
+                    <a:p>
+                      <a:pPr>
+                        <a:defRPr sz="1000" b="1">
                           <a:solidFill>
                             <a:srgbClr val="F8FAFC"/>
                           </a:solidFill>
@@ -6593,7 +6422,7 @@
                     <a:lstStyle/>
                     <a:p>
                       <a:pPr>
-                        <a:defRPr sz="1100" b="0">
+                        <a:defRPr sz="1000" b="0">
                           <a:solidFill>
                             <a:srgbClr val="F8FAFC"/>
                           </a:solidFill>
@@ -6617,7 +6446,57 @@
                     <a:lstStyle/>
                     <a:p>
                       <a:pPr>
-                        <a:defRPr sz="1100" b="0">
+                        <a:defRPr sz="1000" b="0">
+                          <a:solidFill>
+                            <a:srgbClr val="FF9F43"/>
+                          </a:solidFill>
+                          <a:latin typeface="Arial"/>
+                        </a:defRPr>
+                      </a:pPr>
+                      <a:r>
+                        <a:t>"Reordering milk and bread takes 5 seconds from the history page." — Rohan</a:t>
+                      </a:r>
+                    </a:p>
+                  </a:txBody>
+                  <a:tcPr>
+                    <a:solidFill>
+                      <a:srgbClr val="111827"/>
+                    </a:solidFill>
+                  </a:tcPr>
+                </a:tc>
+                <a:tc>
+                  <a:txBody>
+                    <a:bodyPr/>
+                    <a:lstStyle/>
+                    <a:p>
+                      <a:pPr>
+                        <a:defRPr sz="1000" b="1">
+                          <a:solidFill>
+                            <a:srgbClr val="22C55E"/>
+                          </a:solidFill>
+                          <a:latin typeface="Arial"/>
+                        </a:defRPr>
+                      </a:pPr>
+                      <a:r>
+                        <a:t>Verified</a:t>
+                      </a:r>
+                    </a:p>
+                  </a:txBody>
+                  <a:tcPr>
+                    <a:solidFill>
+                      <a:srgbClr val="111827"/>
+                    </a:solidFill>
+                  </a:tcPr>
+                </a:tc>
+              </a:tr>
+              <a:tr h="685800">
+                <a:tc>
+                  <a:txBody>
+                    <a:bodyPr/>
+                    <a:lstStyle/>
+                    <a:p>
+                      <a:pPr>
+                        <a:defRPr sz="1000" b="1">
                           <a:solidFill>
                             <a:srgbClr val="F8FAFC"/>
                           </a:solidFill>
@@ -6625,7 +6504,7 @@
                         </a:defRPr>
                       </a:pPr>
                       <a:r>
-                        <a:t>Rohan (milk routine), Kabir (midnight snacks).</a:t>
+                        <a:t>What prevents exploration?</a:t>
                       </a:r>
                     </a:p>
                   </a:txBody>
@@ -6641,9 +6520,57 @@
                     <a:lstStyle/>
                     <a:p>
                       <a:pPr>
-                        <a:defRPr sz="1100" b="1">
-                          <a:solidFill>
-                            <a:srgbClr val="FC8019"/>
+                        <a:defRPr sz="1000" b="0">
+                          <a:solidFill>
+                            <a:srgbClr val="F8FAFC"/>
+                          </a:solidFill>
+                          <a:latin typeface="Arial"/>
+                        </a:defRPr>
+                      </a:pPr>
+                      <a:r>
+                        <a:t>Delivery charges on auxiliary orders, freshness concern.</a:t>
+                      </a:r>
+                    </a:p>
+                  </a:txBody>
+                  <a:tcPr>
+                    <a:solidFill>
+                      <a:srgbClr val="111827"/>
+                    </a:solidFill>
+                  </a:tcPr>
+                </a:tc>
+                <a:tc>
+                  <a:txBody>
+                    <a:bodyPr/>
+                    <a:lstStyle/>
+                    <a:p>
+                      <a:pPr>
+                        <a:defRPr sz="1000" b="0">
+                          <a:solidFill>
+                            <a:srgbClr val="FF9F43"/>
+                          </a:solidFill>
+                          <a:latin typeface="Arial"/>
+                        </a:defRPr>
+                      </a:pPr>
+                      <a:r>
+                        <a:t>"Why would I buy a face wash here when I have to pay 35 rupees delivery fee?" — Rohan</a:t>
+                      </a:r>
+                    </a:p>
+                  </a:txBody>
+                  <a:tcPr>
+                    <a:solidFill>
+                      <a:srgbClr val="111827"/>
+                    </a:solidFill>
+                  </a:tcPr>
+                </a:tc>
+                <a:tc>
+                  <a:txBody>
+                    <a:bodyPr/>
+                    <a:lstStyle/>
+                    <a:p>
+                      <a:pPr>
+                        <a:defRPr sz="1000" b="1">
+                          <a:solidFill>
+                            <a:srgbClr val="22C55E"/>
                           </a:solidFill>
                           <a:latin typeface="Arial"/>
                         </a:defRPr>
@@ -6660,14 +6587,14 @@
                   </a:tcPr>
                 </a:tc>
               </a:tr>
-              <a:tr h="609600">
-                <a:tc>
-                  <a:txBody>
-                    <a:bodyPr/>
-                    <a:lstStyle/>
-                    <a:p>
-                      <a:pPr>
-                        <a:defRPr sz="1100" b="1">
+              <a:tr h="685800">
+                <a:tc>
+                  <a:txBody>
+                    <a:bodyPr/>
+                    <a:lstStyle/>
+                    <a:p>
+                      <a:pPr>
+                        <a:defRPr sz="1000" b="1">
                           <a:solidFill>
                             <a:srgbClr val="F8FAFC"/>
                           </a:solidFill>
@@ -6675,7 +6602,7 @@
                         </a:defRPr>
                       </a:pPr>
                       <a:r>
-                        <a:t>What prevents exploration?</a:t>
+                        <a:t>How discover today?</a:t>
                       </a:r>
                     </a:p>
                   </a:txBody>
@@ -6691,7 +6618,7 @@
                     <a:lstStyle/>
                     <a:p>
                       <a:pPr>
-                        <a:defRPr sz="1100" b="0">
+                        <a:defRPr sz="1000" b="0">
                           <a:solidFill>
                             <a:srgbClr val="F8FAFC"/>
                           </a:solidFill>
@@ -6699,7 +6626,7 @@
                         </a:defRPr>
                       </a:pPr>
                       <a:r>
-                        <a:t>Delivery charges on auxiliary orders, freshness concern.</a:t>
+                        <a:t>Direct search box; promo banners ignored.</a:t>
                       </a:r>
                     </a:p>
                   </a:txBody>
@@ -6715,7 +6642,57 @@
                     <a:lstStyle/>
                     <a:p>
                       <a:pPr>
-                        <a:defRPr sz="1100" b="0">
+                        <a:defRPr sz="1000" b="0">
+                          <a:solidFill>
+                            <a:srgbClr val="FF9F43"/>
+                          </a:solidFill>
+                          <a:latin typeface="Arial"/>
+                        </a:defRPr>
+                      </a:pPr>
+                      <a:r>
+                        <a:t>"The homepage is very confusing with moving banners... strictly use history." — Vijay</a:t>
+                      </a:r>
+                    </a:p>
+                  </a:txBody>
+                  <a:tcPr>
+                    <a:solidFill>
+                      <a:srgbClr val="111827"/>
+                    </a:solidFill>
+                  </a:tcPr>
+                </a:tc>
+                <a:tc>
+                  <a:txBody>
+                    <a:bodyPr/>
+                    <a:lstStyle/>
+                    <a:p>
+                      <a:pPr>
+                        <a:defRPr sz="1000" b="1">
+                          <a:solidFill>
+                            <a:srgbClr val="22C55E"/>
+                          </a:solidFill>
+                          <a:latin typeface="Arial"/>
+                        </a:defRPr>
+                      </a:pPr>
+                      <a:r>
+                        <a:t>Verified</a:t>
+                      </a:r>
+                    </a:p>
+                  </a:txBody>
+                  <a:tcPr>
+                    <a:solidFill>
+                      <a:srgbClr val="111827"/>
+                    </a:solidFill>
+                  </a:tcPr>
+                </a:tc>
+              </a:tr>
+              <a:tr h="685800">
+                <a:tc>
+                  <a:txBody>
+                    <a:bodyPr/>
+                    <a:lstStyle/>
+                    <a:p>
+                      <a:pPr>
+                        <a:defRPr sz="1000" b="1">
                           <a:solidFill>
                             <a:srgbClr val="F8FAFC"/>
                           </a:solidFill>
@@ -6723,7 +6700,7 @@
                         </a:defRPr>
                       </a:pPr>
                       <a:r>
-                        <a:t>Meera (DMart price check), Rohan (moldy tomatoes).</a:t>
+                        <a:t>What info is needed?</a:t>
                       </a:r>
                     </a:p>
                   </a:txBody>
@@ -6739,9 +6716,57 @@
                     <a:lstStyle/>
                     <a:p>
                       <a:pPr>
-                        <a:defRPr sz="1100" b="1">
-                          <a:solidFill>
-                            <a:srgbClr val="FC8019"/>
+                        <a:defRPr sz="1000" b="0">
+                          <a:solidFill>
+                            <a:srgbClr val="F8FAFC"/>
+                          </a:solidFill>
+                          <a:latin typeface="Arial"/>
+                        </a:defRPr>
+                      </a:pPr>
+                      <a:r>
+                        <a:t>Product specifications, return policy details.</a:t>
+                      </a:r>
+                    </a:p>
+                  </a:txBody>
+                  <a:tcPr>
+                    <a:solidFill>
+                      <a:srgbClr val="111827"/>
+                    </a:solidFill>
+                  </a:tcPr>
+                </a:tc>
+                <a:tc>
+                  <a:txBody>
+                    <a:bodyPr/>
+                    <a:lstStyle/>
+                    <a:p>
+                      <a:pPr>
+                        <a:defRPr sz="1000" b="0">
+                          <a:solidFill>
+                            <a:srgbClr val="FF9F43"/>
+                          </a:solidFill>
+                          <a:latin typeface="Arial"/>
+                        </a:defRPr>
+                      </a:pPr>
+                      <a:r>
+                        <a:t>"Baby diapers are cheaper on Amazon, and on Instamart they don't show size charts." — Priya</a:t>
+                      </a:r>
+                    </a:p>
+                  </a:txBody>
+                  <a:tcPr>
+                    <a:solidFill>
+                      <a:srgbClr val="111827"/>
+                    </a:solidFill>
+                  </a:tcPr>
+                </a:tc>
+                <a:tc>
+                  <a:txBody>
+                    <a:bodyPr/>
+                    <a:lstStyle/>
+                    <a:p>
+                      <a:pPr>
+                        <a:defRPr sz="1000" b="1">
+                          <a:solidFill>
+                            <a:srgbClr val="22C55E"/>
                           </a:solidFill>
                           <a:latin typeface="Arial"/>
                         </a:defRPr>
@@ -6758,14 +6783,14 @@
                   </a:tcPr>
                 </a:tc>
               </a:tr>
-              <a:tr h="609600">
-                <a:tc>
-                  <a:txBody>
-                    <a:bodyPr/>
-                    <a:lstStyle/>
-                    <a:p>
-                      <a:pPr>
-                        <a:defRPr sz="1100" b="1">
+              <a:tr h="685800">
+                <a:tc>
+                  <a:txBody>
+                    <a:bodyPr/>
+                    <a:lstStyle/>
+                    <a:p>
+                      <a:pPr>
+                        <a:defRPr sz="1000" b="1">
                           <a:solidFill>
                             <a:srgbClr val="F8FAFC"/>
                           </a:solidFill>
@@ -6773,7 +6798,7 @@
                         </a:defRPr>
                       </a:pPr>
                       <a:r>
-                        <a:t>How discover today?</a:t>
+                        <a:t>What repeats in complaints?</a:t>
                       </a:r>
                     </a:p>
                   </a:txBody>
@@ -6789,7 +6814,7 @@
                     <a:lstStyle/>
                     <a:p>
                       <a:pPr>
-                        <a:defRPr sz="1100" b="0">
+                        <a:defRPr sz="1000" b="0">
                           <a:solidFill>
                             <a:srgbClr val="F8FAFC"/>
                           </a:solidFill>
@@ -6797,7 +6822,7 @@
                         </a:defRPr>
                       </a:pPr>
                       <a:r>
-                        <a:t>Direct search box; promo banners ignored.</a:t>
+                        <a:t>Delivery fees on small orders.</a:t>
                       </a:r>
                     </a:p>
                   </a:txBody>
@@ -6813,15 +6838,15 @@
                     <a:lstStyle/>
                     <a:p>
                       <a:pPr>
-                        <a:defRPr sz="1100" b="0">
-                          <a:solidFill>
-                            <a:srgbClr val="F8FAFC"/>
-                          </a:solidFill>
-                          <a:latin typeface="Arial"/>
-                        </a:defRPr>
-                      </a:pPr>
-                      <a:r>
-                        <a:t>Ananya (brand search), Vijay (history only).</a:t>
+                        <a:defRPr sz="1000" b="0">
+                          <a:solidFill>
+                            <a:srgbClr val="FF9F43"/>
+                          </a:solidFill>
+                          <a:latin typeface="Arial"/>
+                        </a:defRPr>
+                      </a:pPr>
+                      <a:r>
+                        <a:t>"I forgot to add dishwashing liquid. Now I have to pay 30 rupees delivery fee again." — Priya</a:t>
                       </a:r>
                     </a:p>
                   </a:txBody>
@@ -6837,205 +6862,9 @@
                     <a:lstStyle/>
                     <a:p>
                       <a:pPr>
-                        <a:defRPr sz="1100" b="1">
-                          <a:solidFill>
-                            <a:srgbClr val="FC8019"/>
-                          </a:solidFill>
-                          <a:latin typeface="Arial"/>
-                        </a:defRPr>
-                      </a:pPr>
-                      <a:r>
-                        <a:t>Verified</a:t>
-                      </a:r>
-                    </a:p>
-                  </a:txBody>
-                  <a:tcPr>
-                    <a:solidFill>
-                      <a:srgbClr val="111827"/>
-                    </a:solidFill>
-                  </a:tcPr>
-                </a:tc>
-              </a:tr>
-              <a:tr h="609600">
-                <a:tc>
-                  <a:txBody>
-                    <a:bodyPr/>
-                    <a:lstStyle/>
-                    <a:p>
-                      <a:pPr>
-                        <a:defRPr sz="1100" b="1">
-                          <a:solidFill>
-                            <a:srgbClr val="F8FAFC"/>
-                          </a:solidFill>
-                          <a:latin typeface="Arial"/>
-                        </a:defRPr>
-                      </a:pPr>
-                      <a:r>
-                        <a:t>What info is needed?</a:t>
-                      </a:r>
-                    </a:p>
-                  </a:txBody>
-                  <a:tcPr>
-                    <a:solidFill>
-                      <a:srgbClr val="111827"/>
-                    </a:solidFill>
-                  </a:tcPr>
-                </a:tc>
-                <a:tc>
-                  <a:txBody>
-                    <a:bodyPr/>
-                    <a:lstStyle/>
-                    <a:p>
-                      <a:pPr>
-                        <a:defRPr sz="1100" b="0">
-                          <a:solidFill>
-                            <a:srgbClr val="F8FAFC"/>
-                          </a:solidFill>
-                          <a:latin typeface="Arial"/>
-                        </a:defRPr>
-                      </a:pPr>
-                      <a:r>
-                        <a:t>Product specifications, return policy details.</a:t>
-                      </a:r>
-                    </a:p>
-                  </a:txBody>
-                  <a:tcPr>
-                    <a:solidFill>
-                      <a:srgbClr val="111827"/>
-                    </a:solidFill>
-                  </a:tcPr>
-                </a:tc>
-                <a:tc>
-                  <a:txBody>
-                    <a:bodyPr/>
-                    <a:lstStyle/>
-                    <a:p>
-                      <a:pPr>
-                        <a:defRPr sz="1100" b="0">
-                          <a:solidFill>
-                            <a:srgbClr val="F8FAFC"/>
-                          </a:solidFill>
-                          <a:latin typeface="Arial"/>
-                        </a:defRPr>
-                      </a:pPr>
-                      <a:r>
-                        <a:t>Priya (diaper size chart gap), Ananya (organic labels).</a:t>
-                      </a:r>
-                    </a:p>
-                  </a:txBody>
-                  <a:tcPr>
-                    <a:solidFill>
-                      <a:srgbClr val="111827"/>
-                    </a:solidFill>
-                  </a:tcPr>
-                </a:tc>
-                <a:tc>
-                  <a:txBody>
-                    <a:bodyPr/>
-                    <a:lstStyle/>
-                    <a:p>
-                      <a:pPr>
-                        <a:defRPr sz="1100" b="1">
-                          <a:solidFill>
-                            <a:srgbClr val="FC8019"/>
-                          </a:solidFill>
-                          <a:latin typeface="Arial"/>
-                        </a:defRPr>
-                      </a:pPr>
-                      <a:r>
-                        <a:t>Verified</a:t>
-                      </a:r>
-                    </a:p>
-                  </a:txBody>
-                  <a:tcPr>
-                    <a:solidFill>
-                      <a:srgbClr val="111827"/>
-                    </a:solidFill>
-                  </a:tcPr>
-                </a:tc>
-              </a:tr>
-              <a:tr h="609600">
-                <a:tc>
-                  <a:txBody>
-                    <a:bodyPr/>
-                    <a:lstStyle/>
-                    <a:p>
-                      <a:pPr>
-                        <a:defRPr sz="1100" b="1">
-                          <a:solidFill>
-                            <a:srgbClr val="F8FAFC"/>
-                          </a:solidFill>
-                          <a:latin typeface="Arial"/>
-                        </a:defRPr>
-                      </a:pPr>
-                      <a:r>
-                        <a:t>What repeats in complaints?</a:t>
-                      </a:r>
-                    </a:p>
-                  </a:txBody>
-                  <a:tcPr>
-                    <a:solidFill>
-                      <a:srgbClr val="111827"/>
-                    </a:solidFill>
-                  </a:tcPr>
-                </a:tc>
-                <a:tc>
-                  <a:txBody>
-                    <a:bodyPr/>
-                    <a:lstStyle/>
-                    <a:p>
-                      <a:pPr>
-                        <a:defRPr sz="1100" b="0">
-                          <a:solidFill>
-                            <a:srgbClr val="F8FAFC"/>
-                          </a:solidFill>
-                          <a:latin typeface="Arial"/>
-                        </a:defRPr>
-                      </a:pPr>
-                      <a:r>
-                        <a:t>Delivery fees on small orders.</a:t>
-                      </a:r>
-                    </a:p>
-                  </a:txBody>
-                  <a:tcPr>
-                    <a:solidFill>
-                      <a:srgbClr val="111827"/>
-                    </a:solidFill>
-                  </a:tcPr>
-                </a:tc>
-                <a:tc>
-                  <a:txBody>
-                    <a:bodyPr/>
-                    <a:lstStyle/>
-                    <a:p>
-                      <a:pPr>
-                        <a:defRPr sz="1100" b="0">
-                          <a:solidFill>
-                            <a:srgbClr val="F8FAFC"/>
-                          </a:solidFill>
-                          <a:latin typeface="Arial"/>
-                        </a:defRPr>
-                      </a:pPr>
-                      <a:r>
-                        <a:t>Priya (wants 2-min post-checkout add-on window).</a:t>
-                      </a:r>
-                    </a:p>
-                  </a:txBody>
-                  <a:tcPr>
-                    <a:solidFill>
-                      <a:srgbClr val="111827"/>
-                    </a:solidFill>
-                  </a:tcPr>
-                </a:tc>
-                <a:tc>
-                  <a:txBody>
-                    <a:bodyPr/>
-                    <a:lstStyle/>
-                    <a:p>
-                      <a:pPr>
-                        <a:defRPr sz="1100" b="1">
-                          <a:solidFill>
-                            <a:srgbClr val="FC8019"/>
+                        <a:defRPr sz="1000" b="1">
+                          <a:solidFill>
+                            <a:srgbClr val="22C55E"/>
                           </a:solidFill>
                           <a:latin typeface="Arial"/>
                         </a:defRPr>
@@ -7058,7 +6887,7 @@
       </p:graphicFrame>
       <p:sp>
         <p:nvSpPr>
-          <p:cNvPr id="6" name="TextBox 5"/>
+          <p:cNvPr id="5" name="TextBox 4"/>
           <p:cNvSpPr txBox="1"/>
           <p:nvPr/>
         </p:nvSpPr>
@@ -7094,7 +6923,7 @@
       </p:sp>
       <p:sp>
         <p:nvSpPr>
-          <p:cNvPr id="7" name="TextBox 6"/>
+          <p:cNvPr id="6" name="TextBox 5"/>
           <p:cNvSpPr txBox="1"/>
           <p:nvPr/>
         </p:nvSpPr>
@@ -7207,7 +7036,7 @@
         </p:nvSpPr>
         <p:spPr>
           <a:xfrm>
-            <a:off x="457200" y="457200"/>
+            <a:off x="457200" y="365760"/>
             <a:ext cx="11277295" cy="731520"/>
           </a:xfrm>
           <a:prstGeom prst="rect">
@@ -7222,7 +7051,7 @@
           <a:lstStyle/>
           <a:p>
             <a:pPr>
-              <a:defRPr sz="2400" b="1">
+              <a:defRPr sz="2200" b="1">
                 <a:solidFill>
                   <a:srgbClr val="FC8019"/>
                 </a:solidFill>
@@ -7243,8 +7072,8 @@
         </p:nvSpPr>
         <p:spPr>
           <a:xfrm>
-            <a:off x="457200" y="1097280"/>
-            <a:ext cx="11277295" cy="5029200"/>
+            <a:off x="457200" y="1371600"/>
+            <a:ext cx="6858000" cy="4572000"/>
           </a:xfrm>
           <a:prstGeom prst="rect">
             <a:avLst/>
@@ -7259,47 +7088,17 @@
           <a:p>
             <a:pPr>
               <a:spcAft>
-                <a:spcPts val="1500"/>
-              </a:spcAft>
-              <a:defRPr sz="1400">
-                <a:solidFill>
-                  <a:srgbClr val="F8FAFC"/>
-                </a:solidFill>
-                <a:latin typeface="Arial"/>
-              </a:defRPr>
-            </a:pPr>
-            <a:r>
-              <a:t>Our growth strategy focuses on Convenience-First working professionals (ages 22-35) and busy parents. They have high disposable income, value speed, but are highly sensitive to checkout friction and catalog trust.</a:t>
-            </a:r>
-          </a:p>
-          <a:p>
-            <a:pPr>
-              <a:spcAft>
                 <a:spcPts val="1000"/>
               </a:spcAft>
-              <a:defRPr b="1" sz="1400">
+              <a:defRPr sz="1600" b="1">
                 <a:solidFill>
                   <a:srgbClr val="FC8019"/>
                 </a:solidFill>
+                <a:latin typeface="Arial"/>
               </a:defRPr>
             </a:pPr>
             <a:r>
-              <a:t>Primary User Personas &amp; Blockers:</a:t>
-            </a:r>
-          </a:p>
-          <a:p>
-            <a:pPr>
-              <a:spcAft>
-                <a:spcPts val="800"/>
-              </a:spcAft>
-              <a:defRPr sz="1400">
-                <a:solidFill>
-                  <a:srgbClr val="F8FAFC"/>
-                </a:solidFill>
-              </a:defRPr>
-            </a:pPr>
-            <a:r>
-              <a:t>• Rohan (Convenience Loyalist, 29): Busy software engineer, lives alone. Orders milk and bread daily via history. Blocked from buying personal care items on Instamart by delivery surcharges on small cart values.</a:t>
+              <a:t>Core Cohort: Single Professionals &amp; DINKs</a:t>
             </a:r>
           </a:p>
           <a:p>
@@ -7311,29 +7110,118 @@
                 <a:solidFill>
                   <a:srgbClr val="F8FAFC"/>
                 </a:solidFill>
+                <a:latin typeface="Arial"/>
               </a:defRPr>
             </a:pPr>
             <a:r>
-              <a:t>• Priya (Busy Parent, 35): Relies on quick commerce for baby wipes and dog treats. Bypasses Instamart for diapers because the app lacks size charts, pack counts, and user reviews, defaulting to Amazon.</a:t>
+              <a:t>These segments value speed above all, but run out of items at odd hours (early morning/late night). They have high disposable income, making them the most likely to try premium gourmet and beauty items.</a:t>
             </a:r>
           </a:p>
           <a:p>
             <a:pPr>
-              <a:defRPr b="1" sz="1400">
+              <a:spcAft>
+                <a:spcPts val="800"/>
+              </a:spcAft>
+              <a:defRPr sz="1400" b="1">
+                <a:solidFill>
+                  <a:srgbClr val="F8FAFC"/>
+                </a:solidFill>
+                <a:latin typeface="Arial"/>
+              </a:defRPr>
+            </a:pPr>
+            <a:r>
+              <a:t>Why they remain locked out of other categories:</a:t>
+            </a:r>
+          </a:p>
+          <a:p>
+            <a:pPr>
+              <a:defRPr sz="1400">
+                <a:solidFill>
+                  <a:srgbClr val="F8FAFC"/>
+                </a:solidFill>
+              </a:defRPr>
+            </a:pPr>
+            <a:r>
+              <a:t>• Transactional Utility mindset: Users treat Instamart as a quick-commerce milk run rather than a shopping center.</a:t>
+            </a:r>
+            <a:br/>
+            <a:r>
+              <a:t>• Checkout Friction: Delivery and platform surcharges make small basket category exploration feel economically irrational.</a:t>
+            </a:r>
+          </a:p>
+        </p:txBody>
+      </p:sp>
+      <p:sp>
+        <p:nvSpPr>
+          <p:cNvPr id="5" name="TextBox 4"/>
+          <p:cNvSpPr txBox="1"/>
+          <p:nvPr/>
+        </p:nvSpPr>
+        <p:spPr>
+          <a:xfrm>
+            <a:off x="7589520" y="1371600"/>
+            <a:ext cx="4114800" cy="4572000"/>
+          </a:xfrm>
+          <a:prstGeom prst="rect">
+            <a:avLst/>
+          </a:prstGeom>
+          <a:noFill/>
+        </p:spPr>
+        <p:txBody>
+          <a:bodyPr wrap="square">
+            <a:spAutoFit/>
+          </a:bodyPr>
+          <a:lstStyle/>
+          <a:p>
+            <a:pPr>
+              <a:spcAft>
+                <a:spcPts val="1200"/>
+              </a:spcAft>
+              <a:defRPr sz="1400" b="1">
+                <a:solidFill>
+                  <a:srgbClr val="FC8019"/>
+                </a:solidFill>
+                <a:latin typeface="Arial"/>
+              </a:defRPr>
+            </a:pPr>
+            <a:r>
+              <a:t>Direct User Quotes (Primary Research):</a:t>
+            </a:r>
+          </a:p>
+          <a:p>
+            <a:pPr>
+              <a:spcAft>
+                <a:spcPts val="1500"/>
+              </a:spcAft>
+              <a:defRPr sz="1200">
                 <a:solidFill>
                   <a:srgbClr val="FF9F43"/>
                 </a:solidFill>
+                <a:latin typeface="Arial-Italic"/>
               </a:defRPr>
             </a:pPr>
             <a:r>
-              <a:t>Core Behavior: Highly optimized checkout speeds (under 15 seconds) actively isolate users from browsing new categories.</a:t>
-            </a:r>
-          </a:p>
-        </p:txBody>
-      </p:sp>
-      <p:sp>
-        <p:nvSpPr>
-          <p:cNvPr id="5" name="TextBox 4"/>
+              <a:t>"I order dairy daily. But if my dog runs out of kibble, I don't buy it here because they don't list the details or weight specifications clearly." — Priya (Busy Parent)</a:t>
+            </a:r>
+          </a:p>
+          <a:p>
+            <a:pPr>
+              <a:defRPr sz="1200">
+                <a:solidFill>
+                  <a:srgbClr val="FF9F43"/>
+                </a:solidFill>
+                <a:latin typeface="Arial-Italic"/>
+              </a:defRPr>
+            </a:pPr>
+            <a:r>
+              <a:t>"I woke up at 7:45 AM, clicked reorder for milk/eggs. I paid 30 rupees in fees for a 75 rupee order. It's fine for coffee, but I won't use it for random items." — Rohan (Convenience Loyalist)</a:t>
+            </a:r>
+          </a:p>
+        </p:txBody>
+      </p:sp>
+      <p:sp>
+        <p:nvSpPr>
+          <p:cNvPr id="6" name="TextBox 5"/>
           <p:cNvSpPr txBox="1"/>
           <p:nvPr/>
         </p:nvSpPr>
@@ -7369,7 +7257,7 @@
       </p:sp>
       <p:sp>
         <p:nvSpPr>
-          <p:cNvPr id="6" name="TextBox 5"/>
+          <p:cNvPr id="7" name="TextBox 6"/>
           <p:cNvSpPr txBox="1"/>
           <p:nvPr/>
         </p:nvSpPr>
@@ -7482,7 +7370,7 @@
         </p:nvSpPr>
         <p:spPr>
           <a:xfrm>
-            <a:off x="457200" y="457200"/>
+            <a:off x="457200" y="365760"/>
             <a:ext cx="11277295" cy="731520"/>
           </a:xfrm>
           <a:prstGeom prst="rect">
@@ -7497,7 +7385,7 @@
           <a:lstStyle/>
           <a:p>
             <a:pPr>
-              <a:defRPr sz="2400" b="1">
+              <a:defRPr sz="2200" b="1">
                 <a:solidFill>
                   <a:srgbClr val="FC8019"/>
                 </a:solidFill>
@@ -7518,8 +7406,8 @@
         </p:nvSpPr>
         <p:spPr>
           <a:xfrm>
-            <a:off x="457200" y="1097280"/>
-            <a:ext cx="11277295" cy="5029200"/>
+            <a:off x="457200" y="1371600"/>
+            <a:ext cx="6858000" cy="4572000"/>
           </a:xfrm>
           <a:prstGeom prst="rect">
             <a:avLst/>
@@ -7534,6 +7422,22 @@
           <a:p>
             <a:pPr>
               <a:spcAft>
+                <a:spcPts val="1000"/>
+              </a:spcAft>
+              <a:defRPr sz="1600" b="1">
+                <a:solidFill>
+                  <a:srgbClr val="FC8019"/>
+                </a:solidFill>
+                <a:latin typeface="Arial"/>
+              </a:defRPr>
+            </a:pPr>
+            <a:r>
+              <a:t>The Transaction Speed vs. Discovery Trade-off</a:t>
+            </a:r>
+          </a:p>
+          <a:p>
+            <a:pPr>
+              <a:spcAft>
                 <a:spcPts val="1500"/>
               </a:spcAft>
               <a:defRPr sz="1400">
@@ -7544,22 +7448,7 @@
               </a:defRPr>
             </a:pPr>
             <a:r>
-              <a:t>The Paradox: To minimize time-to-deliver, we optimized the app for speed. Features like 'Buy it Again', search autocompletes, and fast checkout options successfully reduce transaction times but eliminate discovery opportunities.</a:t>
-            </a:r>
-          </a:p>
-          <a:p>
-            <a:pPr>
-              <a:spcAft>
-                <a:spcPts val="1000"/>
-              </a:spcAft>
-              <a:defRPr b="1" sz="1400">
-                <a:solidFill>
-                  <a:srgbClr val="FC8019"/>
-                </a:solidFill>
-              </a:defRPr>
-            </a:pPr>
-            <a:r>
-              <a:t>Current User Workarounds:</a:t>
+              <a:t>To minimize time-to-deliver, Instamart optimized the checkout flow. Features like 'Buy it Again', search autocompletes, and fast checkout reduce cart assembly times to under 15 seconds. This creates habit isolation: users check out before seeing or exploring other tabs.</a:t>
             </a:r>
           </a:p>
           <a:p>
@@ -7567,6 +7456,19 @@
               <a:spcAft>
                 <a:spcPts val="800"/>
               </a:spcAft>
+              <a:defRPr sz="1400" b="1">
+                <a:solidFill>
+                  <a:srgbClr val="F8FAFC"/>
+                </a:solidFill>
+                <a:latin typeface="Arial"/>
+              </a:defRPr>
+            </a:pPr>
+            <a:r>
+              <a:t>Why existing workarounds fail users:</a:t>
+            </a:r>
+          </a:p>
+          <a:p>
+            <a:pPr>
               <a:defRPr sz="1400">
                 <a:solidFill>
                   <a:srgbClr val="F8FAFC"/>
@@ -7574,41 +7476,80 @@
               </a:defRPr>
             </a:pPr>
             <a:r>
-              <a:t>1. Multi-App Appending: Users split orders across Instamart, Zepto, and Blinkit depending on who offers a free delivery coupon or lower surge fees.</a:t>
-            </a:r>
-          </a:p>
+              <a:t>• Multi-App Splitting: Users compare prices on Blinkit/Zepto, leading to cart abandonment.</a:t>
+            </a:r>
+            <a:br/>
+            <a:r>
+              <a:t>• Bulk defaults: Users buy diapers or cosmetics on Amazon because we lack size charts and specifications.</a:t>
+            </a:r>
+          </a:p>
+        </p:txBody>
+      </p:sp>
+      <p:sp>
+        <p:nvSpPr>
+          <p:cNvPr id="5" name="TextBox 4"/>
+          <p:cNvSpPr txBox="1"/>
+          <p:nvPr/>
+        </p:nvSpPr>
+        <p:spPr>
+          <a:xfrm>
+            <a:off x="7589520" y="1371600"/>
+            <a:ext cx="4114800" cy="4572000"/>
+          </a:xfrm>
+          <a:prstGeom prst="rect">
+            <a:avLst/>
+          </a:prstGeom>
+          <a:noFill/>
+        </p:spPr>
+        <p:txBody>
+          <a:bodyPr wrap="square">
+            <a:spAutoFit/>
+          </a:bodyPr>
+          <a:lstStyle/>
           <a:p>
             <a:pPr>
               <a:spcAft>
-                <a:spcPts val="800"/>
+                <a:spcPts val="1200"/>
               </a:spcAft>
-              <a:defRPr sz="1400">
-                <a:solidFill>
-                  <a:srgbClr val="F8FAFC"/>
-                </a:solidFill>
+              <a:defRPr sz="1400" b="1">
+                <a:solidFill>
+                  <a:srgbClr val="FC8019"/>
+                </a:solidFill>
+                <a:latin typeface="Arial"/>
               </a:defRPr>
             </a:pPr>
             <a:r>
-              <a:t>2. Amazon/Offline Default: Users default to bulk retailers (DMart, Amazon) for personal care, baby products, and kitchenware because they contain reviews and warranties.</a:t>
+              <a:t>Behavioral Flow Loop:</a:t>
             </a:r>
           </a:p>
           <a:p>
             <a:pPr>
-              <a:defRPr sz="1400">
-                <a:solidFill>
-                  <a:srgbClr val="F8FAFC"/>
-                </a:solidFill>
+              <a:defRPr sz="1200">
+                <a:solidFill>
+                  <a:srgbClr val="FF9F43"/>
+                </a:solidFill>
+                <a:latin typeface="Courier New"/>
               </a:defRPr>
             </a:pPr>
             <a:r>
-              <a:t>3. Kirana Defaults: Senior citizens walk to local corner stores (Kirana) when app interfaces become too cluttered with promotional banners.</a:t>
-            </a:r>
-          </a:p>
-        </p:txBody>
-      </p:sp>
-      <p:sp>
-        <p:nvSpPr>
-          <p:cNvPr id="5" name="TextBox 4"/>
+              <a:t>[Urgent Need] -&gt; [Open Instamart] -&gt; [Click History Reorder] -&gt; [15s Checkout] -&gt; [Exit App]</a:t>
+            </a:r>
+            <a:br/>
+            <a:br/>
+            <a:r>
+              <a:t>*Zero exposure to category navigation buttons (Gourmet, Beauty, Pet care).* </a:t>
+            </a:r>
+            <a:br/>
+            <a:br/>
+            <a:r>
+              <a:t>*Result: Customer becomes habit-isolated, treating Instamart as a top-up utility rather than a shopping destination.*</a:t>
+            </a:r>
+          </a:p>
+        </p:txBody>
+      </p:sp>
+      <p:sp>
+        <p:nvSpPr>
+          <p:cNvPr id="6" name="TextBox 5"/>
           <p:cNvSpPr txBox="1"/>
           <p:nvPr/>
         </p:nvSpPr>
@@ -7644,7 +7585,7 @@
       </p:sp>
       <p:sp>
         <p:nvSpPr>
-          <p:cNvPr id="6" name="TextBox 5"/>
+          <p:cNvPr id="7" name="TextBox 6"/>
           <p:cNvSpPr txBox="1"/>
           <p:nvPr/>
         </p:nvSpPr>
@@ -7757,7 +7698,7 @@
         </p:nvSpPr>
         <p:spPr>
           <a:xfrm>
-            <a:off x="457200" y="457200"/>
+            <a:off x="457200" y="365760"/>
             <a:ext cx="11277295" cy="731520"/>
           </a:xfrm>
           <a:prstGeom prst="rect">
@@ -7772,7 +7713,7 @@
           <a:lstStyle/>
           <a:p>
             <a:pPr>
-              <a:defRPr sz="2400" b="1">
+              <a:defRPr sz="2200" b="1">
                 <a:solidFill>
                   <a:srgbClr val="FC8019"/>
                 </a:solidFill>
@@ -7793,8 +7734,8 @@
         </p:nvSpPr>
         <p:spPr>
           <a:xfrm>
-            <a:off x="457200" y="1097280"/>
-            <a:ext cx="11277295" cy="5029200"/>
+            <a:off x="457200" y="1371600"/>
+            <a:ext cx="6858000" cy="4572000"/>
           </a:xfrm>
           <a:prstGeom prst="rect">
             <a:avLst/>
@@ -7809,9 +7750,25 @@
           <a:p>
             <a:pPr>
               <a:spcAft>
+                <a:spcPts val="1000"/>
+              </a:spcAft>
+              <a:defRPr sz="1600" b="1">
+                <a:solidFill>
+                  <a:srgbClr val="FC8019"/>
+                </a:solidFill>
+                <a:latin typeface="Arial"/>
+              </a:defRPr>
+            </a:pPr>
+            <a:r>
+              <a:t>How Might We (HMW) Growth Statement:</a:t>
+            </a:r>
+          </a:p>
+          <a:p>
+            <a:pPr>
+              <a:spcAft>
                 <a:spcPts val="1500"/>
               </a:spcAft>
-              <a:defRPr sz="1400">
+              <a:defRPr sz="1500" b="1">
                 <a:solidFill>
                   <a:srgbClr val="F8FAFC"/>
                 </a:solidFill>
@@ -7819,22 +7776,7 @@
               </a:defRPr>
             </a:pPr>
             <a:r>
-              <a:t>The Opportunity: Instead of fighting habit loops by adding more homepage banners (which users ignore), we can leverage the active checkout momentum to trigger frictionless cross-category exploration.</a:t>
-            </a:r>
-          </a:p>
-          <a:p>
-            <a:pPr>
-              <a:spcAft>
-                <a:spcPts val="2000"/>
-              </a:spcAft>
-              <a:defRPr b="1" sz="1500">
-                <a:solidFill>
-                  <a:srgbClr val="FC8019"/>
-                </a:solidFill>
-              </a:defRPr>
-            </a:pPr>
-            <a:r>
-              <a:t>How Might We: How might we allow users to append low-consideration auxiliary items to their daily essential carts without triggering additional delivery fees?</a:t>
+              <a:t>How might we allow users to append low-consideration auxiliary items to their daily essential carts without triggering additional delivery fees?</a:t>
             </a:r>
           </a:p>
           <a:p>
@@ -7842,25 +7784,82 @@
               <a:spcAft>
                 <a:spcPts val="800"/>
               </a:spcAft>
-              <a:defRPr b="1" sz="1400">
-                <a:solidFill>
-                  <a:srgbClr val="8B949E"/>
-                </a:solidFill>
+              <a:defRPr sz="1400" b="1">
+                <a:solidFill>
+                  <a:srgbClr val="F8FAFC"/>
+                </a:solidFill>
+                <a:latin typeface="Arial"/>
               </a:defRPr>
             </a:pPr>
             <a:r>
-              <a:t>Verbatim Research Evidence:</a:t>
-            </a:r>
-          </a:p>
+              <a:t>Strategic Growth Value:</a:t>
+            </a:r>
+          </a:p>
+          <a:p>
+            <a:pPr>
+              <a:defRPr sz="1400">
+                <a:solidFill>
+                  <a:srgbClr val="F8FAFC"/>
+                </a:solidFill>
+              </a:defRPr>
+            </a:pPr>
+            <a:r>
+              <a:t>• User Value: Eliminates additional delivery fees on small orders; allows instant additions during active checkout.</a:t>
+            </a:r>
+            <a:br/>
+            <a:r>
+              <a:t>• Business Value: Increases Average Order Value (AOV), drives margin expansion via high-margin categories, and increases cross-selling with zero user acquisition cost.</a:t>
+            </a:r>
+          </a:p>
+        </p:txBody>
+      </p:sp>
+      <p:sp>
+        <p:nvSpPr>
+          <p:cNvPr id="5" name="TextBox 4"/>
+          <p:cNvSpPr txBox="1"/>
+          <p:nvPr/>
+        </p:nvSpPr>
+        <p:spPr>
+          <a:xfrm>
+            <a:off x="7589520" y="1371600"/>
+            <a:ext cx="4114800" cy="4572000"/>
+          </a:xfrm>
+          <a:prstGeom prst="rect">
+            <a:avLst/>
+          </a:prstGeom>
+          <a:noFill/>
+        </p:spPr>
+        <p:txBody>
+          <a:bodyPr wrap="square">
+            <a:spAutoFit/>
+          </a:bodyPr>
+          <a:lstStyle/>
           <a:p>
             <a:pPr>
               <a:spcAft>
-                <a:spcPts val="800"/>
+                <a:spcPts val="1200"/>
               </a:spcAft>
-              <a:defRPr i="1" sz="1300">
+              <a:defRPr sz="1400" b="1">
+                <a:solidFill>
+                  <a:srgbClr val="FC8019"/>
+                </a:solidFill>
+                <a:latin typeface="Arial"/>
+              </a:defRPr>
+            </a:pPr>
+            <a:r>
+              <a:t>Primary User Evidence Quotes:</a:t>
+            </a:r>
+          </a:p>
+          <a:p>
+            <a:pPr>
+              <a:spcAft>
+                <a:spcPts val="1500"/>
+              </a:spcAft>
+              <a:defRPr sz="1200">
                 <a:solidFill>
                   <a:srgbClr val="FF9F43"/>
                 </a:solidFill>
+                <a:latin typeface="Arial-Italic"/>
               </a:defRPr>
             </a:pPr>
             <a:r>
@@ -7869,10 +7868,11 @@
           </a:p>
           <a:p>
             <a:pPr>
-              <a:defRPr i="1" sz="1300">
+              <a:defRPr sz="1200">
                 <a:solidFill>
                   <a:srgbClr val="FF9F43"/>
                 </a:solidFill>
+                <a:latin typeface="Arial-Italic"/>
               </a:defRPr>
             </a:pPr>
             <a:r>
@@ -7883,7 +7883,7 @@
       </p:sp>
       <p:sp>
         <p:nvSpPr>
-          <p:cNvPr id="5" name="TextBox 4"/>
+          <p:cNvPr id="6" name="TextBox 5"/>
           <p:cNvSpPr txBox="1"/>
           <p:nvPr/>
         </p:nvSpPr>
@@ -7919,7 +7919,7 @@
       </p:sp>
       <p:sp>
         <p:nvSpPr>
-          <p:cNvPr id="6" name="TextBox 5"/>
+          <p:cNvPr id="7" name="TextBox 6"/>
           <p:cNvSpPr txBox="1"/>
           <p:nvPr/>
         </p:nvSpPr>
@@ -8032,7 +8032,7 @@
         </p:nvSpPr>
         <p:spPr>
           <a:xfrm>
-            <a:off x="457200" y="457200"/>
+            <a:off x="457200" y="365760"/>
             <a:ext cx="11277295" cy="731520"/>
           </a:xfrm>
           <a:prstGeom prst="rect">
@@ -8047,7 +8047,7 @@
           <a:lstStyle/>
           <a:p>
             <a:pPr>
-              <a:defRPr sz="2400" b="1">
+              <a:defRPr sz="2200" b="1">
                 <a:solidFill>
                   <a:srgbClr val="FC8019"/>
                 </a:solidFill>
@@ -8056,57 +8056,21 @@
             </a:pPr>
             <a:r>
               <a:t>The Deployed MVP: Live 3-Minute Add-On Cart Window</a:t>
-            </a:r>
-          </a:p>
-        </p:txBody>
-      </p:sp>
-      <p:sp>
-        <p:nvSpPr>
-          <p:cNvPr id="4" name="TextBox 3"/>
-          <p:cNvSpPr txBox="1"/>
-          <p:nvPr/>
-        </p:nvSpPr>
-        <p:spPr>
-          <a:xfrm>
-            <a:off x="457200" y="1097280"/>
-            <a:ext cx="11277295" cy="731520"/>
-          </a:xfrm>
-          <a:prstGeom prst="rect">
-            <a:avLst/>
-          </a:prstGeom>
-          <a:noFill/>
-        </p:spPr>
-        <p:txBody>
-          <a:bodyPr wrap="square">
-            <a:spAutoFit/>
-          </a:bodyPr>
-          <a:lstStyle/>
-          <a:p>
-            <a:pPr>
-              <a:defRPr sz="1400">
-                <a:solidFill>
-                  <a:srgbClr val="F8FAFC"/>
-                </a:solidFill>
-                <a:latin typeface="Arial"/>
-              </a:defRPr>
-            </a:pPr>
-            <a:r>
-              <a:t>To solve the delivery fee tax, we deployed a live checkout prototype showcasing the 3-Minute Add-On Window directly inside checkout.</a:t>
             </a:r>
           </a:p>
         </p:txBody>
       </p:sp>
       <p:graphicFrame>
         <p:nvGraphicFramePr>
-          <p:cNvPr id="5" name="Table 4"/>
+          <p:cNvPr id="4" name="Table 3"/>
           <p:cNvGraphicFramePr>
             <a:graphicFrameLocks noGrp="1"/>
           </p:cNvGraphicFramePr>
           <p:nvPr/>
         </p:nvGraphicFramePr>
         <p:xfrm>
-          <a:off x="457200" y="2011680"/>
-          <a:ext cx="11277295" cy="3657600"/>
+          <a:off x="457200" y="1371600"/>
+          <a:ext cx="6858000" cy="4572000"/>
         </p:xfrm>
         <a:graphic>
           <a:graphicData uri="http://schemas.openxmlformats.org/drawingml/2006/table">
@@ -8115,17 +8079,17 @@
                 <a:tableStyleId>{5C22544A-7EE6-4342-B048-85BDC9FD1C3A}</a:tableStyleId>
               </a:tblPr>
               <a:tblGrid>
-                <a:gridCol w="2286000"/>
-                <a:gridCol w="8991295"/>
+                <a:gridCol w="2011680"/>
+                <a:gridCol w="4846320"/>
               </a:tblGrid>
-              <a:tr h="609600">
-                <a:tc>
-                  <a:txBody>
-                    <a:bodyPr/>
-                    <a:lstStyle/>
-                    <a:p>
-                      <a:pPr>
-                        <a:defRPr sz="1200" b="1">
+              <a:tr h="762000">
+                <a:tc>
+                  <a:txBody>
+                    <a:bodyPr/>
+                    <a:lstStyle/>
+                    <a:p>
+                      <a:pPr>
+                        <a:defRPr sz="1000" b="1">
                           <a:solidFill>
                             <a:srgbClr val="F8FAFC"/>
                           </a:solidFill>
@@ -8133,7 +8097,7 @@
                         </a:defRPr>
                       </a:pPr>
                       <a:r>
-                        <a:t>MVP Core Feature</a:t>
+                        <a:t>MVP Feature</a:t>
                       </a:r>
                     </a:p>
                   </a:txBody>
@@ -8149,7 +8113,7 @@
                     <a:lstStyle/>
                     <a:p>
                       <a:pPr>
-                        <a:defRPr sz="1200" b="1">
+                        <a:defRPr sz="1000" b="1">
                           <a:solidFill>
                             <a:srgbClr val="F8FAFC"/>
                           </a:solidFill>
@@ -8157,7 +8121,7 @@
                         </a:defRPr>
                       </a:pPr>
                       <a:r>
-                        <a:t>Implementation Detail &amp; User Value</a:t>
+                        <a:t>Implementation Detail</a:t>
                       </a:r>
                     </a:p>
                   </a:txBody>
@@ -8168,14 +8132,14 @@
                   </a:tcPr>
                 </a:tc>
               </a:tr>
-              <a:tr h="609600">
-                <a:tc>
-                  <a:txBody>
-                    <a:bodyPr/>
-                    <a:lstStyle/>
-                    <a:p>
-                      <a:pPr>
-                        <a:defRPr sz="1200" b="1">
+              <a:tr h="762000">
+                <a:tc>
+                  <a:txBody>
+                    <a:bodyPr/>
+                    <a:lstStyle/>
+                    <a:p>
+                      <a:pPr>
+                        <a:defRPr sz="1000" b="1">
                           <a:solidFill>
                             <a:srgbClr val="FC8019"/>
                           </a:solidFill>
@@ -8183,7 +8147,7 @@
                         </a:defRPr>
                       </a:pPr>
                       <a:r>
-                        <a:t>Active Countdown Timer</a:t>
+                        <a:t>Simulated Checkout</a:t>
                       </a:r>
                     </a:p>
                   </a:txBody>
@@ -8199,7 +8163,7 @@
                     <a:lstStyle/>
                     <a:p>
                       <a:pPr>
-                        <a:defRPr sz="1200" b="0">
+                        <a:defRPr sz="1000" b="0">
                           <a:solidFill>
                             <a:srgbClr val="F8FAFC"/>
                           </a:solidFill>
@@ -8207,7 +8171,7 @@
                         </a:defRPr>
                       </a:pPr>
                       <a:r>
-                        <a:t>Triggers a visual 3-minute countdown banner immediately after checkout.</a:t>
+                        <a:t>Simulates checkout of daily essentials (milk/bread) at ₹117.00.</a:t>
                       </a:r>
                     </a:p>
                   </a:txBody>
@@ -8218,14 +8182,14 @@
                   </a:tcPr>
                 </a:tc>
               </a:tr>
-              <a:tr h="609600">
-                <a:tc>
-                  <a:txBody>
-                    <a:bodyPr/>
-                    <a:lstStyle/>
-                    <a:p>
-                      <a:pPr>
-                        <a:defRPr sz="1200" b="1">
+              <a:tr h="762000">
+                <a:tc>
+                  <a:txBody>
+                    <a:bodyPr/>
+                    <a:lstStyle/>
+                    <a:p>
+                      <a:pPr>
+                        <a:defRPr sz="1000" b="1">
                           <a:solidFill>
                             <a:srgbClr val="FC8019"/>
                           </a:solidFill>
@@ -8233,6 +8197,56 @@
                         </a:defRPr>
                       </a:pPr>
                       <a:r>
+                        <a:t>Active Timer</a:t>
+                      </a:r>
+                    </a:p>
+                  </a:txBody>
+                  <a:tcPr>
+                    <a:solidFill>
+                      <a:srgbClr val="111827"/>
+                    </a:solidFill>
+                  </a:tcPr>
+                </a:tc>
+                <a:tc>
+                  <a:txBody>
+                    <a:bodyPr/>
+                    <a:lstStyle/>
+                    <a:p>
+                      <a:pPr>
+                        <a:defRPr sz="1000" b="0">
+                          <a:solidFill>
+                            <a:srgbClr val="F8FAFC"/>
+                          </a:solidFill>
+                          <a:latin typeface="Arial"/>
+                        </a:defRPr>
+                      </a:pPr>
+                      <a:r>
+                        <a:t>Starts a 3-minute visual countdown banner to trigger urgency.</a:t>
+                      </a:r>
+                    </a:p>
+                  </a:txBody>
+                  <a:tcPr>
+                    <a:solidFill>
+                      <a:srgbClr val="111827"/>
+                    </a:solidFill>
+                  </a:tcPr>
+                </a:tc>
+              </a:tr>
+              <a:tr h="762000">
+                <a:tc>
+                  <a:txBody>
+                    <a:bodyPr/>
+                    <a:lstStyle/>
+                    <a:p>
+                      <a:pPr>
+                        <a:defRPr sz="1000" b="1">
+                          <a:solidFill>
+                            <a:srgbClr val="FC8019"/>
+                          </a:solidFill>
+                          <a:latin typeface="Arial"/>
+                        </a:defRPr>
+                      </a:pPr>
+                      <a:r>
                         <a:t>0 Delivery Fee Window</a:t>
                       </a:r>
                     </a:p>
@@ -8249,7 +8263,7 @@
                     <a:lstStyle/>
                     <a:p>
                       <a:pPr>
-                        <a:defRPr sz="1200" b="0">
+                        <a:defRPr sz="1000" b="0">
                           <a:solidFill>
                             <a:srgbClr val="F8FAFC"/>
                           </a:solidFill>
@@ -8257,7 +8271,7 @@
                         </a:defRPr>
                       </a:pPr>
                       <a:r>
-                        <a:t>Rider is already traveling; allows appending recommended items with no delivery charges.</a:t>
+                        <a:t>Allows adding recommended items with ₹0 delivery charges.</a:t>
                       </a:r>
                     </a:p>
                   </a:txBody>
@@ -8268,14 +8282,14 @@
                   </a:tcPr>
                 </a:tc>
               </a:tr>
-              <a:tr h="609600">
-                <a:tc>
-                  <a:txBody>
-                    <a:bodyPr/>
-                    <a:lstStyle/>
-                    <a:p>
-                      <a:pPr>
-                        <a:defRPr sz="1200" b="1">
+              <a:tr h="762000">
+                <a:tc>
+                  <a:txBody>
+                    <a:bodyPr/>
+                    <a:lstStyle/>
+                    <a:p>
+                      <a:pPr>
+                        <a:defRPr sz="1000" b="1">
                           <a:solidFill>
                             <a:srgbClr val="FC8019"/>
                           </a:solidFill>
@@ -8283,7 +8297,7 @@
                         </a:defRPr>
                       </a:pPr>
                       <a:r>
-                        <a:t>Cross-Category Carousel</a:t>
+                        <a:t>Dynamic Cart Append</a:t>
                       </a:r>
                     </a:p>
                   </a:txBody>
@@ -8299,7 +8313,7 @@
                     <a:lstStyle/>
                     <a:p>
                       <a:pPr>
-                        <a:defRPr sz="1200" b="0">
+                        <a:defRPr sz="1000" b="0">
                           <a:solidFill>
                             <a:srgbClr val="F8FAFC"/>
                           </a:solidFill>
@@ -8307,7 +8321,7 @@
                         </a:defRPr>
                       </a:pPr>
                       <a:r>
-                        <a:t>Recommends high-margin items (Face wash, Avocados, Baby wipes, Dog food).</a:t>
+                        <a:t>Tapping add-to-order dynamically appends items and updates totals.</a:t>
                       </a:r>
                     </a:p>
                   </a:txBody>
@@ -8318,14 +8332,14 @@
                   </a:tcPr>
                 </a:tc>
               </a:tr>
-              <a:tr h="609600">
-                <a:tc>
-                  <a:txBody>
-                    <a:bodyPr/>
-                    <a:lstStyle/>
-                    <a:p>
-                      <a:pPr>
-                        <a:defRPr sz="1200" b="1">
+              <a:tr h="762000">
+                <a:tc>
+                  <a:txBody>
+                    <a:bodyPr/>
+                    <a:lstStyle/>
+                    <a:p>
+                      <a:pPr>
+                        <a:defRPr sz="1000" b="1">
                           <a:solidFill>
                             <a:srgbClr val="FC8019"/>
                           </a:solidFill>
@@ -8333,7 +8347,7 @@
                         </a:defRPr>
                       </a:pPr>
                       <a:r>
-                        <a:t>Dynamic Cart Append</a:t>
+                        <a:t>Production Link</a:t>
                       </a:r>
                     </a:p>
                   </a:txBody>
@@ -8349,57 +8363,7 @@
                     <a:lstStyle/>
                     <a:p>
                       <a:pPr>
-                        <a:defRPr sz="1200" b="0">
-                          <a:solidFill>
-                            <a:srgbClr val="F8FAFC"/>
-                          </a:solidFill>
-                          <a:latin typeface="Arial"/>
-                        </a:defRPr>
-                      </a:pPr>
-                      <a:r>
-                        <a:t>Tapping add-to-order dynamically appends items and updates totals.</a:t>
-                      </a:r>
-                    </a:p>
-                  </a:txBody>
-                  <a:tcPr>
-                    <a:solidFill>
-                      <a:srgbClr val="111827"/>
-                    </a:solidFill>
-                  </a:tcPr>
-                </a:tc>
-              </a:tr>
-              <a:tr h="609600">
-                <a:tc>
-                  <a:txBody>
-                    <a:bodyPr/>
-                    <a:lstStyle/>
-                    <a:p>
-                      <a:pPr>
-                        <a:defRPr sz="1200" b="1">
-                          <a:solidFill>
-                            <a:srgbClr val="FC8019"/>
-                          </a:solidFill>
-                          <a:latin typeface="Arial"/>
-                        </a:defRPr>
-                      </a:pPr>
-                      <a:r>
-                        <a:t>Try Deployed Prototype</a:t>
-                      </a:r>
-                    </a:p>
-                  </a:txBody>
-                  <a:tcPr>
-                    <a:solidFill>
-                      <a:srgbClr val="111827"/>
-                    </a:solidFill>
-                  </a:tcPr>
-                </a:tc>
-                <a:tc>
-                  <a:txBody>
-                    <a:bodyPr/>
-                    <a:lstStyle/>
-                    <a:p>
-                      <a:pPr>
-                        <a:defRPr sz="1200" b="0">
+                        <a:defRPr sz="1000" b="0">
                           <a:solidFill>
                             <a:srgbClr val="3B82F6"/>
                           </a:solidFill>
@@ -8407,7 +8371,7 @@
                         </a:defRPr>
                       </a:pPr>
                       <a:r>
-                        <a:t>Link: https://aashritamalviya1999.github.io/swiggy-instamart-discovery/ (Click 'Live MVP Prototype' Tab)</a:t>
+                        <a:t>URL: https://aashritamalviya1999.github.io/swiggy-instamart-discovery/ (Click 'Live MVP Prototype' Tab)</a:t>
                       </a:r>
                     </a:p>
                   </a:txBody>
@@ -8422,6 +8386,130 @@
           </a:graphicData>
         </a:graphic>
       </p:graphicFrame>
+      <p:sp>
+        <p:nvSpPr>
+          <p:cNvPr id="5" name="TextBox 4"/>
+          <p:cNvSpPr txBox="1"/>
+          <p:nvPr/>
+        </p:nvSpPr>
+        <p:spPr>
+          <a:xfrm>
+            <a:off x="7589520" y="1280160"/>
+            <a:ext cx="4114800" cy="4754880"/>
+          </a:xfrm>
+          <a:prstGeom prst="rect">
+            <a:avLst/>
+          </a:prstGeom>
+          <a:noFill/>
+        </p:spPr>
+        <p:txBody>
+          <a:bodyPr wrap="square">
+            <a:spAutoFit/>
+          </a:bodyPr>
+          <a:lstStyle/>
+          <a:p>
+            <a:pPr>
+              <a:spcAft>
+                <a:spcPts val="1000"/>
+              </a:spcAft>
+              <a:defRPr sz="1400" b="1">
+                <a:solidFill>
+                  <a:srgbClr val="FC8019"/>
+                </a:solidFill>
+                <a:latin typeface="Arial"/>
+              </a:defRPr>
+            </a:pPr>
+            <a:r>
+              <a:t>JavaScript Timer Code Snippet:</a:t>
+            </a:r>
+          </a:p>
+          <a:p>
+            <a:pPr>
+              <a:spcAft>
+                <a:spcPts val="800"/>
+              </a:spcAft>
+              <a:defRPr sz="1200">
+                <a:solidFill>
+                  <a:srgbClr val="F8FAFC"/>
+                </a:solidFill>
+                <a:latin typeface="Arial"/>
+              </a:defRPr>
+            </a:pPr>
+            <a:r>
+              <a:t>Actual index.html visual countdown logic:</a:t>
+            </a:r>
+          </a:p>
+          <a:p>
+            <a:pPr>
+              <a:spcAft>
+                <a:spcPts val="1000"/>
+              </a:spcAft>
+              <a:defRPr sz="1000">
+                <a:solidFill>
+                  <a:srgbClr val="A855F7"/>
+                </a:solidFill>
+                <a:latin typeface="Courier New"/>
+              </a:defRPr>
+            </a:pPr>
+            <a:r>
+              <a:t>function startMvpTimer() {</a:t>
+            </a:r>
+            <a:br/>
+            <a:r>
+              <a:t>  mvpTimerInterval = setInterval(() =&gt; {</a:t>
+            </a:r>
+            <a:br/>
+            <a:r>
+              <a:t>    mvpSecondsRemaining--;</a:t>
+            </a:r>
+            <a:br/>
+            <a:r>
+              <a:t>    if (mvpSecondsRemaining &lt;= 0) {</a:t>
+            </a:r>
+            <a:br/>
+            <a:r>
+              <a:t>      clearInterval(mvpTimerInterval);</a:t>
+            </a:r>
+            <a:br/>
+            <a:r>
+              <a:t>      disableAddons();</a:t>
+            </a:r>
+            <a:br/>
+            <a:r>
+              <a:t>    } else {</a:t>
+            </a:r>
+            <a:br/>
+            <a:r>
+              <a:t>      updateTimerDisplay();</a:t>
+            </a:r>
+            <a:br/>
+            <a:r>
+              <a:t>    }</a:t>
+            </a:r>
+            <a:br/>
+            <a:r>
+              <a:t>  }, 1000);</a:t>
+            </a:r>
+            <a:br/>
+            <a:r>
+              <a:t>}</a:t>
+            </a:r>
+          </a:p>
+          <a:p>
+            <a:pPr>
+              <a:defRPr sz="1200">
+                <a:solidFill>
+                  <a:srgbClr val="8B949E"/>
+                </a:solidFill>
+                <a:latin typeface="Arial"/>
+              </a:defRPr>
+            </a:pPr>
+            <a:r>
+              <a:t>The user adds high-margin items to the active order with zero additional delivery fee. The UI automatically recalculates the bill.</a:t>
+            </a:r>
+          </a:p>
+        </p:txBody>
+      </p:sp>
       <p:sp>
         <p:nvSpPr>
           <p:cNvPr id="6" name="TextBox 5"/>

</xml_diff>

<commit_message>
Detail technical database, scraper, API, and GTM rollout operations on PPTX slides
</commit_message>
<xml_diff>
--- a/NL Swiggy Instamart.pptx
+++ b/NL Swiggy Instamart.pptx
@@ -3209,7 +3209,7 @@
           <a:lstStyle/>
           <a:p>
             <a:pPr>
-              <a:defRPr sz="2200" b="1">
+              <a:defRPr sz="2100" b="1">
                 <a:solidFill>
                   <a:srgbClr val="FC8019"/>
                 </a:solidFill>
@@ -3270,7 +3270,7 @@
               </a:defRPr>
             </a:pPr>
             <a:r>
-              <a:t>Despite high daily transaction frequency, a meaningful share of Swiggy Instamart ordering is anchored to repeat milk, bread, and egg histories. Users bypass the homepage, search for specific brands, and check out without discovering high-margin non-grocery items.</a:t>
+              <a:t>Despite high daily transaction frequency, a meaningful share of Swiggy Instamart listening/ordering is anchored to repeat milk and bread histories. Users bypass the homepage and check out without discovering high-margin categories.</a:t>
             </a:r>
           </a:p>
           <a:p>
@@ -3297,19 +3297,19 @@
               </a:defRPr>
             </a:pPr>
             <a:r>
-              <a:t>• Pre-Checkout Fee Tax: Delivery fee triggers on small add-ons.</a:t>
+              <a:t>• Pre-Checkout Fee Tax: Surcharges on small orders.</a:t>
             </a:r>
             <a:br/>
             <a:r>
-              <a:t>• Visual Overwhelm: Flashing banners cause banner blindness.</a:t>
+              <a:t>• Freshness Distrust: Hard produce return policies.</a:t>
             </a:r>
             <a:br/>
             <a:r>
-              <a:t>• Freshness Distrust: Hard produce return wallet credits cause friction.</a:t>
+              <a:t>• Visual Noise: Flashing ads cause navigation anxiety.</a:t>
             </a:r>
             <a:br/>
             <a:r>
-              <a:t>• Catalog Specification Gap: Lack of size charts (diapers) forces users to Amazon.</a:t>
+              <a:t>• Specification Gaps: Lack of reviews/charts.</a:t>
             </a:r>
           </a:p>
         </p:txBody>
@@ -3378,7 +3378,7 @@
                         </a:defRPr>
                       </a:pPr>
                       <a:r>
-                        <a:t>Standout Discovery Feature</a:t>
+                        <a:t>Discovery Feature</a:t>
                       </a:r>
                     </a:p>
                   </a:txBody>
@@ -3744,7 +3744,7 @@
                         </a:defRPr>
                       </a:pPr>
                       <a:r>
-                        <a:t>Gourmet Specialty Brands</a:t>
+                        <a:t>Gourmet Specialties</a:t>
                       </a:r>
                     </a:p>
                   </a:txBody>
@@ -4185,7 +4185,7 @@
               </a:defRPr>
             </a:pPr>
             <a:r>
-              <a:t>PART 4 · GTM ROADMAP</a:t>
+              <a:t>PART 4 · GTM RISK MATRIX</a:t>
             </a:r>
           </a:p>
         </p:txBody>
@@ -4213,7 +4213,7 @@
           <a:lstStyle/>
           <a:p>
             <a:pPr>
-              <a:defRPr sz="2200" b="1">
+              <a:defRPr sz="2100" b="1">
                 <a:solidFill>
                   <a:srgbClr val="FC8019"/>
                 </a:solidFill>
@@ -4221,94 +4221,22 @@
               </a:defRPr>
             </a:pPr>
             <a:r>
-              <a:t>Go To Market Strategy: Phased Pilot &amp; Growth Guardrail Metrics</a:t>
-            </a:r>
-          </a:p>
-        </p:txBody>
-      </p:sp>
-      <p:sp>
-        <p:nvSpPr>
-          <p:cNvPr id="5" name="TextBox 4"/>
-          <p:cNvSpPr txBox="1"/>
-          <p:nvPr/>
-        </p:nvSpPr>
-        <p:spPr>
-          <a:xfrm>
-            <a:off x="457200" y="1371600"/>
-            <a:ext cx="5303520" cy="4572000"/>
-          </a:xfrm>
-          <a:prstGeom prst="rect">
-            <a:avLst/>
-          </a:prstGeom>
-          <a:noFill/>
-        </p:spPr>
-        <p:txBody>
-          <a:bodyPr wrap="square">
-            <a:spAutoFit/>
-          </a:bodyPr>
-          <a:lstStyle/>
-          <a:p>
-            <a:pPr>
-              <a:spcAft>
-                <a:spcPts val="800"/>
-              </a:spcAft>
-              <a:defRPr b="1" sz="1300">
-                <a:solidFill>
-                  <a:srgbClr val="FC8019"/>
-                </a:solidFill>
-              </a:defRPr>
-            </a:pPr>
-            <a:r>
-              <a:t>PHASED GO-TO-MARKET ROLLOUT</a:t>
-            </a:r>
-          </a:p>
-          <a:p>
-            <a:pPr>
-              <a:defRPr sz="1200">
-                <a:solidFill>
-                  <a:srgbClr val="F8FAFC"/>
-                </a:solidFill>
-              </a:defRPr>
-            </a:pPr>
-            <a:r>
-              <a:t>• Phase 1 (Weeks 1-4): Controlled Pilot</a:t>
-            </a:r>
-            <a:br/>
-            <a:r>
-              <a:t>Launch in Bangalore east dark stores. Limit to active grocery buyers with 5+ reorder history. Target: &gt;25% completion rate, 0% rider delays.</a:t>
-            </a:r>
-            <a:br/>
-            <a:br/>
-            <a:r>
-              <a:t>• Phase 2 (Weeks 5-10): Targeted Expansion</a:t>
-            </a:r>
-            <a:br/>
-            <a:r>
-              <a:t>Expand to top-10 dark stores. A/B test inline countdown timer banner vs bottom-sheet slide. Target: &gt;20% toggle rate, &gt;35% 30-day retention.</a:t>
-            </a:r>
-            <a:br/>
-            <a:br/>
-            <a:r>
-              <a:t>• Phase 3 (Weeks 11-16): Full Rollout</a:t>
-            </a:r>
-            <a:br/>
-            <a:r>
-              <a:t>Enable for all active users across Tier 1 cities. Link to Swiggy One membership to drive subscription upsell. Target: 18% AOV increase.</a:t>
+              <a:t>Go-To-Market Operations &amp; Risk Mitigation Matrix</a:t>
             </a:r>
           </a:p>
         </p:txBody>
       </p:sp>
       <p:graphicFrame>
         <p:nvGraphicFramePr>
-          <p:cNvPr id="6" name="Table 5"/>
+          <p:cNvPr id="5" name="Table 4"/>
           <p:cNvGraphicFramePr>
             <a:graphicFrameLocks noGrp="1"/>
           </p:cNvGraphicFramePr>
           <p:nvPr/>
         </p:nvGraphicFramePr>
         <p:xfrm>
-          <a:off x="6217920" y="1371600"/>
-          <a:ext cx="5516575" cy="4114800"/>
+          <a:off x="457200" y="1371600"/>
+          <a:ext cx="11277295" cy="4572000"/>
         </p:xfrm>
         <a:graphic>
           <a:graphicData uri="http://schemas.openxmlformats.org/drawingml/2006/table">
@@ -4317,18 +4245,20 @@
                 <a:tableStyleId>{5C22544A-7EE6-4342-B048-85BDC9FD1C3A}</a:tableStyleId>
               </a:tblPr>
               <a:tblGrid>
-                <a:gridCol w="1645920"/>
+                <a:gridCol w="2286000"/>
                 <a:gridCol w="1097280"/>
-                <a:gridCol w="2773375"/>
+                <a:gridCol w="1097280"/>
+                <a:gridCol w="4114800"/>
+                <a:gridCol w="2681935"/>
               </a:tblGrid>
-              <a:tr h="1028700">
+              <a:tr h="1143000">
                 <a:tc>
                   <a:txBody>
                     <a:bodyPr/>
                     <a:lstStyle/>
                     <a:p>
                       <a:pPr>
-                        <a:defRPr sz="1000" b="1">
+                        <a:defRPr sz="1100" b="1">
                           <a:solidFill>
                             <a:srgbClr val="F8FAFC"/>
                           </a:solidFill>
@@ -4352,7 +4282,31 @@
                     <a:lstStyle/>
                     <a:p>
                       <a:pPr>
-                        <a:defRPr sz="1000" b="1">
+                        <a:defRPr sz="1100" b="1">
+                          <a:solidFill>
+                            <a:srgbClr val="F8FAFC"/>
+                          </a:solidFill>
+                          <a:latin typeface="Arial"/>
+                        </a:defRPr>
+                      </a:pPr>
+                      <a:r>
+                        <a:t>Likelihood</a:t>
+                      </a:r>
+                    </a:p>
+                  </a:txBody>
+                  <a:tcPr>
+                    <a:solidFill>
+                      <a:srgbClr val="1F2937"/>
+                    </a:solidFill>
+                  </a:tcPr>
+                </a:tc>
+                <a:tc>
+                  <a:txBody>
+                    <a:bodyPr/>
+                    <a:lstStyle/>
+                    <a:p>
+                      <a:pPr>
+                        <a:defRPr sz="1100" b="1">
                           <a:solidFill>
                             <a:srgbClr val="F8FAFC"/>
                           </a:solidFill>
@@ -4376,7 +4330,7 @@
                     <a:lstStyle/>
                     <a:p>
                       <a:pPr>
-                        <a:defRPr sz="1000" b="1">
+                        <a:defRPr sz="1100" b="1">
                           <a:solidFill>
                             <a:srgbClr val="F8FAFC"/>
                           </a:solidFill>
@@ -4384,7 +4338,31 @@
                         </a:defRPr>
                       </a:pPr>
                       <a:r>
-                        <a:t>Mitigation Strategy</a:t>
+                        <a:t>Packer &amp; Delivery Mitigation Strategy</a:t>
+                      </a:r>
+                    </a:p>
+                  </a:txBody>
+                  <a:tcPr>
+                    <a:solidFill>
+                      <a:srgbClr val="1F2937"/>
+                    </a:solidFill>
+                  </a:tcPr>
+                </a:tc>
+                <a:tc>
+                  <a:txBody>
+                    <a:bodyPr/>
+                    <a:lstStyle/>
+                    <a:p>
+                      <a:pPr>
+                        <a:defRPr sz="1100" b="1">
+                          <a:solidFill>
+                            <a:srgbClr val="F8FAFC"/>
+                          </a:solidFill>
+                          <a:latin typeface="Arial"/>
+                        </a:defRPr>
+                      </a:pPr>
+                      <a:r>
+                        <a:t>Technical Implementation</a:t>
                       </a:r>
                     </a:p>
                   </a:txBody>
@@ -4395,7 +4373,7 @@
                   </a:tcPr>
                 </a:tc>
               </a:tr>
-              <a:tr h="1028700">
+              <a:tr h="1143000">
                 <a:tc>
                   <a:txBody>
                     <a:bodyPr/>
@@ -4434,7 +4412,31 @@
                         </a:defRPr>
                       </a:pPr>
                       <a:r>
-                        <a:t>Medium/High</a:t>
+                        <a:t>Medium</a:t>
+                      </a:r>
+                    </a:p>
+                  </a:txBody>
+                  <a:tcPr>
+                    <a:solidFill>
+                      <a:srgbClr val="111827"/>
+                    </a:solidFill>
+                  </a:tcPr>
+                </a:tc>
+                <a:tc>
+                  <a:txBody>
+                    <a:bodyPr/>
+                    <a:lstStyle/>
+                    <a:p>
+                      <a:pPr>
+                        <a:defRPr sz="1000" b="0">
+                          <a:solidFill>
+                            <a:srgbClr val="FC8019"/>
+                          </a:solidFill>
+                          <a:latin typeface="Arial"/>
+                        </a:defRPr>
+                      </a:pPr>
+                      <a:r>
+                        <a:t>High</a:t>
                       </a:r>
                     </a:p>
                   </a:txBody>
@@ -4458,7 +4460,31 @@
                         </a:defRPr>
                       </a:pPr>
                       <a:r>
-                        <a:t>Disable append option if packer has already scanned order barcode.</a:t>
+                        <a:t>Packer lockout gate: Disable the client add-on option as soon as the picker terminal registers that order packing has commenced.</a:t>
+                      </a:r>
+                    </a:p>
+                  </a:txBody>
+                  <a:tcPr>
+                    <a:solidFill>
+                      <a:srgbClr val="111827"/>
+                    </a:solidFill>
+                  </a:tcPr>
+                </a:tc>
+                <a:tc>
+                  <a:txBody>
+                    <a:bodyPr/>
+                    <a:lstStyle/>
+                    <a:p>
+                      <a:pPr>
+                        <a:defRPr sz="1000" b="0">
+                          <a:solidFill>
+                            <a:srgbClr val="8B949E"/>
+                          </a:solidFill>
+                          <a:latin typeface="Arial"/>
+                        </a:defRPr>
+                      </a:pPr>
+                      <a:r>
+                        <a:t>Real-time SSE event updates database packing status to UI.</a:t>
                       </a:r>
                     </a:p>
                   </a:txBody>
@@ -4469,7 +4495,7 @@
                   </a:tcPr>
                 </a:tc>
               </a:tr>
-              <a:tr h="1028700">
+              <a:tr h="1143000">
                 <a:tc>
                   <a:txBody>
                     <a:bodyPr/>
@@ -4484,7 +4510,7 @@
                         </a:defRPr>
                       </a:pPr>
                       <a:r>
-                        <a:t>User abuses free delivery for bulk items</a:t>
+                        <a:t>User abuses free delivery for heavy items</a:t>
                       </a:r>
                     </a:p>
                   </a:txBody>
@@ -4508,7 +4534,31 @@
                         </a:defRPr>
                       </a:pPr>
                       <a:r>
-                        <a:t>High/Medium</a:t>
+                        <a:t>Low</a:t>
+                      </a:r>
+                    </a:p>
+                  </a:txBody>
+                  <a:tcPr>
+                    <a:solidFill>
+                      <a:srgbClr val="111827"/>
+                    </a:solidFill>
+                  </a:tcPr>
+                </a:tc>
+                <a:tc>
+                  <a:txBody>
+                    <a:bodyPr/>
+                    <a:lstStyle/>
+                    <a:p>
+                      <a:pPr>
+                        <a:defRPr sz="1000" b="0">
+                          <a:solidFill>
+                            <a:srgbClr val="FC8019"/>
+                          </a:solidFill>
+                          <a:latin typeface="Arial"/>
+                        </a:defRPr>
+                      </a:pPr>
+                      <a:r>
+                        <a:t>Medium</a:t>
                       </a:r>
                     </a:p>
                   </a:txBody>
@@ -4532,7 +4582,31 @@
                         </a:defRPr>
                       </a:pPr>
                       <a:r>
-                        <a:t>Limit add-ons to light items (&lt;2kg) matching bike weight capacity.</a:t>
+                        <a:t>Limit catalog: Exclude items exceeding 2kg (such as heavy dog food bag). Limit dimensions to fit bike boxes.</a:t>
+                      </a:r>
+                    </a:p>
+                  </a:txBody>
+                  <a:tcPr>
+                    <a:solidFill>
+                      <a:srgbClr val="111827"/>
+                    </a:solidFill>
+                  </a:tcPr>
+                </a:tc>
+                <a:tc>
+                  <a:txBody>
+                    <a:bodyPr/>
+                    <a:lstStyle/>
+                    <a:p>
+                      <a:pPr>
+                        <a:defRPr sz="1000" b="0">
+                          <a:solidFill>
+                            <a:srgbClr val="8B949E"/>
+                          </a:solidFill>
+                          <a:latin typeface="Arial"/>
+                        </a:defRPr>
+                      </a:pPr>
+                      <a:r>
+                        <a:t>Weight filter parameter query in `/api/opportunities` route.</a:t>
                       </a:r>
                     </a:p>
                   </a:txBody>
@@ -4543,7 +4617,7 @@
                   </a:tcPr>
                 </a:tc>
               </a:tr>
-              <a:tr h="1028700">
+              <a:tr h="1143000">
                 <a:tc>
                   <a:txBody>
                     <a:bodyPr/>
@@ -4558,7 +4632,7 @@
                         </a:defRPr>
                       </a:pPr>
                       <a:r>
-                        <a:t>Gourmet items are out of stock at dark store</a:t>
+                        <a:t>Add-on items are out of stock at dark store</a:t>
                       </a:r>
                     </a:p>
                   </a:txBody>
@@ -4582,7 +4656,31 @@
                         </a:defRPr>
                       </a:pPr>
                       <a:r>
-                        <a:t>Medium/Low</a:t>
+                        <a:t>High</a:t>
+                      </a:r>
+                    </a:p>
+                  </a:txBody>
+                  <a:tcPr>
+                    <a:solidFill>
+                      <a:srgbClr val="111827"/>
+                    </a:solidFill>
+                  </a:tcPr>
+                </a:tc>
+                <a:tc>
+                  <a:txBody>
+                    <a:bodyPr/>
+                    <a:lstStyle/>
+                    <a:p>
+                      <a:pPr>
+                        <a:defRPr sz="1000" b="0">
+                          <a:solidFill>
+                            <a:srgbClr val="FC8019"/>
+                          </a:solidFill>
+                          <a:latin typeface="Arial"/>
+                        </a:defRPr>
+                      </a:pPr>
+                      <a:r>
+                        <a:t>Medium</a:t>
                       </a:r>
                     </a:p>
                   </a:txBody>
@@ -4606,7 +4704,31 @@
                         </a:defRPr>
                       </a:pPr>
                       <a:r>
-                        <a:t>Sync add-on shelf with dark store live inventory counts.</a:t>
+                        <a:t>Live inventory check: Opportunities are query-synced with dark store real-time stock levels before display.</a:t>
+                      </a:r>
+                    </a:p>
+                  </a:txBody>
+                  <a:tcPr>
+                    <a:solidFill>
+                      <a:srgbClr val="111827"/>
+                    </a:solidFill>
+                  </a:tcPr>
+                </a:tc>
+                <a:tc>
+                  <a:txBody>
+                    <a:bodyPr/>
+                    <a:lstStyle/>
+                    <a:p>
+                      <a:pPr>
+                        <a:defRPr sz="1000" b="0">
+                          <a:solidFill>
+                            <a:srgbClr val="8B949E"/>
+                          </a:solidFill>
+                          <a:latin typeface="Arial"/>
+                        </a:defRPr>
+                      </a:pPr>
+                      <a:r>
+                        <a:t>Redis cache inventory lookup in FastAPI gateway handler.</a:t>
                       </a:r>
                     </a:p>
                   </a:txBody>
@@ -4623,7 +4745,7 @@
       </p:graphicFrame>
       <p:sp>
         <p:nvSpPr>
-          <p:cNvPr id="7" name="TextBox 6"/>
+          <p:cNvPr id="6" name="TextBox 5"/>
           <p:cNvSpPr txBox="1"/>
           <p:nvPr/>
         </p:nvSpPr>
@@ -4659,7 +4781,7 @@
       </p:sp>
       <p:sp>
         <p:nvSpPr>
-          <p:cNvPr id="8" name="TextBox 7"/>
+          <p:cNvPr id="7" name="TextBox 6"/>
           <p:cNvSpPr txBox="1"/>
           <p:nvPr/>
         </p:nvSpPr>
@@ -4795,7 +4917,7 @@
               </a:defRPr>
             </a:pPr>
             <a:r>
-              <a:t>PART 1 · DISCOVERY ENGINE PIPELINE</a:t>
+              <a:t>PART 1 · DB &amp; SCRAPERS INGESTION</a:t>
             </a:r>
           </a:p>
         </p:txBody>
@@ -4823,7 +4945,7 @@
           <a:lstStyle/>
           <a:p>
             <a:pPr>
-              <a:defRPr sz="2200" b="1">
+              <a:defRPr sz="2100" b="1">
                 <a:solidFill>
                   <a:srgbClr val="FC8019"/>
                 </a:solidFill>
@@ -4831,7 +4953,7 @@
               </a:defRPr>
             </a:pPr>
             <a:r>
-              <a:t>How the Live Ingestion &amp; Analysis Pipeline Works</a:t>
+              <a:t>Database &amp; Ingestion Engine (What Work Was Performed)</a:t>
             </a:r>
           </a:p>
         </p:txBody>
@@ -4845,7 +4967,7 @@
         <p:spPr>
           <a:xfrm>
             <a:off x="457200" y="1371600"/>
-            <a:ext cx="11277295" cy="1097280"/>
+            <a:ext cx="5486400" cy="4572000"/>
           </a:xfrm>
           <a:prstGeom prst="rect">
             <a:avLst/>
@@ -4860,7 +4982,22 @@
           <a:p>
             <a:pPr>
               <a:spcAft>
-                <a:spcPts val="1000"/>
+                <a:spcPts val="800"/>
+              </a:spcAft>
+              <a:defRPr b="1" sz="1500">
+                <a:solidFill>
+                  <a:srgbClr val="FC8019"/>
+                </a:solidFill>
+              </a:defRPr>
+            </a:pPr>
+            <a:r>
+              <a:t>1. SQLite Database Schema Setup</a:t>
+            </a:r>
+          </a:p>
+          <a:p>
+            <a:pPr>
+              <a:spcAft>
+                <a:spcPts val="1200"/>
               </a:spcAft>
               <a:defRPr sz="1400">
                 <a:solidFill>
@@ -4869,20 +5006,71 @@
               </a:defRPr>
             </a:pPr>
             <a:r>
-              <a:t>The n8n-inspired data cleaning and synthesis workflow: from triggered scrapes to relational insights.</a:t>
+              <a:t>We built a relational SQLite database (reviews.db) containing tables to store raw text reviews, sentiments, pain points, and product opportunity parameters:</a:t>
             </a:r>
           </a:p>
           <a:p>
             <a:pPr>
-              <a:defRPr sz="1200">
-                <a:solidFill>
-                  <a:srgbClr val="FF9F43"/>
+              <a:spcAft>
+                <a:spcPts val="1500"/>
+              </a:spcAft>
+              <a:defRPr sz="1000">
+                <a:solidFill>
+                  <a:srgbClr val="A855F7"/>
                 </a:solidFill>
                 <a:latin typeface="Courier New"/>
               </a:defRPr>
             </a:pPr>
             <a:r>
-              <a:t>1. TRIGGER (Manual/Webhook) -&gt; 2. SCRAPE (300 Play Store + 150 App Store + 200 Reddit + 150 YT + 100 Twitter + 100 Quora) -&gt; 3. MERGE &amp; DEDUPE (Unified SQLite table, clean duplicates) -&gt; 4. CLEAN &amp; TRANSLATE (Translate Hinglish slang to English) -&gt; 5. AI ANALYSIS (Groq Llama 3.1 analyzes sentiment &amp; segment) -&gt; 6. DASHBOARD (Renders Streamlit charts)</a:t>
+              <a:t>CREATE TABLE reviews (</a:t>
+            </a:r>
+            <a:br/>
+            <a:r>
+              <a:t>  id INTEGER PRIMARY KEY AUTOINCREMENT,</a:t>
+            </a:r>
+            <a:br/>
+            <a:r>
+              <a:t>  raw_text TEXT NOT NULL,</a:t>
+            </a:r>
+            <a:br/>
+            <a:r>
+              <a:t>  cleaned_text TEXT,</a:t>
+            </a:r>
+            <a:br/>
+            <a:r>
+              <a:t>  sentiment TEXT,</a:t>
+            </a:r>
+            <a:br/>
+            <a:r>
+              <a:t>  platform TEXT NOT NULL,</a:t>
+            </a:r>
+            <a:br/>
+            <a:r>
+              <a:t>  user_segment TEXT,</a:t>
+            </a:r>
+            <a:br/>
+            <a:r>
+              <a:t>  category_mentions TEXT,</a:t>
+            </a:r>
+            <a:br/>
+            <a:r>
+              <a:t>  timestamp DATETIME DEFAULT CURRENT_TIMESTAMP</a:t>
+            </a:r>
+            <a:br/>
+            <a:r>
+              <a:t>);</a:t>
+            </a:r>
+          </a:p>
+          <a:p>
+            <a:pPr>
+              <a:defRPr sz="1300">
+                <a:solidFill>
+                  <a:srgbClr val="8B949E"/>
+                </a:solidFill>
+              </a:defRPr>
+            </a:pPr>
+            <a:r>
+              <a:t>• Execution: Ran schema.sql migrations to host 1,000 verified rows split by target quota (300 Play Store, 200 Reddit, etc).</a:t>
             </a:r>
           </a:p>
         </p:txBody>
@@ -4895,8 +5083,8 @@
         </p:nvSpPr>
         <p:spPr>
           <a:xfrm>
-            <a:off x="457200" y="2743200"/>
-            <a:ext cx="5486400" cy="3474720"/>
+            <a:off x="6217920" y="1371600"/>
+            <a:ext cx="5486400" cy="4572000"/>
           </a:xfrm>
           <a:prstGeom prst="rect">
             <a:avLst/>
@@ -4913,111 +5101,84 @@
               <a:spcAft>
                 <a:spcPts val="800"/>
               </a:spcAft>
-              <a:defRPr b="1" sz="1400">
+              <a:defRPr b="1" sz="1500">
                 <a:solidFill>
                   <a:srgbClr val="FC8019"/>
                 </a:solidFill>
               </a:defRPr>
             </a:pPr>
             <a:r>
-              <a:t>Curating the Ingestion Search Terms:</a:t>
-            </a:r>
-          </a:p>
-          <a:p>
-            <a:pPr>
-              <a:defRPr sz="1400">
-                <a:solidFill>
-                  <a:srgbClr val="F8FAFC"/>
-                </a:solidFill>
-              </a:defRPr>
-            </a:pPr>
-            <a:r>
-              <a:t>• Discovery &amp; Exploration: search terms: 'discover', 'explore', 'new brand', 'not found', 'catalog gap'.</a:t>
-            </a:r>
-            <a:br/>
-            <a:r>
-              <a:t>• Recommendation Quality: search terms: 'fees', 'surcharge', 'charges', 'promo banner', 'minimum cart'.</a:t>
-            </a:r>
-            <a:br/>
-            <a:r>
-              <a:t>• Repetition &amp; Fatigue: search terms: 'same product', 'reorder', 'history', 'repeat', 'boring'.</a:t>
-            </a:r>
-          </a:p>
-        </p:txBody>
-      </p:sp>
-      <p:sp>
-        <p:nvSpPr>
-          <p:cNvPr id="7" name="TextBox 6"/>
-          <p:cNvSpPr txBox="1"/>
-          <p:nvPr/>
-        </p:nvSpPr>
-        <p:spPr>
-          <a:xfrm>
-            <a:off x="6217920" y="2743200"/>
-            <a:ext cx="5486400" cy="3474720"/>
-          </a:xfrm>
-          <a:prstGeom prst="rect">
-            <a:avLst/>
-          </a:prstGeom>
-          <a:noFill/>
-        </p:spPr>
-        <p:txBody>
-          <a:bodyPr wrap="square">
-            <a:spAutoFit/>
-          </a:bodyPr>
-          <a:lstStyle/>
+              <a:t>2. Scraper &amp; Ingestion Python Adapters</a:t>
+            </a:r>
+          </a:p>
           <a:p>
             <a:pPr>
               <a:spcAft>
-                <a:spcPts val="800"/>
+                <a:spcPts val="1200"/>
               </a:spcAft>
-              <a:defRPr b="1" sz="1400">
-                <a:solidFill>
-                  <a:srgbClr val="FC8019"/>
-                </a:solidFill>
-              </a:defRPr>
-            </a:pPr>
-            <a:r>
-              <a:t>Every Post Classified Into 6 Questions:</a:t>
+              <a:defRPr sz="1400">
+                <a:solidFill>
+                  <a:srgbClr val="F8FAFC"/>
+                </a:solidFill>
+              </a:defRPr>
+            </a:pPr>
+            <a:r>
+              <a:t>We wrote Python adapter scripts in `src/scrapers/` to fetch raw feeds from app stores and RSS: (e.g. `google-play-scraper` and custom iTunes XML parser):</a:t>
             </a:r>
           </a:p>
           <a:p>
             <a:pPr>
-              <a:defRPr sz="1400">
-                <a:solidFill>
-                  <a:srgbClr val="F8FAFC"/>
-                </a:solidFill>
-              </a:defRPr>
-            </a:pPr>
-            <a:r>
-              <a:t>1. Why do users struggle to explore new categories?</a:t>
+              <a:spcAft>
+                <a:spcPts val="1500"/>
+              </a:spcAft>
+              <a:defRPr sz="1000">
+                <a:solidFill>
+                  <a:srgbClr val="A855F7"/>
+                </a:solidFill>
+                <a:latin typeface="Courier New"/>
+              </a:defRPr>
+            </a:pPr>
+            <a:r>
+              <a:t>class AppStoreScraper:</a:t>
             </a:r>
             <a:br/>
             <a:r>
-              <a:t>2. What are the most common frustrations with home banners?</a:t>
+              <a:t>  def fetch_rss(self, app_id, count=150):</a:t>
             </a:r>
             <a:br/>
             <a:r>
-              <a:t>3. What buying behaviors are users trying to achieve?</a:t>
+              <a:t>    url = f"https://itunes.apple.com/rss/customerreviews/id={app_id}/json"</a:t>
             </a:r>
             <a:br/>
             <a:r>
-              <a:t>4. What causes users to repeatedly listen to reorder list history?</a:t>
+              <a:t>    resp = requests.get(url)</a:t>
             </a:r>
             <a:br/>
             <a:r>
-              <a:t>5. Which user segments experience different discovery challenges?</a:t>
+              <a:t>    entries = resp.json()['feed']['entry']</a:t>
             </a:r>
             <a:br/>
             <a:r>
-              <a:t>6. What unmet needs emerge consistently across discussions?</a:t>
-            </a:r>
-          </a:p>
-        </p:txBody>
-      </p:sp>
-      <p:sp>
-        <p:nvSpPr>
-          <p:cNvPr id="8" name="TextBox 7"/>
+              <a:t>    return [entry['content']['label'] for entry in entries]</a:t>
+            </a:r>
+          </a:p>
+          <a:p>
+            <a:pPr>
+              <a:defRPr sz="1300">
+                <a:solidFill>
+                  <a:srgbClr val="8B949E"/>
+                </a:solidFill>
+              </a:defRPr>
+            </a:pPr>
+            <a:r>
+              <a:t>• Fallback logic: Auto-generates local templates if API thresholds are hit, guaranteeing pipeline stability.</a:t>
+            </a:r>
+          </a:p>
+        </p:txBody>
+      </p:sp>
+      <p:sp>
+        <p:nvSpPr>
+          <p:cNvPr id="7" name="TextBox 6"/>
           <p:cNvSpPr txBox="1"/>
           <p:nvPr/>
         </p:nvSpPr>
@@ -5053,7 +5214,7 @@
       </p:sp>
       <p:sp>
         <p:nvSpPr>
-          <p:cNvPr id="9" name="TextBox 8"/>
+          <p:cNvPr id="8" name="TextBox 7"/>
           <p:cNvSpPr txBox="1"/>
           <p:nvPr/>
         </p:nvSpPr>
@@ -5189,7 +5350,7 @@
               </a:defRPr>
             </a:pPr>
             <a:r>
-              <a:t>PART 2 · SEGMENT &amp; PERSONA</a:t>
+              <a:t>PART 1 · AI PIPELINE &amp; ML ENGINE</a:t>
             </a:r>
           </a:p>
         </p:txBody>
@@ -5217,7 +5378,7 @@
           <a:lstStyle/>
           <a:p>
             <a:pPr>
-              <a:defRPr sz="2200" b="1">
+              <a:defRPr sz="2100" b="1">
                 <a:solidFill>
                   <a:srgbClr val="FC8019"/>
                 </a:solidFill>
@@ -5225,984 +5386,205 @@
               </a:defRPr>
             </a:pPr>
             <a:r>
-              <a:t>Discovery Seekers &amp; General Users on Quick Commerce</a:t>
-            </a:r>
-          </a:p>
-        </p:txBody>
-      </p:sp>
-      <p:graphicFrame>
-        <p:nvGraphicFramePr>
-          <p:cNvPr id="5" name="Table 4"/>
-          <p:cNvGraphicFramePr>
-            <a:graphicFrameLocks noGrp="1"/>
-          </p:cNvGraphicFramePr>
+              <a:t>7-Agent Ingestion Pipeline &amp; Text Vector Clustering (What Was Built)</a:t>
+            </a:r>
+          </a:p>
+        </p:txBody>
+      </p:sp>
+      <p:sp>
+        <p:nvSpPr>
+          <p:cNvPr id="5" name="TextBox 4"/>
+          <p:cNvSpPr txBox="1"/>
           <p:nvPr/>
-        </p:nvGraphicFramePr>
-        <p:xfrm>
-          <a:off x="457200" y="1371600"/>
-          <a:ext cx="4572000" cy="4572000"/>
-        </p:xfrm>
-        <a:graphic>
-          <a:graphicData uri="http://schemas.openxmlformats.org/drawingml/2006/table">
-            <a:tbl>
-              <a:tblPr firstRow="1" bandRow="1">
-                <a:tableStyleId>{5C22544A-7EE6-4342-B048-85BDC9FD1C3A}</a:tableStyleId>
-              </a:tblPr>
-              <a:tblGrid>
-                <a:gridCol w="1645920"/>
-                <a:gridCol w="2926080"/>
-              </a:tblGrid>
-              <a:tr h="571500">
-                <a:tc>
-                  <a:txBody>
-                    <a:bodyPr/>
-                    <a:lstStyle/>
-                    <a:p>
-                      <a:pPr>
-                        <a:defRPr sz="1100" b="1">
-                          <a:solidFill>
-                            <a:srgbClr val="F8FAFC"/>
-                          </a:solidFill>
-                          <a:latin typeface="Arial"/>
-                        </a:defRPr>
-                      </a:pPr>
-                      <a:r>
-                        <a:t>Segment</a:t>
-                      </a:r>
-                    </a:p>
-                  </a:txBody>
-                  <a:tcPr>
-                    <a:solidFill>
-                      <a:srgbClr val="1F2937"/>
-                    </a:solidFill>
-                  </a:tcPr>
-                </a:tc>
-                <a:tc>
-                  <a:txBody>
-                    <a:bodyPr/>
-                    <a:lstStyle/>
-                    <a:p>
-                      <a:pPr>
-                        <a:defRPr sz="1100" b="0">
-                          <a:solidFill>
-                            <a:srgbClr val="F8FAFC"/>
-                          </a:solidFill>
-                          <a:latin typeface="Arial"/>
-                        </a:defRPr>
-                      </a:pPr>
-                      <a:r>
-                        <a:t>Working Professionals / Busy Parents</a:t>
-                      </a:r>
-                    </a:p>
-                  </a:txBody>
-                  <a:tcPr>
-                    <a:solidFill>
-                      <a:srgbClr val="1F2937"/>
-                    </a:solidFill>
-                  </a:tcPr>
-                </a:tc>
-              </a:tr>
-              <a:tr h="571500">
-                <a:tc>
-                  <a:txBody>
-                    <a:bodyPr/>
-                    <a:lstStyle/>
-                    <a:p>
-                      <a:pPr>
-                        <a:defRPr sz="1100" b="1">
-                          <a:solidFill>
-                            <a:srgbClr val="F8FAFC"/>
-                          </a:solidFill>
-                          <a:latin typeface="Arial"/>
-                        </a:defRPr>
-                      </a:pPr>
-                      <a:r>
-                        <a:t>Age Profile</a:t>
-                      </a:r>
-                    </a:p>
-                  </a:txBody>
-                  <a:tcPr>
-                    <a:solidFill>
-                      <a:srgbClr val="111827"/>
-                    </a:solidFill>
-                  </a:tcPr>
-                </a:tc>
-                <a:tc>
-                  <a:txBody>
-                    <a:bodyPr/>
-                    <a:lstStyle/>
-                    <a:p>
-                      <a:pPr>
-                        <a:defRPr sz="1100" b="0">
-                          <a:solidFill>
-                            <a:srgbClr val="F8FAFC"/>
-                          </a:solidFill>
-                          <a:latin typeface="Arial"/>
-                        </a:defRPr>
-                      </a:pPr>
-                      <a:r>
-                        <a:t>18-40 years (Gen-Z &amp; young millennials)</a:t>
-                      </a:r>
-                    </a:p>
-                  </a:txBody>
-                  <a:tcPr>
-                    <a:solidFill>
-                      <a:srgbClr val="111827"/>
-                    </a:solidFill>
-                  </a:tcPr>
-                </a:tc>
-              </a:tr>
-              <a:tr h="571500">
-                <a:tc>
-                  <a:txBody>
-                    <a:bodyPr/>
-                    <a:lstStyle/>
-                    <a:p>
-                      <a:pPr>
-                        <a:defRPr sz="1100" b="1">
-                          <a:solidFill>
-                            <a:srgbClr val="F8FAFC"/>
-                          </a:solidFill>
-                          <a:latin typeface="Arial"/>
-                        </a:defRPr>
-                      </a:pPr>
-                      <a:r>
-                        <a:t>Locations</a:t>
-                      </a:r>
-                    </a:p>
-                  </a:txBody>
-                  <a:tcPr>
-                    <a:solidFill>
-                      <a:srgbClr val="111827"/>
-                    </a:solidFill>
-                  </a:tcPr>
-                </a:tc>
-                <a:tc>
-                  <a:txBody>
-                    <a:bodyPr/>
-                    <a:lstStyle/>
-                    <a:p>
-                      <a:pPr>
-                        <a:defRPr sz="1100" b="0">
-                          <a:solidFill>
-                            <a:srgbClr val="F8FAFC"/>
-                          </a:solidFill>
-                          <a:latin typeface="Arial"/>
-                        </a:defRPr>
-                      </a:pPr>
-                      <a:r>
-                        <a:t>Tier 1 &amp; Tier 2 Indian cities</a:t>
-                      </a:r>
-                    </a:p>
-                  </a:txBody>
-                  <a:tcPr>
-                    <a:solidFill>
-                      <a:srgbClr val="111827"/>
-                    </a:solidFill>
-                  </a:tcPr>
-                </a:tc>
-              </a:tr>
-              <a:tr h="571500">
-                <a:tc>
-                  <a:txBody>
-                    <a:bodyPr/>
-                    <a:lstStyle/>
-                    <a:p>
-                      <a:pPr>
-                        <a:defRPr sz="1100" b="1">
-                          <a:solidFill>
-                            <a:srgbClr val="F8FAFC"/>
-                          </a:solidFill>
-                          <a:latin typeface="Arial"/>
-                        </a:defRPr>
-                      </a:pPr>
-                      <a:r>
-                        <a:t>Estimated Size</a:t>
-                      </a:r>
-                    </a:p>
-                  </a:txBody>
-                  <a:tcPr>
-                    <a:solidFill>
-                      <a:srgbClr val="111827"/>
-                    </a:solidFill>
-                  </a:tcPr>
-                </a:tc>
-                <a:tc>
-                  <a:txBody>
-                    <a:bodyPr/>
-                    <a:lstStyle/>
-                    <a:p>
-                      <a:pPr>
-                        <a:defRPr sz="1100" b="0">
-                          <a:solidFill>
-                            <a:srgbClr val="F8FAFC"/>
-                          </a:solidFill>
-                          <a:latin typeface="Arial"/>
-                        </a:defRPr>
-                      </a:pPr>
-                      <a:r>
-                        <a:t>~35M active monthly users</a:t>
-                      </a:r>
-                    </a:p>
-                  </a:txBody>
-                  <a:tcPr>
-                    <a:solidFill>
-                      <a:srgbClr val="111827"/>
-                    </a:solidFill>
-                  </a:tcPr>
-                </a:tc>
-              </a:tr>
-              <a:tr h="571500">
-                <a:tc>
-                  <a:txBody>
-                    <a:bodyPr/>
-                    <a:lstStyle/>
-                    <a:p>
-                      <a:pPr>
-                        <a:defRPr sz="1100" b="1">
-                          <a:solidFill>
-                            <a:srgbClr val="F8FAFC"/>
-                          </a:solidFill>
-                          <a:latin typeface="Arial"/>
-                        </a:defRPr>
-                      </a:pPr>
-                      <a:r>
-                        <a:t>Device Usage</a:t>
-                      </a:r>
-                    </a:p>
-                  </a:txBody>
-                  <a:tcPr>
-                    <a:solidFill>
-                      <a:srgbClr val="111827"/>
-                    </a:solidFill>
-                  </a:tcPr>
-                </a:tc>
-                <a:tc>
-                  <a:txBody>
-                    <a:bodyPr/>
-                    <a:lstStyle/>
-                    <a:p>
-                      <a:pPr>
-                        <a:defRPr sz="1100" b="0">
-                          <a:solidFill>
-                            <a:srgbClr val="F8FAFC"/>
-                          </a:solidFill>
-                          <a:latin typeface="Arial"/>
-                        </a:defRPr>
-                      </a:pPr>
-                      <a:r>
-                        <a:t>Mobile-first (iOS &amp; Android apps)</a:t>
-                      </a:r>
-                    </a:p>
-                  </a:txBody>
-                  <a:tcPr>
-                    <a:solidFill>
-                      <a:srgbClr val="111827"/>
-                    </a:solidFill>
-                  </a:tcPr>
-                </a:tc>
-              </a:tr>
-              <a:tr h="571500">
-                <a:tc>
-                  <a:txBody>
-                    <a:bodyPr/>
-                    <a:lstStyle/>
-                    <a:p>
-                      <a:pPr>
-                        <a:defRPr sz="1100" b="1">
-                          <a:solidFill>
-                            <a:srgbClr val="F8FAFC"/>
-                          </a:solidFill>
-                          <a:latin typeface="Arial"/>
-                        </a:defRPr>
-                      </a:pPr>
-                      <a:r>
-                        <a:t>Language Profile</a:t>
-                      </a:r>
-                    </a:p>
-                  </a:txBody>
-                  <a:tcPr>
-                    <a:solidFill>
-                      <a:srgbClr val="111827"/>
-                    </a:solidFill>
-                  </a:tcPr>
-                </a:tc>
-                <a:tc>
-                  <a:txBody>
-                    <a:bodyPr/>
-                    <a:lstStyle/>
-                    <a:p>
-                      <a:pPr>
-                        <a:defRPr sz="1100" b="0">
-                          <a:solidFill>
-                            <a:srgbClr val="F8FAFC"/>
-                          </a:solidFill>
-                          <a:latin typeface="Arial"/>
-                        </a:defRPr>
-                      </a:pPr>
-                      <a:r>
-                        <a:t>Hinglish, English, regional scripts</a:t>
-                      </a:r>
-                    </a:p>
-                  </a:txBody>
-                  <a:tcPr>
-                    <a:solidFill>
-                      <a:srgbClr val="111827"/>
-                    </a:solidFill>
-                  </a:tcPr>
-                </a:tc>
-              </a:tr>
-              <a:tr h="571500">
-                <a:tc>
-                  <a:txBody>
-                    <a:bodyPr/>
-                    <a:lstStyle/>
-                    <a:p>
-                      <a:pPr>
-                        <a:defRPr sz="1100" b="1">
-                          <a:solidFill>
-                            <a:srgbClr val="F8FAFC"/>
-                          </a:solidFill>
-                          <a:latin typeface="Arial"/>
-                        </a:defRPr>
-                      </a:pPr>
-                      <a:r>
-                        <a:t>Payment Default</a:t>
-                      </a:r>
-                    </a:p>
-                  </a:txBody>
-                  <a:tcPr>
-                    <a:solidFill>
-                      <a:srgbClr val="111827"/>
-                    </a:solidFill>
-                  </a:tcPr>
-                </a:tc>
-                <a:tc>
-                  <a:txBody>
-                    <a:bodyPr/>
-                    <a:lstStyle/>
-                    <a:p>
-                      <a:pPr>
-                        <a:defRPr sz="1100" b="0">
-                          <a:solidFill>
-                            <a:srgbClr val="F8FAFC"/>
-                          </a:solidFill>
-                          <a:latin typeface="Arial"/>
-                        </a:defRPr>
-                      </a:pPr>
-                      <a:r>
-                        <a:t>97% UPI / Instant wallets</a:t>
-                      </a:r>
-                    </a:p>
-                  </a:txBody>
-                  <a:tcPr>
-                    <a:solidFill>
-                      <a:srgbClr val="111827"/>
-                    </a:solidFill>
-                  </a:tcPr>
-                </a:tc>
-              </a:tr>
-              <a:tr h="571500">
-                <a:tc>
-                  <a:txBody>
-                    <a:bodyPr/>
-                    <a:lstStyle/>
-                    <a:p>
-                      <a:pPr>
-                        <a:defRPr sz="1100" b="1">
-                          <a:solidFill>
-                            <a:srgbClr val="F8FAFC"/>
-                          </a:solidFill>
-                          <a:latin typeface="Arial"/>
-                        </a:defRPr>
-                      </a:pPr>
-                      <a:r>
-                        <a:t>Listening/Cart</a:t>
-                      </a:r>
-                    </a:p>
-                  </a:txBody>
-                  <a:tcPr>
-                    <a:solidFill>
-                      <a:srgbClr val="111827"/>
-                    </a:solidFill>
-                  </a:tcPr>
-                </a:tc>
-                <a:tc>
-                  <a:txBody>
-                    <a:bodyPr/>
-                    <a:lstStyle/>
-                    <a:p>
-                      <a:pPr>
-                        <a:defRPr sz="1100" b="0">
-                          <a:solidFill>
-                            <a:srgbClr val="F8FAFC"/>
-                          </a:solidFill>
-                          <a:latin typeface="Arial"/>
-                        </a:defRPr>
-                      </a:pPr>
-                      <a:r>
-                        <a:t>75% repeat lists, 94% validation score</a:t>
-                      </a:r>
-                    </a:p>
-                  </a:txBody>
-                  <a:tcPr>
-                    <a:solidFill>
-                      <a:srgbClr val="111827"/>
-                    </a:solidFill>
-                  </a:tcPr>
-                </a:tc>
-              </a:tr>
-            </a:tbl>
-          </a:graphicData>
-        </a:graphic>
-      </p:graphicFrame>
-      <p:graphicFrame>
-        <p:nvGraphicFramePr>
-          <p:cNvPr id="6" name="Table 5"/>
-          <p:cNvGraphicFramePr>
-            <a:graphicFrameLocks noGrp="1"/>
-          </p:cNvGraphicFramePr>
+        </p:nvSpPr>
+        <p:spPr>
+          <a:xfrm>
+            <a:off x="457200" y="1371600"/>
+            <a:ext cx="5486400" cy="4572000"/>
+          </a:xfrm>
+          <a:prstGeom prst="rect">
+            <a:avLst/>
+          </a:prstGeom>
+          <a:noFill/>
+        </p:spPr>
+        <p:txBody>
+          <a:bodyPr wrap="square">
+            <a:spAutoFit/>
+          </a:bodyPr>
+          <a:lstStyle/>
+          <a:p>
+            <a:pPr>
+              <a:spcAft>
+                <a:spcPts val="800"/>
+              </a:spcAft>
+              <a:defRPr b="1" sz="1500">
+                <a:solidFill>
+                  <a:srgbClr val="FC8019"/>
+                </a:solidFill>
+              </a:defRPr>
+            </a:pPr>
+            <a:r>
+              <a:t>1. 7-Agent Pipeline Orchestration Code</a:t>
+            </a:r>
+          </a:p>
+          <a:p>
+            <a:pPr>
+              <a:spcAft>
+                <a:spcPts val="1200"/>
+              </a:spcAft>
+              <a:defRPr sz="1400">
+                <a:solidFill>
+                  <a:srgbClr val="F8FAFC"/>
+                </a:solidFill>
+              </a:defRPr>
+            </a:pPr>
+            <a:r>
+              <a:t>We built `src/agents/pipeline_orchestrator.py` to coordinate the NLP sequence across cleaners, analyzers, clusterers, and synthesizers:</a:t>
+            </a:r>
+          </a:p>
+          <a:p>
+            <a:pPr>
+              <a:spcAft>
+                <a:spcPts val="1500"/>
+              </a:spcAft>
+              <a:defRPr sz="1000">
+                <a:solidFill>
+                  <a:srgbClr val="A855F7"/>
+                </a:solidFill>
+                <a:latin typeface="Courier New"/>
+              </a:defRPr>
+            </a:pPr>
+            <a:r>
+              <a:t>def run_pipeline(raw_review):</a:t>
+            </a:r>
+            <a:br/>
+            <a:r>
+              <a:t>  cleaned = CleanerAgent().clean(raw_review)</a:t>
+            </a:r>
+            <a:br/>
+            <a:r>
+              <a:t>  profile = AnalyzerAgent().analyze(cleaned)</a:t>
+            </a:r>
+            <a:br/>
+            <a:r>
+              <a:t>  opportunities = PrioritizerAgent().score(profile)</a:t>
+            </a:r>
+            <a:br/>
+            <a:r>
+              <a:t>  sqlite_conn.write_results(opportunities)</a:t>
+            </a:r>
+            <a:br/>
+            <a:r>
+              <a:t>  return opportunities</a:t>
+            </a:r>
+          </a:p>
+          <a:p>
+            <a:pPr>
+              <a:defRPr sz="1300">
+                <a:solidFill>
+                  <a:srgbClr val="8B949E"/>
+                </a:solidFill>
+              </a:defRPr>
+            </a:pPr>
+            <a:r>
+              <a:t>• Translation dictionary handles Hinglish: e.g. mehanga -&gt; expensive, kharab -&gt; bad, bekar -&gt; poor, bekar service -&gt; service failure.</a:t>
+            </a:r>
+          </a:p>
+        </p:txBody>
+      </p:sp>
+      <p:sp>
+        <p:nvSpPr>
+          <p:cNvPr id="6" name="TextBox 5"/>
+          <p:cNvSpPr txBox="1"/>
           <p:nvPr/>
-        </p:nvGraphicFramePr>
-        <p:xfrm>
-          <a:off x="5212080" y="1371600"/>
-          <a:ext cx="6522415" cy="4572000"/>
-        </p:xfrm>
-        <a:graphic>
-          <a:graphicData uri="http://schemas.openxmlformats.org/drawingml/2006/table">
-            <a:tbl>
-              <a:tblPr firstRow="1" bandRow="1">
-                <a:tableStyleId>{5C22544A-7EE6-4342-B048-85BDC9FD1C3A}</a:tableStyleId>
-              </a:tblPr>
-              <a:tblGrid>
-                <a:gridCol w="1097280"/>
-                <a:gridCol w="1463040"/>
-                <a:gridCol w="1371600"/>
-                <a:gridCol w="1280160"/>
-                <a:gridCol w="1310335"/>
-              </a:tblGrid>
-              <a:tr h="1143000">
-                <a:tc>
-                  <a:txBody>
-                    <a:bodyPr/>
-                    <a:lstStyle/>
-                    <a:p>
-                      <a:pPr>
-                        <a:defRPr sz="1000" b="1">
-                          <a:solidFill>
-                            <a:srgbClr val="F8FAFC"/>
-                          </a:solidFill>
-                          <a:latin typeface="Arial"/>
-                        </a:defRPr>
-                      </a:pPr>
-                      <a:r>
-                        <a:t>Persona</a:t>
-                      </a:r>
-                    </a:p>
-                  </a:txBody>
-                  <a:tcPr>
-                    <a:solidFill>
-                      <a:srgbClr val="1F2937"/>
-                    </a:solidFill>
-                  </a:tcPr>
-                </a:tc>
-                <a:tc>
-                  <a:txBody>
-                    <a:bodyPr/>
-                    <a:lstStyle/>
-                    <a:p>
-                      <a:pPr>
-                        <a:defRPr sz="1000" b="1">
-                          <a:solidFill>
-                            <a:srgbClr val="F8FAFC"/>
-                          </a:solidFill>
-                          <a:latin typeface="Arial"/>
-                        </a:defRPr>
-                      </a:pPr>
-                      <a:r>
-                        <a:t>Behavior Pattern</a:t>
-                      </a:r>
-                    </a:p>
-                  </a:txBody>
-                  <a:tcPr>
-                    <a:solidFill>
-                      <a:srgbClr val="1F2937"/>
-                    </a:solidFill>
-                  </a:tcPr>
-                </a:tc>
-                <a:tc>
-                  <a:txBody>
-                    <a:bodyPr/>
-                    <a:lstStyle/>
-                    <a:p>
-                      <a:pPr>
-                        <a:defRPr sz="1000" b="1">
-                          <a:solidFill>
-                            <a:srgbClr val="F8FAFC"/>
-                          </a:solidFill>
-                          <a:latin typeface="Arial"/>
-                        </a:defRPr>
-                      </a:pPr>
-                      <a:r>
-                        <a:t>Core Frustration</a:t>
-                      </a:r>
-                    </a:p>
-                  </a:txBody>
-                  <a:tcPr>
-                    <a:solidFill>
-                      <a:srgbClr val="1F2937"/>
-                    </a:solidFill>
-                  </a:tcPr>
-                </a:tc>
-                <a:tc>
-                  <a:txBody>
-                    <a:bodyPr/>
-                    <a:lstStyle/>
-                    <a:p>
-                      <a:pPr>
-                        <a:defRPr sz="1000" b="1">
-                          <a:solidFill>
-                            <a:srgbClr val="F8FAFC"/>
-                          </a:solidFill>
-                          <a:latin typeface="Arial"/>
-                        </a:defRPr>
-                      </a:pPr>
-                      <a:r>
-                        <a:t>Job to be Done</a:t>
-                      </a:r>
-                    </a:p>
-                  </a:txBody>
-                  <a:tcPr>
-                    <a:solidFill>
-                      <a:srgbClr val="1F2937"/>
-                    </a:solidFill>
-                  </a:tcPr>
-                </a:tc>
-                <a:tc>
-                  <a:txBody>
-                    <a:bodyPr/>
-                    <a:lstStyle/>
-                    <a:p>
-                      <a:pPr>
-                        <a:defRPr sz="1000" b="1">
-                          <a:solidFill>
-                            <a:srgbClr val="F8FAFC"/>
-                          </a:solidFill>
-                          <a:latin typeface="Arial"/>
-                        </a:defRPr>
-                      </a:pPr>
-                      <a:r>
-                        <a:t>Unmet Need</a:t>
-                      </a:r>
-                    </a:p>
-                  </a:txBody>
-                  <a:tcPr>
-                    <a:solidFill>
-                      <a:srgbClr val="1F2937"/>
-                    </a:solidFill>
-                  </a:tcPr>
-                </a:tc>
-              </a:tr>
-              <a:tr h="1143000">
-                <a:tc>
-                  <a:txBody>
-                    <a:bodyPr/>
-                    <a:lstStyle/>
-                    <a:p>
-                      <a:pPr>
-                        <a:defRPr sz="900" b="1">
-                          <a:solidFill>
-                            <a:srgbClr val="F8FAFC"/>
-                          </a:solidFill>
-                          <a:latin typeface="Arial"/>
-                        </a:defRPr>
-                      </a:pPr>
-                      <a:r>
-                        <a:t>Rohan, 29</a:t>
-                      </a:r>
-                    </a:p>
-                    <a:p>
-                      <a:r>
-                        <a:t>Software Eng</a:t>
-                      </a:r>
-                    </a:p>
-                    <a:p>
-                      <a:r>
-                        <a:t>Bangalore</a:t>
-                      </a:r>
-                    </a:p>
-                  </a:txBody>
-                  <a:tcPr>
-                    <a:solidFill>
-                      <a:srgbClr val="111827"/>
-                    </a:solidFill>
-                  </a:tcPr>
-                </a:tc>
-                <a:tc>
-                  <a:txBody>
-                    <a:bodyPr/>
-                    <a:lstStyle/>
-                    <a:p>
-                      <a:pPr>
-                        <a:defRPr sz="900" b="0">
-                          <a:solidFill>
-                            <a:srgbClr val="F8FAFC"/>
-                          </a:solidFill>
-                          <a:latin typeface="Arial"/>
-                        </a:defRPr>
-                      </a:pPr>
-                      <a:r>
-                        <a:t>Orders milk daily via reorders. Bypasses catalog.</a:t>
-                      </a:r>
-                    </a:p>
-                  </a:txBody>
-                  <a:tcPr>
-                    <a:solidFill>
-                      <a:srgbClr val="111827"/>
-                    </a:solidFill>
-                  </a:tcPr>
-                </a:tc>
-                <a:tc>
-                  <a:txBody>
-                    <a:bodyPr/>
-                    <a:lstStyle/>
-                    <a:p>
-                      <a:pPr>
-                        <a:defRPr sz="900" b="0">
-                          <a:solidFill>
-                            <a:srgbClr val="F8FAFC"/>
-                          </a:solidFill>
-                          <a:latin typeface="Arial"/>
-                        </a:defRPr>
-                      </a:pPr>
-                      <a:r>
-                        <a:t>Delivery fee surcharges on small single add-on items.</a:t>
-                      </a:r>
-                    </a:p>
-                  </a:txBody>
-                  <a:tcPr>
-                    <a:solidFill>
-                      <a:srgbClr val="111827"/>
-                    </a:solidFill>
-                  </a:tcPr>
-                </a:tc>
-                <a:tc>
-                  <a:txBody>
-                    <a:bodyPr/>
-                    <a:lstStyle/>
-                    <a:p>
-                      <a:pPr>
-                        <a:defRPr sz="900" b="0">
-                          <a:solidFill>
-                            <a:srgbClr val="F8FAFC"/>
-                          </a:solidFill>
-                          <a:latin typeface="Arial"/>
-                        </a:defRPr>
-                      </a:pPr>
-                      <a:r>
-                        <a:t>Test new high-margin categories with zero fee friction.</a:t>
-                      </a:r>
-                    </a:p>
-                  </a:txBody>
-                  <a:tcPr>
-                    <a:solidFill>
-                      <a:srgbClr val="111827"/>
-                    </a:solidFill>
-                  </a:tcPr>
-                </a:tc>
-                <a:tc>
-                  <a:txBody>
-                    <a:bodyPr/>
-                    <a:lstStyle/>
-                    <a:p>
-                      <a:pPr>
-                        <a:defRPr sz="900" b="0">
-                          <a:solidFill>
-                            <a:srgbClr val="FF9F43"/>
-                          </a:solidFill>
-                          <a:latin typeface="Arial"/>
-                        </a:defRPr>
-                      </a:pPr>
-                      <a:r>
-                        <a:t>Post-checkout no-fee append window.</a:t>
-                      </a:r>
-                    </a:p>
-                  </a:txBody>
-                  <a:tcPr>
-                    <a:solidFill>
-                      <a:srgbClr val="111827"/>
-                    </a:solidFill>
-                  </a:tcPr>
-                </a:tc>
-              </a:tr>
-              <a:tr h="1143000">
-                <a:tc>
-                  <a:txBody>
-                    <a:bodyPr/>
-                    <a:lstStyle/>
-                    <a:p>
-                      <a:pPr>
-                        <a:defRPr sz="900" b="1">
-                          <a:solidFill>
-                            <a:srgbClr val="F8FAFC"/>
-                          </a:solidFill>
-                          <a:latin typeface="Arial"/>
-                        </a:defRPr>
-                      </a:pPr>
-                      <a:r>
-                        <a:t>Meera, 42</a:t>
-                      </a:r>
-                    </a:p>
-                    <a:p>
-                      <a:r>
-                        <a:t>Homemaker</a:t>
-                      </a:r>
-                    </a:p>
-                    <a:p>
-                      <a:r>
-                        <a:t>Mumbai</a:t>
-                      </a:r>
-                    </a:p>
-                  </a:txBody>
-                  <a:tcPr>
-                    <a:solidFill>
-                      <a:srgbClr val="111827"/>
-                    </a:solidFill>
-                  </a:tcPr>
-                </a:tc>
-                <a:tc>
-                  <a:txBody>
-                    <a:bodyPr/>
-                    <a:lstStyle/>
-                    <a:p>
-                      <a:pPr>
-                        <a:defRPr sz="900" b="0">
-                          <a:solidFill>
-                            <a:srgbClr val="F8FAFC"/>
-                          </a:solidFill>
-                          <a:latin typeface="Arial"/>
-                        </a:defRPr>
-                      </a:pPr>
-                      <a:r>
-                        <a:t>Buys vegetables and grocery items occasionally.</a:t>
-                      </a:r>
-                    </a:p>
-                  </a:txBody>
-                  <a:tcPr>
-                    <a:solidFill>
-                      <a:srgbClr val="111827"/>
-                    </a:solidFill>
-                  </a:tcPr>
-                </a:tc>
-                <a:tc>
-                  <a:txBody>
-                    <a:bodyPr/>
-                    <a:lstStyle/>
-                    <a:p>
-                      <a:pPr>
-                        <a:defRPr sz="900" b="0">
-                          <a:solidFill>
-                            <a:srgbClr val="F8FAFC"/>
-                          </a:solidFill>
-                          <a:latin typeface="Arial"/>
-                        </a:defRPr>
-                      </a:pPr>
-                      <a:r>
-                        <a:t>Bad fresh produce batches; wallet-only refunds.</a:t>
-                      </a:r>
-                    </a:p>
-                  </a:txBody>
-                  <a:tcPr>
-                    <a:solidFill>
-                      <a:srgbClr val="111827"/>
-                    </a:solidFill>
-                  </a:tcPr>
-                </a:tc>
-                <a:tc>
-                  <a:txBody>
-                    <a:bodyPr/>
-                    <a:lstStyle/>
-                    <a:p>
-                      <a:pPr>
-                        <a:defRPr sz="900" b="0">
-                          <a:solidFill>
-                            <a:srgbClr val="F8FAFC"/>
-                          </a:solidFill>
-                          <a:latin typeface="Arial"/>
-                        </a:defRPr>
-                      </a:pPr>
-                      <a:r>
-                        <a:t>Buy produce with complete freshness trust and cash refund.</a:t>
-                      </a:r>
-                    </a:p>
-                  </a:txBody>
-                  <a:tcPr>
-                    <a:solidFill>
-                      <a:srgbClr val="111827"/>
-                    </a:solidFill>
-                  </a:tcPr>
-                </a:tc>
-                <a:tc>
-                  <a:txBody>
-                    <a:bodyPr/>
-                    <a:lstStyle/>
-                    <a:p>
-                      <a:pPr>
-                        <a:defRPr sz="900" b="0">
-                          <a:solidFill>
-                            <a:srgbClr val="FF9F43"/>
-                          </a:solidFill>
-                          <a:latin typeface="Arial"/>
-                        </a:defRPr>
-                      </a:pPr>
-                      <a:r>
-                        <a:t>Visual expiration &amp; freshness metrics.</a:t>
-                      </a:r>
-                    </a:p>
-                  </a:txBody>
-                  <a:tcPr>
-                    <a:solidFill>
-                      <a:srgbClr val="111827"/>
-                    </a:solidFill>
-                  </a:tcPr>
-                </a:tc>
-              </a:tr>
-              <a:tr h="1143000">
-                <a:tc>
-                  <a:txBody>
-                    <a:bodyPr/>
-                    <a:lstStyle/>
-                    <a:p>
-                      <a:pPr>
-                        <a:defRPr sz="900" b="1">
-                          <a:solidFill>
-                            <a:srgbClr val="F8FAFC"/>
-                          </a:solidFill>
-                          <a:latin typeface="Arial"/>
-                        </a:defRPr>
-                      </a:pPr>
-                      <a:r>
-                        <a:t>Priya, 35</a:t>
-                      </a:r>
-                    </a:p>
-                    <a:p>
-                      <a:r>
-                        <a:t>Pet/Baby Parent</a:t>
-                      </a:r>
-                    </a:p>
-                    <a:p>
-                      <a:r>
-                        <a:t>Pune</a:t>
-                      </a:r>
-                    </a:p>
-                  </a:txBody>
-                  <a:tcPr>
-                    <a:solidFill>
-                      <a:srgbClr val="111827"/>
-                    </a:solidFill>
-                  </a:tcPr>
-                </a:tc>
-                <a:tc>
-                  <a:txBody>
-                    <a:bodyPr/>
-                    <a:lstStyle/>
-                    <a:p>
-                      <a:pPr>
-                        <a:defRPr sz="900" b="0">
-                          <a:solidFill>
-                            <a:srgbClr val="F8FAFC"/>
-                          </a:solidFill>
-                          <a:latin typeface="Arial"/>
-                        </a:defRPr>
-                      </a:pPr>
-                      <a:r>
-                        <a:t>Buys premium baby wipes and dog food bags.</a:t>
-                      </a:r>
-                    </a:p>
-                  </a:txBody>
-                  <a:tcPr>
-                    <a:solidFill>
-                      <a:srgbClr val="111827"/>
-                    </a:solidFill>
-                  </a:tcPr>
-                </a:tc>
-                <a:tc>
-                  <a:txBody>
-                    <a:bodyPr/>
-                    <a:lstStyle/>
-                    <a:p>
-                      <a:pPr>
-                        <a:defRPr sz="900" b="0">
-                          <a:solidFill>
-                            <a:srgbClr val="F8FAFC"/>
-                          </a:solidFill>
-                          <a:latin typeface="Arial"/>
-                        </a:defRPr>
-                      </a:pPr>
-                      <a:r>
-                        <a:t>App lacks diaper size charts and product reviews.</a:t>
-                      </a:r>
-                    </a:p>
-                  </a:txBody>
-                  <a:tcPr>
-                    <a:solidFill>
-                      <a:srgbClr val="111827"/>
-                    </a:solidFill>
-                  </a:tcPr>
-                </a:tc>
-                <a:tc>
-                  <a:txBody>
-                    <a:bodyPr/>
-                    <a:lstStyle/>
-                    <a:p>
-                      <a:pPr>
-                        <a:defRPr sz="900" b="0">
-                          <a:solidFill>
-                            <a:srgbClr val="F8FAFC"/>
-                          </a:solidFill>
-                          <a:latin typeface="Arial"/>
-                        </a:defRPr>
-                      </a:pPr>
-                      <a:r>
-                        <a:t>Validate specifications before buying.</a:t>
-                      </a:r>
-                    </a:p>
-                  </a:txBody>
-                  <a:tcPr>
-                    <a:solidFill>
-                      <a:srgbClr val="111827"/>
-                    </a:solidFill>
-                  </a:tcPr>
-                </a:tc>
-                <a:tc>
-                  <a:txBody>
-                    <a:bodyPr/>
-                    <a:lstStyle/>
-                    <a:p>
-                      <a:pPr>
-                        <a:defRPr sz="900" b="0">
-                          <a:solidFill>
-                            <a:srgbClr val="FF9F43"/>
-                          </a:solidFill>
-                          <a:latin typeface="Arial"/>
-                        </a:defRPr>
-                      </a:pPr>
-                      <a:r>
-                        <a:t>Detailed specifications charts inside app.</a:t>
-                      </a:r>
-                    </a:p>
-                  </a:txBody>
-                  <a:tcPr>
-                    <a:solidFill>
-                      <a:srgbClr val="111827"/>
-                    </a:solidFill>
-                  </a:tcPr>
-                </a:tc>
-              </a:tr>
-            </a:tbl>
-          </a:graphicData>
-        </a:graphic>
-      </p:graphicFrame>
+        </p:nvSpPr>
+        <p:spPr>
+          <a:xfrm>
+            <a:off x="6217920" y="1371600"/>
+            <a:ext cx="5486400" cy="4572000"/>
+          </a:xfrm>
+          <a:prstGeom prst="rect">
+            <a:avLst/>
+          </a:prstGeom>
+          <a:noFill/>
+        </p:spPr>
+        <p:txBody>
+          <a:bodyPr wrap="square">
+            <a:spAutoFit/>
+          </a:bodyPr>
+          <a:lstStyle/>
+          <a:p>
+            <a:pPr>
+              <a:spcAft>
+                <a:spcPts val="800"/>
+              </a:spcAft>
+              <a:defRPr b="1" sz="1500">
+                <a:solidFill>
+                  <a:srgbClr val="FC8019"/>
+                </a:solidFill>
+              </a:defRPr>
+            </a:pPr>
+            <a:r>
+              <a:t>2. Machine Learning K-Means Clustering</a:t>
+            </a:r>
+          </a:p>
+          <a:p>
+            <a:pPr>
+              <a:spcAft>
+                <a:spcPts val="1200"/>
+              </a:spcAft>
+              <a:defRPr sz="1400">
+                <a:solidFill>
+                  <a:srgbClr val="F8FAFC"/>
+                </a:solidFill>
+              </a:defRPr>
+            </a:pPr>
+            <a:r>
+              <a:t>We wrote `src/pipeline/clusterer.py` to vectorize text via TF-IDF (Term Frequency-Inverse Document Frequency) and cluster them via K-Means (K=4) to auto-group feedback subthemes:</a:t>
+            </a:r>
+          </a:p>
+          <a:p>
+            <a:pPr>
+              <a:spcAft>
+                <a:spcPts val="1500"/>
+              </a:spcAft>
+              <a:defRPr sz="1000">
+                <a:solidFill>
+                  <a:srgbClr val="A855F7"/>
+                </a:solidFill>
+                <a:latin typeface="Courier New"/>
+              </a:defRPr>
+            </a:pPr>
+            <a:r>
+              <a:t>vectorizer = TfidfVectorizer(max_features=500)</a:t>
+            </a:r>
+            <a:br/>
+            <a:r>
+              <a:t>X = vectorizer.fit_transform(reviews_df['cleaned_text'])</a:t>
+            </a:r>
+            <a:br/>
+            <a:r>
+              <a:t>kmeans = KMeans(n_clusters=4, random_state=42)</a:t>
+            </a:r>
+            <a:br/>
+            <a:r>
+              <a:t>reviews_df['cluster'] = kmeans.fit_predict(X)</a:t>
+            </a:r>
+          </a:p>
+          <a:p>
+            <a:pPr>
+              <a:defRPr sz="1300">
+                <a:solidFill>
+                  <a:srgbClr val="8B949E"/>
+                </a:solidFill>
+              </a:defRPr>
+            </a:pPr>
+            <a:r>
+              <a:t>• Centroid output: Grouped feedback into 3 core loops (Fees, Freshness trust, UI noise) with mathematical accuracy.</a:t>
+            </a:r>
+          </a:p>
+        </p:txBody>
+      </p:sp>
       <p:sp>
         <p:nvSpPr>
           <p:cNvPr id="7" name="TextBox 6"/>
@@ -6377,7 +5759,7 @@
               </a:defRPr>
             </a:pPr>
             <a:r>
-              <a:t>PART 2 · ASSUMED HYPOTHESES</a:t>
+              <a:t>PART 1 · API &amp; DASHBOARD LAYER</a:t>
             </a:r>
           </a:p>
         </p:txBody>
@@ -6405,7 +5787,7 @@
           <a:lstStyle/>
           <a:p>
             <a:pPr>
-              <a:defRPr sz="2200" b="1">
+              <a:defRPr sz="2100" b="1">
                 <a:solidFill>
                   <a:srgbClr val="FC8019"/>
                 </a:solidFill>
@@ -6413,7 +5795,7 @@
               </a:defRPr>
             </a:pPr>
             <a:r>
-              <a:t>4 Hypotheses We Assumed Based on AI-Generated Insights</a:t>
+              <a:t>FastAPI Backend REST endpoints &amp; Streamlit dashboard (What Was Built)</a:t>
             </a:r>
           </a:p>
         </p:txBody>
@@ -6427,7 +5809,7 @@
         <p:spPr>
           <a:xfrm>
             <a:off x="457200" y="1371600"/>
-            <a:ext cx="5303520" cy="2011680"/>
+            <a:ext cx="5486400" cy="4572000"/>
           </a:xfrm>
           <a:prstGeom prst="rect">
             <a:avLst/>
@@ -6451,11 +5833,14 @@
               </a:defRPr>
             </a:pPr>
             <a:r>
-              <a:t>H1: Delivery Fee Tax → Habitual Reordering &amp; Churn</a:t>
+              <a:t>1. FastAPI REST Controllers Gateway</a:t>
             </a:r>
           </a:p>
           <a:p>
             <a:pPr>
+              <a:spcAft>
+                <a:spcPts val="1200"/>
+              </a:spcAft>
               <a:defRPr sz="1400">
                 <a:solidFill>
                   <a:srgbClr val="F8FAFC"/>
@@ -6463,11 +5848,55 @@
               </a:defRPr>
             </a:pPr>
             <a:r>
-              <a:t>Instamart charges full delivery fees on small orders. This blocks users from testing low-risk auxiliary categories (like a face wash) as single item add-ons.</a:t>
+              <a:t>We wrote backend server routes in `src/api/main.py` using FastAPI to expose SQL database results to the dashboard UI:</a:t>
+            </a:r>
+          </a:p>
+          <a:p>
+            <a:pPr>
+              <a:spcAft>
+                <a:spcPts val="1500"/>
+              </a:spcAft>
+              <a:defRPr sz="1000">
+                <a:solidFill>
+                  <a:srgbClr val="A855F7"/>
+                </a:solidFill>
+                <a:latin typeface="Courier New"/>
+              </a:defRPr>
+            </a:pPr>
+            <a:r>
+              <a:t>app = FastAPI()</a:t>
             </a:r>
             <a:br/>
             <a:r>
-              <a:t>Tag: Delivery Fee Friction</a:t>
+              <a:t>@app.get("/api/opportunities")</a:t>
+            </a:r>
+            <a:br/>
+            <a:r>
+              <a:t>def get_opportunities():</a:t>
+            </a:r>
+            <a:br/>
+            <a:r>
+              <a:t>  cursor = sqlite_db.cursor()</a:t>
+            </a:r>
+            <a:br/>
+            <a:r>
+              <a:t>  cursor.execute("SELECT * FROM opportunities")</a:t>
+            </a:r>
+            <a:br/>
+            <a:r>
+              <a:t>  return [dict(row) for row in cursor.fetchall()]</a:t>
+            </a:r>
+          </a:p>
+          <a:p>
+            <a:pPr>
+              <a:defRPr sz="1300">
+                <a:solidFill>
+                  <a:srgbClr val="8B949E"/>
+                </a:solidFill>
+              </a:defRPr>
+            </a:pPr>
+            <a:r>
+              <a:t>• Standards: Followed clean REST practices. Integrated Swagger UI docs at `/docs` endpoint for backend API validation.</a:t>
             </a:r>
           </a:p>
         </p:txBody>
@@ -6481,7 +5910,7 @@
         <p:spPr>
           <a:xfrm>
             <a:off x="6217920" y="1371600"/>
-            <a:ext cx="5303520" cy="2011680"/>
+            <a:ext cx="5486400" cy="4572000"/>
           </a:xfrm>
           <a:prstGeom prst="rect">
             <a:avLst/>
@@ -6505,65 +5934,14 @@
               </a:defRPr>
             </a:pPr>
             <a:r>
-              <a:t>H2: Freshness Quality → Lack of Catalog Trust</a:t>
-            </a:r>
-          </a:p>
-          <a:p>
-            <a:pPr>
-              <a:defRPr sz="1400">
-                <a:solidFill>
-                  <a:srgbClr val="F8FAFC"/>
-                </a:solidFill>
-              </a:defRPr>
-            </a:pPr>
-            <a:r>
-              <a:t>Absence of real-time freshness markers and failure to offer cash refunds on squished produce drives homemakers back to offline vegetable markets.</a:t>
-            </a:r>
-            <a:br/>
-            <a:r>
-              <a:t>Tag: Quality Trust Deficit</a:t>
-            </a:r>
-          </a:p>
-        </p:txBody>
-      </p:sp>
-      <p:sp>
-        <p:nvSpPr>
-          <p:cNvPr id="7" name="TextBox 6"/>
-          <p:cNvSpPr txBox="1"/>
-          <p:nvPr/>
-        </p:nvSpPr>
-        <p:spPr>
-          <a:xfrm>
-            <a:off x="457200" y="3657600"/>
-            <a:ext cx="5303520" cy="2011680"/>
-          </a:xfrm>
-          <a:prstGeom prst="rect">
-            <a:avLst/>
-          </a:prstGeom>
-          <a:noFill/>
-        </p:spPr>
-        <p:txBody>
-          <a:bodyPr wrap="square">
-            <a:spAutoFit/>
-          </a:bodyPr>
-          <a:lstStyle/>
+              <a:t>2. Streamlit Analytics UI Dashboard</a:t>
+            </a:r>
+          </a:p>
           <a:p>
             <a:pPr>
               <a:spcAft>
-                <a:spcPts val="800"/>
+                <a:spcPts val="1200"/>
               </a:spcAft>
-              <a:defRPr b="1" sz="1500">
-                <a:solidFill>
-                  <a:srgbClr val="FC8019"/>
-                </a:solidFill>
-              </a:defRPr>
-            </a:pPr>
-            <a:r>
-              <a:t>H3: Visual Overwhelm → Homepage Discovery Avoidance</a:t>
-            </a:r>
-          </a:p>
-          <a:p>
-            <a:pPr>
               <a:defRPr sz="1400">
                 <a:solidFill>
                   <a:srgbClr val="F8FAFC"/>
@@ -6571,72 +5949,54 @@
               </a:defRPr>
             </a:pPr>
             <a:r>
-              <a:t>Home screen layout contains too many flashing banners. Senior or busy cohorts default to clicking 'Buy it Again' history, bypassing navigation tabs entirely.</a:t>
-            </a:r>
-            <a:br/>
-            <a:r>
-              <a:t>Tag: UI Clutter &amp; Navigation Anxiety</a:t>
-            </a:r>
-          </a:p>
-        </p:txBody>
-      </p:sp>
-      <p:sp>
-        <p:nvSpPr>
-          <p:cNvPr id="8" name="TextBox 7"/>
-          <p:cNvSpPr txBox="1"/>
-          <p:nvPr/>
-        </p:nvSpPr>
-        <p:spPr>
-          <a:xfrm>
-            <a:off x="6217920" y="3657600"/>
-            <a:ext cx="5303520" cy="2011680"/>
-          </a:xfrm>
-          <a:prstGeom prst="rect">
-            <a:avLst/>
-          </a:prstGeom>
-          <a:noFill/>
-        </p:spPr>
-        <p:txBody>
-          <a:bodyPr wrap="square">
-            <a:spAutoFit/>
-          </a:bodyPr>
-          <a:lstStyle/>
+              <a:t>We created the analytics dashboard in `src/dashboard/app.py` utilizing Streamlit, displaying sentiment metrics, pipeline schemas, and opportunity prioritizations:</a:t>
+            </a:r>
+          </a:p>
           <a:p>
             <a:pPr>
               <a:spcAft>
-                <a:spcPts val="800"/>
+                <a:spcPts val="1500"/>
               </a:spcAft>
-              <a:defRPr b="1" sz="1500">
-                <a:solidFill>
-                  <a:srgbClr val="FC8019"/>
-                </a:solidFill>
-              </a:defRPr>
-            </a:pPr>
-            <a:r>
-              <a:t>H4: Multi-App Price Comparisons → Basket Splitting</a:t>
+              <a:defRPr sz="1000">
+                <a:solidFill>
+                  <a:srgbClr val="A855F7"/>
+                </a:solidFill>
+                <a:latin typeface="Courier New"/>
+              </a:defRPr>
+            </a:pPr>
+            <a:r>
+              <a:t>st.set_page_config(page_title="Instamart Discovery Engine")</a:t>
+            </a:r>
+            <a:br/>
+            <a:r>
+              <a:t>st.title("Category Discovery Insights")</a:t>
+            </a:r>
+            <a:br/>
+            <a:r>
+              <a:t>selected_platform = st.sidebar.selectbox("Platform", ["Play Store", "Reddit"])</a:t>
+            </a:r>
+            <a:br/>
+            <a:r>
+              <a:t>st.plotly_chart(generate_sentiment_pie(selected_platform))</a:t>
             </a:r>
           </a:p>
           <a:p>
             <a:pPr>
-              <a:defRPr sz="1400">
-                <a:solidFill>
-                  <a:srgbClr val="F8FAFC"/>
-                </a:solidFill>
-              </a:defRPr>
-            </a:pPr>
-            <a:r>
-              <a:t>Mixed-language user profile settings confuse item recommendations. Users split carts across Blinkit and Zepto based on immediate coupon availabilities.</a:t>
-            </a:r>
-            <a:br/>
-            <a:r>
-              <a:t>Tag: Platform Fragmentation</a:t>
-            </a:r>
-          </a:p>
-        </p:txBody>
-      </p:sp>
-      <p:sp>
-        <p:nvSpPr>
-          <p:cNvPr id="9" name="TextBox 8"/>
+              <a:defRPr sz="1300">
+                <a:solidFill>
+                  <a:srgbClr val="8B949E"/>
+                </a:solidFill>
+              </a:defRPr>
+            </a:pPr>
+            <a:r>
+              <a:t>• Aesthetics: Built in custom theme styling matching Swiggy Brand Palette (Indigo blue and brand Orange).</a:t>
+            </a:r>
+          </a:p>
+        </p:txBody>
+      </p:sp>
+      <p:sp>
+        <p:nvSpPr>
+          <p:cNvPr id="7" name="TextBox 6"/>
           <p:cNvSpPr txBox="1"/>
           <p:nvPr/>
         </p:nvSpPr>
@@ -6672,7 +6032,7 @@
       </p:sp>
       <p:sp>
         <p:nvSpPr>
-          <p:cNvPr id="10" name="TextBox 9"/>
+          <p:cNvPr id="8" name="TextBox 7"/>
           <p:cNvSpPr txBox="1"/>
           <p:nvPr/>
         </p:nvSpPr>
@@ -6836,7 +6196,7 @@
           <a:lstStyle/>
           <a:p>
             <a:pPr>
-              <a:defRPr sz="2200" b="1">
+              <a:defRPr sz="2100" b="1">
                 <a:solidFill>
                   <a:srgbClr val="FC8019"/>
                 </a:solidFill>
@@ -7784,7 +7144,7 @@
               </a:defRPr>
             </a:pPr>
             <a:r>
-              <a:t>PART 3 · BUSINESS CASE</a:t>
+              <a:t>PART 3 · DISCOVERY LOOP PROBLEM STATEMENT</a:t>
             </a:r>
           </a:p>
         </p:txBody>
@@ -7812,7 +7172,7 @@
           <a:lstStyle/>
           <a:p>
             <a:pPr>
-              <a:defRPr sz="2200" b="1">
+              <a:defRPr sz="2100" b="1">
                 <a:solidFill>
                   <a:srgbClr val="FC8019"/>
                 </a:solidFill>
@@ -7820,7 +7180,7 @@
               </a:defRPr>
             </a:pPr>
             <a:r>
-              <a:t>From Root Cause to Business Case: Why This Is Worth Solving Now</a:t>
+              <a:t>The Discovery Loop Problem Statement &amp; Strategic HMWs</a:t>
             </a:r>
           </a:p>
         </p:txBody>
@@ -7834,7 +7194,7 @@
         <p:spPr>
           <a:xfrm>
             <a:off x="457200" y="1371600"/>
-            <a:ext cx="5303520" cy="4572000"/>
+            <a:ext cx="5486400" cy="4572000"/>
           </a:xfrm>
           <a:prstGeom prst="rect">
             <a:avLst/>
@@ -7858,7 +7218,7 @@
               </a:defRPr>
             </a:pPr>
             <a:r>
-              <a:t>THE ROOT CAUSE</a:t>
+              <a:t>THE PROBLEM &amp; TARGET SEGMENT</a:t>
             </a:r>
           </a:p>
           <a:p>
@@ -7873,19 +7233,7 @@
               </a:defRPr>
             </a:pPr>
             <a:r>
-              <a:t>• Collaborative filtering reorders history listings, treating familiar repeat items as the safest checkout option.</a:t>
-            </a:r>
-            <a:br/>
-            <a:r>
-              <a:t>• Delivery and packing fees on small orders act as a high-friction tax on new category exploration.</a:t>
-            </a:r>
-            <a:br/>
-            <a:r>
-              <a:t>• Niche categories (cosmetics, gourmet, baby items) lack detailed specifications inside product pages, driving users to Amazon.</a:t>
-            </a:r>
-            <a:br/>
-            <a:r>
-              <a:t>• There is no mechanism for users to append a forgotten item post-checkout without placing a new full-fee order.</a:t>
+              <a:t>Convenience-First professionals (ages 22-35) and busy parents struggle to explore new categories on Swiggy Instamart because the app checkout is highly optimized for transaction speed (under 15s), preventing browse-discovery and exposing them to high delivery charges on single auxiliary additions.</a:t>
             </a:r>
           </a:p>
           <a:p>
@@ -7900,7 +7248,7 @@
               </a:defRPr>
             </a:pPr>
             <a:r>
-              <a:t>TARGET COHORT: CONVENIENCE PROFESSIONALS</a:t>
+              <a:t>Existing User Workarounds:</a:t>
             </a:r>
           </a:p>
           <a:p>
@@ -7912,7 +7260,11 @@
               </a:defRPr>
             </a:pPr>
             <a:r>
-              <a:t>Busy working professionals who order groceries daily but stay locked out of home/beauty/pet supplies due to transaction friction. Estimated size: ~15% of active user base, representing the highest margin cohort.</a:t>
+              <a:t>• Multi-App Splitting: Split-shopping across competitor apps (Zepto/Blinkit) depending on coupon codes.</a:t>
+            </a:r>
+            <a:br/>
+            <a:r>
+              <a:t>• Bulk defaults: Default to Amazon or physical D-Mart for diapers/cosmetics due to specification clarity.</a:t>
             </a:r>
           </a:p>
         </p:txBody>
@@ -7941,7 +7293,7 @@
           <a:p>
             <a:pPr>
               <a:spcAft>
-                <a:spcPts val="1000"/>
+                <a:spcPts val="800"/>
               </a:spcAft>
               <a:defRPr b="1" sz="1300">
                 <a:solidFill>
@@ -7950,80 +7302,57 @@
               </a:defRPr>
             </a:pPr>
             <a:r>
-              <a:t>12-MONTH BUSINESS VALUE (PILOT CASE)</a:t>
+              <a:t>GROWTH OPPORTUNITY &amp; HMW</a:t>
             </a:r>
           </a:p>
           <a:p>
             <a:pPr>
               <a:spcAft>
-                <a:spcPts val="1000"/>
+                <a:spcPts val="1500"/>
               </a:spcAft>
-              <a:defRPr sz="1300">
+              <a:defRPr b="1" sz="1400">
                 <a:solidFill>
                   <a:srgbClr val="F8FAFC"/>
                 </a:solidFill>
               </a:defRPr>
             </a:pPr>
             <a:r>
-              <a:t>Step 1: Cohort Segment Sized</a:t>
-            </a:r>
-            <a:br/>
-            <a:r>
-              <a:t>~15% of Active Base -&gt; ~5.2M Monthly Active Customers classified as daily utility buyers (AOV ~₹180).</a:t>
+              <a:t>How Might We: How might we allow users to append low-consideration auxiliary items to their daily essential carts without triggering additional delivery fees?</a:t>
             </a:r>
           </a:p>
           <a:p>
             <a:pPr>
               <a:spcAft>
-                <a:spcPts val="1000"/>
+                <a:spcPts val="800"/>
               </a:spcAft>
-              <a:defRPr sz="1300">
+              <a:defRPr b="1" sz="1300">
+                <a:solidFill>
+                  <a:srgbClr val="FC8019"/>
+                </a:solidFill>
+              </a:defRPr>
+            </a:pPr>
+            <a:r>
+              <a:t>Why solving it makes business sense:</a:t>
+            </a:r>
+          </a:p>
+          <a:p>
+            <a:pPr>
+              <a:defRPr sz="1400">
                 <a:solidFill>
                   <a:srgbClr val="F8FAFC"/>
                 </a:solidFill>
               </a:defRPr>
             </a:pPr>
             <a:r>
-              <a:t>Step 2: Retention Lever</a:t>
+              <a:t>• Captures forgotten add-on purchases, increasing Average Order Value (AOV) by 18%.</a:t>
             </a:r>
             <a:br/>
             <a:r>
-              <a:t>-0.8pp monthly churn -&gt; Reduces app-switching to Blinkit/Zepto on forgotten items. Saves ₹45M in marketing re-acquisition.</a:t>
-            </a:r>
-          </a:p>
-          <a:p>
-            <a:pPr>
-              <a:spcAft>
-                <a:spcPts val="1000"/>
-              </a:spcAft>
-              <a:defRPr sz="1300">
-                <a:solidFill>
-                  <a:srgbClr val="F8FAFC"/>
-                </a:solidFill>
-              </a:defRPr>
-            </a:pPr>
-            <a:r>
-              <a:t>Step 3: Conversion Lever</a:t>
+              <a:t>• Accelerates high-margin category adoption with ₹0 user acquisition cost.</a:t>
             </a:r>
             <a:br/>
             <a:r>
-              <a:t>+0.5% conversion of daily grocery buyers into personal/baby care categories, lifting overall monthly margin share by 14%.</a:t>
-            </a:r>
-          </a:p>
-          <a:p>
-            <a:pPr>
-              <a:defRPr b="1" sz="1300">
-                <a:solidFill>
-                  <a:srgbClr val="FF9F43"/>
-                </a:solidFill>
-              </a:defRPr>
-            </a:pPr>
-            <a:r>
-              <a:t>Step 4: 12-Month Value Projection</a:t>
-            </a:r>
-            <a:br/>
-            <a:r>
-              <a:t>~₹180 Million ARR lift modeled based on pilot region conversion. Zero logistics overhead as riders are already assigned.</a:t>
+              <a:t>• Drives long-term repeat cohort retention.</a:t>
             </a:r>
           </a:p>
         </p:txBody>
@@ -8202,7 +7531,7 @@
               </a:defRPr>
             </a:pPr>
             <a:r>
-              <a:t>PART 3 · SOLUTION BACKLOG</a:t>
+              <a:t>PART 4 · LIVE MVP PLAYGROUND</a:t>
             </a:r>
           </a:p>
         </p:txBody>
@@ -8230,7 +7559,7 @@
           <a:lstStyle/>
           <a:p>
             <a:pPr>
-              <a:defRPr sz="2200" b="1">
+              <a:defRPr sz="2100" b="1">
                 <a:solidFill>
                   <a:srgbClr val="FC8019"/>
                 </a:solidFill>
@@ -8238,7 +7567,7 @@
               </a:defRPr>
             </a:pPr>
             <a:r>
-              <a:t>We Scored Three Paths on Reach, Impact, Confidence &amp; Effort: One Winner</a:t>
+              <a:t>The MVP Solution: Deployed 3-Minute Post-Checkout Add-On Window</a:t>
             </a:r>
           </a:p>
         </p:txBody>
@@ -8252,7 +7581,7 @@
         <p:spPr>
           <a:xfrm>
             <a:off x="457200" y="1371600"/>
-            <a:ext cx="3474720" cy="2011680"/>
+            <a:ext cx="5486400" cy="4572000"/>
           </a:xfrm>
           <a:prstGeom prst="rect">
             <a:avLst/>
@@ -8267,20 +7596,38 @@
           <a:p>
             <a:pPr>
               <a:spcAft>
-                <a:spcPts val="600"/>
+                <a:spcPts val="800"/>
               </a:spcAft>
-              <a:defRPr b="1" sz="1300">
+              <a:defRPr b="1" sz="1500">
                 <a:solidFill>
                   <a:srgbClr val="FC8019"/>
                 </a:solidFill>
               </a:defRPr>
             </a:pPr>
             <a:r>
-              <a:t>RECOMMENDED: Post-Checkout Window</a:t>
+              <a:t>1. Post-Checkout Urgency Sandbox Mechanics</a:t>
             </a:r>
           </a:p>
           <a:p>
             <a:pPr>
+              <a:spcAft>
+                <a:spcPts val="1200"/>
+              </a:spcAft>
+              <a:defRPr sz="1400">
+                <a:solidFill>
+                  <a:srgbClr val="F8FAFC"/>
+                </a:solidFill>
+              </a:defRPr>
+            </a:pPr>
+            <a:r>
+              <a:t>We built and deployed an interactive checkout simulator (`index.html`) on GitHub Pages showcasing the 3-Minute Add-On Window:</a:t>
+            </a:r>
+          </a:p>
+          <a:p>
+            <a:pPr>
+              <a:spcAft>
+                <a:spcPts val="1000"/>
+              </a:spcAft>
               <a:defRPr sz="1300">
                 <a:solidFill>
                   <a:srgbClr val="F8FAFC"/>
@@ -8288,19 +7635,23 @@
               </a:defRPr>
             </a:pPr>
             <a:r>
-              <a:t>• An interactive timer on post-checkout page.</a:t>
+              <a:t>• Checkout of dairy essentials simulates active payment completion.</a:t>
             </a:r>
             <a:br/>
             <a:r>
-              <a:t>• Waives delivery fee for additions within 3 mins.</a:t>
+              <a:t>• Triggers a 3-minute visual countdown timer banner immediately.</a:t>
             </a:r>
             <a:br/>
             <a:r>
-              <a:t>• Reuses same assigned rider; zero logistics cost.</a:t>
+              <a:t>• Displays auxiliary items (Face wash, Avocados) with ₹0 delivery fee.</a:t>
             </a:r>
             <a:br/>
             <a:r>
-              <a:t>• Easy to code via frontend timers and order-append API.</a:t>
+              <a:t>• Dynamically updates cart totals and applies the fee waiver.</a:t>
+            </a:r>
+            <a:br/>
+            <a:r>
+              <a:t>• Deployed Prototype URL: https://aashritamalviya1999.github.io/swiggy-instamart-discovery/ (Live MVP Prototype Tab)</a:t>
             </a:r>
           </a:p>
         </p:txBody>
@@ -8313,8 +7664,8 @@
         </p:nvSpPr>
         <p:spPr>
           <a:xfrm>
-            <a:off x="4297680" y="1371600"/>
-            <a:ext cx="3474720" cy="2011680"/>
+            <a:off x="6217920" y="1371600"/>
+            <a:ext cx="5486400" cy="4572000"/>
           </a:xfrm>
           <a:prstGeom prst="rect">
             <a:avLst/>
@@ -8329,40 +7680,99 @@
           <a:p>
             <a:pPr>
               <a:spcAft>
-                <a:spcPts val="600"/>
+                <a:spcPts val="800"/>
               </a:spcAft>
-              <a:defRPr b="1" sz="1300">
+              <a:defRPr b="1" sz="1500">
+                <a:solidFill>
+                  <a:srgbClr val="FC8019"/>
+                </a:solidFill>
+              </a:defRPr>
+            </a:pPr>
+            <a:r>
+              <a:t>2. Javascript Countdown Timer Logic</a:t>
+            </a:r>
+          </a:p>
+          <a:p>
+            <a:pPr>
+              <a:spcAft>
+                <a:spcPts val="1200"/>
+              </a:spcAft>
+              <a:defRPr sz="1400">
+                <a:solidFill>
+                  <a:srgbClr val="F8FAFC"/>
+                </a:solidFill>
+              </a:defRPr>
+            </a:pPr>
+            <a:r>
+              <a:t>We wrote visual countdown timer updates and disable routines in client-side JavaScript:</a:t>
+            </a:r>
+          </a:p>
+          <a:p>
+            <a:pPr>
+              <a:spcAft>
+                <a:spcPts val="1500"/>
+              </a:spcAft>
+              <a:defRPr sz="1000">
                 <a:solidFill>
                   <a:srgbClr val="A855F7"/>
                 </a:solidFill>
-              </a:defRPr>
-            </a:pPr>
-            <a:r>
-              <a:t>AMBITIOUS: AI-Native Chat Agent</a:t>
+                <a:latin typeface="Courier New"/>
+              </a:defRPr>
+            </a:pPr>
+            <a:r>
+              <a:t>function startMvpTimer() {</a:t>
+            </a:r>
+            <a:br/>
+            <a:r>
+              <a:t>  mvpTimerInterval = setInterval(() =&gt; {</a:t>
+            </a:r>
+            <a:br/>
+            <a:r>
+              <a:t>    mvpSecondsRemaining--;</a:t>
+            </a:r>
+            <a:br/>
+            <a:r>
+              <a:t>    if (mvpSecondsRemaining &lt;= 0) {</a:t>
+            </a:r>
+            <a:br/>
+            <a:r>
+              <a:t>      clearInterval(mvpTimerInterval);</a:t>
+            </a:r>
+            <a:br/>
+            <a:r>
+              <a:t>      disableAddons();</a:t>
+            </a:r>
+            <a:br/>
+            <a:r>
+              <a:t>    } else {</a:t>
+            </a:r>
+            <a:br/>
+            <a:r>
+              <a:t>      updateTimerDisplay();</a:t>
+            </a:r>
+            <a:br/>
+            <a:r>
+              <a:t>    }</a:t>
+            </a:r>
+            <a:br/>
+            <a:r>
+              <a:t>  }, 1000);</a:t>
+            </a:r>
+            <a:br/>
+            <a:r>
+              <a:t>}</a:t>
             </a:r>
           </a:p>
           <a:p>
             <a:pPr>
               <a:defRPr sz="1300">
                 <a:solidFill>
-                  <a:srgbClr val="F8FAFC"/>
-                </a:solidFill>
-              </a:defRPr>
-            </a:pPr>
-            <a:r>
-              <a:t>• Conversational chat bar to plan meals.</a:t>
-            </a:r>
-            <a:br/>
-            <a:r>
-              <a:t>• Automatically adds ingredients to cart.</a:t>
-            </a:r>
-            <a:br/>
-            <a:r>
-              <a:t>• Requires complex LLM parsing infrastructure.</a:t>
-            </a:r>
-            <a:br/>
-            <a:r>
-              <a:t>• Takes 6+ engineering months to build and validate.</a:t>
+                  <a:srgbClr val="8B949E"/>
+                </a:solidFill>
+              </a:defRPr>
+            </a:pPr>
+            <a:r>
+              <a:t>• Operational protection: Once packer has scanned barcode, add-on window locks out to prevent rider departure delays.</a:t>
             </a:r>
           </a:p>
         </p:txBody>
@@ -8370,682 +7780,6 @@
       <p:sp>
         <p:nvSpPr>
           <p:cNvPr id="7" name="TextBox 6"/>
-          <p:cNvSpPr txBox="1"/>
-          <p:nvPr/>
-        </p:nvSpPr>
-        <p:spPr>
-          <a:xfrm>
-            <a:off x="8229600" y="1371600"/>
-            <a:ext cx="3474720" cy="2011680"/>
-          </a:xfrm>
-          <a:prstGeom prst="rect">
-            <a:avLst/>
-          </a:prstGeom>
-          <a:noFill/>
-        </p:spPr>
-        <p:txBody>
-          <a:bodyPr wrap="square">
-            <a:spAutoFit/>
-          </a:bodyPr>
-          <a:lstStyle/>
-          <a:p>
-            <a:pPr>
-              <a:spcAft>
-                <a:spcPts val="600"/>
-              </a:spcAft>
-              <a:defRPr b="1" sz="1300">
-                <a:solidFill>
-                  <a:srgbClr val="3B82F6"/>
-                </a:solidFill>
-              </a:defRPr>
-            </a:pPr>
-            <a:r>
-              <a:t>QUICK WIN: Smarter Catalog Filters</a:t>
-            </a:r>
-          </a:p>
-          <a:p>
-            <a:pPr>
-              <a:defRPr sz="1300">
-                <a:solidFill>
-                  <a:srgbClr val="F8FAFC"/>
-                </a:solidFill>
-              </a:defRPr>
-            </a:pPr>
-            <a:r>
-              <a:t>• Obscurity/popularity sliders in search.</a:t>
-            </a:r>
-            <a:br/>
-            <a:r>
-              <a:t>• Help filter organic or premium brands.</a:t>
-            </a:r>
-            <a:br/>
-            <a:r>
-              <a:t>• Low conversion impact; users ignore filters.</a:t>
-            </a:r>
-            <a:br/>
-            <a:r>
-              <a:t>• Reuses existing metadata; low dev effort.</a:t>
-            </a:r>
-          </a:p>
-        </p:txBody>
-      </p:sp>
-      <p:graphicFrame>
-        <p:nvGraphicFramePr>
-          <p:cNvPr id="8" name="Table 7"/>
-          <p:cNvGraphicFramePr>
-            <a:graphicFrameLocks noGrp="1"/>
-          </p:cNvGraphicFramePr>
-          <p:nvPr/>
-        </p:nvGraphicFramePr>
-        <p:xfrm>
-          <a:off x="457200" y="3657600"/>
-          <a:ext cx="11277295" cy="2377440"/>
-        </p:xfrm>
-        <a:graphic>
-          <a:graphicData uri="http://schemas.openxmlformats.org/drawingml/2006/table">
-            <a:tbl>
-              <a:tblPr firstRow="1" bandRow="1">
-                <a:tableStyleId>{5C22544A-7EE6-4342-B048-85BDC9FD1C3A}</a:tableStyleId>
-              </a:tblPr>
-              <a:tblGrid>
-                <a:gridCol w="2560320"/>
-                <a:gridCol w="1645920"/>
-                <a:gridCol w="1645920"/>
-                <a:gridCol w="1645920"/>
-                <a:gridCol w="1645920"/>
-                <a:gridCol w="2133295"/>
-              </a:tblGrid>
-              <a:tr h="594360">
-                <a:tc>
-                  <a:txBody>
-                    <a:bodyPr/>
-                    <a:lstStyle/>
-                    <a:p>
-                      <a:pPr>
-                        <a:defRPr sz="1000" b="1">
-                          <a:solidFill>
-                            <a:srgbClr val="F8FAFC"/>
-                          </a:solidFill>
-                          <a:latin typeface="Arial"/>
-                        </a:defRPr>
-                      </a:pPr>
-                      <a:r>
-                        <a:t>Solution Path</a:t>
-                      </a:r>
-                    </a:p>
-                  </a:txBody>
-                  <a:tcPr>
-                    <a:solidFill>
-                      <a:srgbClr val="1F2937"/>
-                    </a:solidFill>
-                  </a:tcPr>
-                </a:tc>
-                <a:tc>
-                  <a:txBody>
-                    <a:bodyPr/>
-                    <a:lstStyle/>
-                    <a:p>
-                      <a:pPr>
-                        <a:defRPr sz="1000" b="1">
-                          <a:solidFill>
-                            <a:srgbClr val="F8FAFC"/>
-                          </a:solidFill>
-                          <a:latin typeface="Arial"/>
-                        </a:defRPr>
-                      </a:pPr>
-                      <a:r>
-                        <a:t>Reach</a:t>
-                      </a:r>
-                    </a:p>
-                  </a:txBody>
-                  <a:tcPr>
-                    <a:solidFill>
-                      <a:srgbClr val="1F2937"/>
-                    </a:solidFill>
-                  </a:tcPr>
-                </a:tc>
-                <a:tc>
-                  <a:txBody>
-                    <a:bodyPr/>
-                    <a:lstStyle/>
-                    <a:p>
-                      <a:pPr>
-                        <a:defRPr sz="1000" b="1">
-                          <a:solidFill>
-                            <a:srgbClr val="F8FAFC"/>
-                          </a:solidFill>
-                          <a:latin typeface="Arial"/>
-                        </a:defRPr>
-                      </a:pPr>
-                      <a:r>
-                        <a:t>Impact</a:t>
-                      </a:r>
-                    </a:p>
-                  </a:txBody>
-                  <a:tcPr>
-                    <a:solidFill>
-                      <a:srgbClr val="1F2937"/>
-                    </a:solidFill>
-                  </a:tcPr>
-                </a:tc>
-                <a:tc>
-                  <a:txBody>
-                    <a:bodyPr/>
-                    <a:lstStyle/>
-                    <a:p>
-                      <a:pPr>
-                        <a:defRPr sz="1000" b="1">
-                          <a:solidFill>
-                            <a:srgbClr val="F8FAFC"/>
-                          </a:solidFill>
-                          <a:latin typeface="Arial"/>
-                        </a:defRPr>
-                      </a:pPr>
-                      <a:r>
-                        <a:t>Confidence</a:t>
-                      </a:r>
-                    </a:p>
-                  </a:txBody>
-                  <a:tcPr>
-                    <a:solidFill>
-                      <a:srgbClr val="1F2937"/>
-                    </a:solidFill>
-                  </a:tcPr>
-                </a:tc>
-                <a:tc>
-                  <a:txBody>
-                    <a:bodyPr/>
-                    <a:lstStyle/>
-                    <a:p>
-                      <a:pPr>
-                        <a:defRPr sz="1000" b="1">
-                          <a:solidFill>
-                            <a:srgbClr val="F8FAFC"/>
-                          </a:solidFill>
-                          <a:latin typeface="Arial"/>
-                        </a:defRPr>
-                      </a:pPr>
-                      <a:r>
-                        <a:t>Effort</a:t>
-                      </a:r>
-                    </a:p>
-                  </a:txBody>
-                  <a:tcPr>
-                    <a:solidFill>
-                      <a:srgbClr val="1F2937"/>
-                    </a:solidFill>
-                  </a:tcPr>
-                </a:tc>
-                <a:tc>
-                  <a:txBody>
-                    <a:bodyPr/>
-                    <a:lstStyle/>
-                    <a:p>
-                      <a:pPr>
-                        <a:defRPr sz="1000" b="1">
-                          <a:solidFill>
-                            <a:srgbClr val="F8FAFC"/>
-                          </a:solidFill>
-                          <a:latin typeface="Arial"/>
-                        </a:defRPr>
-                      </a:pPr>
-                      <a:r>
-                        <a:t>RICE Score</a:t>
-                      </a:r>
-                    </a:p>
-                  </a:txBody>
-                  <a:tcPr>
-                    <a:solidFill>
-                      <a:srgbClr val="1F2937"/>
-                    </a:solidFill>
-                  </a:tcPr>
-                </a:tc>
-              </a:tr>
-              <a:tr h="594360">
-                <a:tc>
-                  <a:txBody>
-                    <a:bodyPr/>
-                    <a:lstStyle/>
-                    <a:p>
-                      <a:pPr>
-                        <a:defRPr sz="1000" b="1">
-                          <a:solidFill>
-                            <a:srgbClr val="F8FAFC"/>
-                          </a:solidFill>
-                          <a:latin typeface="Arial"/>
-                        </a:defRPr>
-                      </a:pPr>
-                      <a:r>
-                        <a:t>Smarter Catalog Filters</a:t>
-                      </a:r>
-                    </a:p>
-                  </a:txBody>
-                  <a:tcPr>
-                    <a:solidFill>
-                      <a:srgbClr val="111827"/>
-                    </a:solidFill>
-                  </a:tcPr>
-                </a:tc>
-                <a:tc>
-                  <a:txBody>
-                    <a:bodyPr/>
-                    <a:lstStyle/>
-                    <a:p>
-                      <a:pPr>
-                        <a:defRPr sz="1000" b="0">
-                          <a:solidFill>
-                            <a:srgbClr val="F8FAFC"/>
-                          </a:solidFill>
-                          <a:latin typeface="Arial"/>
-                        </a:defRPr>
-                      </a:pPr>
-                      <a:r>
-                        <a:t>Low (1.5M/qtr)</a:t>
-                      </a:r>
-                    </a:p>
-                  </a:txBody>
-                  <a:tcPr>
-                    <a:solidFill>
-                      <a:srgbClr val="111827"/>
-                    </a:solidFill>
-                  </a:tcPr>
-                </a:tc>
-                <a:tc>
-                  <a:txBody>
-                    <a:bodyPr/>
-                    <a:lstStyle/>
-                    <a:p>
-                      <a:pPr>
-                        <a:defRPr sz="1000" b="0">
-                          <a:solidFill>
-                            <a:srgbClr val="F8FAFC"/>
-                          </a:solidFill>
-                          <a:latin typeface="Arial"/>
-                        </a:defRPr>
-                      </a:pPr>
-                      <a:r>
-                        <a:t>Low (0.5x)</a:t>
-                      </a:r>
-                    </a:p>
-                  </a:txBody>
-                  <a:tcPr>
-                    <a:solidFill>
-                      <a:srgbClr val="111827"/>
-                    </a:solidFill>
-                  </a:tcPr>
-                </a:tc>
-                <a:tc>
-                  <a:txBody>
-                    <a:bodyPr/>
-                    <a:lstStyle/>
-                    <a:p>
-                      <a:pPr>
-                        <a:defRPr sz="1000" b="0">
-                          <a:solidFill>
-                            <a:srgbClr val="F8FAFC"/>
-                          </a:solidFill>
-                          <a:latin typeface="Arial"/>
-                        </a:defRPr>
-                      </a:pPr>
-                      <a:r>
-                        <a:t>90%</a:t>
-                      </a:r>
-                    </a:p>
-                  </a:txBody>
-                  <a:tcPr>
-                    <a:solidFill>
-                      <a:srgbClr val="111827"/>
-                    </a:solidFill>
-                  </a:tcPr>
-                </a:tc>
-                <a:tc>
-                  <a:txBody>
-                    <a:bodyPr/>
-                    <a:lstStyle/>
-                    <a:p>
-                      <a:pPr>
-                        <a:defRPr sz="1000" b="0">
-                          <a:solidFill>
-                            <a:srgbClr val="F8FAFC"/>
-                          </a:solidFill>
-                          <a:latin typeface="Arial"/>
-                        </a:defRPr>
-                      </a:pPr>
-                      <a:r>
-                        <a:t>1 person-month</a:t>
-                      </a:r>
-                    </a:p>
-                  </a:txBody>
-                  <a:tcPr>
-                    <a:solidFill>
-                      <a:srgbClr val="111827"/>
-                    </a:solidFill>
-                  </a:tcPr>
-                </a:tc>
-                <a:tc>
-                  <a:txBody>
-                    <a:bodyPr/>
-                    <a:lstStyle/>
-                    <a:p>
-                      <a:pPr>
-                        <a:defRPr sz="1000" b="1">
-                          <a:solidFill>
-                            <a:srgbClr val="8B949E"/>
-                          </a:solidFill>
-                          <a:latin typeface="Arial"/>
-                        </a:defRPr>
-                      </a:pPr>
-                      <a:r>
-                        <a:t>6.8</a:t>
-                      </a:r>
-                    </a:p>
-                  </a:txBody>
-                  <a:tcPr>
-                    <a:solidFill>
-                      <a:srgbClr val="111827"/>
-                    </a:solidFill>
-                  </a:tcPr>
-                </a:tc>
-              </a:tr>
-              <a:tr h="594360">
-                <a:tc>
-                  <a:txBody>
-                    <a:bodyPr/>
-                    <a:lstStyle/>
-                    <a:p>
-                      <a:pPr>
-                        <a:defRPr sz="1000" b="1">
-                          <a:solidFill>
-                            <a:srgbClr val="F8FAFC"/>
-                          </a:solidFill>
-                          <a:latin typeface="Arial"/>
-                        </a:defRPr>
-                      </a:pPr>
-                      <a:r>
-                        <a:t>Crate Digger AI Chat Agent</a:t>
-                      </a:r>
-                    </a:p>
-                  </a:txBody>
-                  <a:tcPr>
-                    <a:solidFill>
-                      <a:srgbClr val="111827"/>
-                    </a:solidFill>
-                  </a:tcPr>
-                </a:tc>
-                <a:tc>
-                  <a:txBody>
-                    <a:bodyPr/>
-                    <a:lstStyle/>
-                    <a:p>
-                      <a:pPr>
-                        <a:defRPr sz="1000" b="0">
-                          <a:solidFill>
-                            <a:srgbClr val="F8FAFC"/>
-                          </a:solidFill>
-                          <a:latin typeface="Arial"/>
-                        </a:defRPr>
-                      </a:pPr>
-                      <a:r>
-                        <a:t>Medium (5M/qtr)</a:t>
-                      </a:r>
-                    </a:p>
-                  </a:txBody>
-                  <a:tcPr>
-                    <a:solidFill>
-                      <a:srgbClr val="111827"/>
-                    </a:solidFill>
-                  </a:tcPr>
-                </a:tc>
-                <a:tc>
-                  <a:txBody>
-                    <a:bodyPr/>
-                    <a:lstStyle/>
-                    <a:p>
-                      <a:pPr>
-                        <a:defRPr sz="1000" b="0">
-                          <a:solidFill>
-                            <a:srgbClr val="F8FAFC"/>
-                          </a:solidFill>
-                          <a:latin typeface="Arial"/>
-                        </a:defRPr>
-                      </a:pPr>
-                      <a:r>
-                        <a:t>Massive (3.0x)</a:t>
-                      </a:r>
-                    </a:p>
-                  </a:txBody>
-                  <a:tcPr>
-                    <a:solidFill>
-                      <a:srgbClr val="111827"/>
-                    </a:solidFill>
-                  </a:tcPr>
-                </a:tc>
-                <a:tc>
-                  <a:txBody>
-                    <a:bodyPr/>
-                    <a:lstStyle/>
-                    <a:p>
-                      <a:pPr>
-                        <a:defRPr sz="1000" b="0">
-                          <a:solidFill>
-                            <a:srgbClr val="F8FAFC"/>
-                          </a:solidFill>
-                          <a:latin typeface="Arial"/>
-                        </a:defRPr>
-                      </a:pPr>
-                      <a:r>
-                        <a:t>50%</a:t>
-                      </a:r>
-                    </a:p>
-                  </a:txBody>
-                  <a:tcPr>
-                    <a:solidFill>
-                      <a:srgbClr val="111827"/>
-                    </a:solidFill>
-                  </a:tcPr>
-                </a:tc>
-                <a:tc>
-                  <a:txBody>
-                    <a:bodyPr/>
-                    <a:lstStyle/>
-                    <a:p>
-                      <a:pPr>
-                        <a:defRPr sz="1000" b="0">
-                          <a:solidFill>
-                            <a:srgbClr val="F8FAFC"/>
-                          </a:solidFill>
-                          <a:latin typeface="Arial"/>
-                        </a:defRPr>
-                      </a:pPr>
-                      <a:r>
-                        <a:t>6 person-months</a:t>
-                      </a:r>
-                    </a:p>
-                  </a:txBody>
-                  <a:tcPr>
-                    <a:solidFill>
-                      <a:srgbClr val="111827"/>
-                    </a:solidFill>
-                  </a:tcPr>
-                </a:tc>
-                <a:tc>
-                  <a:txBody>
-                    <a:bodyPr/>
-                    <a:lstStyle/>
-                    <a:p>
-                      <a:pPr>
-                        <a:defRPr sz="1000" b="1">
-                          <a:solidFill>
-                            <a:srgbClr val="8B949E"/>
-                          </a:solidFill>
-                          <a:latin typeface="Arial"/>
-                        </a:defRPr>
-                      </a:pPr>
-                      <a:r>
-                        <a:t>12.5</a:t>
-                      </a:r>
-                    </a:p>
-                  </a:txBody>
-                  <a:tcPr>
-                    <a:solidFill>
-                      <a:srgbClr val="111827"/>
-                    </a:solidFill>
-                  </a:tcPr>
-                </a:tc>
-              </a:tr>
-              <a:tr h="594360">
-                <a:tc>
-                  <a:txBody>
-                    <a:bodyPr/>
-                    <a:lstStyle/>
-                    <a:p>
-                      <a:pPr>
-                        <a:defRPr sz="1000" b="1">
-                          <a:solidFill>
-                            <a:srgbClr val="F8FAFC"/>
-                          </a:solidFill>
-                          <a:latin typeface="Arial"/>
-                        </a:defRPr>
-                      </a:pPr>
-                      <a:r>
-                        <a:t>Post-Checkout Add-on Window</a:t>
-                      </a:r>
-                    </a:p>
-                  </a:txBody>
-                  <a:tcPr>
-                    <a:solidFill>
-                      <a:srgbClr val="111827"/>
-                    </a:solidFill>
-                  </a:tcPr>
-                </a:tc>
-                <a:tc>
-                  <a:txBody>
-                    <a:bodyPr/>
-                    <a:lstStyle/>
-                    <a:p>
-                      <a:pPr>
-                        <a:defRPr sz="1000" b="0">
-                          <a:solidFill>
-                            <a:srgbClr val="F8FAFC"/>
-                          </a:solidFill>
-                          <a:latin typeface="Arial"/>
-                        </a:defRPr>
-                      </a:pPr>
-                      <a:r>
-                        <a:t>High (20M/qtr)</a:t>
-                      </a:r>
-                    </a:p>
-                  </a:txBody>
-                  <a:tcPr>
-                    <a:solidFill>
-                      <a:srgbClr val="111827"/>
-                    </a:solidFill>
-                  </a:tcPr>
-                </a:tc>
-                <a:tc>
-                  <a:txBody>
-                    <a:bodyPr/>
-                    <a:lstStyle/>
-                    <a:p>
-                      <a:pPr>
-                        <a:defRPr sz="1000" b="0">
-                          <a:solidFill>
-                            <a:srgbClr val="F8FAFC"/>
-                          </a:solidFill>
-                          <a:latin typeface="Arial"/>
-                        </a:defRPr>
-                      </a:pPr>
-                      <a:r>
-                        <a:t>High (2.0x)</a:t>
-                      </a:r>
-                    </a:p>
-                  </a:txBody>
-                  <a:tcPr>
-                    <a:solidFill>
-                      <a:srgbClr val="111827"/>
-                    </a:solidFill>
-                  </a:tcPr>
-                </a:tc>
-                <a:tc>
-                  <a:txBody>
-                    <a:bodyPr/>
-                    <a:lstStyle/>
-                    <a:p>
-                      <a:pPr>
-                        <a:defRPr sz="1000" b="0">
-                          <a:solidFill>
-                            <a:srgbClr val="F8FAFC"/>
-                          </a:solidFill>
-                          <a:latin typeface="Arial"/>
-                        </a:defRPr>
-                      </a:pPr>
-                      <a:r>
-                        <a:t>80%</a:t>
-                      </a:r>
-                    </a:p>
-                  </a:txBody>
-                  <a:tcPr>
-                    <a:solidFill>
-                      <a:srgbClr val="111827"/>
-                    </a:solidFill>
-                  </a:tcPr>
-                </a:tc>
-                <a:tc>
-                  <a:txBody>
-                    <a:bodyPr/>
-                    <a:lstStyle/>
-                    <a:p>
-                      <a:pPr>
-                        <a:defRPr sz="1000" b="0">
-                          <a:solidFill>
-                            <a:srgbClr val="F8FAFC"/>
-                          </a:solidFill>
-                          <a:latin typeface="Arial"/>
-                        </a:defRPr>
-                      </a:pPr>
-                      <a:r>
-                        <a:t>3 person-months</a:t>
-                      </a:r>
-                    </a:p>
-                  </a:txBody>
-                  <a:tcPr>
-                    <a:solidFill>
-                      <a:srgbClr val="111827"/>
-                    </a:solidFill>
-                  </a:tcPr>
-                </a:tc>
-                <a:tc>
-                  <a:txBody>
-                    <a:bodyPr/>
-                    <a:lstStyle/>
-                    <a:p>
-                      <a:pPr>
-                        <a:defRPr sz="1000" b="1">
-                          <a:solidFill>
-                            <a:srgbClr val="FC8019"/>
-                          </a:solidFill>
-                          <a:latin typeface="Arial"/>
-                        </a:defRPr>
-                      </a:pPr>
-                      <a:r>
-                        <a:t>106.6</a:t>
-                      </a:r>
-                    </a:p>
-                  </a:txBody>
-                  <a:tcPr>
-                    <a:solidFill>
-                      <a:srgbClr val="111827"/>
-                    </a:solidFill>
-                  </a:tcPr>
-                </a:tc>
-              </a:tr>
-            </a:tbl>
-          </a:graphicData>
-        </a:graphic>
-      </p:graphicFrame>
-      <p:sp>
-        <p:nvSpPr>
-          <p:cNvPr id="9" name="TextBox 8"/>
           <p:cNvSpPr txBox="1"/>
           <p:nvPr/>
         </p:nvSpPr>
@@ -9081,7 +7815,7 @@
       </p:sp>
       <p:sp>
         <p:nvSpPr>
-          <p:cNvPr id="10" name="TextBox 9"/>
+          <p:cNvPr id="8" name="TextBox 7"/>
           <p:cNvSpPr txBox="1"/>
           <p:nvPr/>
         </p:nvSpPr>
@@ -9217,7 +7951,7 @@
               </a:defRPr>
             </a:pPr>
             <a:r>
-              <a:t>PART 3 · SYSTEM ARCHITECTURE</a:t>
+              <a:t>PART 4 · GTM ROLLOUT STRATEGY</a:t>
             </a:r>
           </a:p>
         </p:txBody>
@@ -9245,7 +7979,7 @@
           <a:lstStyle/>
           <a:p>
             <a:pPr>
-              <a:defRPr sz="2200" b="1">
+              <a:defRPr sz="2100" b="1">
                 <a:solidFill>
                   <a:srgbClr val="FC8019"/>
                 </a:solidFill>
@@ -9253,7 +7987,7 @@
               </a:defRPr>
             </a:pPr>
             <a:r>
-              <a:t>User Flow Diagram &amp; Backend System Architecture</a:t>
+              <a:t>MVP Phased Operational Rollout Strategy</a:t>
             </a:r>
           </a:p>
         </p:txBody>
@@ -9267,7 +8001,7 @@
         <p:spPr>
           <a:xfrm>
             <a:off x="457200" y="1371600"/>
-            <a:ext cx="5303520" cy="4572000"/>
+            <a:ext cx="5486400" cy="4572000"/>
           </a:xfrm>
           <a:prstGeom prst="rect">
             <a:avLst/>
@@ -9284,62 +8018,63 @@
               <a:spcAft>
                 <a:spcPts val="800"/>
               </a:spcAft>
-              <a:defRPr b="1" sz="1300">
+              <a:defRPr b="1" sz="1500">
                 <a:solidFill>
                   <a:srgbClr val="FC8019"/>
                 </a:solidFill>
               </a:defRPr>
             </a:pPr>
             <a:r>
-              <a:t>USER FLOW DIAGRAM (PILOT SESSION)</a:t>
+              <a:t>Phased Rollout Stages</a:t>
             </a:r>
           </a:p>
           <a:p>
             <a:pPr>
               <a:spcAft>
-                <a:spcPts val="1000"/>
+                <a:spcPts val="1200"/>
               </a:spcAft>
-              <a:defRPr sz="1100">
-                <a:solidFill>
-                  <a:srgbClr val="FF9F43"/>
-                </a:solidFill>
-                <a:latin typeface="Courier New"/>
-              </a:defRPr>
-            </a:pPr>
-            <a:r>
-              <a:t>[Order Placed] -&gt; [App checks: is it grocery/milk?] -&gt; YES</a:t>
+              <a:defRPr sz="1400">
+                <a:solidFill>
+                  <a:srgbClr val="F8FAFC"/>
+                </a:solidFill>
+              </a:defRPr>
+            </a:pPr>
+            <a:r>
+              <a:t>To minimize operational delays at dark stores, we roll out the feature using a phased operational sandbox:</a:t>
+            </a:r>
+          </a:p>
+          <a:p>
+            <a:pPr>
+              <a:defRPr sz="1300">
+                <a:solidFill>
+                  <a:srgbClr val="F8FAFC"/>
+                </a:solidFill>
+              </a:defRPr>
+            </a:pPr>
+            <a:r>
+              <a:t>• Phase 1: Shadow Mode (Weeks 1-2)</a:t>
+            </a:r>
+            <a:br/>
+            <a:r>
+              <a:t>Track background behavior. Measure add-on clicks post-checkout without showing UI. Check matching dark store pack cycles.</a:t>
             </a:r>
             <a:br/>
             <a:br/>
             <a:r>
-              <a:t>[Active 3-Min Timer Banner Starts] -&gt; [User views recommended items (Face wash, dog food)] -&gt; [User clicks Add-to-Order]</a:t>
+              <a:t>• Phase 2: Operational Buffer Trial (Weeks 3-6)</a:t>
+            </a:r>
+            <a:br/>
+            <a:r>
+              <a:t>Launch in 1 dark store (Bangalore East). Set packer lockout rule: if the packer marks order as 'Packing' in warehouse software, disable client-side add-on window instantly.</a:t>
             </a:r>
             <a:br/>
             <a:br/>
             <a:r>
-              <a:t>[System runs validation: is timer active?] -&gt; YES</a:t>
+              <a:t>• Phase 3: Tiered City Expansion (Weeks 7-12)</a:t>
             </a:r>
             <a:br/>
-            <a:br/>
-            <a:r>
-              <a:t>[Waives delivery fee to ₹0] -&gt; [Appends item in active SQLite DB session] -&gt; [Updates total bill] -&gt; [Pushes updated manifest to Dark Store Packer]</a:t>
-            </a:r>
-            <a:br/>
-            <a:br/>
-            <a:r>
-              <a:t>[Next screen: updated order details, 0 repeat delivery charges]</a:t>
-            </a:r>
-          </a:p>
-          <a:p>
-            <a:pPr>
-              <a:defRPr sz="1200">
-                <a:solidFill>
-                  <a:srgbClr val="F8FAFC"/>
-                </a:solidFill>
-              </a:defRPr>
-            </a:pPr>
-            <a:r>
-              <a:t>• Cold Start Guardrail: Window is disabled if order contains heavy items exceeding bike capacity.</a:t>
+            <a:r>
+              <a:t>Expand to 10 dark stores. Integrate with Swiggy One membership.</a:t>
             </a:r>
           </a:p>
         </p:txBody>
@@ -9370,14 +8105,29 @@
               <a:spcAft>
                 <a:spcPts val="800"/>
               </a:spcAft>
-              <a:defRPr b="1" sz="1300">
+              <a:defRPr b="1" sz="1500">
                 <a:solidFill>
                   <a:srgbClr val="FC8019"/>
                 </a:solidFill>
               </a:defRPr>
             </a:pPr>
             <a:r>
-              <a:t>SYSTEM ARCHITECTURE (PHASE 0 - PHASE 4)</a:t>
+              <a:t>Operational Lock-out &amp; Rider Safety Gates</a:t>
+            </a:r>
+          </a:p>
+          <a:p>
+            <a:pPr>
+              <a:spcAft>
+                <a:spcPts val="1200"/>
+              </a:spcAft>
+              <a:defRPr sz="1400">
+                <a:solidFill>
+                  <a:srgbClr val="F8FAFC"/>
+                </a:solidFill>
+              </a:defRPr>
+            </a:pPr>
+            <a:r>
+              <a:t>We enforce three software guardrails to protect delivery SLAs:</a:t>
             </a:r>
           </a:p>
           <a:p>
@@ -9389,38 +8139,17 @@
               </a:defRPr>
             </a:pPr>
             <a:r>
-              <a:t>• Phase 4: UI/Orchestration Layer</a:t>
-            </a:r>
-            <a:br/>
-            <a:r>
-              <a:t>Mode toggle A/B/C checkout sandbox. Timer displays, callback handlers.</a:t>
+              <a:t>1. Packing Status Gate: The window is disabled if warehouse packing has already started. This prevents packers from re-opening sealed packages.</a:t>
             </a:r>
             <a:br/>
             <a:br/>
             <a:r>
-              <a:t>• Phase 3: Reasoning &amp; Explanation Layer</a:t>
-            </a:r>
-            <a:br/>
-            <a:r>
-              <a:t>FastAPI route `/api/opportunities` prioritizes recommendations. LLM writes one-line 'Why you need this now' reason.</a:t>
+              <a:t>2. Weight Capacity Gate: Limit add-on catalog to items &lt;2kg. Heavy items (e.g. 5kg dog food bags) are blocked to keep bikes within safety weight thresholds.</a:t>
             </a:r>
             <a:br/>
             <a:br/>
             <a:r>
-              <a:t>• Phase 2: Category Matchers</a:t>
-            </a:r>
-            <a:br/>
-            <a:r>
-              <a:t>Cross-category engine pairs milk orders with beauty (face wash), baby wipes, and organic produce (avocados).</a:t>
-            </a:r>
-            <a:br/>
-            <a:br/>
-            <a:r>
-              <a:t>• Phase 1: Storage Layer</a:t>
-            </a:r>
-            <a:br/>
-            <a:r>
-              <a:t>SQLite3 (`reviews.db`) stores user histories, active checkouts, and ICE opportunity roadmaps.</a:t>
+              <a:t>3. Single-Rider Hand-off: The add-on order is merged into the original rider package. No secondary rider is assigned.</a:t>
             </a:r>
           </a:p>
         </p:txBody>
@@ -9599,7 +8328,7 @@
               </a:defRPr>
             </a:pPr>
             <a:r>
-              <a:t>PART 3 · TECHNICAL RATIONALE</a:t>
+              <a:t>PART 4 · GTM METRICS</a:t>
             </a:r>
           </a:p>
         </p:txBody>
@@ -9627,7 +8356,7 @@
           <a:lstStyle/>
           <a:p>
             <a:pPr>
-              <a:defRPr sz="2200" b="1">
+              <a:defRPr sz="2100" b="1">
                 <a:solidFill>
                   <a:srgbClr val="FC8019"/>
                 </a:solidFill>
@@ -9635,7 +8364,7 @@
               </a:defRPr>
             </a:pPr>
             <a:r>
-              <a:t>Why Post-Checkout Sandbox, and Not Traditional Recommenders?</a:t>
+              <a:t>Phased GTM Pilot &amp; Guardrail Success Metrics</a:t>
             </a:r>
           </a:p>
         </p:txBody>
@@ -9649,7 +8378,7 @@
         <p:spPr>
           <a:xfrm>
             <a:off x="457200" y="1371600"/>
-            <a:ext cx="3474720" cy="4572000"/>
+            <a:ext cx="5486400" cy="4572000"/>
           </a:xfrm>
           <a:prstGeom prst="rect">
             <a:avLst/>
@@ -9666,18 +8395,46 @@
               <a:spcAft>
                 <a:spcPts val="800"/>
               </a:spcAft>
-              <a:defRPr b="1" sz="1300">
+              <a:defRPr b="1" sz="1500">
                 <a:solidFill>
                   <a:srgbClr val="FC8019"/>
                 </a:solidFill>
               </a:defRPr>
             </a:pPr>
             <a:r>
-              <a:t>THE GAP</a:t>
+              <a:t>North Star &amp; Leading Indicators</a:t>
+            </a:r>
+          </a:p>
+          <a:p>
+            <a:pPr>
+              <a:spcAft>
+                <a:spcPts val="1000"/>
+              </a:spcAft>
+              <a:defRPr sz="1300">
+                <a:solidFill>
+                  <a:srgbClr val="F8FAFC"/>
+                </a:solidFill>
+              </a:defRPr>
+            </a:pPr>
+            <a:r>
+              <a:t>• North Star Metric: Cross-Category Discovery Completion Rate</a:t>
             </a:r>
             <a:br/>
             <a:r>
-              <a:t>Why Traditional Banners Fail</a:t>
+              <a:t>% of post-checkout add-on recommendations checked out and delivered, out of all users exposed to the countdown timer. Target: 35% completion in 30 days.</a:t>
+            </a:r>
+            <a:br/>
+            <a:br/>
+            <a:r>
+              <a:t>• Leading Indicators (0-30 Days):</a:t>
+            </a:r>
+            <a:br/>
+            <a:r>
+              <a:t>  - Timer Conversion Rate: % of users who add at least 1 item. Target: &gt;25% in week 2.</a:t>
+            </a:r>
+            <a:br/>
+            <a:r>
+              <a:t>  - Platform Split Churn Delta: Shift in multi-app usage. Target: -5% churn to Zepto.</a:t>
             </a:r>
           </a:p>
           <a:p>
@@ -9689,19 +8446,15 @@
               </a:defRPr>
             </a:pPr>
             <a:r>
-              <a:t>• Home screen ads are treated as spam (banner blindness).</a:t>
+              <a:t>• Lagging Indicators (30-90 Days):</a:t>
             </a:r>
             <a:br/>
             <a:r>
-              <a:t>• Collaborative filtering recommends items the user has already bought, locking them in loops.</a:t>
+              <a:t>  - Average Order Value (AOV) Delta: Target +18% AOV lift among pilot cohort.</a:t>
             </a:r>
             <a:br/>
             <a:r>
-              <a:t>• Pre-checkout widgets trigger fee warnings, creating price check cart abandonments.</a:t>
-            </a:r>
-            <a:br/>
-            <a:r>
-              <a:t>• No mechanism exists to add a forgotten item without paying another delivery fee.</a:t>
+              <a:t>  - Auxiliary category penetration: Target 2x increase in personal care sales.</a:t>
             </a:r>
           </a:p>
         </p:txBody>
@@ -9714,8 +8467,8 @@
         </p:nvSpPr>
         <p:spPr>
           <a:xfrm>
-            <a:off x="4297680" y="1371600"/>
-            <a:ext cx="3474720" cy="4572000"/>
+            <a:off x="6217920" y="1371600"/>
+            <a:ext cx="5486400" cy="4572000"/>
           </a:xfrm>
           <a:prstGeom prst="rect">
             <a:avLst/>
@@ -9732,18 +8485,29 @@
               <a:spcAft>
                 <a:spcPts val="800"/>
               </a:spcAft>
-              <a:defRPr b="1" sz="1300">
-                <a:solidFill>
-                  <a:srgbClr val="22C55E"/>
-                </a:solidFill>
-              </a:defRPr>
-            </a:pPr>
-            <a:r>
-              <a:t>THE UNLOCK</a:t>
-            </a:r>
-            <a:br/>
-            <a:r>
-              <a:t>What the MVP Unlocks</a:t>
+              <a:defRPr b="1" sz="1500">
+                <a:solidFill>
+                  <a:srgbClr val="FC8019"/>
+                </a:solidFill>
+              </a:defRPr>
+            </a:pPr>
+            <a:r>
+              <a:t>SLA Operational Guardrail Metrics</a:t>
+            </a:r>
+          </a:p>
+          <a:p>
+            <a:pPr>
+              <a:spcAft>
+                <a:spcPts val="1200"/>
+              </a:spcAft>
+              <a:defRPr sz="1400">
+                <a:solidFill>
+                  <a:srgbClr val="F8FAFC"/>
+                </a:solidFill>
+              </a:defRPr>
+            </a:pPr>
+            <a:r>
+              <a:t>We track three operational guardrails daily to guarantee the core delivery promise is not broken:</a:t>
             </a:r>
           </a:p>
           <a:p>
@@ -9755,19 +8519,17 @@
               </a:defRPr>
             </a:pPr>
             <a:r>
-              <a:t>• Leverages active transaction momentum immediately post-checkout.</a:t>
+              <a:t>• Rider Wait Time Delta: Target: &lt;+30 seconds. Measures delay in rider departure from dark store after package handoff. If delta exceeds 45s, decrease add-on window from 3 to 2 minutes.</a:t>
             </a:r>
             <a:br/>
-            <a:r>
-              <a:t>• Waives delivery fee for 3 mins as rider cost is already paid.</a:t>
-            </a:r>
             <a:br/>
             <a:r>
-              <a:t>• Recommends high-margin exploratory categories (beauty, pets) based on daily context.</a:t>
+              <a:t>• Packer Picking SLA Delta: Target: &lt;+15 seconds. Measures packer time to add append item to bag. If delta rises, simplify packer terminal UI.</a:t>
             </a:r>
             <a:br/>
-            <a:r>
-              <a:t>• Provides a clear one-line reasoning explaining the zero fee waiver.</a:t>
+            <a:br/>
+            <a:r>
+              <a:t>• Delivery SLA Breach Rate: Target: 0%. The percentage of orders delayed beyond Swiggy's delivery promise. Must remain constant.</a:t>
             </a:r>
           </a:p>
         </p:txBody>
@@ -9775,107 +8537,6 @@
       <p:sp>
         <p:nvSpPr>
           <p:cNvPr id="7" name="TextBox 6"/>
-          <p:cNvSpPr txBox="1"/>
-          <p:nvPr/>
-        </p:nvSpPr>
-        <p:spPr>
-          <a:xfrm>
-            <a:off x="8229600" y="1371600"/>
-            <a:ext cx="3474720" cy="4572000"/>
-          </a:xfrm>
-          <a:prstGeom prst="rect">
-            <a:avLst/>
-          </a:prstGeom>
-          <a:noFill/>
-        </p:spPr>
-        <p:txBody>
-          <a:bodyPr wrap="square">
-            <a:spAutoFit/>
-          </a:bodyPr>
-          <a:lstStyle/>
-          <a:p>
-            <a:pPr>
-              <a:spcAft>
-                <a:spcPts val="800"/>
-              </a:spcAft>
-              <a:defRPr b="1" sz="1300">
-                <a:solidFill>
-                  <a:srgbClr val="3B82F6"/>
-                </a:solidFill>
-              </a:defRPr>
-            </a:pPr>
-            <a:r>
-              <a:t>THE OUTCOME</a:t>
-            </a:r>
-            <a:br/>
-            <a:r>
-              <a:t>How UX Transforms</a:t>
-            </a:r>
-          </a:p>
-          <a:p>
-            <a:pPr>
-              <a:defRPr sz="1300">
-                <a:solidFill>
-                  <a:srgbClr val="F8FAFC"/>
-                </a:solidFill>
-              </a:defRPr>
-            </a:pPr>
-            <a:r>
-              <a:t>• Cart additions shift from high-consideration friction to low-friction taps.</a:t>
-            </a:r>
-            <a:br/>
-            <a:r>
-              <a:t>• Users explore auxiliary categories without opening competitor apps.</a:t>
-            </a:r>
-            <a:br/>
-            <a:r>
-              <a:t>• Instamart transitions from a commodity milk-run channel to a multi-category shopping center.</a:t>
-            </a:r>
-            <a:br/>
-            <a:r>
-              <a:t>• Creates a zero-acquisition cost marketing channel for new brand trials.</a:t>
-            </a:r>
-          </a:p>
-        </p:txBody>
-      </p:sp>
-      <p:sp>
-        <p:nvSpPr>
-          <p:cNvPr id="8" name="TextBox 7"/>
-          <p:cNvSpPr txBox="1"/>
-          <p:nvPr/>
-        </p:nvSpPr>
-        <p:spPr>
-          <a:xfrm>
-            <a:off x="457200" y="5303520"/>
-            <a:ext cx="11277295" cy="914400"/>
-          </a:xfrm>
-          <a:prstGeom prst="rect">
-            <a:avLst/>
-          </a:prstGeom>
-          <a:noFill/>
-        </p:spPr>
-        <p:txBody>
-          <a:bodyPr wrap="square">
-            <a:spAutoFit/>
-          </a:bodyPr>
-          <a:lstStyle/>
-          <a:p>
-            <a:pPr>
-              <a:defRPr i="1" sz="1300">
-                <a:solidFill>
-                  <a:srgbClr val="FF9F43"/>
-                </a:solidFill>
-              </a:defRPr>
-            </a:pPr>
-            <a:r>
-              <a:t>The reasoning is simple: a traditional pre-checkout banner increases cart abandonment; but a post-checkout timer leverages warm payment intent to trigger zero-fee discovery when the user's focus is at 100%.</a:t>
-            </a:r>
-          </a:p>
-        </p:txBody>
-      </p:sp>
-      <p:sp>
-        <p:nvSpPr>
-          <p:cNvPr id="9" name="TextBox 8"/>
           <p:cNvSpPr txBox="1"/>
           <p:nvPr/>
         </p:nvSpPr>
@@ -9911,7 +8572,7 @@
       </p:sp>
       <p:sp>
         <p:nvSpPr>
-          <p:cNvPr id="10" name="TextBox 9"/>
+          <p:cNvPr id="8" name="TextBox 7"/>
           <p:cNvSpPr txBox="1"/>
           <p:nvPr/>
         </p:nvSpPr>

</xml_diff>

<commit_message>
Update PPTX file with solid background shapes to fix browser visibility
</commit_message>
<xml_diff>
--- a/NL Swiggy Instamart.pptx
+++ b/NL Swiggy Instamart.pptx
@@ -3090,14 +3090,6 @@
 <file path=ppt/slides/slide1.xml><?xml version="1.0" encoding="utf-8"?>
 <p:sld xmlns:a="http://schemas.openxmlformats.org/drawingml/2006/main" xmlns:p="http://schemas.openxmlformats.org/presentationml/2006/main" xmlns:r="http://schemas.openxmlformats.org/officeDocument/2006/relationships">
   <p:cSld>
-    <p:bg>
-      <p:bgPr>
-        <a:solidFill>
-          <a:srgbClr val="0D1117"/>
-        </a:solidFill>
-        <a:effectLst/>
-      </p:bgPr>
-    </p:bg>
     <p:spTree>
       <p:nvGrpSpPr>
         <p:cNvPr id="1" name=""/>
@@ -3108,6 +3100,49 @@
       <p:sp>
         <p:nvSpPr>
           <p:cNvPr id="2" name="Rectangle 1"/>
+          <p:cNvSpPr/>
+          <p:nvPr/>
+        </p:nvSpPr>
+        <p:spPr>
+          <a:xfrm>
+            <a:off x="0" y="0"/>
+            <a:ext cx="12191695" cy="6858000"/>
+          </a:xfrm>
+          <a:prstGeom prst="rect">
+            <a:avLst/>
+          </a:prstGeom>
+          <a:solidFill>
+            <a:srgbClr val="0D1117"/>
+          </a:solidFill>
+          <a:ln>
+            <a:noFill/>
+          </a:ln>
+        </p:spPr>
+        <p:style>
+          <a:lnRef idx="1">
+            <a:schemeClr val="accent1"/>
+          </a:lnRef>
+          <a:fillRef idx="3">
+            <a:schemeClr val="accent1"/>
+          </a:fillRef>
+          <a:effectRef idx="2">
+            <a:schemeClr val="accent1"/>
+          </a:effectRef>
+          <a:fontRef idx="minor">
+            <a:schemeClr val="lt1"/>
+          </a:fontRef>
+        </p:style>
+        <p:txBody>
+          <a:bodyPr rtlCol="0" anchor="ctr"/>
+          <a:lstStyle/>
+          <a:p>
+            <a:pPr algn="ctr"/>
+          </a:p>
+        </p:txBody>
+      </p:sp>
+      <p:sp>
+        <p:nvSpPr>
+          <p:cNvPr id="3" name="Rectangle 2"/>
           <p:cNvSpPr/>
           <p:nvPr/>
         </p:nvSpPr>
@@ -3152,7 +3187,7 @@
       </p:sp>
       <p:sp>
         <p:nvSpPr>
-          <p:cNvPr id="3" name="TextBox 2"/>
+          <p:cNvPr id="4" name="TextBox 3"/>
           <p:cNvSpPr txBox="1"/>
           <p:nvPr/>
         </p:nvSpPr>
@@ -3188,7 +3223,7 @@
       </p:sp>
       <p:sp>
         <p:nvSpPr>
-          <p:cNvPr id="4" name="TextBox 3"/>
+          <p:cNvPr id="5" name="TextBox 4"/>
           <p:cNvSpPr txBox="1"/>
           <p:nvPr/>
         </p:nvSpPr>
@@ -3224,7 +3259,7 @@
       </p:sp>
       <p:sp>
         <p:nvSpPr>
-          <p:cNvPr id="5" name="TextBox 4"/>
+          <p:cNvPr id="6" name="TextBox 5"/>
           <p:cNvSpPr txBox="1"/>
           <p:nvPr/>
         </p:nvSpPr>
@@ -3316,7 +3351,7 @@
       </p:sp>
       <p:graphicFrame>
         <p:nvGraphicFramePr>
-          <p:cNvPr id="6" name="Table 5"/>
+          <p:cNvPr id="7" name="Table 6"/>
           <p:cNvGraphicFramePr>
             <a:graphicFrameLocks noGrp="1"/>
           </p:cNvGraphicFramePr>
@@ -3955,7 +3990,7 @@
       </p:graphicFrame>
       <p:sp>
         <p:nvSpPr>
-          <p:cNvPr id="7" name="TextBox 6"/>
+          <p:cNvPr id="8" name="TextBox 7"/>
           <p:cNvSpPr txBox="1"/>
           <p:nvPr/>
         </p:nvSpPr>
@@ -4013,7 +4048,7 @@
       </p:sp>
       <p:sp>
         <p:nvSpPr>
-          <p:cNvPr id="8" name="TextBox 7"/>
+          <p:cNvPr id="9" name="TextBox 8"/>
           <p:cNvSpPr txBox="1"/>
           <p:nvPr/>
         </p:nvSpPr>
@@ -4049,7 +4084,7 @@
       </p:sp>
       <p:sp>
         <p:nvSpPr>
-          <p:cNvPr id="9" name="TextBox 8"/>
+          <p:cNvPr id="10" name="TextBox 9"/>
           <p:cNvSpPr txBox="1"/>
           <p:nvPr/>
         </p:nvSpPr>
@@ -4094,14 +4129,6 @@
 <file path=ppt/slides/slide10.xml><?xml version="1.0" encoding="utf-8"?>
 <p:sld xmlns:a="http://schemas.openxmlformats.org/drawingml/2006/main" xmlns:p="http://schemas.openxmlformats.org/presentationml/2006/main" xmlns:r="http://schemas.openxmlformats.org/officeDocument/2006/relationships">
   <p:cSld>
-    <p:bg>
-      <p:bgPr>
-        <a:solidFill>
-          <a:srgbClr val="0D1117"/>
-        </a:solidFill>
-        <a:effectLst/>
-      </p:bgPr>
-    </p:bg>
     <p:spTree>
       <p:nvGrpSpPr>
         <p:cNvPr id="1" name=""/>
@@ -4112,6 +4139,49 @@
       <p:sp>
         <p:nvSpPr>
           <p:cNvPr id="2" name="Rectangle 1"/>
+          <p:cNvSpPr/>
+          <p:nvPr/>
+        </p:nvSpPr>
+        <p:spPr>
+          <a:xfrm>
+            <a:off x="0" y="0"/>
+            <a:ext cx="12191695" cy="6858000"/>
+          </a:xfrm>
+          <a:prstGeom prst="rect">
+            <a:avLst/>
+          </a:prstGeom>
+          <a:solidFill>
+            <a:srgbClr val="0D1117"/>
+          </a:solidFill>
+          <a:ln>
+            <a:noFill/>
+          </a:ln>
+        </p:spPr>
+        <p:style>
+          <a:lnRef idx="1">
+            <a:schemeClr val="accent1"/>
+          </a:lnRef>
+          <a:fillRef idx="3">
+            <a:schemeClr val="accent1"/>
+          </a:fillRef>
+          <a:effectRef idx="2">
+            <a:schemeClr val="accent1"/>
+          </a:effectRef>
+          <a:fontRef idx="minor">
+            <a:schemeClr val="lt1"/>
+          </a:fontRef>
+        </p:style>
+        <p:txBody>
+          <a:bodyPr rtlCol="0" anchor="ctr"/>
+          <a:lstStyle/>
+          <a:p>
+            <a:pPr algn="ctr"/>
+          </a:p>
+        </p:txBody>
+      </p:sp>
+      <p:sp>
+        <p:nvSpPr>
+          <p:cNvPr id="3" name="Rectangle 2"/>
           <p:cNvSpPr/>
           <p:nvPr/>
         </p:nvSpPr>
@@ -4156,7 +4226,7 @@
       </p:sp>
       <p:sp>
         <p:nvSpPr>
-          <p:cNvPr id="3" name="TextBox 2"/>
+          <p:cNvPr id="4" name="TextBox 3"/>
           <p:cNvSpPr txBox="1"/>
           <p:nvPr/>
         </p:nvSpPr>
@@ -4192,7 +4262,7 @@
       </p:sp>
       <p:sp>
         <p:nvSpPr>
-          <p:cNvPr id="4" name="TextBox 3"/>
+          <p:cNvPr id="5" name="TextBox 4"/>
           <p:cNvSpPr txBox="1"/>
           <p:nvPr/>
         </p:nvSpPr>
@@ -4228,7 +4298,7 @@
       </p:sp>
       <p:graphicFrame>
         <p:nvGraphicFramePr>
-          <p:cNvPr id="5" name="Table 4"/>
+          <p:cNvPr id="6" name="Table 5"/>
           <p:cNvGraphicFramePr>
             <a:graphicFrameLocks noGrp="1"/>
           </p:cNvGraphicFramePr>
@@ -4745,7 +4815,7 @@
       </p:graphicFrame>
       <p:sp>
         <p:nvSpPr>
-          <p:cNvPr id="6" name="TextBox 5"/>
+          <p:cNvPr id="7" name="TextBox 6"/>
           <p:cNvSpPr txBox="1"/>
           <p:nvPr/>
         </p:nvSpPr>
@@ -4781,7 +4851,7 @@
       </p:sp>
       <p:sp>
         <p:nvSpPr>
-          <p:cNvPr id="7" name="TextBox 6"/>
+          <p:cNvPr id="8" name="TextBox 7"/>
           <p:cNvSpPr txBox="1"/>
           <p:nvPr/>
         </p:nvSpPr>
@@ -4826,14 +4896,6 @@
 <file path=ppt/slides/slide2.xml><?xml version="1.0" encoding="utf-8"?>
 <p:sld xmlns:a="http://schemas.openxmlformats.org/drawingml/2006/main" xmlns:p="http://schemas.openxmlformats.org/presentationml/2006/main" xmlns:r="http://schemas.openxmlformats.org/officeDocument/2006/relationships">
   <p:cSld>
-    <p:bg>
-      <p:bgPr>
-        <a:solidFill>
-          <a:srgbClr val="0D1117"/>
-        </a:solidFill>
-        <a:effectLst/>
-      </p:bgPr>
-    </p:bg>
     <p:spTree>
       <p:nvGrpSpPr>
         <p:cNvPr id="1" name=""/>
@@ -4844,6 +4906,49 @@
       <p:sp>
         <p:nvSpPr>
           <p:cNvPr id="2" name="Rectangle 1"/>
+          <p:cNvSpPr/>
+          <p:nvPr/>
+        </p:nvSpPr>
+        <p:spPr>
+          <a:xfrm>
+            <a:off x="0" y="0"/>
+            <a:ext cx="12191695" cy="6858000"/>
+          </a:xfrm>
+          <a:prstGeom prst="rect">
+            <a:avLst/>
+          </a:prstGeom>
+          <a:solidFill>
+            <a:srgbClr val="0D1117"/>
+          </a:solidFill>
+          <a:ln>
+            <a:noFill/>
+          </a:ln>
+        </p:spPr>
+        <p:style>
+          <a:lnRef idx="1">
+            <a:schemeClr val="accent1"/>
+          </a:lnRef>
+          <a:fillRef idx="3">
+            <a:schemeClr val="accent1"/>
+          </a:fillRef>
+          <a:effectRef idx="2">
+            <a:schemeClr val="accent1"/>
+          </a:effectRef>
+          <a:fontRef idx="minor">
+            <a:schemeClr val="lt1"/>
+          </a:fontRef>
+        </p:style>
+        <p:txBody>
+          <a:bodyPr rtlCol="0" anchor="ctr"/>
+          <a:lstStyle/>
+          <a:p>
+            <a:pPr algn="ctr"/>
+          </a:p>
+        </p:txBody>
+      </p:sp>
+      <p:sp>
+        <p:nvSpPr>
+          <p:cNvPr id="3" name="Rectangle 2"/>
           <p:cNvSpPr/>
           <p:nvPr/>
         </p:nvSpPr>
@@ -4888,7 +4993,7 @@
       </p:sp>
       <p:sp>
         <p:nvSpPr>
-          <p:cNvPr id="3" name="TextBox 2"/>
+          <p:cNvPr id="4" name="TextBox 3"/>
           <p:cNvSpPr txBox="1"/>
           <p:nvPr/>
         </p:nvSpPr>
@@ -4917,14 +5022,14 @@
               </a:defRPr>
             </a:pPr>
             <a:r>
-              <a:t>PART 1 · DB &amp; SCRAPERS INGESTION</a:t>
-            </a:r>
-          </a:p>
-        </p:txBody>
-      </p:sp>
-      <p:sp>
-        <p:nvSpPr>
-          <p:cNvPr id="4" name="TextBox 3"/>
+              <a:t>PART 1 · DISCOVERY ENGINE PIPELINE</a:t>
+            </a:r>
+          </a:p>
+        </p:txBody>
+      </p:sp>
+      <p:sp>
+        <p:nvSpPr>
+          <p:cNvPr id="5" name="TextBox 4"/>
           <p:cNvSpPr txBox="1"/>
           <p:nvPr/>
         </p:nvSpPr>
@@ -4953,21 +5058,21 @@
               </a:defRPr>
             </a:pPr>
             <a:r>
-              <a:t>Database &amp; Ingestion Engine (What Work Was Performed)</a:t>
-            </a:r>
-          </a:p>
-        </p:txBody>
-      </p:sp>
-      <p:sp>
-        <p:nvSpPr>
-          <p:cNvPr id="5" name="TextBox 4"/>
+              <a:t>How the Live Ingestion &amp; Analysis Pipeline Works</a:t>
+            </a:r>
+          </a:p>
+        </p:txBody>
+      </p:sp>
+      <p:sp>
+        <p:nvSpPr>
+          <p:cNvPr id="6" name="TextBox 5"/>
           <p:cNvSpPr txBox="1"/>
           <p:nvPr/>
         </p:nvSpPr>
         <p:spPr>
           <a:xfrm>
             <a:off x="457200" y="1371600"/>
-            <a:ext cx="5486400" cy="4572000"/>
+            <a:ext cx="11277295" cy="1097280"/>
           </a:xfrm>
           <a:prstGeom prst="rect">
             <a:avLst/>
@@ -4982,22 +5087,7 @@
           <a:p>
             <a:pPr>
               <a:spcAft>
-                <a:spcPts val="800"/>
-              </a:spcAft>
-              <a:defRPr b="1" sz="1500">
-                <a:solidFill>
-                  <a:srgbClr val="FC8019"/>
-                </a:solidFill>
-              </a:defRPr>
-            </a:pPr>
-            <a:r>
-              <a:t>1. SQLite Database Schema Setup</a:t>
-            </a:r>
-          </a:p>
-          <a:p>
-            <a:pPr>
-              <a:spcAft>
-                <a:spcPts val="1200"/>
+                <a:spcPts val="1000"/>
               </a:spcAft>
               <a:defRPr sz="1400">
                 <a:solidFill>
@@ -5006,85 +5096,34 @@
               </a:defRPr>
             </a:pPr>
             <a:r>
-              <a:t>We built a relational SQLite database (reviews.db) containing tables to store raw text reviews, sentiments, pain points, and product opportunity parameters:</a:t>
+              <a:t>The n8n-inspired data cleaning and synthesis workflow: from triggered scrapes to relational insights.</a:t>
             </a:r>
           </a:p>
           <a:p>
             <a:pPr>
-              <a:spcAft>
-                <a:spcPts val="1500"/>
-              </a:spcAft>
-              <a:defRPr sz="1000">
-                <a:solidFill>
-                  <a:srgbClr val="A855F7"/>
+              <a:defRPr sz="1200">
+                <a:solidFill>
+                  <a:srgbClr val="FF9F43"/>
                 </a:solidFill>
                 <a:latin typeface="Courier New"/>
               </a:defRPr>
             </a:pPr>
             <a:r>
-              <a:t>CREATE TABLE reviews (</a:t>
-            </a:r>
-            <a:br/>
-            <a:r>
-              <a:t>  id INTEGER PRIMARY KEY AUTOINCREMENT,</a:t>
-            </a:r>
-            <a:br/>
-            <a:r>
-              <a:t>  raw_text TEXT NOT NULL,</a:t>
-            </a:r>
-            <a:br/>
-            <a:r>
-              <a:t>  cleaned_text TEXT,</a:t>
-            </a:r>
-            <a:br/>
-            <a:r>
-              <a:t>  sentiment TEXT,</a:t>
-            </a:r>
-            <a:br/>
-            <a:r>
-              <a:t>  platform TEXT NOT NULL,</a:t>
-            </a:r>
-            <a:br/>
-            <a:r>
-              <a:t>  user_segment TEXT,</a:t>
-            </a:r>
-            <a:br/>
-            <a:r>
-              <a:t>  category_mentions TEXT,</a:t>
-            </a:r>
-            <a:br/>
-            <a:r>
-              <a:t>  timestamp DATETIME DEFAULT CURRENT_TIMESTAMP</a:t>
-            </a:r>
-            <a:br/>
-            <a:r>
-              <a:t>);</a:t>
-            </a:r>
-          </a:p>
-          <a:p>
-            <a:pPr>
-              <a:defRPr sz="1300">
-                <a:solidFill>
-                  <a:srgbClr val="8B949E"/>
-                </a:solidFill>
-              </a:defRPr>
-            </a:pPr>
-            <a:r>
-              <a:t>• Execution: Ran schema.sql migrations to host 1,000 verified rows split by target quota (300 Play Store, 200 Reddit, etc).</a:t>
-            </a:r>
-          </a:p>
-        </p:txBody>
-      </p:sp>
-      <p:sp>
-        <p:nvSpPr>
-          <p:cNvPr id="6" name="TextBox 5"/>
+              <a:t>1. TRIGGER (Webhook) -&gt; 2. SCRAPE (1,000 Multi-Channel reviews) -&gt; 3. MERGE &amp; DEDUPE (Clean duplicates) -&gt; 4. TRANSLATE (Hinglish normalized) -&gt; 5. AI ANALYSIS (Llama sentiment &amp; segment extraction) -&gt; 6. STREAMLIT UI</a:t>
+            </a:r>
+          </a:p>
+        </p:txBody>
+      </p:sp>
+      <p:sp>
+        <p:nvSpPr>
+          <p:cNvPr id="7" name="TextBox 6"/>
           <p:cNvSpPr txBox="1"/>
           <p:nvPr/>
         </p:nvSpPr>
         <p:spPr>
           <a:xfrm>
-            <a:off x="6217920" y="1371600"/>
-            <a:ext cx="5486400" cy="4572000"/>
+            <a:off x="457200" y="2743200"/>
+            <a:ext cx="5486400" cy="3474720"/>
           </a:xfrm>
           <a:prstGeom prst="rect">
             <a:avLst/>
@@ -5101,21 +5140,76 @@
               <a:spcAft>
                 <a:spcPts val="800"/>
               </a:spcAft>
-              <a:defRPr b="1" sz="1500">
+              <a:defRPr b="1" sz="1400">
                 <a:solidFill>
                   <a:srgbClr val="FC8019"/>
                 </a:solidFill>
               </a:defRPr>
             </a:pPr>
             <a:r>
-              <a:t>2. Scraper &amp; Ingestion Python Adapters</a:t>
-            </a:r>
-          </a:p>
+              <a:t>Curating the Ingestion Search Terms:</a:t>
+            </a:r>
+          </a:p>
+          <a:p>
+            <a:pPr>
+              <a:defRPr sz="1400">
+                <a:solidFill>
+                  <a:srgbClr val="F8FAFC"/>
+                </a:solidFill>
+              </a:defRPr>
+            </a:pPr>
+            <a:r>
+              <a:t>• Discovery &amp; Exploration: search terms: 'discover', 'explore', 'new brand', 'not found', 'catalog gap'.</a:t>
+            </a:r>
+            <a:br/>
+            <a:r>
+              <a:t>• Recommendation Quality: search terms: 'fees', 'surcharge', 'charges', 'promo banner', 'minimum cart'.</a:t>
+            </a:r>
+            <a:br/>
+            <a:r>
+              <a:t>• Repetition &amp; Fatigue: search terms: 'same product', 'reorder', 'history', 'repeat', 'boring'.</a:t>
+            </a:r>
+          </a:p>
+        </p:txBody>
+      </p:sp>
+      <p:sp>
+        <p:nvSpPr>
+          <p:cNvPr id="8" name="TextBox 7"/>
+          <p:cNvSpPr txBox="1"/>
+          <p:nvPr/>
+        </p:nvSpPr>
+        <p:spPr>
+          <a:xfrm>
+            <a:off x="6217920" y="2743200"/>
+            <a:ext cx="5486400" cy="3474720"/>
+          </a:xfrm>
+          <a:prstGeom prst="rect">
+            <a:avLst/>
+          </a:prstGeom>
+          <a:noFill/>
+        </p:spPr>
+        <p:txBody>
+          <a:bodyPr wrap="square">
+            <a:spAutoFit/>
+          </a:bodyPr>
+          <a:lstStyle/>
           <a:p>
             <a:pPr>
               <a:spcAft>
-                <a:spcPts val="1200"/>
+                <a:spcPts val="800"/>
               </a:spcAft>
+              <a:defRPr b="1" sz="1400">
+                <a:solidFill>
+                  <a:srgbClr val="FC8019"/>
+                </a:solidFill>
+              </a:defRPr>
+            </a:pPr>
+            <a:r>
+              <a:t>Every Post Classified Into 6 Questions:</a:t>
+            </a:r>
+          </a:p>
+          <a:p>
+            <a:pPr>
               <a:defRPr sz="1400">
                 <a:solidFill>
                   <a:srgbClr val="F8FAFC"/>
@@ -5123,62 +5217,34 @@
               </a:defRPr>
             </a:pPr>
             <a:r>
-              <a:t>We wrote Python adapter scripts in `src/scrapers/` to fetch raw feeds from app stores and RSS: (e.g. `google-play-scraper` and custom iTunes XML parser):</a:t>
-            </a:r>
-          </a:p>
-          <a:p>
-            <a:pPr>
-              <a:spcAft>
-                <a:spcPts val="1500"/>
-              </a:spcAft>
-              <a:defRPr sz="1000">
-                <a:solidFill>
-                  <a:srgbClr val="A855F7"/>
-                </a:solidFill>
-                <a:latin typeface="Courier New"/>
-              </a:defRPr>
-            </a:pPr>
-            <a:r>
-              <a:t>class AppStoreScraper:</a:t>
+              <a:t>1. Why do users struggle to explore new categories?</a:t>
             </a:r>
             <a:br/>
             <a:r>
-              <a:t>  def fetch_rss(self, app_id, count=150):</a:t>
+              <a:t>2. What are the most common frustrations with home banners?</a:t>
             </a:r>
             <a:br/>
             <a:r>
-              <a:t>    url = f"https://itunes.apple.com/rss/customerreviews/id={app_id}/json"</a:t>
+              <a:t>3. What buying behaviors are users trying to achieve?</a:t>
             </a:r>
             <a:br/>
             <a:r>
-              <a:t>    resp = requests.get(url)</a:t>
+              <a:t>4. What causes users to repeatedly listen to reorder list history?</a:t>
             </a:r>
             <a:br/>
             <a:r>
-              <a:t>    entries = resp.json()['feed']['entry']</a:t>
+              <a:t>5. Which user segments experience different discovery challenges?</a:t>
             </a:r>
             <a:br/>
             <a:r>
-              <a:t>    return [entry['content']['label'] for entry in entries]</a:t>
-            </a:r>
-          </a:p>
-          <a:p>
-            <a:pPr>
-              <a:defRPr sz="1300">
-                <a:solidFill>
-                  <a:srgbClr val="8B949E"/>
-                </a:solidFill>
-              </a:defRPr>
-            </a:pPr>
-            <a:r>
-              <a:t>• Fallback logic: Auto-generates local templates if API thresholds are hit, guaranteeing pipeline stability.</a:t>
-            </a:r>
-          </a:p>
-        </p:txBody>
-      </p:sp>
-      <p:sp>
-        <p:nvSpPr>
-          <p:cNvPr id="7" name="TextBox 6"/>
+              <a:t>6. What unmet needs emerge consistently across discussions?</a:t>
+            </a:r>
+          </a:p>
+        </p:txBody>
+      </p:sp>
+      <p:sp>
+        <p:nvSpPr>
+          <p:cNvPr id="9" name="TextBox 8"/>
           <p:cNvSpPr txBox="1"/>
           <p:nvPr/>
         </p:nvSpPr>
@@ -5214,7 +5280,7 @@
       </p:sp>
       <p:sp>
         <p:nvSpPr>
-          <p:cNvPr id="8" name="TextBox 7"/>
+          <p:cNvPr id="10" name="TextBox 9"/>
           <p:cNvSpPr txBox="1"/>
           <p:nvPr/>
         </p:nvSpPr>
@@ -5259,14 +5325,6 @@
 <file path=ppt/slides/slide3.xml><?xml version="1.0" encoding="utf-8"?>
 <p:sld xmlns:a="http://schemas.openxmlformats.org/drawingml/2006/main" xmlns:p="http://schemas.openxmlformats.org/presentationml/2006/main" xmlns:r="http://schemas.openxmlformats.org/officeDocument/2006/relationships">
   <p:cSld>
-    <p:bg>
-      <p:bgPr>
-        <a:solidFill>
-          <a:srgbClr val="0D1117"/>
-        </a:solidFill>
-        <a:effectLst/>
-      </p:bgPr>
-    </p:bg>
     <p:spTree>
       <p:nvGrpSpPr>
         <p:cNvPr id="1" name=""/>
@@ -5277,6 +5335,49 @@
       <p:sp>
         <p:nvSpPr>
           <p:cNvPr id="2" name="Rectangle 1"/>
+          <p:cNvSpPr/>
+          <p:nvPr/>
+        </p:nvSpPr>
+        <p:spPr>
+          <a:xfrm>
+            <a:off x="0" y="0"/>
+            <a:ext cx="12191695" cy="6858000"/>
+          </a:xfrm>
+          <a:prstGeom prst="rect">
+            <a:avLst/>
+          </a:prstGeom>
+          <a:solidFill>
+            <a:srgbClr val="0D1117"/>
+          </a:solidFill>
+          <a:ln>
+            <a:noFill/>
+          </a:ln>
+        </p:spPr>
+        <p:style>
+          <a:lnRef idx="1">
+            <a:schemeClr val="accent1"/>
+          </a:lnRef>
+          <a:fillRef idx="3">
+            <a:schemeClr val="accent1"/>
+          </a:fillRef>
+          <a:effectRef idx="2">
+            <a:schemeClr val="accent1"/>
+          </a:effectRef>
+          <a:fontRef idx="minor">
+            <a:schemeClr val="lt1"/>
+          </a:fontRef>
+        </p:style>
+        <p:txBody>
+          <a:bodyPr rtlCol="0" anchor="ctr"/>
+          <a:lstStyle/>
+          <a:p>
+            <a:pPr algn="ctr"/>
+          </a:p>
+        </p:txBody>
+      </p:sp>
+      <p:sp>
+        <p:nvSpPr>
+          <p:cNvPr id="3" name="Rectangle 2"/>
           <p:cNvSpPr/>
           <p:nvPr/>
         </p:nvSpPr>
@@ -5321,7 +5422,7 @@
       </p:sp>
       <p:sp>
         <p:nvSpPr>
-          <p:cNvPr id="3" name="TextBox 2"/>
+          <p:cNvPr id="4" name="TextBox 3"/>
           <p:cNvSpPr txBox="1"/>
           <p:nvPr/>
         </p:nvSpPr>
@@ -5350,14 +5451,14 @@
               </a:defRPr>
             </a:pPr>
             <a:r>
-              <a:t>PART 1 · AI PIPELINE &amp; ML ENGINE</a:t>
-            </a:r>
-          </a:p>
-        </p:txBody>
-      </p:sp>
-      <p:sp>
-        <p:nvSpPr>
-          <p:cNvPr id="4" name="TextBox 3"/>
+              <a:t>PART 2 · SEGMENT &amp; PERSONA</a:t>
+            </a:r>
+          </a:p>
+        </p:txBody>
+      </p:sp>
+      <p:sp>
+        <p:nvSpPr>
+          <p:cNvPr id="5" name="TextBox 4"/>
           <p:cNvSpPr txBox="1"/>
           <p:nvPr/>
         </p:nvSpPr>
@@ -5386,208 +5487,987 @@
               </a:defRPr>
             </a:pPr>
             <a:r>
-              <a:t>7-Agent Ingestion Pipeline &amp; Text Vector Clustering (What Was Built)</a:t>
-            </a:r>
-          </a:p>
-        </p:txBody>
-      </p:sp>
-      <p:sp>
-        <p:nvSpPr>
-          <p:cNvPr id="5" name="TextBox 4"/>
-          <p:cNvSpPr txBox="1"/>
+              <a:t>Discovery Seekers &amp; General Users on Quick Commerce</a:t>
+            </a:r>
+          </a:p>
+        </p:txBody>
+      </p:sp>
+      <p:graphicFrame>
+        <p:nvGraphicFramePr>
+          <p:cNvPr id="6" name="Table 5"/>
+          <p:cNvGraphicFramePr>
+            <a:graphicFrameLocks noGrp="1"/>
+          </p:cNvGraphicFramePr>
           <p:nvPr/>
-        </p:nvSpPr>
-        <p:spPr>
-          <a:xfrm>
-            <a:off x="457200" y="1371600"/>
-            <a:ext cx="5486400" cy="4572000"/>
-          </a:xfrm>
-          <a:prstGeom prst="rect">
-            <a:avLst/>
-          </a:prstGeom>
-          <a:noFill/>
-        </p:spPr>
-        <p:txBody>
-          <a:bodyPr wrap="square">
-            <a:spAutoFit/>
-          </a:bodyPr>
-          <a:lstStyle/>
-          <a:p>
-            <a:pPr>
-              <a:spcAft>
-                <a:spcPts val="800"/>
-              </a:spcAft>
-              <a:defRPr b="1" sz="1500">
-                <a:solidFill>
-                  <a:srgbClr val="FC8019"/>
-                </a:solidFill>
-              </a:defRPr>
-            </a:pPr>
-            <a:r>
-              <a:t>1. 7-Agent Pipeline Orchestration Code</a:t>
-            </a:r>
-          </a:p>
-          <a:p>
-            <a:pPr>
-              <a:spcAft>
-                <a:spcPts val="1200"/>
-              </a:spcAft>
-              <a:defRPr sz="1400">
-                <a:solidFill>
-                  <a:srgbClr val="F8FAFC"/>
-                </a:solidFill>
-              </a:defRPr>
-            </a:pPr>
-            <a:r>
-              <a:t>We built `src/agents/pipeline_orchestrator.py` to coordinate the NLP sequence across cleaners, analyzers, clusterers, and synthesizers:</a:t>
-            </a:r>
-          </a:p>
-          <a:p>
-            <a:pPr>
-              <a:spcAft>
-                <a:spcPts val="1500"/>
-              </a:spcAft>
-              <a:defRPr sz="1000">
-                <a:solidFill>
-                  <a:srgbClr val="A855F7"/>
-                </a:solidFill>
-                <a:latin typeface="Courier New"/>
-              </a:defRPr>
-            </a:pPr>
-            <a:r>
-              <a:t>def run_pipeline(raw_review):</a:t>
-            </a:r>
-            <a:br/>
-            <a:r>
-              <a:t>  cleaned = CleanerAgent().clean(raw_review)</a:t>
-            </a:r>
-            <a:br/>
-            <a:r>
-              <a:t>  profile = AnalyzerAgent().analyze(cleaned)</a:t>
-            </a:r>
-            <a:br/>
-            <a:r>
-              <a:t>  opportunities = PrioritizerAgent().score(profile)</a:t>
-            </a:r>
-            <a:br/>
-            <a:r>
-              <a:t>  sqlite_conn.write_results(opportunities)</a:t>
-            </a:r>
-            <a:br/>
-            <a:r>
-              <a:t>  return opportunities</a:t>
-            </a:r>
-          </a:p>
-          <a:p>
-            <a:pPr>
-              <a:defRPr sz="1300">
-                <a:solidFill>
-                  <a:srgbClr val="8B949E"/>
-                </a:solidFill>
-              </a:defRPr>
-            </a:pPr>
-            <a:r>
-              <a:t>• Translation dictionary handles Hinglish: e.g. mehanga -&gt; expensive, kharab -&gt; bad, bekar -&gt; poor, bekar service -&gt; service failure.</a:t>
-            </a:r>
-          </a:p>
-        </p:txBody>
-      </p:sp>
-      <p:sp>
-        <p:nvSpPr>
-          <p:cNvPr id="6" name="TextBox 5"/>
-          <p:cNvSpPr txBox="1"/>
+        </p:nvGraphicFramePr>
+        <p:xfrm>
+          <a:off x="457200" y="1371600"/>
+          <a:ext cx="4572000" cy="4572000"/>
+        </p:xfrm>
+        <a:graphic>
+          <a:graphicData uri="http://schemas.openxmlformats.org/drawingml/2006/table">
+            <a:tbl>
+              <a:tblPr firstRow="1" bandRow="1">
+                <a:tableStyleId>{5C22544A-7EE6-4342-B048-85BDC9FD1C3A}</a:tableStyleId>
+              </a:tblPr>
+              <a:tblGrid>
+                <a:gridCol w="1645920"/>
+                <a:gridCol w="2926080"/>
+              </a:tblGrid>
+              <a:tr h="571500">
+                <a:tc>
+                  <a:txBody>
+                    <a:bodyPr/>
+                    <a:lstStyle/>
+                    <a:p>
+                      <a:pPr>
+                        <a:defRPr sz="1100" b="1">
+                          <a:solidFill>
+                            <a:srgbClr val="F8FAFC"/>
+                          </a:solidFill>
+                          <a:latin typeface="Arial"/>
+                        </a:defRPr>
+                      </a:pPr>
+                      <a:r>
+                        <a:t>Segment</a:t>
+                      </a:r>
+                    </a:p>
+                  </a:txBody>
+                  <a:tcPr>
+                    <a:solidFill>
+                      <a:srgbClr val="1F2937"/>
+                    </a:solidFill>
+                  </a:tcPr>
+                </a:tc>
+                <a:tc>
+                  <a:txBody>
+                    <a:bodyPr/>
+                    <a:lstStyle/>
+                    <a:p>
+                      <a:pPr>
+                        <a:defRPr sz="1100" b="0">
+                          <a:solidFill>
+                            <a:srgbClr val="F8FAFC"/>
+                          </a:solidFill>
+                          <a:latin typeface="Arial"/>
+                        </a:defRPr>
+                      </a:pPr>
+                      <a:r>
+                        <a:t>Working Professionals / Busy Parents</a:t>
+                      </a:r>
+                    </a:p>
+                  </a:txBody>
+                  <a:tcPr>
+                    <a:solidFill>
+                      <a:srgbClr val="1F2937"/>
+                    </a:solidFill>
+                  </a:tcPr>
+                </a:tc>
+              </a:tr>
+              <a:tr h="571500">
+                <a:tc>
+                  <a:txBody>
+                    <a:bodyPr/>
+                    <a:lstStyle/>
+                    <a:p>
+                      <a:pPr>
+                        <a:defRPr sz="1100" b="1">
+                          <a:solidFill>
+                            <a:srgbClr val="F8FAFC"/>
+                          </a:solidFill>
+                          <a:latin typeface="Arial"/>
+                        </a:defRPr>
+                      </a:pPr>
+                      <a:r>
+                        <a:t>Age Profile</a:t>
+                      </a:r>
+                    </a:p>
+                  </a:txBody>
+                  <a:tcPr>
+                    <a:solidFill>
+                      <a:srgbClr val="111827"/>
+                    </a:solidFill>
+                  </a:tcPr>
+                </a:tc>
+                <a:tc>
+                  <a:txBody>
+                    <a:bodyPr/>
+                    <a:lstStyle/>
+                    <a:p>
+                      <a:pPr>
+                        <a:defRPr sz="1100" b="0">
+                          <a:solidFill>
+                            <a:srgbClr val="F8FAFC"/>
+                          </a:solidFill>
+                          <a:latin typeface="Arial"/>
+                        </a:defRPr>
+                      </a:pPr>
+                      <a:r>
+                        <a:t>18-40 years (Gen-Z &amp; young millennials)</a:t>
+                      </a:r>
+                    </a:p>
+                  </a:txBody>
+                  <a:tcPr>
+                    <a:solidFill>
+                      <a:srgbClr val="111827"/>
+                    </a:solidFill>
+                  </a:tcPr>
+                </a:tc>
+              </a:tr>
+              <a:tr h="571500">
+                <a:tc>
+                  <a:txBody>
+                    <a:bodyPr/>
+                    <a:lstStyle/>
+                    <a:p>
+                      <a:pPr>
+                        <a:defRPr sz="1100" b="1">
+                          <a:solidFill>
+                            <a:srgbClr val="F8FAFC"/>
+                          </a:solidFill>
+                          <a:latin typeface="Arial"/>
+                        </a:defRPr>
+                      </a:pPr>
+                      <a:r>
+                        <a:t>Locations</a:t>
+                      </a:r>
+                    </a:p>
+                  </a:txBody>
+                  <a:tcPr>
+                    <a:solidFill>
+                      <a:srgbClr val="111827"/>
+                    </a:solidFill>
+                  </a:tcPr>
+                </a:tc>
+                <a:tc>
+                  <a:txBody>
+                    <a:bodyPr/>
+                    <a:lstStyle/>
+                    <a:p>
+                      <a:pPr>
+                        <a:defRPr sz="1100" b="0">
+                          <a:solidFill>
+                            <a:srgbClr val="F8FAFC"/>
+                          </a:solidFill>
+                          <a:latin typeface="Arial"/>
+                        </a:defRPr>
+                      </a:pPr>
+                      <a:r>
+                        <a:t>Tier 1 &amp; Tier 2 Indian cities</a:t>
+                      </a:r>
+                    </a:p>
+                  </a:txBody>
+                  <a:tcPr>
+                    <a:solidFill>
+                      <a:srgbClr val="111827"/>
+                    </a:solidFill>
+                  </a:tcPr>
+                </a:tc>
+              </a:tr>
+              <a:tr h="571500">
+                <a:tc>
+                  <a:txBody>
+                    <a:bodyPr/>
+                    <a:lstStyle/>
+                    <a:p>
+                      <a:pPr>
+                        <a:defRPr sz="1100" b="1">
+                          <a:solidFill>
+                            <a:srgbClr val="F8FAFC"/>
+                          </a:solidFill>
+                          <a:latin typeface="Arial"/>
+                        </a:defRPr>
+                      </a:pPr>
+                      <a:r>
+                        <a:t>Estimated Size</a:t>
+                      </a:r>
+                    </a:p>
+                  </a:txBody>
+                  <a:tcPr>
+                    <a:solidFill>
+                      <a:srgbClr val="111827"/>
+                    </a:solidFill>
+                  </a:tcPr>
+                </a:tc>
+                <a:tc>
+                  <a:txBody>
+                    <a:bodyPr/>
+                    <a:lstStyle/>
+                    <a:p>
+                      <a:pPr>
+                        <a:defRPr sz="1100" b="0">
+                          <a:solidFill>
+                            <a:srgbClr val="F8FAFC"/>
+                          </a:solidFill>
+                          <a:latin typeface="Arial"/>
+                        </a:defRPr>
+                      </a:pPr>
+                      <a:r>
+                        <a:t>~35M active monthly users</a:t>
+                      </a:r>
+                    </a:p>
+                  </a:txBody>
+                  <a:tcPr>
+                    <a:solidFill>
+                      <a:srgbClr val="111827"/>
+                    </a:solidFill>
+                  </a:tcPr>
+                </a:tc>
+              </a:tr>
+              <a:tr h="571500">
+                <a:tc>
+                  <a:txBody>
+                    <a:bodyPr/>
+                    <a:lstStyle/>
+                    <a:p>
+                      <a:pPr>
+                        <a:defRPr sz="1100" b="1">
+                          <a:solidFill>
+                            <a:srgbClr val="F8FAFC"/>
+                          </a:solidFill>
+                          <a:latin typeface="Arial"/>
+                        </a:defRPr>
+                      </a:pPr>
+                      <a:r>
+                        <a:t>Device Usage</a:t>
+                      </a:r>
+                    </a:p>
+                  </a:txBody>
+                  <a:tcPr>
+                    <a:solidFill>
+                      <a:srgbClr val="111827"/>
+                    </a:solidFill>
+                  </a:tcPr>
+                </a:tc>
+                <a:tc>
+                  <a:txBody>
+                    <a:bodyPr/>
+                    <a:lstStyle/>
+                    <a:p>
+                      <a:pPr>
+                        <a:defRPr sz="1100" b="0">
+                          <a:solidFill>
+                            <a:srgbClr val="F8FAFC"/>
+                          </a:solidFill>
+                          <a:latin typeface="Arial"/>
+                        </a:defRPr>
+                      </a:pPr>
+                      <a:r>
+                        <a:t>Mobile-first (iOS &amp; Android apps)</a:t>
+                      </a:r>
+                    </a:p>
+                  </a:txBody>
+                  <a:tcPr>
+                    <a:solidFill>
+                      <a:srgbClr val="111827"/>
+                    </a:solidFill>
+                  </a:tcPr>
+                </a:tc>
+              </a:tr>
+              <a:tr h="571500">
+                <a:tc>
+                  <a:txBody>
+                    <a:bodyPr/>
+                    <a:lstStyle/>
+                    <a:p>
+                      <a:pPr>
+                        <a:defRPr sz="1100" b="1">
+                          <a:solidFill>
+                            <a:srgbClr val="F8FAFC"/>
+                          </a:solidFill>
+                          <a:latin typeface="Arial"/>
+                        </a:defRPr>
+                      </a:pPr>
+                      <a:r>
+                        <a:t>Language Profile</a:t>
+                      </a:r>
+                    </a:p>
+                  </a:txBody>
+                  <a:tcPr>
+                    <a:solidFill>
+                      <a:srgbClr val="111827"/>
+                    </a:solidFill>
+                  </a:tcPr>
+                </a:tc>
+                <a:tc>
+                  <a:txBody>
+                    <a:bodyPr/>
+                    <a:lstStyle/>
+                    <a:p>
+                      <a:pPr>
+                        <a:defRPr sz="1100" b="0">
+                          <a:solidFill>
+                            <a:srgbClr val="F8FAFC"/>
+                          </a:solidFill>
+                          <a:latin typeface="Arial"/>
+                        </a:defRPr>
+                      </a:pPr>
+                      <a:r>
+                        <a:t>Hinglish, English, regional scripts</a:t>
+                      </a:r>
+                    </a:p>
+                  </a:txBody>
+                  <a:tcPr>
+                    <a:solidFill>
+                      <a:srgbClr val="111827"/>
+                    </a:solidFill>
+                  </a:tcPr>
+                </a:tc>
+              </a:tr>
+              <a:tr h="571500">
+                <a:tc>
+                  <a:txBody>
+                    <a:bodyPr/>
+                    <a:lstStyle/>
+                    <a:p>
+                      <a:pPr>
+                        <a:defRPr sz="1100" b="1">
+                          <a:solidFill>
+                            <a:srgbClr val="F8FAFC"/>
+                          </a:solidFill>
+                          <a:latin typeface="Arial"/>
+                        </a:defRPr>
+                      </a:pPr>
+                      <a:r>
+                        <a:t>Payment Default</a:t>
+                      </a:r>
+                    </a:p>
+                  </a:txBody>
+                  <a:tcPr>
+                    <a:solidFill>
+                      <a:srgbClr val="111827"/>
+                    </a:solidFill>
+                  </a:tcPr>
+                </a:tc>
+                <a:tc>
+                  <a:txBody>
+                    <a:bodyPr/>
+                    <a:lstStyle/>
+                    <a:p>
+                      <a:pPr>
+                        <a:defRPr sz="1100" b="0">
+                          <a:solidFill>
+                            <a:srgbClr val="F8FAFC"/>
+                          </a:solidFill>
+                          <a:latin typeface="Arial"/>
+                        </a:defRPr>
+                      </a:pPr>
+                      <a:r>
+                        <a:t>97% UPI / Instant wallets</a:t>
+                      </a:r>
+                    </a:p>
+                  </a:txBody>
+                  <a:tcPr>
+                    <a:solidFill>
+                      <a:srgbClr val="111827"/>
+                    </a:solidFill>
+                  </a:tcPr>
+                </a:tc>
+              </a:tr>
+              <a:tr h="571500">
+                <a:tc>
+                  <a:txBody>
+                    <a:bodyPr/>
+                    <a:lstStyle/>
+                    <a:p>
+                      <a:pPr>
+                        <a:defRPr sz="1100" b="1">
+                          <a:solidFill>
+                            <a:srgbClr val="F8FAFC"/>
+                          </a:solidFill>
+                          <a:latin typeface="Arial"/>
+                        </a:defRPr>
+                      </a:pPr>
+                      <a:r>
+                        <a:t>Listening/Cart</a:t>
+                      </a:r>
+                    </a:p>
+                  </a:txBody>
+                  <a:tcPr>
+                    <a:solidFill>
+                      <a:srgbClr val="111827"/>
+                    </a:solidFill>
+                  </a:tcPr>
+                </a:tc>
+                <a:tc>
+                  <a:txBody>
+                    <a:bodyPr/>
+                    <a:lstStyle/>
+                    <a:p>
+                      <a:pPr>
+                        <a:defRPr sz="1100" b="0">
+                          <a:solidFill>
+                            <a:srgbClr val="F8FAFC"/>
+                          </a:solidFill>
+                          <a:latin typeface="Arial"/>
+                        </a:defRPr>
+                      </a:pPr>
+                      <a:r>
+                        <a:t>75% repeat lists, 94% validation score</a:t>
+                      </a:r>
+                    </a:p>
+                  </a:txBody>
+                  <a:tcPr>
+                    <a:solidFill>
+                      <a:srgbClr val="111827"/>
+                    </a:solidFill>
+                  </a:tcPr>
+                </a:tc>
+              </a:tr>
+            </a:tbl>
+          </a:graphicData>
+        </a:graphic>
+      </p:graphicFrame>
+      <p:graphicFrame>
+        <p:nvGraphicFramePr>
+          <p:cNvPr id="7" name="Table 6"/>
+          <p:cNvGraphicFramePr>
+            <a:graphicFrameLocks noGrp="1"/>
+          </p:cNvGraphicFramePr>
           <p:nvPr/>
-        </p:nvSpPr>
-        <p:spPr>
-          <a:xfrm>
-            <a:off x="6217920" y="1371600"/>
-            <a:ext cx="5486400" cy="4572000"/>
-          </a:xfrm>
-          <a:prstGeom prst="rect">
-            <a:avLst/>
-          </a:prstGeom>
-          <a:noFill/>
-        </p:spPr>
-        <p:txBody>
-          <a:bodyPr wrap="square">
-            <a:spAutoFit/>
-          </a:bodyPr>
-          <a:lstStyle/>
-          <a:p>
-            <a:pPr>
-              <a:spcAft>
-                <a:spcPts val="800"/>
-              </a:spcAft>
-              <a:defRPr b="1" sz="1500">
-                <a:solidFill>
-                  <a:srgbClr val="FC8019"/>
-                </a:solidFill>
-              </a:defRPr>
-            </a:pPr>
-            <a:r>
-              <a:t>2. Machine Learning K-Means Clustering</a:t>
-            </a:r>
-          </a:p>
-          <a:p>
-            <a:pPr>
-              <a:spcAft>
-                <a:spcPts val="1200"/>
-              </a:spcAft>
-              <a:defRPr sz="1400">
-                <a:solidFill>
-                  <a:srgbClr val="F8FAFC"/>
-                </a:solidFill>
-              </a:defRPr>
-            </a:pPr>
-            <a:r>
-              <a:t>We wrote `src/pipeline/clusterer.py` to vectorize text via TF-IDF (Term Frequency-Inverse Document Frequency) and cluster them via K-Means (K=4) to auto-group feedback subthemes:</a:t>
-            </a:r>
-          </a:p>
-          <a:p>
-            <a:pPr>
-              <a:spcAft>
-                <a:spcPts val="1500"/>
-              </a:spcAft>
-              <a:defRPr sz="1000">
-                <a:solidFill>
-                  <a:srgbClr val="A855F7"/>
-                </a:solidFill>
-                <a:latin typeface="Courier New"/>
-              </a:defRPr>
-            </a:pPr>
-            <a:r>
-              <a:t>vectorizer = TfidfVectorizer(max_features=500)</a:t>
-            </a:r>
-            <a:br/>
-            <a:r>
-              <a:t>X = vectorizer.fit_transform(reviews_df['cleaned_text'])</a:t>
-            </a:r>
-            <a:br/>
-            <a:r>
-              <a:t>kmeans = KMeans(n_clusters=4, random_state=42)</a:t>
-            </a:r>
-            <a:br/>
-            <a:r>
-              <a:t>reviews_df['cluster'] = kmeans.fit_predict(X)</a:t>
-            </a:r>
-          </a:p>
-          <a:p>
-            <a:pPr>
-              <a:defRPr sz="1300">
-                <a:solidFill>
-                  <a:srgbClr val="8B949E"/>
-                </a:solidFill>
-              </a:defRPr>
-            </a:pPr>
-            <a:r>
-              <a:t>• Centroid output: Grouped feedback into 3 core loops (Fees, Freshness trust, UI noise) with mathematical accuracy.</a:t>
-            </a:r>
-          </a:p>
-        </p:txBody>
-      </p:sp>
-      <p:sp>
-        <p:nvSpPr>
-          <p:cNvPr id="7" name="TextBox 6"/>
+        </p:nvGraphicFramePr>
+        <p:xfrm>
+          <a:off x="5212080" y="1371600"/>
+          <a:ext cx="6522415" cy="4572000"/>
+        </p:xfrm>
+        <a:graphic>
+          <a:graphicData uri="http://schemas.openxmlformats.org/drawingml/2006/table">
+            <a:tbl>
+              <a:tblPr firstRow="1" bandRow="1">
+                <a:tableStyleId>{5C22544A-7EE6-4342-B048-85BDC9FD1C3A}</a:tableStyleId>
+              </a:tblPr>
+              <a:tblGrid>
+                <a:gridCol w="1097280"/>
+                <a:gridCol w="1463040"/>
+                <a:gridCol w="1371600"/>
+                <a:gridCol w="1280160"/>
+                <a:gridCol w="1310335"/>
+              </a:tblGrid>
+              <a:tr h="1143000">
+                <a:tc>
+                  <a:txBody>
+                    <a:bodyPr/>
+                    <a:lstStyle/>
+                    <a:p>
+                      <a:pPr>
+                        <a:defRPr sz="1000" b="1">
+                          <a:solidFill>
+                            <a:srgbClr val="F8FAFC"/>
+                          </a:solidFill>
+                          <a:latin typeface="Arial"/>
+                        </a:defRPr>
+                      </a:pPr>
+                      <a:r>
+                        <a:t>Persona</a:t>
+                      </a:r>
+                    </a:p>
+                  </a:txBody>
+                  <a:tcPr>
+                    <a:solidFill>
+                      <a:srgbClr val="1F2937"/>
+                    </a:solidFill>
+                  </a:tcPr>
+                </a:tc>
+                <a:tc>
+                  <a:txBody>
+                    <a:bodyPr/>
+                    <a:lstStyle/>
+                    <a:p>
+                      <a:pPr>
+                        <a:defRPr sz="1000" b="1">
+                          <a:solidFill>
+                            <a:srgbClr val="F8FAFC"/>
+                          </a:solidFill>
+                          <a:latin typeface="Arial"/>
+                        </a:defRPr>
+                      </a:pPr>
+                      <a:r>
+                        <a:t>Behavior Pattern</a:t>
+                      </a:r>
+                    </a:p>
+                  </a:txBody>
+                  <a:tcPr>
+                    <a:solidFill>
+                      <a:srgbClr val="1F2937"/>
+                    </a:solidFill>
+                  </a:tcPr>
+                </a:tc>
+                <a:tc>
+                  <a:txBody>
+                    <a:bodyPr/>
+                    <a:lstStyle/>
+                    <a:p>
+                      <a:pPr>
+                        <a:defRPr sz="1000" b="1">
+                          <a:solidFill>
+                            <a:srgbClr val="F8FAFC"/>
+                          </a:solidFill>
+                          <a:latin typeface="Arial"/>
+                        </a:defRPr>
+                      </a:pPr>
+                      <a:r>
+                        <a:t>Core Frustration</a:t>
+                      </a:r>
+                    </a:p>
+                  </a:txBody>
+                  <a:tcPr>
+                    <a:solidFill>
+                      <a:srgbClr val="1F2937"/>
+                    </a:solidFill>
+                  </a:tcPr>
+                </a:tc>
+                <a:tc>
+                  <a:txBody>
+                    <a:bodyPr/>
+                    <a:lstStyle/>
+                    <a:p>
+                      <a:pPr>
+                        <a:defRPr sz="1000" b="1">
+                          <a:solidFill>
+                            <a:srgbClr val="F8FAFC"/>
+                          </a:solidFill>
+                          <a:latin typeface="Arial"/>
+                        </a:defRPr>
+                      </a:pPr>
+                      <a:r>
+                        <a:t>Job to be Done</a:t>
+                      </a:r>
+                    </a:p>
+                  </a:txBody>
+                  <a:tcPr>
+                    <a:solidFill>
+                      <a:srgbClr val="1F2937"/>
+                    </a:solidFill>
+                  </a:tcPr>
+                </a:tc>
+                <a:tc>
+                  <a:txBody>
+                    <a:bodyPr/>
+                    <a:lstStyle/>
+                    <a:p>
+                      <a:pPr>
+                        <a:defRPr sz="1000" b="1">
+                          <a:solidFill>
+                            <a:srgbClr val="F8FAFC"/>
+                          </a:solidFill>
+                          <a:latin typeface="Arial"/>
+                        </a:defRPr>
+                      </a:pPr>
+                      <a:r>
+                        <a:t>Unmet Need</a:t>
+                      </a:r>
+                    </a:p>
+                  </a:txBody>
+                  <a:tcPr>
+                    <a:solidFill>
+                      <a:srgbClr val="1F2937"/>
+                    </a:solidFill>
+                  </a:tcPr>
+                </a:tc>
+              </a:tr>
+              <a:tr h="1143000">
+                <a:tc>
+                  <a:txBody>
+                    <a:bodyPr/>
+                    <a:lstStyle/>
+                    <a:p>
+                      <a:pPr>
+                        <a:defRPr sz="900" b="1">
+                          <a:solidFill>
+                            <a:srgbClr val="F8FAFC"/>
+                          </a:solidFill>
+                          <a:latin typeface="Arial"/>
+                        </a:defRPr>
+                      </a:pPr>
+                      <a:r>
+                        <a:t>Rohan, 29</a:t>
+                      </a:r>
+                    </a:p>
+                    <a:p>
+                      <a:r>
+                        <a:t>Software Eng</a:t>
+                      </a:r>
+                    </a:p>
+                    <a:p>
+                      <a:r>
+                        <a:t>Bangalore</a:t>
+                      </a:r>
+                    </a:p>
+                  </a:txBody>
+                  <a:tcPr>
+                    <a:solidFill>
+                      <a:srgbClr val="111827"/>
+                    </a:solidFill>
+                  </a:tcPr>
+                </a:tc>
+                <a:tc>
+                  <a:txBody>
+                    <a:bodyPr/>
+                    <a:lstStyle/>
+                    <a:p>
+                      <a:pPr>
+                        <a:defRPr sz="900" b="0">
+                          <a:solidFill>
+                            <a:srgbClr val="F8FAFC"/>
+                          </a:solidFill>
+                          <a:latin typeface="Arial"/>
+                        </a:defRPr>
+                      </a:pPr>
+                      <a:r>
+                        <a:t>Orders milk daily via reorders. Bypasses catalog.</a:t>
+                      </a:r>
+                    </a:p>
+                  </a:txBody>
+                  <a:tcPr>
+                    <a:solidFill>
+                      <a:srgbClr val="111827"/>
+                    </a:solidFill>
+                  </a:tcPr>
+                </a:tc>
+                <a:tc>
+                  <a:txBody>
+                    <a:bodyPr/>
+                    <a:lstStyle/>
+                    <a:p>
+                      <a:pPr>
+                        <a:defRPr sz="900" b="0">
+                          <a:solidFill>
+                            <a:srgbClr val="F8FAFC"/>
+                          </a:solidFill>
+                          <a:latin typeface="Arial"/>
+                        </a:defRPr>
+                      </a:pPr>
+                      <a:r>
+                        <a:t>Delivery fee surcharges on small single add-on items.</a:t>
+                      </a:r>
+                    </a:p>
+                  </a:txBody>
+                  <a:tcPr>
+                    <a:solidFill>
+                      <a:srgbClr val="111827"/>
+                    </a:solidFill>
+                  </a:tcPr>
+                </a:tc>
+                <a:tc>
+                  <a:txBody>
+                    <a:bodyPr/>
+                    <a:lstStyle/>
+                    <a:p>
+                      <a:pPr>
+                        <a:defRPr sz="900" b="0">
+                          <a:solidFill>
+                            <a:srgbClr val="F8FAFC"/>
+                          </a:solidFill>
+                          <a:latin typeface="Arial"/>
+                        </a:defRPr>
+                      </a:pPr>
+                      <a:r>
+                        <a:t>Test new high-margin categories with zero fee friction.</a:t>
+                      </a:r>
+                    </a:p>
+                  </a:txBody>
+                  <a:tcPr>
+                    <a:solidFill>
+                      <a:srgbClr val="111827"/>
+                    </a:solidFill>
+                  </a:tcPr>
+                </a:tc>
+                <a:tc>
+                  <a:txBody>
+                    <a:bodyPr/>
+                    <a:lstStyle/>
+                    <a:p>
+                      <a:pPr>
+                        <a:defRPr sz="900" b="0">
+                          <a:solidFill>
+                            <a:srgbClr val="FF9F43"/>
+                          </a:solidFill>
+                          <a:latin typeface="Arial"/>
+                        </a:defRPr>
+                      </a:pPr>
+                      <a:r>
+                        <a:t>Post-checkout no-fee append window.</a:t>
+                      </a:r>
+                    </a:p>
+                  </a:txBody>
+                  <a:tcPr>
+                    <a:solidFill>
+                      <a:srgbClr val="111827"/>
+                    </a:solidFill>
+                  </a:tcPr>
+                </a:tc>
+              </a:tr>
+              <a:tr h="1143000">
+                <a:tc>
+                  <a:txBody>
+                    <a:bodyPr/>
+                    <a:lstStyle/>
+                    <a:p>
+                      <a:pPr>
+                        <a:defRPr sz="900" b="1">
+                          <a:solidFill>
+                            <a:srgbClr val="F8FAFC"/>
+                          </a:solidFill>
+                          <a:latin typeface="Arial"/>
+                        </a:defRPr>
+                      </a:pPr>
+                      <a:r>
+                        <a:t>Meera, 42</a:t>
+                      </a:r>
+                    </a:p>
+                    <a:p>
+                      <a:r>
+                        <a:t>Homemaker</a:t>
+                      </a:r>
+                    </a:p>
+                    <a:p>
+                      <a:r>
+                        <a:t>Mumbai</a:t>
+                      </a:r>
+                    </a:p>
+                  </a:txBody>
+                  <a:tcPr>
+                    <a:solidFill>
+                      <a:srgbClr val="111827"/>
+                    </a:solidFill>
+                  </a:tcPr>
+                </a:tc>
+                <a:tc>
+                  <a:txBody>
+                    <a:bodyPr/>
+                    <a:lstStyle/>
+                    <a:p>
+                      <a:pPr>
+                        <a:defRPr sz="900" b="0">
+                          <a:solidFill>
+                            <a:srgbClr val="F8FAFC"/>
+                          </a:solidFill>
+                          <a:latin typeface="Arial"/>
+                        </a:defRPr>
+                      </a:pPr>
+                      <a:r>
+                        <a:t>Buys vegetables and grocery items occasionally.</a:t>
+                      </a:r>
+                    </a:p>
+                  </a:txBody>
+                  <a:tcPr>
+                    <a:solidFill>
+                      <a:srgbClr val="111827"/>
+                    </a:solidFill>
+                  </a:tcPr>
+                </a:tc>
+                <a:tc>
+                  <a:txBody>
+                    <a:bodyPr/>
+                    <a:lstStyle/>
+                    <a:p>
+                      <a:pPr>
+                        <a:defRPr sz="900" b="0">
+                          <a:solidFill>
+                            <a:srgbClr val="F8FAFC"/>
+                          </a:solidFill>
+                          <a:latin typeface="Arial"/>
+                        </a:defRPr>
+                      </a:pPr>
+                      <a:r>
+                        <a:t>Bad fresh produce batches; wallet-only refunds.</a:t>
+                      </a:r>
+                    </a:p>
+                  </a:txBody>
+                  <a:tcPr>
+                    <a:solidFill>
+                      <a:srgbClr val="111827"/>
+                    </a:solidFill>
+                  </a:tcPr>
+                </a:tc>
+                <a:tc>
+                  <a:txBody>
+                    <a:bodyPr/>
+                    <a:lstStyle/>
+                    <a:p>
+                      <a:pPr>
+                        <a:defRPr sz="900" b="0">
+                          <a:solidFill>
+                            <a:srgbClr val="F8FAFC"/>
+                          </a:solidFill>
+                          <a:latin typeface="Arial"/>
+                        </a:defRPr>
+                      </a:pPr>
+                      <a:r>
+                        <a:t>Buy produce with complete freshness trust and cash refund.</a:t>
+                      </a:r>
+                    </a:p>
+                  </a:txBody>
+                  <a:tcPr>
+                    <a:solidFill>
+                      <a:srgbClr val="111827"/>
+                    </a:solidFill>
+                  </a:tcPr>
+                </a:tc>
+                <a:tc>
+                  <a:txBody>
+                    <a:bodyPr/>
+                    <a:lstStyle/>
+                    <a:p>
+                      <a:pPr>
+                        <a:defRPr sz="900" b="0">
+                          <a:solidFill>
+                            <a:srgbClr val="FF9F43"/>
+                          </a:solidFill>
+                          <a:latin typeface="Arial"/>
+                        </a:defRPr>
+                      </a:pPr>
+                      <a:r>
+                        <a:t>Visual expiration &amp; freshness metrics.</a:t>
+                      </a:r>
+                    </a:p>
+                  </a:txBody>
+                  <a:tcPr>
+                    <a:solidFill>
+                      <a:srgbClr val="111827"/>
+                    </a:solidFill>
+                  </a:tcPr>
+                </a:tc>
+              </a:tr>
+              <a:tr h="1143000">
+                <a:tc>
+                  <a:txBody>
+                    <a:bodyPr/>
+                    <a:lstStyle/>
+                    <a:p>
+                      <a:pPr>
+                        <a:defRPr sz="900" b="1">
+                          <a:solidFill>
+                            <a:srgbClr val="F8FAFC"/>
+                          </a:solidFill>
+                          <a:latin typeface="Arial"/>
+                        </a:defRPr>
+                      </a:pPr>
+                      <a:r>
+                        <a:t>Priya, 35</a:t>
+                      </a:r>
+                    </a:p>
+                    <a:p>
+                      <a:r>
+                        <a:t>Pet/Baby Parent</a:t>
+                      </a:r>
+                    </a:p>
+                    <a:p>
+                      <a:r>
+                        <a:t>Pune</a:t>
+                      </a:r>
+                    </a:p>
+                  </a:txBody>
+                  <a:tcPr>
+                    <a:solidFill>
+                      <a:srgbClr val="111827"/>
+                    </a:solidFill>
+                  </a:tcPr>
+                </a:tc>
+                <a:tc>
+                  <a:txBody>
+                    <a:bodyPr/>
+                    <a:lstStyle/>
+                    <a:p>
+                      <a:pPr>
+                        <a:defRPr sz="900" b="0">
+                          <a:solidFill>
+                            <a:srgbClr val="F8FAFC"/>
+                          </a:solidFill>
+                          <a:latin typeface="Arial"/>
+                        </a:defRPr>
+                      </a:pPr>
+                      <a:r>
+                        <a:t>Buys premium baby wipes and dog food bags.</a:t>
+                      </a:r>
+                    </a:p>
+                  </a:txBody>
+                  <a:tcPr>
+                    <a:solidFill>
+                      <a:srgbClr val="111827"/>
+                    </a:solidFill>
+                  </a:tcPr>
+                </a:tc>
+                <a:tc>
+                  <a:txBody>
+                    <a:bodyPr/>
+                    <a:lstStyle/>
+                    <a:p>
+                      <a:pPr>
+                        <a:defRPr sz="900" b="0">
+                          <a:solidFill>
+                            <a:srgbClr val="F8FAFC"/>
+                          </a:solidFill>
+                          <a:latin typeface="Arial"/>
+                        </a:defRPr>
+                      </a:pPr>
+                      <a:r>
+                        <a:t>App lacks diaper size charts and product reviews.</a:t>
+                      </a:r>
+                    </a:p>
+                  </a:txBody>
+                  <a:tcPr>
+                    <a:solidFill>
+                      <a:srgbClr val="111827"/>
+                    </a:solidFill>
+                  </a:tcPr>
+                </a:tc>
+                <a:tc>
+                  <a:txBody>
+                    <a:bodyPr/>
+                    <a:lstStyle/>
+                    <a:p>
+                      <a:pPr>
+                        <a:defRPr sz="900" b="0">
+                          <a:solidFill>
+                            <a:srgbClr val="F8FAFC"/>
+                          </a:solidFill>
+                          <a:latin typeface="Arial"/>
+                        </a:defRPr>
+                      </a:pPr>
+                      <a:r>
+                        <a:t>Validate specifications before buying.</a:t>
+                      </a:r>
+                    </a:p>
+                  </a:txBody>
+                  <a:tcPr>
+                    <a:solidFill>
+                      <a:srgbClr val="111827"/>
+                    </a:solidFill>
+                  </a:tcPr>
+                </a:tc>
+                <a:tc>
+                  <a:txBody>
+                    <a:bodyPr/>
+                    <a:lstStyle/>
+                    <a:p>
+                      <a:pPr>
+                        <a:defRPr sz="900" b="0">
+                          <a:solidFill>
+                            <a:srgbClr val="FF9F43"/>
+                          </a:solidFill>
+                          <a:latin typeface="Arial"/>
+                        </a:defRPr>
+                      </a:pPr>
+                      <a:r>
+                        <a:t>Detailed specifications charts inside app.</a:t>
+                      </a:r>
+                    </a:p>
+                  </a:txBody>
+                  <a:tcPr>
+                    <a:solidFill>
+                      <a:srgbClr val="111827"/>
+                    </a:solidFill>
+                  </a:tcPr>
+                </a:tc>
+              </a:tr>
+            </a:tbl>
+          </a:graphicData>
+        </a:graphic>
+      </p:graphicFrame>
+      <p:sp>
+        <p:nvSpPr>
+          <p:cNvPr id="8" name="TextBox 7"/>
           <p:cNvSpPr txBox="1"/>
           <p:nvPr/>
         </p:nvSpPr>
@@ -5623,7 +6503,7 @@
       </p:sp>
       <p:sp>
         <p:nvSpPr>
-          <p:cNvPr id="8" name="TextBox 7"/>
+          <p:cNvPr id="9" name="TextBox 8"/>
           <p:cNvSpPr txBox="1"/>
           <p:nvPr/>
         </p:nvSpPr>
@@ -5668,14 +6548,6 @@
 <file path=ppt/slides/slide4.xml><?xml version="1.0" encoding="utf-8"?>
 <p:sld xmlns:a="http://schemas.openxmlformats.org/drawingml/2006/main" xmlns:p="http://schemas.openxmlformats.org/presentationml/2006/main" xmlns:r="http://schemas.openxmlformats.org/officeDocument/2006/relationships">
   <p:cSld>
-    <p:bg>
-      <p:bgPr>
-        <a:solidFill>
-          <a:srgbClr val="0D1117"/>
-        </a:solidFill>
-        <a:effectLst/>
-      </p:bgPr>
-    </p:bg>
     <p:spTree>
       <p:nvGrpSpPr>
         <p:cNvPr id="1" name=""/>
@@ -5686,6 +6558,49 @@
       <p:sp>
         <p:nvSpPr>
           <p:cNvPr id="2" name="Rectangle 1"/>
+          <p:cNvSpPr/>
+          <p:nvPr/>
+        </p:nvSpPr>
+        <p:spPr>
+          <a:xfrm>
+            <a:off x="0" y="0"/>
+            <a:ext cx="12191695" cy="6858000"/>
+          </a:xfrm>
+          <a:prstGeom prst="rect">
+            <a:avLst/>
+          </a:prstGeom>
+          <a:solidFill>
+            <a:srgbClr val="0D1117"/>
+          </a:solidFill>
+          <a:ln>
+            <a:noFill/>
+          </a:ln>
+        </p:spPr>
+        <p:style>
+          <a:lnRef idx="1">
+            <a:schemeClr val="accent1"/>
+          </a:lnRef>
+          <a:fillRef idx="3">
+            <a:schemeClr val="accent1"/>
+          </a:fillRef>
+          <a:effectRef idx="2">
+            <a:schemeClr val="accent1"/>
+          </a:effectRef>
+          <a:fontRef idx="minor">
+            <a:schemeClr val="lt1"/>
+          </a:fontRef>
+        </p:style>
+        <p:txBody>
+          <a:bodyPr rtlCol="0" anchor="ctr"/>
+          <a:lstStyle/>
+          <a:p>
+            <a:pPr algn="ctr"/>
+          </a:p>
+        </p:txBody>
+      </p:sp>
+      <p:sp>
+        <p:nvSpPr>
+          <p:cNvPr id="3" name="Rectangle 2"/>
           <p:cNvSpPr/>
           <p:nvPr/>
         </p:nvSpPr>
@@ -5730,7 +6645,7 @@
       </p:sp>
       <p:sp>
         <p:nvSpPr>
-          <p:cNvPr id="3" name="TextBox 2"/>
+          <p:cNvPr id="4" name="TextBox 3"/>
           <p:cNvSpPr txBox="1"/>
           <p:nvPr/>
         </p:nvSpPr>
@@ -5759,14 +6674,14 @@
               </a:defRPr>
             </a:pPr>
             <a:r>
-              <a:t>PART 1 · API &amp; DASHBOARD LAYER</a:t>
-            </a:r>
-          </a:p>
-        </p:txBody>
-      </p:sp>
-      <p:sp>
-        <p:nvSpPr>
-          <p:cNvPr id="4" name="TextBox 3"/>
+              <a:t>PART 2 · ASSUMED HYPOTHESES</a:t>
+            </a:r>
+          </a:p>
+        </p:txBody>
+      </p:sp>
+      <p:sp>
+        <p:nvSpPr>
+          <p:cNvPr id="5" name="TextBox 4"/>
           <p:cNvSpPr txBox="1"/>
           <p:nvPr/>
         </p:nvSpPr>
@@ -5795,21 +6710,21 @@
               </a:defRPr>
             </a:pPr>
             <a:r>
-              <a:t>FastAPI Backend REST endpoints &amp; Streamlit dashboard (What Was Built)</a:t>
-            </a:r>
-          </a:p>
-        </p:txBody>
-      </p:sp>
-      <p:sp>
-        <p:nvSpPr>
-          <p:cNvPr id="5" name="TextBox 4"/>
+              <a:t>4 Hypotheses We Assumed Based on AI-Generated Insights</a:t>
+            </a:r>
+          </a:p>
+        </p:txBody>
+      </p:sp>
+      <p:sp>
+        <p:nvSpPr>
+          <p:cNvPr id="6" name="TextBox 5"/>
           <p:cNvSpPr txBox="1"/>
           <p:nvPr/>
         </p:nvSpPr>
         <p:spPr>
           <a:xfrm>
             <a:off x="457200" y="1371600"/>
-            <a:ext cx="5486400" cy="4572000"/>
+            <a:ext cx="5303520" cy="2011680"/>
           </a:xfrm>
           <a:prstGeom prst="rect">
             <a:avLst/>
@@ -5833,14 +6748,11 @@
               </a:defRPr>
             </a:pPr>
             <a:r>
-              <a:t>1. FastAPI REST Controllers Gateway</a:t>
+              <a:t>H1: Delivery Fee Tax → Habitual Reordering &amp; Churn</a:t>
             </a:r>
           </a:p>
           <a:p>
             <a:pPr>
-              <a:spcAft>
-                <a:spcPts val="1200"/>
-              </a:spcAft>
               <a:defRPr sz="1400">
                 <a:solidFill>
                   <a:srgbClr val="F8FAFC"/>
@@ -5848,69 +6760,25 @@
               </a:defRPr>
             </a:pPr>
             <a:r>
-              <a:t>We wrote backend server routes in `src/api/main.py` using FastAPI to expose SQL database results to the dashboard UI:</a:t>
-            </a:r>
-          </a:p>
-          <a:p>
-            <a:pPr>
-              <a:spcAft>
-                <a:spcPts val="1500"/>
-              </a:spcAft>
-              <a:defRPr sz="1000">
-                <a:solidFill>
-                  <a:srgbClr val="A855F7"/>
-                </a:solidFill>
-                <a:latin typeface="Courier New"/>
-              </a:defRPr>
-            </a:pPr>
-            <a:r>
-              <a:t>app = FastAPI()</a:t>
+              <a:t>Instamart charges full delivery fees on small orders. This blocks users from testing low-risk auxiliary categories (like a face wash) as single item add-ons.</a:t>
             </a:r>
             <a:br/>
             <a:r>
-              <a:t>@app.get("/api/opportunities")</a:t>
-            </a:r>
-            <a:br/>
-            <a:r>
-              <a:t>def get_opportunities():</a:t>
-            </a:r>
-            <a:br/>
-            <a:r>
-              <a:t>  cursor = sqlite_db.cursor()</a:t>
-            </a:r>
-            <a:br/>
-            <a:r>
-              <a:t>  cursor.execute("SELECT * FROM opportunities")</a:t>
-            </a:r>
-            <a:br/>
-            <a:r>
-              <a:t>  return [dict(row) for row in cursor.fetchall()]</a:t>
-            </a:r>
-          </a:p>
-          <a:p>
-            <a:pPr>
-              <a:defRPr sz="1300">
-                <a:solidFill>
-                  <a:srgbClr val="8B949E"/>
-                </a:solidFill>
-              </a:defRPr>
-            </a:pPr>
-            <a:r>
-              <a:t>• Standards: Followed clean REST practices. Integrated Swagger UI docs at `/docs` endpoint for backend API validation.</a:t>
-            </a:r>
-          </a:p>
-        </p:txBody>
-      </p:sp>
-      <p:sp>
-        <p:nvSpPr>
-          <p:cNvPr id="6" name="TextBox 5"/>
+              <a:t>Tag: Delivery Fee Friction</a:t>
+            </a:r>
+          </a:p>
+        </p:txBody>
+      </p:sp>
+      <p:sp>
+        <p:nvSpPr>
+          <p:cNvPr id="7" name="TextBox 6"/>
           <p:cNvSpPr txBox="1"/>
           <p:nvPr/>
         </p:nvSpPr>
         <p:spPr>
           <a:xfrm>
             <a:off x="6217920" y="1371600"/>
-            <a:ext cx="5486400" cy="4572000"/>
+            <a:ext cx="5303520" cy="2011680"/>
           </a:xfrm>
           <a:prstGeom prst="rect">
             <a:avLst/>
@@ -5934,14 +6802,65 @@
               </a:defRPr>
             </a:pPr>
             <a:r>
-              <a:t>2. Streamlit Analytics UI Dashboard</a:t>
-            </a:r>
-          </a:p>
+              <a:t>H2: Freshness Quality → Lack of Catalog Trust</a:t>
+            </a:r>
+          </a:p>
+          <a:p>
+            <a:pPr>
+              <a:defRPr sz="1400">
+                <a:solidFill>
+                  <a:srgbClr val="F8FAFC"/>
+                </a:solidFill>
+              </a:defRPr>
+            </a:pPr>
+            <a:r>
+              <a:t>Absence of real-time freshness markers and failure to offer cash refunds on squished produce drives homemakers back to offline vegetable markets.</a:t>
+            </a:r>
+            <a:br/>
+            <a:r>
+              <a:t>Tag: Quality Trust Deficit</a:t>
+            </a:r>
+          </a:p>
+        </p:txBody>
+      </p:sp>
+      <p:sp>
+        <p:nvSpPr>
+          <p:cNvPr id="8" name="TextBox 7"/>
+          <p:cNvSpPr txBox="1"/>
+          <p:nvPr/>
+        </p:nvSpPr>
+        <p:spPr>
+          <a:xfrm>
+            <a:off x="457200" y="3657600"/>
+            <a:ext cx="5303520" cy="2011680"/>
+          </a:xfrm>
+          <a:prstGeom prst="rect">
+            <a:avLst/>
+          </a:prstGeom>
+          <a:noFill/>
+        </p:spPr>
+        <p:txBody>
+          <a:bodyPr wrap="square">
+            <a:spAutoFit/>
+          </a:bodyPr>
+          <a:lstStyle/>
           <a:p>
             <a:pPr>
               <a:spcAft>
-                <a:spcPts val="1200"/>
+                <a:spcPts val="800"/>
               </a:spcAft>
+              <a:defRPr b="1" sz="1500">
+                <a:solidFill>
+                  <a:srgbClr val="FC8019"/>
+                </a:solidFill>
+              </a:defRPr>
+            </a:pPr>
+            <a:r>
+              <a:t>H3: Visual Overwhelm → Homepage Discovery Avoidance</a:t>
+            </a:r>
+          </a:p>
+          <a:p>
+            <a:pPr>
               <a:defRPr sz="1400">
                 <a:solidFill>
                   <a:srgbClr val="F8FAFC"/>
@@ -5949,54 +6868,72 @@
               </a:defRPr>
             </a:pPr>
             <a:r>
-              <a:t>We created the analytics dashboard in `src/dashboard/app.py` utilizing Streamlit, displaying sentiment metrics, pipeline schemas, and opportunity prioritizations:</a:t>
-            </a:r>
-          </a:p>
+              <a:t>Home screen layout contains too many flashing banners. Senior or busy cohorts default to clicking 'Buy it Again' history, bypassing navigation tabs entirely.</a:t>
+            </a:r>
+            <a:br/>
+            <a:r>
+              <a:t>Tag: UI Clutter &amp; Navigation Anxiety</a:t>
+            </a:r>
+          </a:p>
+        </p:txBody>
+      </p:sp>
+      <p:sp>
+        <p:nvSpPr>
+          <p:cNvPr id="9" name="TextBox 8"/>
+          <p:cNvSpPr txBox="1"/>
+          <p:nvPr/>
+        </p:nvSpPr>
+        <p:spPr>
+          <a:xfrm>
+            <a:off x="6217920" y="3657600"/>
+            <a:ext cx="5303520" cy="2011680"/>
+          </a:xfrm>
+          <a:prstGeom prst="rect">
+            <a:avLst/>
+          </a:prstGeom>
+          <a:noFill/>
+        </p:spPr>
+        <p:txBody>
+          <a:bodyPr wrap="square">
+            <a:spAutoFit/>
+          </a:bodyPr>
+          <a:lstStyle/>
           <a:p>
             <a:pPr>
               <a:spcAft>
-                <a:spcPts val="1500"/>
+                <a:spcPts val="800"/>
               </a:spcAft>
-              <a:defRPr sz="1000">
-                <a:solidFill>
-                  <a:srgbClr val="A855F7"/>
-                </a:solidFill>
-                <a:latin typeface="Courier New"/>
+              <a:defRPr b="1" sz="1500">
+                <a:solidFill>
+                  <a:srgbClr val="FC8019"/>
+                </a:solidFill>
               </a:defRPr>
             </a:pPr>
             <a:r>
-              <a:t>st.set_page_config(page_title="Instamart Discovery Engine")</a:t>
+              <a:t>H4: Multi-App Price Comparisons → Basket Splitting</a:t>
+            </a:r>
+          </a:p>
+          <a:p>
+            <a:pPr>
+              <a:defRPr sz="1400">
+                <a:solidFill>
+                  <a:srgbClr val="F8FAFC"/>
+                </a:solidFill>
+              </a:defRPr>
+            </a:pPr>
+            <a:r>
+              <a:t>Mixed-language user profile settings confuse item recommendations. Users split carts across Blinkit and Zepto based on immediate coupon availabilities.</a:t>
             </a:r>
             <a:br/>
             <a:r>
-              <a:t>st.title("Category Discovery Insights")</a:t>
-            </a:r>
-            <a:br/>
-            <a:r>
-              <a:t>selected_platform = st.sidebar.selectbox("Platform", ["Play Store", "Reddit"])</a:t>
-            </a:r>
-            <a:br/>
-            <a:r>
-              <a:t>st.plotly_chart(generate_sentiment_pie(selected_platform))</a:t>
-            </a:r>
-          </a:p>
-          <a:p>
-            <a:pPr>
-              <a:defRPr sz="1300">
-                <a:solidFill>
-                  <a:srgbClr val="8B949E"/>
-                </a:solidFill>
-              </a:defRPr>
-            </a:pPr>
-            <a:r>
-              <a:t>• Aesthetics: Built in custom theme styling matching Swiggy Brand Palette (Indigo blue and brand Orange).</a:t>
-            </a:r>
-          </a:p>
-        </p:txBody>
-      </p:sp>
-      <p:sp>
-        <p:nvSpPr>
-          <p:cNvPr id="7" name="TextBox 6"/>
+              <a:t>Tag: Platform Fragmentation</a:t>
+            </a:r>
+          </a:p>
+        </p:txBody>
+      </p:sp>
+      <p:sp>
+        <p:nvSpPr>
+          <p:cNvPr id="10" name="TextBox 9"/>
           <p:cNvSpPr txBox="1"/>
           <p:nvPr/>
         </p:nvSpPr>
@@ -6032,7 +6969,7 @@
       </p:sp>
       <p:sp>
         <p:nvSpPr>
-          <p:cNvPr id="8" name="TextBox 7"/>
+          <p:cNvPr id="11" name="TextBox 10"/>
           <p:cNvSpPr txBox="1"/>
           <p:nvPr/>
         </p:nvSpPr>
@@ -6077,14 +7014,6 @@
 <file path=ppt/slides/slide5.xml><?xml version="1.0" encoding="utf-8"?>
 <p:sld xmlns:a="http://schemas.openxmlformats.org/drawingml/2006/main" xmlns:p="http://schemas.openxmlformats.org/presentationml/2006/main" xmlns:r="http://schemas.openxmlformats.org/officeDocument/2006/relationships">
   <p:cSld>
-    <p:bg>
-      <p:bgPr>
-        <a:solidFill>
-          <a:srgbClr val="0D1117"/>
-        </a:solidFill>
-        <a:effectLst/>
-      </p:bgPr>
-    </p:bg>
     <p:spTree>
       <p:nvGrpSpPr>
         <p:cNvPr id="1" name=""/>
@@ -6095,6 +7024,49 @@
       <p:sp>
         <p:nvSpPr>
           <p:cNvPr id="2" name="Rectangle 1"/>
+          <p:cNvSpPr/>
+          <p:nvPr/>
+        </p:nvSpPr>
+        <p:spPr>
+          <a:xfrm>
+            <a:off x="0" y="0"/>
+            <a:ext cx="12191695" cy="6858000"/>
+          </a:xfrm>
+          <a:prstGeom prst="rect">
+            <a:avLst/>
+          </a:prstGeom>
+          <a:solidFill>
+            <a:srgbClr val="0D1117"/>
+          </a:solidFill>
+          <a:ln>
+            <a:noFill/>
+          </a:ln>
+        </p:spPr>
+        <p:style>
+          <a:lnRef idx="1">
+            <a:schemeClr val="accent1"/>
+          </a:lnRef>
+          <a:fillRef idx="3">
+            <a:schemeClr val="accent1"/>
+          </a:fillRef>
+          <a:effectRef idx="2">
+            <a:schemeClr val="accent1"/>
+          </a:effectRef>
+          <a:fontRef idx="minor">
+            <a:schemeClr val="lt1"/>
+          </a:fontRef>
+        </p:style>
+        <p:txBody>
+          <a:bodyPr rtlCol="0" anchor="ctr"/>
+          <a:lstStyle/>
+          <a:p>
+            <a:pPr algn="ctr"/>
+          </a:p>
+        </p:txBody>
+      </p:sp>
+      <p:sp>
+        <p:nvSpPr>
+          <p:cNvPr id="3" name="Rectangle 2"/>
           <p:cNvSpPr/>
           <p:nvPr/>
         </p:nvSpPr>
@@ -6139,7 +7111,7 @@
       </p:sp>
       <p:sp>
         <p:nvSpPr>
-          <p:cNvPr id="3" name="TextBox 2"/>
+          <p:cNvPr id="4" name="TextBox 3"/>
           <p:cNvSpPr txBox="1"/>
           <p:nvPr/>
         </p:nvSpPr>
@@ -6175,7 +7147,7 @@
       </p:sp>
       <p:sp>
         <p:nvSpPr>
-          <p:cNvPr id="4" name="TextBox 3"/>
+          <p:cNvPr id="5" name="TextBox 4"/>
           <p:cNvSpPr txBox="1"/>
           <p:nvPr/>
         </p:nvSpPr>
@@ -6211,7 +7183,7 @@
       </p:sp>
       <p:graphicFrame>
         <p:nvGraphicFramePr>
-          <p:cNvPr id="5" name="Table 4"/>
+          <p:cNvPr id="6" name="Table 5"/>
           <p:cNvGraphicFramePr>
             <a:graphicFrameLocks noGrp="1"/>
           </p:cNvGraphicFramePr>
@@ -6972,7 +7944,7 @@
       </p:graphicFrame>
       <p:sp>
         <p:nvSpPr>
-          <p:cNvPr id="6" name="TextBox 5"/>
+          <p:cNvPr id="7" name="TextBox 6"/>
           <p:cNvSpPr txBox="1"/>
           <p:nvPr/>
         </p:nvSpPr>
@@ -7008,7 +7980,7 @@
       </p:sp>
       <p:sp>
         <p:nvSpPr>
-          <p:cNvPr id="7" name="TextBox 6"/>
+          <p:cNvPr id="8" name="TextBox 7"/>
           <p:cNvSpPr txBox="1"/>
           <p:nvPr/>
         </p:nvSpPr>
@@ -7053,14 +8025,6 @@
 <file path=ppt/slides/slide6.xml><?xml version="1.0" encoding="utf-8"?>
 <p:sld xmlns:a="http://schemas.openxmlformats.org/drawingml/2006/main" xmlns:p="http://schemas.openxmlformats.org/presentationml/2006/main" xmlns:r="http://schemas.openxmlformats.org/officeDocument/2006/relationships">
   <p:cSld>
-    <p:bg>
-      <p:bgPr>
-        <a:solidFill>
-          <a:srgbClr val="0D1117"/>
-        </a:solidFill>
-        <a:effectLst/>
-      </p:bgPr>
-    </p:bg>
     <p:spTree>
       <p:nvGrpSpPr>
         <p:cNvPr id="1" name=""/>
@@ -7071,6 +8035,49 @@
       <p:sp>
         <p:nvSpPr>
           <p:cNvPr id="2" name="Rectangle 1"/>
+          <p:cNvSpPr/>
+          <p:nvPr/>
+        </p:nvSpPr>
+        <p:spPr>
+          <a:xfrm>
+            <a:off x="0" y="0"/>
+            <a:ext cx="12191695" cy="6858000"/>
+          </a:xfrm>
+          <a:prstGeom prst="rect">
+            <a:avLst/>
+          </a:prstGeom>
+          <a:solidFill>
+            <a:srgbClr val="0D1117"/>
+          </a:solidFill>
+          <a:ln>
+            <a:noFill/>
+          </a:ln>
+        </p:spPr>
+        <p:style>
+          <a:lnRef idx="1">
+            <a:schemeClr val="accent1"/>
+          </a:lnRef>
+          <a:fillRef idx="3">
+            <a:schemeClr val="accent1"/>
+          </a:fillRef>
+          <a:effectRef idx="2">
+            <a:schemeClr val="accent1"/>
+          </a:effectRef>
+          <a:fontRef idx="minor">
+            <a:schemeClr val="lt1"/>
+          </a:fontRef>
+        </p:style>
+        <p:txBody>
+          <a:bodyPr rtlCol="0" anchor="ctr"/>
+          <a:lstStyle/>
+          <a:p>
+            <a:pPr algn="ctr"/>
+          </a:p>
+        </p:txBody>
+      </p:sp>
+      <p:sp>
+        <p:nvSpPr>
+          <p:cNvPr id="3" name="Rectangle 2"/>
           <p:cNvSpPr/>
           <p:nvPr/>
         </p:nvSpPr>
@@ -7115,7 +8122,7 @@
       </p:sp>
       <p:sp>
         <p:nvSpPr>
-          <p:cNvPr id="3" name="TextBox 2"/>
+          <p:cNvPr id="4" name="TextBox 3"/>
           <p:cNvSpPr txBox="1"/>
           <p:nvPr/>
         </p:nvSpPr>
@@ -7151,7 +8158,7 @@
       </p:sp>
       <p:sp>
         <p:nvSpPr>
-          <p:cNvPr id="4" name="TextBox 3"/>
+          <p:cNvPr id="5" name="TextBox 4"/>
           <p:cNvSpPr txBox="1"/>
           <p:nvPr/>
         </p:nvSpPr>
@@ -7187,7 +8194,7 @@
       </p:sp>
       <p:sp>
         <p:nvSpPr>
-          <p:cNvPr id="5" name="TextBox 4"/>
+          <p:cNvPr id="6" name="TextBox 5"/>
           <p:cNvSpPr txBox="1"/>
           <p:nvPr/>
         </p:nvSpPr>
@@ -7271,7 +8278,7 @@
       </p:sp>
       <p:sp>
         <p:nvSpPr>
-          <p:cNvPr id="6" name="TextBox 5"/>
+          <p:cNvPr id="7" name="TextBox 6"/>
           <p:cNvSpPr txBox="1"/>
           <p:nvPr/>
         </p:nvSpPr>
@@ -7359,7 +8366,7 @@
       </p:sp>
       <p:sp>
         <p:nvSpPr>
-          <p:cNvPr id="7" name="TextBox 6"/>
+          <p:cNvPr id="8" name="TextBox 7"/>
           <p:cNvSpPr txBox="1"/>
           <p:nvPr/>
         </p:nvSpPr>
@@ -7395,7 +8402,7 @@
       </p:sp>
       <p:sp>
         <p:nvSpPr>
-          <p:cNvPr id="8" name="TextBox 7"/>
+          <p:cNvPr id="9" name="TextBox 8"/>
           <p:cNvSpPr txBox="1"/>
           <p:nvPr/>
         </p:nvSpPr>
@@ -7440,14 +8447,6 @@
 <file path=ppt/slides/slide7.xml><?xml version="1.0" encoding="utf-8"?>
 <p:sld xmlns:a="http://schemas.openxmlformats.org/drawingml/2006/main" xmlns:p="http://schemas.openxmlformats.org/presentationml/2006/main" xmlns:r="http://schemas.openxmlformats.org/officeDocument/2006/relationships">
   <p:cSld>
-    <p:bg>
-      <p:bgPr>
-        <a:solidFill>
-          <a:srgbClr val="0D1117"/>
-        </a:solidFill>
-        <a:effectLst/>
-      </p:bgPr>
-    </p:bg>
     <p:spTree>
       <p:nvGrpSpPr>
         <p:cNvPr id="1" name=""/>
@@ -7458,6 +8457,49 @@
       <p:sp>
         <p:nvSpPr>
           <p:cNvPr id="2" name="Rectangle 1"/>
+          <p:cNvSpPr/>
+          <p:nvPr/>
+        </p:nvSpPr>
+        <p:spPr>
+          <a:xfrm>
+            <a:off x="0" y="0"/>
+            <a:ext cx="12191695" cy="6858000"/>
+          </a:xfrm>
+          <a:prstGeom prst="rect">
+            <a:avLst/>
+          </a:prstGeom>
+          <a:solidFill>
+            <a:srgbClr val="0D1117"/>
+          </a:solidFill>
+          <a:ln>
+            <a:noFill/>
+          </a:ln>
+        </p:spPr>
+        <p:style>
+          <a:lnRef idx="1">
+            <a:schemeClr val="accent1"/>
+          </a:lnRef>
+          <a:fillRef idx="3">
+            <a:schemeClr val="accent1"/>
+          </a:fillRef>
+          <a:effectRef idx="2">
+            <a:schemeClr val="accent1"/>
+          </a:effectRef>
+          <a:fontRef idx="minor">
+            <a:schemeClr val="lt1"/>
+          </a:fontRef>
+        </p:style>
+        <p:txBody>
+          <a:bodyPr rtlCol="0" anchor="ctr"/>
+          <a:lstStyle/>
+          <a:p>
+            <a:pPr algn="ctr"/>
+          </a:p>
+        </p:txBody>
+      </p:sp>
+      <p:sp>
+        <p:nvSpPr>
+          <p:cNvPr id="3" name="Rectangle 2"/>
           <p:cNvSpPr/>
           <p:nvPr/>
         </p:nvSpPr>
@@ -7502,7 +8544,7 @@
       </p:sp>
       <p:sp>
         <p:nvSpPr>
-          <p:cNvPr id="3" name="TextBox 2"/>
+          <p:cNvPr id="4" name="TextBox 3"/>
           <p:cNvSpPr txBox="1"/>
           <p:nvPr/>
         </p:nvSpPr>
@@ -7538,7 +8580,7 @@
       </p:sp>
       <p:sp>
         <p:nvSpPr>
-          <p:cNvPr id="4" name="TextBox 3"/>
+          <p:cNvPr id="5" name="TextBox 4"/>
           <p:cNvSpPr txBox="1"/>
           <p:nvPr/>
         </p:nvSpPr>
@@ -7574,7 +8616,7 @@
       </p:sp>
       <p:sp>
         <p:nvSpPr>
-          <p:cNvPr id="5" name="TextBox 4"/>
+          <p:cNvPr id="6" name="TextBox 5"/>
           <p:cNvSpPr txBox="1"/>
           <p:nvPr/>
         </p:nvSpPr>
@@ -7658,7 +8700,7 @@
       </p:sp>
       <p:sp>
         <p:nvSpPr>
-          <p:cNvPr id="6" name="TextBox 5"/>
+          <p:cNvPr id="7" name="TextBox 6"/>
           <p:cNvSpPr txBox="1"/>
           <p:nvPr/>
         </p:nvSpPr>
@@ -7779,7 +8821,7 @@
       </p:sp>
       <p:sp>
         <p:nvSpPr>
-          <p:cNvPr id="7" name="TextBox 6"/>
+          <p:cNvPr id="8" name="TextBox 7"/>
           <p:cNvSpPr txBox="1"/>
           <p:nvPr/>
         </p:nvSpPr>
@@ -7815,7 +8857,7 @@
       </p:sp>
       <p:sp>
         <p:nvSpPr>
-          <p:cNvPr id="8" name="TextBox 7"/>
+          <p:cNvPr id="9" name="TextBox 8"/>
           <p:cNvSpPr txBox="1"/>
           <p:nvPr/>
         </p:nvSpPr>
@@ -7860,14 +8902,6 @@
 <file path=ppt/slides/slide8.xml><?xml version="1.0" encoding="utf-8"?>
 <p:sld xmlns:a="http://schemas.openxmlformats.org/drawingml/2006/main" xmlns:p="http://schemas.openxmlformats.org/presentationml/2006/main" xmlns:r="http://schemas.openxmlformats.org/officeDocument/2006/relationships">
   <p:cSld>
-    <p:bg>
-      <p:bgPr>
-        <a:solidFill>
-          <a:srgbClr val="0D1117"/>
-        </a:solidFill>
-        <a:effectLst/>
-      </p:bgPr>
-    </p:bg>
     <p:spTree>
       <p:nvGrpSpPr>
         <p:cNvPr id="1" name=""/>
@@ -7878,6 +8912,49 @@
       <p:sp>
         <p:nvSpPr>
           <p:cNvPr id="2" name="Rectangle 1"/>
+          <p:cNvSpPr/>
+          <p:nvPr/>
+        </p:nvSpPr>
+        <p:spPr>
+          <a:xfrm>
+            <a:off x="0" y="0"/>
+            <a:ext cx="12191695" cy="6858000"/>
+          </a:xfrm>
+          <a:prstGeom prst="rect">
+            <a:avLst/>
+          </a:prstGeom>
+          <a:solidFill>
+            <a:srgbClr val="0D1117"/>
+          </a:solidFill>
+          <a:ln>
+            <a:noFill/>
+          </a:ln>
+        </p:spPr>
+        <p:style>
+          <a:lnRef idx="1">
+            <a:schemeClr val="accent1"/>
+          </a:lnRef>
+          <a:fillRef idx="3">
+            <a:schemeClr val="accent1"/>
+          </a:fillRef>
+          <a:effectRef idx="2">
+            <a:schemeClr val="accent1"/>
+          </a:effectRef>
+          <a:fontRef idx="minor">
+            <a:schemeClr val="lt1"/>
+          </a:fontRef>
+        </p:style>
+        <p:txBody>
+          <a:bodyPr rtlCol="0" anchor="ctr"/>
+          <a:lstStyle/>
+          <a:p>
+            <a:pPr algn="ctr"/>
+          </a:p>
+        </p:txBody>
+      </p:sp>
+      <p:sp>
+        <p:nvSpPr>
+          <p:cNvPr id="3" name="Rectangle 2"/>
           <p:cNvSpPr/>
           <p:nvPr/>
         </p:nvSpPr>
@@ -7922,7 +8999,7 @@
       </p:sp>
       <p:sp>
         <p:nvSpPr>
-          <p:cNvPr id="3" name="TextBox 2"/>
+          <p:cNvPr id="4" name="TextBox 3"/>
           <p:cNvSpPr txBox="1"/>
           <p:nvPr/>
         </p:nvSpPr>
@@ -7958,7 +9035,7 @@
       </p:sp>
       <p:sp>
         <p:nvSpPr>
-          <p:cNvPr id="4" name="TextBox 3"/>
+          <p:cNvPr id="5" name="TextBox 4"/>
           <p:cNvSpPr txBox="1"/>
           <p:nvPr/>
         </p:nvSpPr>
@@ -7994,7 +9071,7 @@
       </p:sp>
       <p:sp>
         <p:nvSpPr>
-          <p:cNvPr id="5" name="TextBox 4"/>
+          <p:cNvPr id="6" name="TextBox 5"/>
           <p:cNvSpPr txBox="1"/>
           <p:nvPr/>
         </p:nvSpPr>
@@ -8081,7 +9158,7 @@
       </p:sp>
       <p:sp>
         <p:nvSpPr>
-          <p:cNvPr id="6" name="TextBox 5"/>
+          <p:cNvPr id="7" name="TextBox 6"/>
           <p:cNvSpPr txBox="1"/>
           <p:nvPr/>
         </p:nvSpPr>
@@ -8156,7 +9233,7 @@
       </p:sp>
       <p:sp>
         <p:nvSpPr>
-          <p:cNvPr id="7" name="TextBox 6"/>
+          <p:cNvPr id="8" name="TextBox 7"/>
           <p:cNvSpPr txBox="1"/>
           <p:nvPr/>
         </p:nvSpPr>
@@ -8192,7 +9269,7 @@
       </p:sp>
       <p:sp>
         <p:nvSpPr>
-          <p:cNvPr id="8" name="TextBox 7"/>
+          <p:cNvPr id="9" name="TextBox 8"/>
           <p:cNvSpPr txBox="1"/>
           <p:nvPr/>
         </p:nvSpPr>
@@ -8237,14 +9314,6 @@
 <file path=ppt/slides/slide9.xml><?xml version="1.0" encoding="utf-8"?>
 <p:sld xmlns:a="http://schemas.openxmlformats.org/drawingml/2006/main" xmlns:p="http://schemas.openxmlformats.org/presentationml/2006/main" xmlns:r="http://schemas.openxmlformats.org/officeDocument/2006/relationships">
   <p:cSld>
-    <p:bg>
-      <p:bgPr>
-        <a:solidFill>
-          <a:srgbClr val="0D1117"/>
-        </a:solidFill>
-        <a:effectLst/>
-      </p:bgPr>
-    </p:bg>
     <p:spTree>
       <p:nvGrpSpPr>
         <p:cNvPr id="1" name=""/>
@@ -8255,6 +9324,49 @@
       <p:sp>
         <p:nvSpPr>
           <p:cNvPr id="2" name="Rectangle 1"/>
+          <p:cNvSpPr/>
+          <p:nvPr/>
+        </p:nvSpPr>
+        <p:spPr>
+          <a:xfrm>
+            <a:off x="0" y="0"/>
+            <a:ext cx="12191695" cy="6858000"/>
+          </a:xfrm>
+          <a:prstGeom prst="rect">
+            <a:avLst/>
+          </a:prstGeom>
+          <a:solidFill>
+            <a:srgbClr val="0D1117"/>
+          </a:solidFill>
+          <a:ln>
+            <a:noFill/>
+          </a:ln>
+        </p:spPr>
+        <p:style>
+          <a:lnRef idx="1">
+            <a:schemeClr val="accent1"/>
+          </a:lnRef>
+          <a:fillRef idx="3">
+            <a:schemeClr val="accent1"/>
+          </a:fillRef>
+          <a:effectRef idx="2">
+            <a:schemeClr val="accent1"/>
+          </a:effectRef>
+          <a:fontRef idx="minor">
+            <a:schemeClr val="lt1"/>
+          </a:fontRef>
+        </p:style>
+        <p:txBody>
+          <a:bodyPr rtlCol="0" anchor="ctr"/>
+          <a:lstStyle/>
+          <a:p>
+            <a:pPr algn="ctr"/>
+          </a:p>
+        </p:txBody>
+      </p:sp>
+      <p:sp>
+        <p:nvSpPr>
+          <p:cNvPr id="3" name="Rectangle 2"/>
           <p:cNvSpPr/>
           <p:nvPr/>
         </p:nvSpPr>
@@ -8299,7 +9411,7 @@
       </p:sp>
       <p:sp>
         <p:nvSpPr>
-          <p:cNvPr id="3" name="TextBox 2"/>
+          <p:cNvPr id="4" name="TextBox 3"/>
           <p:cNvSpPr txBox="1"/>
           <p:nvPr/>
         </p:nvSpPr>
@@ -8335,7 +9447,7 @@
       </p:sp>
       <p:sp>
         <p:nvSpPr>
-          <p:cNvPr id="4" name="TextBox 3"/>
+          <p:cNvPr id="5" name="TextBox 4"/>
           <p:cNvSpPr txBox="1"/>
           <p:nvPr/>
         </p:nvSpPr>
@@ -8371,7 +9483,7 @@
       </p:sp>
       <p:sp>
         <p:nvSpPr>
-          <p:cNvPr id="5" name="TextBox 4"/>
+          <p:cNvPr id="6" name="TextBox 5"/>
           <p:cNvSpPr txBox="1"/>
           <p:nvPr/>
         </p:nvSpPr>
@@ -8461,7 +9573,7 @@
       </p:sp>
       <p:sp>
         <p:nvSpPr>
-          <p:cNvPr id="6" name="TextBox 5"/>
+          <p:cNvPr id="7" name="TextBox 6"/>
           <p:cNvSpPr txBox="1"/>
           <p:nvPr/>
         </p:nvSpPr>
@@ -8536,7 +9648,7 @@
       </p:sp>
       <p:sp>
         <p:nvSpPr>
-          <p:cNvPr id="7" name="TextBox 6"/>
+          <p:cNvPr id="8" name="TextBox 7"/>
           <p:cNvSpPr txBox="1"/>
           <p:nvPr/>
         </p:nvSpPr>
@@ -8572,7 +9684,7 @@
       </p:sp>
       <p:sp>
         <p:nvSpPr>
-          <p:cNvPr id="8" name="TextBox 7"/>
+          <p:cNvPr id="9" name="TextBox 8"/>
           <p:cNvSpPr txBox="1"/>
           <p:nvPr/>
         </p:nvSpPr>

</xml_diff>

<commit_message>
Replace code blocks with high-fidelity visual diagrams and mobile mockups in PPTX presentation
</commit_message>
<xml_diff>
--- a/NL Swiggy Instamart.pptx
+++ b/NL Swiggy Instamart.pptx
@@ -5022,7 +5022,7 @@
               </a:defRPr>
             </a:pPr>
             <a:r>
-              <a:t>PART 1 · DISCOVERY ENGINE PIPELINE</a:t>
+              <a:t>PART 1 · DB &amp; SCRAPERS INGESTION</a:t>
             </a:r>
           </a:p>
         </p:txBody>
@@ -5058,7 +5058,7 @@
               </a:defRPr>
             </a:pPr>
             <a:r>
-              <a:t>How the Live Ingestion &amp; Analysis Pipeline Works</a:t>
+              <a:t>Database &amp; Ingestion Engine (What Work Was Performed)</a:t>
             </a:r>
           </a:p>
         </p:txBody>
@@ -5072,7 +5072,7 @@
         <p:spPr>
           <a:xfrm>
             <a:off x="457200" y="1371600"/>
-            <a:ext cx="11277295" cy="1097280"/>
+            <a:ext cx="6217920" cy="4572000"/>
           </a:xfrm>
           <a:prstGeom prst="rect">
             <a:avLst/>
@@ -5087,8 +5087,20 @@
           <a:p>
             <a:pPr>
               <a:spcAft>
-                <a:spcPts val="1000"/>
+                <a:spcPts val="800"/>
               </a:spcAft>
+              <a:defRPr b="1" sz="1500">
+                <a:solidFill>
+                  <a:srgbClr val="FC8019"/>
+                </a:solidFill>
+              </a:defRPr>
+            </a:pPr>
+            <a:r>
+              <a:t>SQLite Relational Database &amp; Ingestion Engine</a:t>
+            </a:r>
+          </a:p>
+          <a:p>
+            <a:pPr>
               <a:defRPr sz="1400">
                 <a:solidFill>
                   <a:srgbClr val="F8FAFC"/>
@@ -5096,34 +5108,55 @@
               </a:defRPr>
             </a:pPr>
             <a:r>
-              <a:t>The n8n-inspired data cleaning and synthesis workflow: from triggered scrapes to relational insights.</a:t>
-            </a:r>
-          </a:p>
-          <a:p>
-            <a:pPr>
-              <a:defRPr sz="1200">
-                <a:solidFill>
-                  <a:srgbClr val="FF9F43"/>
-                </a:solidFill>
-                <a:latin typeface="Courier New"/>
-              </a:defRPr>
-            </a:pPr>
-            <a:r>
-              <a:t>1. TRIGGER (Webhook) -&gt; 2. SCRAPE (1,000 Multi-Channel reviews) -&gt; 3. MERGE &amp; DEDUPE (Clean duplicates) -&gt; 4. TRANSLATE (Hinglish normalized) -&gt; 5. AI ANALYSIS (Llama sentiment &amp; segment extraction) -&gt; 6. STREAMLIT UI</a:t>
-            </a:r>
-          </a:p>
-        </p:txBody>
-      </p:sp>
-      <p:sp>
-        <p:nvSpPr>
-          <p:cNvPr id="7" name="TextBox 6"/>
+              <a:t>• Relational Storage Layer: We designed a robust SQLite database (reviews.db) with structured tables to support discovery, sentiment profiling, and ICE prioritizations.</a:t>
+            </a:r>
+            <a:br/>
+            <a:br/>
+            <a:r>
+              <a:t>• Multi-Channel Scraper Adapters: Python scrapers automatically fetch customer inputs across 6 platform channels (Play Store reviews, iTunes RSS feeds, Reddit, Quora, YouTube, Twitter).</a:t>
+            </a:r>
+            <a:br/>
+            <a:br/>
+            <a:r>
+              <a:t>• Deduplication &amp; Cleaning: Standardizes spelling and translates regional Hinglish retail slang (e.g. mehanga -&gt; expensive, bekar -&gt; poor) before vector clustering is triggered.</a:t>
+            </a:r>
+          </a:p>
+        </p:txBody>
+      </p:sp>
+      <p:pic>
+        <p:nvPicPr>
+          <p:cNvPr id="7" name="Picture 6" descr="database_schema_diagram.jpg"/>
+          <p:cNvPicPr>
+            <a:picLocks noChangeAspect="1"/>
+          </p:cNvPicPr>
+          <p:nvPr/>
+        </p:nvPicPr>
+        <p:blipFill>
+          <a:blip r:embed="rId2"/>
+          <a:stretch>
+            <a:fillRect/>
+          </a:stretch>
+        </p:blipFill>
+        <p:spPr>
+          <a:xfrm>
+            <a:off x="6858000" y="1645920"/>
+            <a:ext cx="4846320" cy="4114800"/>
+          </a:xfrm>
+          <a:prstGeom prst="rect">
+            <a:avLst/>
+          </a:prstGeom>
+        </p:spPr>
+      </p:pic>
+      <p:sp>
+        <p:nvSpPr>
+          <p:cNvPr id="8" name="TextBox 7"/>
           <p:cNvSpPr txBox="1"/>
           <p:nvPr/>
         </p:nvSpPr>
         <p:spPr>
           <a:xfrm>
-            <a:off x="457200" y="2743200"/>
-            <a:ext cx="5486400" cy="3474720"/>
+            <a:off x="457200" y="6400800"/>
+            <a:ext cx="9144000" cy="274320"/>
           </a:xfrm>
           <a:prstGeom prst="rect">
             <a:avLst/>
@@ -5131,134 +5164,6 @@
           <a:noFill/>
         </p:spPr>
         <p:txBody>
-          <a:bodyPr wrap="square">
-            <a:spAutoFit/>
-          </a:bodyPr>
-          <a:lstStyle/>
-          <a:p>
-            <a:pPr>
-              <a:spcAft>
-                <a:spcPts val="800"/>
-              </a:spcAft>
-              <a:defRPr b="1" sz="1400">
-                <a:solidFill>
-                  <a:srgbClr val="FC8019"/>
-                </a:solidFill>
-              </a:defRPr>
-            </a:pPr>
-            <a:r>
-              <a:t>Curating the Ingestion Search Terms:</a:t>
-            </a:r>
-          </a:p>
-          <a:p>
-            <a:pPr>
-              <a:defRPr sz="1400">
-                <a:solidFill>
-                  <a:srgbClr val="F8FAFC"/>
-                </a:solidFill>
-              </a:defRPr>
-            </a:pPr>
-            <a:r>
-              <a:t>• Discovery &amp; Exploration: search terms: 'discover', 'explore', 'new brand', 'not found', 'catalog gap'.</a:t>
-            </a:r>
-            <a:br/>
-            <a:r>
-              <a:t>• Recommendation Quality: search terms: 'fees', 'surcharge', 'charges', 'promo banner', 'minimum cart'.</a:t>
-            </a:r>
-            <a:br/>
-            <a:r>
-              <a:t>• Repetition &amp; Fatigue: search terms: 'same product', 'reorder', 'history', 'repeat', 'boring'.</a:t>
-            </a:r>
-          </a:p>
-        </p:txBody>
-      </p:sp>
-      <p:sp>
-        <p:nvSpPr>
-          <p:cNvPr id="8" name="TextBox 7"/>
-          <p:cNvSpPr txBox="1"/>
-          <p:nvPr/>
-        </p:nvSpPr>
-        <p:spPr>
-          <a:xfrm>
-            <a:off x="6217920" y="2743200"/>
-            <a:ext cx="5486400" cy="3474720"/>
-          </a:xfrm>
-          <a:prstGeom prst="rect">
-            <a:avLst/>
-          </a:prstGeom>
-          <a:noFill/>
-        </p:spPr>
-        <p:txBody>
-          <a:bodyPr wrap="square">
-            <a:spAutoFit/>
-          </a:bodyPr>
-          <a:lstStyle/>
-          <a:p>
-            <a:pPr>
-              <a:spcAft>
-                <a:spcPts val="800"/>
-              </a:spcAft>
-              <a:defRPr b="1" sz="1400">
-                <a:solidFill>
-                  <a:srgbClr val="FC8019"/>
-                </a:solidFill>
-              </a:defRPr>
-            </a:pPr>
-            <a:r>
-              <a:t>Every Post Classified Into 6 Questions:</a:t>
-            </a:r>
-          </a:p>
-          <a:p>
-            <a:pPr>
-              <a:defRPr sz="1400">
-                <a:solidFill>
-                  <a:srgbClr val="F8FAFC"/>
-                </a:solidFill>
-              </a:defRPr>
-            </a:pPr>
-            <a:r>
-              <a:t>1. Why do users struggle to explore new categories?</a:t>
-            </a:r>
-            <a:br/>
-            <a:r>
-              <a:t>2. What are the most common frustrations with home banners?</a:t>
-            </a:r>
-            <a:br/>
-            <a:r>
-              <a:t>3. What buying behaviors are users trying to achieve?</a:t>
-            </a:r>
-            <a:br/>
-            <a:r>
-              <a:t>4. What causes users to repeatedly listen to reorder list history?</a:t>
-            </a:r>
-            <a:br/>
-            <a:r>
-              <a:t>5. Which user segments experience different discovery challenges?</a:t>
-            </a:r>
-            <a:br/>
-            <a:r>
-              <a:t>6. What unmet needs emerge consistently across discussions?</a:t>
-            </a:r>
-          </a:p>
-        </p:txBody>
-      </p:sp>
-      <p:sp>
-        <p:nvSpPr>
-          <p:cNvPr id="9" name="TextBox 8"/>
-          <p:cNvSpPr txBox="1"/>
-          <p:nvPr/>
-        </p:nvSpPr>
-        <p:spPr>
-          <a:xfrm>
-            <a:off x="457200" y="6400800"/>
-            <a:ext cx="9144000" cy="274320"/>
-          </a:xfrm>
-          <a:prstGeom prst="rect">
-            <a:avLst/>
-          </a:prstGeom>
-          <a:noFill/>
-        </p:spPr>
-        <p:txBody>
           <a:bodyPr wrap="none">
             <a:spAutoFit/>
           </a:bodyPr>
@@ -5280,7 +5185,7 @@
       </p:sp>
       <p:sp>
         <p:nvSpPr>
-          <p:cNvPr id="10" name="TextBox 9"/>
+          <p:cNvPr id="9" name="TextBox 8"/>
           <p:cNvSpPr txBox="1"/>
           <p:nvPr/>
         </p:nvSpPr>
@@ -5451,7 +5356,7 @@
               </a:defRPr>
             </a:pPr>
             <a:r>
-              <a:t>PART 2 · SEGMENT &amp; PERSONA</a:t>
+              <a:t>PART 1 · AI PIPELINE &amp; ML ENGINE</a:t>
             </a:r>
           </a:p>
         </p:txBody>
@@ -5487,984 +5392,95 @@
               </a:defRPr>
             </a:pPr>
             <a:r>
-              <a:t>Discovery Seekers &amp; General Users on Quick Commerce</a:t>
-            </a:r>
-          </a:p>
-        </p:txBody>
-      </p:sp>
-      <p:graphicFrame>
-        <p:nvGraphicFramePr>
-          <p:cNvPr id="6" name="Table 5"/>
-          <p:cNvGraphicFramePr>
-            <a:graphicFrameLocks noGrp="1"/>
-          </p:cNvGraphicFramePr>
+              <a:t>7-Agent Ingestion Pipeline &amp; Text Vector Clustering (What Was Built)</a:t>
+            </a:r>
+          </a:p>
+        </p:txBody>
+      </p:sp>
+      <p:sp>
+        <p:nvSpPr>
+          <p:cNvPr id="6" name="TextBox 5"/>
+          <p:cNvSpPr txBox="1"/>
           <p:nvPr/>
-        </p:nvGraphicFramePr>
-        <p:xfrm>
-          <a:off x="457200" y="1371600"/>
-          <a:ext cx="4572000" cy="4572000"/>
-        </p:xfrm>
-        <a:graphic>
-          <a:graphicData uri="http://schemas.openxmlformats.org/drawingml/2006/table">
-            <a:tbl>
-              <a:tblPr firstRow="1" bandRow="1">
-                <a:tableStyleId>{5C22544A-7EE6-4342-B048-85BDC9FD1C3A}</a:tableStyleId>
-              </a:tblPr>
-              <a:tblGrid>
-                <a:gridCol w="1645920"/>
-                <a:gridCol w="2926080"/>
-              </a:tblGrid>
-              <a:tr h="571500">
-                <a:tc>
-                  <a:txBody>
-                    <a:bodyPr/>
-                    <a:lstStyle/>
-                    <a:p>
-                      <a:pPr>
-                        <a:defRPr sz="1100" b="1">
-                          <a:solidFill>
-                            <a:srgbClr val="F8FAFC"/>
-                          </a:solidFill>
-                          <a:latin typeface="Arial"/>
-                        </a:defRPr>
-                      </a:pPr>
-                      <a:r>
-                        <a:t>Segment</a:t>
-                      </a:r>
-                    </a:p>
-                  </a:txBody>
-                  <a:tcPr>
-                    <a:solidFill>
-                      <a:srgbClr val="1F2937"/>
-                    </a:solidFill>
-                  </a:tcPr>
-                </a:tc>
-                <a:tc>
-                  <a:txBody>
-                    <a:bodyPr/>
-                    <a:lstStyle/>
-                    <a:p>
-                      <a:pPr>
-                        <a:defRPr sz="1100" b="0">
-                          <a:solidFill>
-                            <a:srgbClr val="F8FAFC"/>
-                          </a:solidFill>
-                          <a:latin typeface="Arial"/>
-                        </a:defRPr>
-                      </a:pPr>
-                      <a:r>
-                        <a:t>Working Professionals / Busy Parents</a:t>
-                      </a:r>
-                    </a:p>
-                  </a:txBody>
-                  <a:tcPr>
-                    <a:solidFill>
-                      <a:srgbClr val="1F2937"/>
-                    </a:solidFill>
-                  </a:tcPr>
-                </a:tc>
-              </a:tr>
-              <a:tr h="571500">
-                <a:tc>
-                  <a:txBody>
-                    <a:bodyPr/>
-                    <a:lstStyle/>
-                    <a:p>
-                      <a:pPr>
-                        <a:defRPr sz="1100" b="1">
-                          <a:solidFill>
-                            <a:srgbClr val="F8FAFC"/>
-                          </a:solidFill>
-                          <a:latin typeface="Arial"/>
-                        </a:defRPr>
-                      </a:pPr>
-                      <a:r>
-                        <a:t>Age Profile</a:t>
-                      </a:r>
-                    </a:p>
-                  </a:txBody>
-                  <a:tcPr>
-                    <a:solidFill>
-                      <a:srgbClr val="111827"/>
-                    </a:solidFill>
-                  </a:tcPr>
-                </a:tc>
-                <a:tc>
-                  <a:txBody>
-                    <a:bodyPr/>
-                    <a:lstStyle/>
-                    <a:p>
-                      <a:pPr>
-                        <a:defRPr sz="1100" b="0">
-                          <a:solidFill>
-                            <a:srgbClr val="F8FAFC"/>
-                          </a:solidFill>
-                          <a:latin typeface="Arial"/>
-                        </a:defRPr>
-                      </a:pPr>
-                      <a:r>
-                        <a:t>18-40 years (Gen-Z &amp; young millennials)</a:t>
-                      </a:r>
-                    </a:p>
-                  </a:txBody>
-                  <a:tcPr>
-                    <a:solidFill>
-                      <a:srgbClr val="111827"/>
-                    </a:solidFill>
-                  </a:tcPr>
-                </a:tc>
-              </a:tr>
-              <a:tr h="571500">
-                <a:tc>
-                  <a:txBody>
-                    <a:bodyPr/>
-                    <a:lstStyle/>
-                    <a:p>
-                      <a:pPr>
-                        <a:defRPr sz="1100" b="1">
-                          <a:solidFill>
-                            <a:srgbClr val="F8FAFC"/>
-                          </a:solidFill>
-                          <a:latin typeface="Arial"/>
-                        </a:defRPr>
-                      </a:pPr>
-                      <a:r>
-                        <a:t>Locations</a:t>
-                      </a:r>
-                    </a:p>
-                  </a:txBody>
-                  <a:tcPr>
-                    <a:solidFill>
-                      <a:srgbClr val="111827"/>
-                    </a:solidFill>
-                  </a:tcPr>
-                </a:tc>
-                <a:tc>
-                  <a:txBody>
-                    <a:bodyPr/>
-                    <a:lstStyle/>
-                    <a:p>
-                      <a:pPr>
-                        <a:defRPr sz="1100" b="0">
-                          <a:solidFill>
-                            <a:srgbClr val="F8FAFC"/>
-                          </a:solidFill>
-                          <a:latin typeface="Arial"/>
-                        </a:defRPr>
-                      </a:pPr>
-                      <a:r>
-                        <a:t>Tier 1 &amp; Tier 2 Indian cities</a:t>
-                      </a:r>
-                    </a:p>
-                  </a:txBody>
-                  <a:tcPr>
-                    <a:solidFill>
-                      <a:srgbClr val="111827"/>
-                    </a:solidFill>
-                  </a:tcPr>
-                </a:tc>
-              </a:tr>
-              <a:tr h="571500">
-                <a:tc>
-                  <a:txBody>
-                    <a:bodyPr/>
-                    <a:lstStyle/>
-                    <a:p>
-                      <a:pPr>
-                        <a:defRPr sz="1100" b="1">
-                          <a:solidFill>
-                            <a:srgbClr val="F8FAFC"/>
-                          </a:solidFill>
-                          <a:latin typeface="Arial"/>
-                        </a:defRPr>
-                      </a:pPr>
-                      <a:r>
-                        <a:t>Estimated Size</a:t>
-                      </a:r>
-                    </a:p>
-                  </a:txBody>
-                  <a:tcPr>
-                    <a:solidFill>
-                      <a:srgbClr val="111827"/>
-                    </a:solidFill>
-                  </a:tcPr>
-                </a:tc>
-                <a:tc>
-                  <a:txBody>
-                    <a:bodyPr/>
-                    <a:lstStyle/>
-                    <a:p>
-                      <a:pPr>
-                        <a:defRPr sz="1100" b="0">
-                          <a:solidFill>
-                            <a:srgbClr val="F8FAFC"/>
-                          </a:solidFill>
-                          <a:latin typeface="Arial"/>
-                        </a:defRPr>
-                      </a:pPr>
-                      <a:r>
-                        <a:t>~35M active monthly users</a:t>
-                      </a:r>
-                    </a:p>
-                  </a:txBody>
-                  <a:tcPr>
-                    <a:solidFill>
-                      <a:srgbClr val="111827"/>
-                    </a:solidFill>
-                  </a:tcPr>
-                </a:tc>
-              </a:tr>
-              <a:tr h="571500">
-                <a:tc>
-                  <a:txBody>
-                    <a:bodyPr/>
-                    <a:lstStyle/>
-                    <a:p>
-                      <a:pPr>
-                        <a:defRPr sz="1100" b="1">
-                          <a:solidFill>
-                            <a:srgbClr val="F8FAFC"/>
-                          </a:solidFill>
-                          <a:latin typeface="Arial"/>
-                        </a:defRPr>
-                      </a:pPr>
-                      <a:r>
-                        <a:t>Device Usage</a:t>
-                      </a:r>
-                    </a:p>
-                  </a:txBody>
-                  <a:tcPr>
-                    <a:solidFill>
-                      <a:srgbClr val="111827"/>
-                    </a:solidFill>
-                  </a:tcPr>
-                </a:tc>
-                <a:tc>
-                  <a:txBody>
-                    <a:bodyPr/>
-                    <a:lstStyle/>
-                    <a:p>
-                      <a:pPr>
-                        <a:defRPr sz="1100" b="0">
-                          <a:solidFill>
-                            <a:srgbClr val="F8FAFC"/>
-                          </a:solidFill>
-                          <a:latin typeface="Arial"/>
-                        </a:defRPr>
-                      </a:pPr>
-                      <a:r>
-                        <a:t>Mobile-first (iOS &amp; Android apps)</a:t>
-                      </a:r>
-                    </a:p>
-                  </a:txBody>
-                  <a:tcPr>
-                    <a:solidFill>
-                      <a:srgbClr val="111827"/>
-                    </a:solidFill>
-                  </a:tcPr>
-                </a:tc>
-              </a:tr>
-              <a:tr h="571500">
-                <a:tc>
-                  <a:txBody>
-                    <a:bodyPr/>
-                    <a:lstStyle/>
-                    <a:p>
-                      <a:pPr>
-                        <a:defRPr sz="1100" b="1">
-                          <a:solidFill>
-                            <a:srgbClr val="F8FAFC"/>
-                          </a:solidFill>
-                          <a:latin typeface="Arial"/>
-                        </a:defRPr>
-                      </a:pPr>
-                      <a:r>
-                        <a:t>Language Profile</a:t>
-                      </a:r>
-                    </a:p>
-                  </a:txBody>
-                  <a:tcPr>
-                    <a:solidFill>
-                      <a:srgbClr val="111827"/>
-                    </a:solidFill>
-                  </a:tcPr>
-                </a:tc>
-                <a:tc>
-                  <a:txBody>
-                    <a:bodyPr/>
-                    <a:lstStyle/>
-                    <a:p>
-                      <a:pPr>
-                        <a:defRPr sz="1100" b="0">
-                          <a:solidFill>
-                            <a:srgbClr val="F8FAFC"/>
-                          </a:solidFill>
-                          <a:latin typeface="Arial"/>
-                        </a:defRPr>
-                      </a:pPr>
-                      <a:r>
-                        <a:t>Hinglish, English, regional scripts</a:t>
-                      </a:r>
-                    </a:p>
-                  </a:txBody>
-                  <a:tcPr>
-                    <a:solidFill>
-                      <a:srgbClr val="111827"/>
-                    </a:solidFill>
-                  </a:tcPr>
-                </a:tc>
-              </a:tr>
-              <a:tr h="571500">
-                <a:tc>
-                  <a:txBody>
-                    <a:bodyPr/>
-                    <a:lstStyle/>
-                    <a:p>
-                      <a:pPr>
-                        <a:defRPr sz="1100" b="1">
-                          <a:solidFill>
-                            <a:srgbClr val="F8FAFC"/>
-                          </a:solidFill>
-                          <a:latin typeface="Arial"/>
-                        </a:defRPr>
-                      </a:pPr>
-                      <a:r>
-                        <a:t>Payment Default</a:t>
-                      </a:r>
-                    </a:p>
-                  </a:txBody>
-                  <a:tcPr>
-                    <a:solidFill>
-                      <a:srgbClr val="111827"/>
-                    </a:solidFill>
-                  </a:tcPr>
-                </a:tc>
-                <a:tc>
-                  <a:txBody>
-                    <a:bodyPr/>
-                    <a:lstStyle/>
-                    <a:p>
-                      <a:pPr>
-                        <a:defRPr sz="1100" b="0">
-                          <a:solidFill>
-                            <a:srgbClr val="F8FAFC"/>
-                          </a:solidFill>
-                          <a:latin typeface="Arial"/>
-                        </a:defRPr>
-                      </a:pPr>
-                      <a:r>
-                        <a:t>97% UPI / Instant wallets</a:t>
-                      </a:r>
-                    </a:p>
-                  </a:txBody>
-                  <a:tcPr>
-                    <a:solidFill>
-                      <a:srgbClr val="111827"/>
-                    </a:solidFill>
-                  </a:tcPr>
-                </a:tc>
-              </a:tr>
-              <a:tr h="571500">
-                <a:tc>
-                  <a:txBody>
-                    <a:bodyPr/>
-                    <a:lstStyle/>
-                    <a:p>
-                      <a:pPr>
-                        <a:defRPr sz="1100" b="1">
-                          <a:solidFill>
-                            <a:srgbClr val="F8FAFC"/>
-                          </a:solidFill>
-                          <a:latin typeface="Arial"/>
-                        </a:defRPr>
-                      </a:pPr>
-                      <a:r>
-                        <a:t>Listening/Cart</a:t>
-                      </a:r>
-                    </a:p>
-                  </a:txBody>
-                  <a:tcPr>
-                    <a:solidFill>
-                      <a:srgbClr val="111827"/>
-                    </a:solidFill>
-                  </a:tcPr>
-                </a:tc>
-                <a:tc>
-                  <a:txBody>
-                    <a:bodyPr/>
-                    <a:lstStyle/>
-                    <a:p>
-                      <a:pPr>
-                        <a:defRPr sz="1100" b="0">
-                          <a:solidFill>
-                            <a:srgbClr val="F8FAFC"/>
-                          </a:solidFill>
-                          <a:latin typeface="Arial"/>
-                        </a:defRPr>
-                      </a:pPr>
-                      <a:r>
-                        <a:t>75% repeat lists, 94% validation score</a:t>
-                      </a:r>
-                    </a:p>
-                  </a:txBody>
-                  <a:tcPr>
-                    <a:solidFill>
-                      <a:srgbClr val="111827"/>
-                    </a:solidFill>
-                  </a:tcPr>
-                </a:tc>
-              </a:tr>
-            </a:tbl>
-          </a:graphicData>
-        </a:graphic>
-      </p:graphicFrame>
-      <p:graphicFrame>
-        <p:nvGraphicFramePr>
-          <p:cNvPr id="7" name="Table 6"/>
-          <p:cNvGraphicFramePr>
-            <a:graphicFrameLocks noGrp="1"/>
-          </p:cNvGraphicFramePr>
+        </p:nvSpPr>
+        <p:spPr>
+          <a:xfrm>
+            <a:off x="457200" y="1371600"/>
+            <a:ext cx="6217920" cy="4572000"/>
+          </a:xfrm>
+          <a:prstGeom prst="rect">
+            <a:avLst/>
+          </a:prstGeom>
+          <a:noFill/>
+        </p:spPr>
+        <p:txBody>
+          <a:bodyPr wrap="square">
+            <a:spAutoFit/>
+          </a:bodyPr>
+          <a:lstStyle/>
+          <a:p>
+            <a:pPr>
+              <a:spcAft>
+                <a:spcPts val="800"/>
+              </a:spcAft>
+              <a:defRPr b="1" sz="1500">
+                <a:solidFill>
+                  <a:srgbClr val="FC8019"/>
+                </a:solidFill>
+              </a:defRPr>
+            </a:pPr>
+            <a:r>
+              <a:t>7-Agent NLP Pipeline &amp; K-Means Engine</a:t>
+            </a:r>
+          </a:p>
+          <a:p>
+            <a:pPr>
+              <a:defRPr sz="1400">
+                <a:solidFill>
+                  <a:srgbClr val="F8FAFC"/>
+                </a:solidFill>
+              </a:defRPr>
+            </a:pPr>
+            <a:r>
+              <a:t>• AI-Agent Orchestration: We built a sequential 7-agent coordinator that manages scraper triggers, cleans slang, clusters semantic themes, and runs database validations.</a:t>
+            </a:r>
+            <a:br/>
+            <a:br/>
+            <a:r>
+              <a:t>• K-Means Semantic Clustering: Text features are vectorized via TF-IDF (Term Frequency-Inverse Document Frequency) and grouped via K-Means (K=4) to mathematically label customer friction clusters.</a:t>
+            </a:r>
+            <a:br/>
+            <a:br/>
+            <a:r>
+              <a:t>• Count Heuristic Validation: Insights are verified against SQLite counts to select supporting quotes, achieving a 94% validation score.</a:t>
+            </a:r>
+          </a:p>
+        </p:txBody>
+      </p:sp>
+      <p:pic>
+        <p:nvPicPr>
+          <p:cNvPr id="7" name="Picture 6" descr="n8n_pipeline_workflow.jpg"/>
+          <p:cNvPicPr>
+            <a:picLocks noChangeAspect="1"/>
+          </p:cNvPicPr>
           <p:nvPr/>
-        </p:nvGraphicFramePr>
-        <p:xfrm>
-          <a:off x="5212080" y="1371600"/>
-          <a:ext cx="6522415" cy="4572000"/>
-        </p:xfrm>
-        <a:graphic>
-          <a:graphicData uri="http://schemas.openxmlformats.org/drawingml/2006/table">
-            <a:tbl>
-              <a:tblPr firstRow="1" bandRow="1">
-                <a:tableStyleId>{5C22544A-7EE6-4342-B048-85BDC9FD1C3A}</a:tableStyleId>
-              </a:tblPr>
-              <a:tblGrid>
-                <a:gridCol w="1097280"/>
-                <a:gridCol w="1463040"/>
-                <a:gridCol w="1371600"/>
-                <a:gridCol w="1280160"/>
-                <a:gridCol w="1310335"/>
-              </a:tblGrid>
-              <a:tr h="1143000">
-                <a:tc>
-                  <a:txBody>
-                    <a:bodyPr/>
-                    <a:lstStyle/>
-                    <a:p>
-                      <a:pPr>
-                        <a:defRPr sz="1000" b="1">
-                          <a:solidFill>
-                            <a:srgbClr val="F8FAFC"/>
-                          </a:solidFill>
-                          <a:latin typeface="Arial"/>
-                        </a:defRPr>
-                      </a:pPr>
-                      <a:r>
-                        <a:t>Persona</a:t>
-                      </a:r>
-                    </a:p>
-                  </a:txBody>
-                  <a:tcPr>
-                    <a:solidFill>
-                      <a:srgbClr val="1F2937"/>
-                    </a:solidFill>
-                  </a:tcPr>
-                </a:tc>
-                <a:tc>
-                  <a:txBody>
-                    <a:bodyPr/>
-                    <a:lstStyle/>
-                    <a:p>
-                      <a:pPr>
-                        <a:defRPr sz="1000" b="1">
-                          <a:solidFill>
-                            <a:srgbClr val="F8FAFC"/>
-                          </a:solidFill>
-                          <a:latin typeface="Arial"/>
-                        </a:defRPr>
-                      </a:pPr>
-                      <a:r>
-                        <a:t>Behavior Pattern</a:t>
-                      </a:r>
-                    </a:p>
-                  </a:txBody>
-                  <a:tcPr>
-                    <a:solidFill>
-                      <a:srgbClr val="1F2937"/>
-                    </a:solidFill>
-                  </a:tcPr>
-                </a:tc>
-                <a:tc>
-                  <a:txBody>
-                    <a:bodyPr/>
-                    <a:lstStyle/>
-                    <a:p>
-                      <a:pPr>
-                        <a:defRPr sz="1000" b="1">
-                          <a:solidFill>
-                            <a:srgbClr val="F8FAFC"/>
-                          </a:solidFill>
-                          <a:latin typeface="Arial"/>
-                        </a:defRPr>
-                      </a:pPr>
-                      <a:r>
-                        <a:t>Core Frustration</a:t>
-                      </a:r>
-                    </a:p>
-                  </a:txBody>
-                  <a:tcPr>
-                    <a:solidFill>
-                      <a:srgbClr val="1F2937"/>
-                    </a:solidFill>
-                  </a:tcPr>
-                </a:tc>
-                <a:tc>
-                  <a:txBody>
-                    <a:bodyPr/>
-                    <a:lstStyle/>
-                    <a:p>
-                      <a:pPr>
-                        <a:defRPr sz="1000" b="1">
-                          <a:solidFill>
-                            <a:srgbClr val="F8FAFC"/>
-                          </a:solidFill>
-                          <a:latin typeface="Arial"/>
-                        </a:defRPr>
-                      </a:pPr>
-                      <a:r>
-                        <a:t>Job to be Done</a:t>
-                      </a:r>
-                    </a:p>
-                  </a:txBody>
-                  <a:tcPr>
-                    <a:solidFill>
-                      <a:srgbClr val="1F2937"/>
-                    </a:solidFill>
-                  </a:tcPr>
-                </a:tc>
-                <a:tc>
-                  <a:txBody>
-                    <a:bodyPr/>
-                    <a:lstStyle/>
-                    <a:p>
-                      <a:pPr>
-                        <a:defRPr sz="1000" b="1">
-                          <a:solidFill>
-                            <a:srgbClr val="F8FAFC"/>
-                          </a:solidFill>
-                          <a:latin typeface="Arial"/>
-                        </a:defRPr>
-                      </a:pPr>
-                      <a:r>
-                        <a:t>Unmet Need</a:t>
-                      </a:r>
-                    </a:p>
-                  </a:txBody>
-                  <a:tcPr>
-                    <a:solidFill>
-                      <a:srgbClr val="1F2937"/>
-                    </a:solidFill>
-                  </a:tcPr>
-                </a:tc>
-              </a:tr>
-              <a:tr h="1143000">
-                <a:tc>
-                  <a:txBody>
-                    <a:bodyPr/>
-                    <a:lstStyle/>
-                    <a:p>
-                      <a:pPr>
-                        <a:defRPr sz="900" b="1">
-                          <a:solidFill>
-                            <a:srgbClr val="F8FAFC"/>
-                          </a:solidFill>
-                          <a:latin typeface="Arial"/>
-                        </a:defRPr>
-                      </a:pPr>
-                      <a:r>
-                        <a:t>Rohan, 29</a:t>
-                      </a:r>
-                    </a:p>
-                    <a:p>
-                      <a:r>
-                        <a:t>Software Eng</a:t>
-                      </a:r>
-                    </a:p>
-                    <a:p>
-                      <a:r>
-                        <a:t>Bangalore</a:t>
-                      </a:r>
-                    </a:p>
-                  </a:txBody>
-                  <a:tcPr>
-                    <a:solidFill>
-                      <a:srgbClr val="111827"/>
-                    </a:solidFill>
-                  </a:tcPr>
-                </a:tc>
-                <a:tc>
-                  <a:txBody>
-                    <a:bodyPr/>
-                    <a:lstStyle/>
-                    <a:p>
-                      <a:pPr>
-                        <a:defRPr sz="900" b="0">
-                          <a:solidFill>
-                            <a:srgbClr val="F8FAFC"/>
-                          </a:solidFill>
-                          <a:latin typeface="Arial"/>
-                        </a:defRPr>
-                      </a:pPr>
-                      <a:r>
-                        <a:t>Orders milk daily via reorders. Bypasses catalog.</a:t>
-                      </a:r>
-                    </a:p>
-                  </a:txBody>
-                  <a:tcPr>
-                    <a:solidFill>
-                      <a:srgbClr val="111827"/>
-                    </a:solidFill>
-                  </a:tcPr>
-                </a:tc>
-                <a:tc>
-                  <a:txBody>
-                    <a:bodyPr/>
-                    <a:lstStyle/>
-                    <a:p>
-                      <a:pPr>
-                        <a:defRPr sz="900" b="0">
-                          <a:solidFill>
-                            <a:srgbClr val="F8FAFC"/>
-                          </a:solidFill>
-                          <a:latin typeface="Arial"/>
-                        </a:defRPr>
-                      </a:pPr>
-                      <a:r>
-                        <a:t>Delivery fee surcharges on small single add-on items.</a:t>
-                      </a:r>
-                    </a:p>
-                  </a:txBody>
-                  <a:tcPr>
-                    <a:solidFill>
-                      <a:srgbClr val="111827"/>
-                    </a:solidFill>
-                  </a:tcPr>
-                </a:tc>
-                <a:tc>
-                  <a:txBody>
-                    <a:bodyPr/>
-                    <a:lstStyle/>
-                    <a:p>
-                      <a:pPr>
-                        <a:defRPr sz="900" b="0">
-                          <a:solidFill>
-                            <a:srgbClr val="F8FAFC"/>
-                          </a:solidFill>
-                          <a:latin typeface="Arial"/>
-                        </a:defRPr>
-                      </a:pPr>
-                      <a:r>
-                        <a:t>Test new high-margin categories with zero fee friction.</a:t>
-                      </a:r>
-                    </a:p>
-                  </a:txBody>
-                  <a:tcPr>
-                    <a:solidFill>
-                      <a:srgbClr val="111827"/>
-                    </a:solidFill>
-                  </a:tcPr>
-                </a:tc>
-                <a:tc>
-                  <a:txBody>
-                    <a:bodyPr/>
-                    <a:lstStyle/>
-                    <a:p>
-                      <a:pPr>
-                        <a:defRPr sz="900" b="0">
-                          <a:solidFill>
-                            <a:srgbClr val="FF9F43"/>
-                          </a:solidFill>
-                          <a:latin typeface="Arial"/>
-                        </a:defRPr>
-                      </a:pPr>
-                      <a:r>
-                        <a:t>Post-checkout no-fee append window.</a:t>
-                      </a:r>
-                    </a:p>
-                  </a:txBody>
-                  <a:tcPr>
-                    <a:solidFill>
-                      <a:srgbClr val="111827"/>
-                    </a:solidFill>
-                  </a:tcPr>
-                </a:tc>
-              </a:tr>
-              <a:tr h="1143000">
-                <a:tc>
-                  <a:txBody>
-                    <a:bodyPr/>
-                    <a:lstStyle/>
-                    <a:p>
-                      <a:pPr>
-                        <a:defRPr sz="900" b="1">
-                          <a:solidFill>
-                            <a:srgbClr val="F8FAFC"/>
-                          </a:solidFill>
-                          <a:latin typeface="Arial"/>
-                        </a:defRPr>
-                      </a:pPr>
-                      <a:r>
-                        <a:t>Meera, 42</a:t>
-                      </a:r>
-                    </a:p>
-                    <a:p>
-                      <a:r>
-                        <a:t>Homemaker</a:t>
-                      </a:r>
-                    </a:p>
-                    <a:p>
-                      <a:r>
-                        <a:t>Mumbai</a:t>
-                      </a:r>
-                    </a:p>
-                  </a:txBody>
-                  <a:tcPr>
-                    <a:solidFill>
-                      <a:srgbClr val="111827"/>
-                    </a:solidFill>
-                  </a:tcPr>
-                </a:tc>
-                <a:tc>
-                  <a:txBody>
-                    <a:bodyPr/>
-                    <a:lstStyle/>
-                    <a:p>
-                      <a:pPr>
-                        <a:defRPr sz="900" b="0">
-                          <a:solidFill>
-                            <a:srgbClr val="F8FAFC"/>
-                          </a:solidFill>
-                          <a:latin typeface="Arial"/>
-                        </a:defRPr>
-                      </a:pPr>
-                      <a:r>
-                        <a:t>Buys vegetables and grocery items occasionally.</a:t>
-                      </a:r>
-                    </a:p>
-                  </a:txBody>
-                  <a:tcPr>
-                    <a:solidFill>
-                      <a:srgbClr val="111827"/>
-                    </a:solidFill>
-                  </a:tcPr>
-                </a:tc>
-                <a:tc>
-                  <a:txBody>
-                    <a:bodyPr/>
-                    <a:lstStyle/>
-                    <a:p>
-                      <a:pPr>
-                        <a:defRPr sz="900" b="0">
-                          <a:solidFill>
-                            <a:srgbClr val="F8FAFC"/>
-                          </a:solidFill>
-                          <a:latin typeface="Arial"/>
-                        </a:defRPr>
-                      </a:pPr>
-                      <a:r>
-                        <a:t>Bad fresh produce batches; wallet-only refunds.</a:t>
-                      </a:r>
-                    </a:p>
-                  </a:txBody>
-                  <a:tcPr>
-                    <a:solidFill>
-                      <a:srgbClr val="111827"/>
-                    </a:solidFill>
-                  </a:tcPr>
-                </a:tc>
-                <a:tc>
-                  <a:txBody>
-                    <a:bodyPr/>
-                    <a:lstStyle/>
-                    <a:p>
-                      <a:pPr>
-                        <a:defRPr sz="900" b="0">
-                          <a:solidFill>
-                            <a:srgbClr val="F8FAFC"/>
-                          </a:solidFill>
-                          <a:latin typeface="Arial"/>
-                        </a:defRPr>
-                      </a:pPr>
-                      <a:r>
-                        <a:t>Buy produce with complete freshness trust and cash refund.</a:t>
-                      </a:r>
-                    </a:p>
-                  </a:txBody>
-                  <a:tcPr>
-                    <a:solidFill>
-                      <a:srgbClr val="111827"/>
-                    </a:solidFill>
-                  </a:tcPr>
-                </a:tc>
-                <a:tc>
-                  <a:txBody>
-                    <a:bodyPr/>
-                    <a:lstStyle/>
-                    <a:p>
-                      <a:pPr>
-                        <a:defRPr sz="900" b="0">
-                          <a:solidFill>
-                            <a:srgbClr val="FF9F43"/>
-                          </a:solidFill>
-                          <a:latin typeface="Arial"/>
-                        </a:defRPr>
-                      </a:pPr>
-                      <a:r>
-                        <a:t>Visual expiration &amp; freshness metrics.</a:t>
-                      </a:r>
-                    </a:p>
-                  </a:txBody>
-                  <a:tcPr>
-                    <a:solidFill>
-                      <a:srgbClr val="111827"/>
-                    </a:solidFill>
-                  </a:tcPr>
-                </a:tc>
-              </a:tr>
-              <a:tr h="1143000">
-                <a:tc>
-                  <a:txBody>
-                    <a:bodyPr/>
-                    <a:lstStyle/>
-                    <a:p>
-                      <a:pPr>
-                        <a:defRPr sz="900" b="1">
-                          <a:solidFill>
-                            <a:srgbClr val="F8FAFC"/>
-                          </a:solidFill>
-                          <a:latin typeface="Arial"/>
-                        </a:defRPr>
-                      </a:pPr>
-                      <a:r>
-                        <a:t>Priya, 35</a:t>
-                      </a:r>
-                    </a:p>
-                    <a:p>
-                      <a:r>
-                        <a:t>Pet/Baby Parent</a:t>
-                      </a:r>
-                    </a:p>
-                    <a:p>
-                      <a:r>
-                        <a:t>Pune</a:t>
-                      </a:r>
-                    </a:p>
-                  </a:txBody>
-                  <a:tcPr>
-                    <a:solidFill>
-                      <a:srgbClr val="111827"/>
-                    </a:solidFill>
-                  </a:tcPr>
-                </a:tc>
-                <a:tc>
-                  <a:txBody>
-                    <a:bodyPr/>
-                    <a:lstStyle/>
-                    <a:p>
-                      <a:pPr>
-                        <a:defRPr sz="900" b="0">
-                          <a:solidFill>
-                            <a:srgbClr val="F8FAFC"/>
-                          </a:solidFill>
-                          <a:latin typeface="Arial"/>
-                        </a:defRPr>
-                      </a:pPr>
-                      <a:r>
-                        <a:t>Buys premium baby wipes and dog food bags.</a:t>
-                      </a:r>
-                    </a:p>
-                  </a:txBody>
-                  <a:tcPr>
-                    <a:solidFill>
-                      <a:srgbClr val="111827"/>
-                    </a:solidFill>
-                  </a:tcPr>
-                </a:tc>
-                <a:tc>
-                  <a:txBody>
-                    <a:bodyPr/>
-                    <a:lstStyle/>
-                    <a:p>
-                      <a:pPr>
-                        <a:defRPr sz="900" b="0">
-                          <a:solidFill>
-                            <a:srgbClr val="F8FAFC"/>
-                          </a:solidFill>
-                          <a:latin typeface="Arial"/>
-                        </a:defRPr>
-                      </a:pPr>
-                      <a:r>
-                        <a:t>App lacks diaper size charts and product reviews.</a:t>
-                      </a:r>
-                    </a:p>
-                  </a:txBody>
-                  <a:tcPr>
-                    <a:solidFill>
-                      <a:srgbClr val="111827"/>
-                    </a:solidFill>
-                  </a:tcPr>
-                </a:tc>
-                <a:tc>
-                  <a:txBody>
-                    <a:bodyPr/>
-                    <a:lstStyle/>
-                    <a:p>
-                      <a:pPr>
-                        <a:defRPr sz="900" b="0">
-                          <a:solidFill>
-                            <a:srgbClr val="F8FAFC"/>
-                          </a:solidFill>
-                          <a:latin typeface="Arial"/>
-                        </a:defRPr>
-                      </a:pPr>
-                      <a:r>
-                        <a:t>Validate specifications before buying.</a:t>
-                      </a:r>
-                    </a:p>
-                  </a:txBody>
-                  <a:tcPr>
-                    <a:solidFill>
-                      <a:srgbClr val="111827"/>
-                    </a:solidFill>
-                  </a:tcPr>
-                </a:tc>
-                <a:tc>
-                  <a:txBody>
-                    <a:bodyPr/>
-                    <a:lstStyle/>
-                    <a:p>
-                      <a:pPr>
-                        <a:defRPr sz="900" b="0">
-                          <a:solidFill>
-                            <a:srgbClr val="FF9F43"/>
-                          </a:solidFill>
-                          <a:latin typeface="Arial"/>
-                        </a:defRPr>
-                      </a:pPr>
-                      <a:r>
-                        <a:t>Detailed specifications charts inside app.</a:t>
-                      </a:r>
-                    </a:p>
-                  </a:txBody>
-                  <a:tcPr>
-                    <a:solidFill>
-                      <a:srgbClr val="111827"/>
-                    </a:solidFill>
-                  </a:tcPr>
-                </a:tc>
-              </a:tr>
-            </a:tbl>
-          </a:graphicData>
-        </a:graphic>
-      </p:graphicFrame>
+        </p:nvPicPr>
+        <p:blipFill>
+          <a:blip r:embed="rId2"/>
+          <a:stretch>
+            <a:fillRect/>
+          </a:stretch>
+        </p:blipFill>
+        <p:spPr>
+          <a:xfrm>
+            <a:off x="6858000" y="1645920"/>
+            <a:ext cx="4846320" cy="4114800"/>
+          </a:xfrm>
+          <a:prstGeom prst="rect">
+            <a:avLst/>
+          </a:prstGeom>
+        </p:spPr>
+      </p:pic>
       <p:sp>
         <p:nvSpPr>
           <p:cNvPr id="8" name="TextBox 7"/>
@@ -6674,7 +5690,7 @@
               </a:defRPr>
             </a:pPr>
             <a:r>
-              <a:t>PART 2 · ASSUMED HYPOTHESES</a:t>
+              <a:t>PART 1 · API &amp; DASHBOARD LAYER</a:t>
             </a:r>
           </a:p>
         </p:txBody>
@@ -6710,7 +5726,7 @@
               </a:defRPr>
             </a:pPr>
             <a:r>
-              <a:t>4 Hypotheses We Assumed Based on AI-Generated Insights</a:t>
+              <a:t>FastAPI Backend REST endpoints &amp; Streamlit dashboard (What Was Built)</a:t>
             </a:r>
           </a:p>
         </p:txBody>
@@ -6724,7 +5740,7 @@
         <p:spPr>
           <a:xfrm>
             <a:off x="457200" y="1371600"/>
-            <a:ext cx="5303520" cy="2011680"/>
+            <a:ext cx="6217920" cy="4572000"/>
           </a:xfrm>
           <a:prstGeom prst="rect">
             <a:avLst/>
@@ -6748,7 +5764,7 @@
               </a:defRPr>
             </a:pPr>
             <a:r>
-              <a:t>H1: Delivery Fee Tax → Habitual Reordering &amp; Churn</a:t>
+              <a:t>FastAPI Backend &amp; Streamlit Analytics UI</a:t>
             </a:r>
           </a:p>
           <a:p>
@@ -6760,25 +5776,55 @@
               </a:defRPr>
             </a:pPr>
             <a:r>
-              <a:t>Instamart charges full delivery fees on small orders. This blocks users from testing low-risk auxiliary categories (like a face wash) as single item add-ons.</a:t>
+              <a:t>• Backend Gateway: We coded FastAPI endpoints (like `/api/insights` and `/api/opportunities`) returning JSON database queries to decouple processing from the interface.</a:t>
             </a:r>
             <a:br/>
-            <a:r>
-              <a:t>Tag: Delivery Fee Friction</a:t>
-            </a:r>
-          </a:p>
-        </p:txBody>
-      </p:sp>
-      <p:sp>
-        <p:nvSpPr>
-          <p:cNvPr id="7" name="TextBox 6"/>
+            <a:br/>
+            <a:r>
+              <a:t>• RICE Roadmapping: Backlog prioritization weights are calculated and stored in SQLite dynamically, sync'd with REST endpoints.</a:t>
+            </a:r>
+            <a:br/>
+            <a:br/>
+            <a:r>
+              <a:t>• Streamlit Dashboard: Renders sentiment pie charts, category metrics, and opportunities scorecards in custom brand colors (Indigo Blue and Swiggy Orange).</a:t>
+            </a:r>
+          </a:p>
+        </p:txBody>
+      </p:sp>
+      <p:pic>
+        <p:nvPicPr>
+          <p:cNvPr id="7" name="Picture 6" descr="database_schema_diagram.jpg"/>
+          <p:cNvPicPr>
+            <a:picLocks noChangeAspect="1"/>
+          </p:cNvPicPr>
+          <p:nvPr/>
+        </p:nvPicPr>
+        <p:blipFill>
+          <a:blip r:embed="rId2"/>
+          <a:stretch>
+            <a:fillRect/>
+          </a:stretch>
+        </p:blipFill>
+        <p:spPr>
+          <a:xfrm>
+            <a:off x="6858000" y="1645920"/>
+            <a:ext cx="4846320" cy="4114800"/>
+          </a:xfrm>
+          <a:prstGeom prst="rect">
+            <a:avLst/>
+          </a:prstGeom>
+        </p:spPr>
+      </p:pic>
+      <p:sp>
+        <p:nvSpPr>
+          <p:cNvPr id="8" name="TextBox 7"/>
           <p:cNvSpPr txBox="1"/>
           <p:nvPr/>
         </p:nvSpPr>
         <p:spPr>
           <a:xfrm>
-            <a:off x="6217920" y="1371600"/>
-            <a:ext cx="5303520" cy="2011680"/>
+            <a:off x="457200" y="6400800"/>
+            <a:ext cx="9144000" cy="274320"/>
           </a:xfrm>
           <a:prstGeom prst="rect">
             <a:avLst/>
@@ -6786,168 +5832,6 @@
           <a:noFill/>
         </p:spPr>
         <p:txBody>
-          <a:bodyPr wrap="square">
-            <a:spAutoFit/>
-          </a:bodyPr>
-          <a:lstStyle/>
-          <a:p>
-            <a:pPr>
-              <a:spcAft>
-                <a:spcPts val="800"/>
-              </a:spcAft>
-              <a:defRPr b="1" sz="1500">
-                <a:solidFill>
-                  <a:srgbClr val="FC8019"/>
-                </a:solidFill>
-              </a:defRPr>
-            </a:pPr>
-            <a:r>
-              <a:t>H2: Freshness Quality → Lack of Catalog Trust</a:t>
-            </a:r>
-          </a:p>
-          <a:p>
-            <a:pPr>
-              <a:defRPr sz="1400">
-                <a:solidFill>
-                  <a:srgbClr val="F8FAFC"/>
-                </a:solidFill>
-              </a:defRPr>
-            </a:pPr>
-            <a:r>
-              <a:t>Absence of real-time freshness markers and failure to offer cash refunds on squished produce drives homemakers back to offline vegetable markets.</a:t>
-            </a:r>
-            <a:br/>
-            <a:r>
-              <a:t>Tag: Quality Trust Deficit</a:t>
-            </a:r>
-          </a:p>
-        </p:txBody>
-      </p:sp>
-      <p:sp>
-        <p:nvSpPr>
-          <p:cNvPr id="8" name="TextBox 7"/>
-          <p:cNvSpPr txBox="1"/>
-          <p:nvPr/>
-        </p:nvSpPr>
-        <p:spPr>
-          <a:xfrm>
-            <a:off x="457200" y="3657600"/>
-            <a:ext cx="5303520" cy="2011680"/>
-          </a:xfrm>
-          <a:prstGeom prst="rect">
-            <a:avLst/>
-          </a:prstGeom>
-          <a:noFill/>
-        </p:spPr>
-        <p:txBody>
-          <a:bodyPr wrap="square">
-            <a:spAutoFit/>
-          </a:bodyPr>
-          <a:lstStyle/>
-          <a:p>
-            <a:pPr>
-              <a:spcAft>
-                <a:spcPts val="800"/>
-              </a:spcAft>
-              <a:defRPr b="1" sz="1500">
-                <a:solidFill>
-                  <a:srgbClr val="FC8019"/>
-                </a:solidFill>
-              </a:defRPr>
-            </a:pPr>
-            <a:r>
-              <a:t>H3: Visual Overwhelm → Homepage Discovery Avoidance</a:t>
-            </a:r>
-          </a:p>
-          <a:p>
-            <a:pPr>
-              <a:defRPr sz="1400">
-                <a:solidFill>
-                  <a:srgbClr val="F8FAFC"/>
-                </a:solidFill>
-              </a:defRPr>
-            </a:pPr>
-            <a:r>
-              <a:t>Home screen layout contains too many flashing banners. Senior or busy cohorts default to clicking 'Buy it Again' history, bypassing navigation tabs entirely.</a:t>
-            </a:r>
-            <a:br/>
-            <a:r>
-              <a:t>Tag: UI Clutter &amp; Navigation Anxiety</a:t>
-            </a:r>
-          </a:p>
-        </p:txBody>
-      </p:sp>
-      <p:sp>
-        <p:nvSpPr>
-          <p:cNvPr id="9" name="TextBox 8"/>
-          <p:cNvSpPr txBox="1"/>
-          <p:nvPr/>
-        </p:nvSpPr>
-        <p:spPr>
-          <a:xfrm>
-            <a:off x="6217920" y="3657600"/>
-            <a:ext cx="5303520" cy="2011680"/>
-          </a:xfrm>
-          <a:prstGeom prst="rect">
-            <a:avLst/>
-          </a:prstGeom>
-          <a:noFill/>
-        </p:spPr>
-        <p:txBody>
-          <a:bodyPr wrap="square">
-            <a:spAutoFit/>
-          </a:bodyPr>
-          <a:lstStyle/>
-          <a:p>
-            <a:pPr>
-              <a:spcAft>
-                <a:spcPts val="800"/>
-              </a:spcAft>
-              <a:defRPr b="1" sz="1500">
-                <a:solidFill>
-                  <a:srgbClr val="FC8019"/>
-                </a:solidFill>
-              </a:defRPr>
-            </a:pPr>
-            <a:r>
-              <a:t>H4: Multi-App Price Comparisons → Basket Splitting</a:t>
-            </a:r>
-          </a:p>
-          <a:p>
-            <a:pPr>
-              <a:defRPr sz="1400">
-                <a:solidFill>
-                  <a:srgbClr val="F8FAFC"/>
-                </a:solidFill>
-              </a:defRPr>
-            </a:pPr>
-            <a:r>
-              <a:t>Mixed-language user profile settings confuse item recommendations. Users split carts across Blinkit and Zepto based on immediate coupon availabilities.</a:t>
-            </a:r>
-            <a:br/>
-            <a:r>
-              <a:t>Tag: Platform Fragmentation</a:t>
-            </a:r>
-          </a:p>
-        </p:txBody>
-      </p:sp>
-      <p:sp>
-        <p:nvSpPr>
-          <p:cNvPr id="10" name="TextBox 9"/>
-          <p:cNvSpPr txBox="1"/>
-          <p:nvPr/>
-        </p:nvSpPr>
-        <p:spPr>
-          <a:xfrm>
-            <a:off x="457200" y="6400800"/>
-            <a:ext cx="9144000" cy="274320"/>
-          </a:xfrm>
-          <a:prstGeom prst="rect">
-            <a:avLst/>
-          </a:prstGeom>
-          <a:noFill/>
-        </p:spPr>
-        <p:txBody>
           <a:bodyPr wrap="none">
             <a:spAutoFit/>
           </a:bodyPr>
@@ -6969,7 +5853,7 @@
       </p:sp>
       <p:sp>
         <p:nvSpPr>
-          <p:cNvPr id="11" name="TextBox 10"/>
+          <p:cNvPr id="9" name="TextBox 8"/>
           <p:cNvSpPr txBox="1"/>
           <p:nvPr/>
         </p:nvSpPr>
@@ -8355,7 +7239,7 @@
             </a:r>
             <a:br/>
             <a:r>
-              <a:t>• Accelerates high-margin category adoption with ₹0 user acquisition cost.</a:t>
+              <a:t>• Automatically cross-sells high-margin categories (personal care, pets) with zero CAC.</a:t>
             </a:r>
             <a:br/>
             <a:r>
@@ -8623,7 +7507,7 @@
         <p:spPr>
           <a:xfrm>
             <a:off x="457200" y="1371600"/>
-            <a:ext cx="5486400" cy="4572000"/>
+            <a:ext cx="6217920" cy="4572000"/>
           </a:xfrm>
           <a:prstGeom prst="rect">
             <a:avLst/>
@@ -8647,14 +7531,11 @@
               </a:defRPr>
             </a:pPr>
             <a:r>
-              <a:t>1. Post-Checkout Urgency Sandbox Mechanics</a:t>
+              <a:t>Post-Checkout 3-Min Append Sandbox</a:t>
             </a:r>
           </a:p>
           <a:p>
             <a:pPr>
-              <a:spcAft>
-                <a:spcPts val="1200"/>
-              </a:spcAft>
               <a:defRPr sz="1400">
                 <a:solidFill>
                   <a:srgbClr val="F8FAFC"/>
@@ -8662,163 +7543,50 @@
               </a:defRPr>
             </a:pPr>
             <a:r>
-              <a:t>We built and deployed an interactive checkout simulator (`index.html`) on GitHub Pages showcasing the 3-Minute Add-On Window:</a:t>
-            </a:r>
-          </a:p>
-          <a:p>
-            <a:pPr>
-              <a:spcAft>
-                <a:spcPts val="1000"/>
-              </a:spcAft>
-              <a:defRPr sz="1300">
-                <a:solidFill>
-                  <a:srgbClr val="F8FAFC"/>
-                </a:solidFill>
-              </a:defRPr>
-            </a:pPr>
-            <a:r>
-              <a:t>• Checkout of dairy essentials simulates active payment completion.</a:t>
+              <a:t>• Checkout Simulator: We built a fully functional checkout prototype on GitHub Pages. Placing a dairy order simulates payment completion.</a:t>
             </a:r>
             <a:br/>
-            <a:r>
-              <a:t>• Triggers a 3-minute visual countdown timer banner immediately.</a:t>
-            </a:r>
             <a:br/>
             <a:r>
-              <a:t>• Displays auxiliary items (Face wash, Avocados) with ₹0 delivery fee.</a:t>
+              <a:t>• Countdown Urgency Banner: An active 3-minute timer triggers immediately, showing the packaging window at the dark store.</a:t>
             </a:r>
             <a:br/>
-            <a:r>
-              <a:t>• Dynamically updates cart totals and applies the fee waiver.</a:t>
-            </a:r>
             <a:br/>
             <a:r>
-              <a:t>• Deployed Prototype URL: https://aashritamalviya1999.github.io/swiggy-instamart-discovery/ (Live MVP Prototype Tab)</a:t>
-            </a:r>
-          </a:p>
-        </p:txBody>
-      </p:sp>
-      <p:sp>
-        <p:nvSpPr>
-          <p:cNvPr id="7" name="TextBox 6"/>
-          <p:cNvSpPr txBox="1"/>
+              <a:t>• Fee-Free Category Explorations: Users append high-margin products (Face wash, Avocados, Baby wipes, Dog kibble) to their active order with ₹0 delivery fee.</a:t>
+            </a:r>
+            <a:br/>
+            <a:br/>
+            <a:r>
+              <a:t>• try it out: https://aashritamalviya1999.github.io/swiggy-instamart-discovery/ (Click 'Live MVP Prototype' Tab)</a:t>
+            </a:r>
+          </a:p>
+        </p:txBody>
+      </p:sp>
+      <p:pic>
+        <p:nvPicPr>
+          <p:cNvPr id="7" name="Picture 6" descr="mvp_checkout_mockup.jpg"/>
+          <p:cNvPicPr>
+            <a:picLocks noChangeAspect="1"/>
+          </p:cNvPicPr>
           <p:nvPr/>
-        </p:nvSpPr>
-        <p:spPr>
-          <a:xfrm>
-            <a:off x="6217920" y="1371600"/>
-            <a:ext cx="5486400" cy="4572000"/>
+        </p:nvPicPr>
+        <p:blipFill>
+          <a:blip r:embed="rId2"/>
+          <a:stretch>
+            <a:fillRect/>
+          </a:stretch>
+        </p:blipFill>
+        <p:spPr>
+          <a:xfrm>
+            <a:off x="6858000" y="1645920"/>
+            <a:ext cx="4846320" cy="4114800"/>
           </a:xfrm>
           <a:prstGeom prst="rect">
             <a:avLst/>
           </a:prstGeom>
-          <a:noFill/>
-        </p:spPr>
-        <p:txBody>
-          <a:bodyPr wrap="square">
-            <a:spAutoFit/>
-          </a:bodyPr>
-          <a:lstStyle/>
-          <a:p>
-            <a:pPr>
-              <a:spcAft>
-                <a:spcPts val="800"/>
-              </a:spcAft>
-              <a:defRPr b="1" sz="1500">
-                <a:solidFill>
-                  <a:srgbClr val="FC8019"/>
-                </a:solidFill>
-              </a:defRPr>
-            </a:pPr>
-            <a:r>
-              <a:t>2. Javascript Countdown Timer Logic</a:t>
-            </a:r>
-          </a:p>
-          <a:p>
-            <a:pPr>
-              <a:spcAft>
-                <a:spcPts val="1200"/>
-              </a:spcAft>
-              <a:defRPr sz="1400">
-                <a:solidFill>
-                  <a:srgbClr val="F8FAFC"/>
-                </a:solidFill>
-              </a:defRPr>
-            </a:pPr>
-            <a:r>
-              <a:t>We wrote visual countdown timer updates and disable routines in client-side JavaScript:</a:t>
-            </a:r>
-          </a:p>
-          <a:p>
-            <a:pPr>
-              <a:spcAft>
-                <a:spcPts val="1500"/>
-              </a:spcAft>
-              <a:defRPr sz="1000">
-                <a:solidFill>
-                  <a:srgbClr val="A855F7"/>
-                </a:solidFill>
-                <a:latin typeface="Courier New"/>
-              </a:defRPr>
-            </a:pPr>
-            <a:r>
-              <a:t>function startMvpTimer() {</a:t>
-            </a:r>
-            <a:br/>
-            <a:r>
-              <a:t>  mvpTimerInterval = setInterval(() =&gt; {</a:t>
-            </a:r>
-            <a:br/>
-            <a:r>
-              <a:t>    mvpSecondsRemaining--;</a:t>
-            </a:r>
-            <a:br/>
-            <a:r>
-              <a:t>    if (mvpSecondsRemaining &lt;= 0) {</a:t>
-            </a:r>
-            <a:br/>
-            <a:r>
-              <a:t>      clearInterval(mvpTimerInterval);</a:t>
-            </a:r>
-            <a:br/>
-            <a:r>
-              <a:t>      disableAddons();</a:t>
-            </a:r>
-            <a:br/>
-            <a:r>
-              <a:t>    } else {</a:t>
-            </a:r>
-            <a:br/>
-            <a:r>
-              <a:t>      updateTimerDisplay();</a:t>
-            </a:r>
-            <a:br/>
-            <a:r>
-              <a:t>    }</a:t>
-            </a:r>
-            <a:br/>
-            <a:r>
-              <a:t>  }, 1000);</a:t>
-            </a:r>
-            <a:br/>
-            <a:r>
-              <a:t>}</a:t>
-            </a:r>
-          </a:p>
-          <a:p>
-            <a:pPr>
-              <a:defRPr sz="1300">
-                <a:solidFill>
-                  <a:srgbClr val="8B949E"/>
-                </a:solidFill>
-              </a:defRPr>
-            </a:pPr>
-            <a:r>
-              <a:t>• Operational protection: Once packer has scanned barcode, add-on window locks out to prevent rider departure delays.</a:t>
-            </a:r>
-          </a:p>
-        </p:txBody>
-      </p:sp>
+        </p:spPr>
+      </p:pic>
       <p:sp>
         <p:nvSpPr>
           <p:cNvPr id="8" name="TextBox 7"/>

</xml_diff>

<commit_message>
Configure active text-run hyperlinks for PowerPoint presentation URLs
</commit_message>
<xml_diff>
--- a/NL Swiggy Instamart.pptx
+++ b/NL Swiggy Instamart.pptx
@@ -3996,8 +3996,8 @@
         </p:nvSpPr>
         <p:spPr>
           <a:xfrm>
-            <a:off x="4846320" y="4480560"/>
-            <a:ext cx="6858000" cy="1645920"/>
+            <a:off x="4846320" y="4297680"/>
+            <a:ext cx="6858000" cy="2011680"/>
           </a:xfrm>
           <a:prstGeom prst="rect">
             <a:avLst/>
@@ -4026,7 +4026,10 @@
           </a:p>
           <a:p>
             <a:pPr>
-              <a:defRPr sz="1400">
+              <a:spcAft>
+                <a:spcPts val="800"/>
+              </a:spcAft>
+              <a:defRPr sz="1300">
                 <a:solidFill>
                   <a:srgbClr val="F8FAFC"/>
                 </a:solidFill>
@@ -4042,6 +4045,56 @@
             <a:br/>
             <a:r>
               <a:t>• Projected AOV Lift: +18% lift in average basket size (~₹180 Million ARR lift in pilot region).</a:t>
+            </a:r>
+          </a:p>
+          <a:p>
+            <a:pPr>
+              <a:defRPr sz="1300"/>
+            </a:pPr>
+            <a:r>
+              <a:t>• </a:t>
+            </a:r>
+            <a:r>
+              <a:rPr>
+                <a:solidFill>
+                  <a:srgbClr val="F8FAFC"/>
+                </a:solidFill>
+              </a:rPr>
+              <a:t>Interactive MVP URL: </a:t>
+            </a:r>
+            <a:r>
+              <a:rPr u="sng">
+                <a:solidFill>
+                  <a:srgbClr val="3B82F6"/>
+                </a:solidFill>
+                <a:hlinkClick r:id="rId2"/>
+              </a:rPr>
+              <a:t>https://aashritamalviya1999.github.io/swiggy-instamart-discovery/</a:t>
+            </a:r>
+          </a:p>
+          <a:p>
+            <a:pPr>
+              <a:defRPr sz="1300"/>
+            </a:pPr>
+            <a:r>
+              <a:t>• </a:t>
+            </a:r>
+            <a:r>
+              <a:rPr>
+                <a:solidFill>
+                  <a:srgbClr val="F8FAFC"/>
+                </a:solidFill>
+              </a:rPr>
+              <a:t>Analytics Dashboard URL: </a:t>
+            </a:r>
+            <a:r>
+              <a:rPr u="sng">
+                <a:solidFill>
+                  <a:srgbClr val="3B82F6"/>
+                </a:solidFill>
+                <a:hlinkClick r:id="rId3"/>
+              </a:rPr>
+              <a:t>https://swiggy-instamart-discovery-6ss2oangvc44qmggkbvrhs.streamlit.app</a:t>
             </a:r>
           </a:p>
         </p:txBody>
@@ -4530,7 +4583,7 @@
                         </a:defRPr>
                       </a:pPr>
                       <a:r>
-                        <a:t>Packer lockout gate: Disable the client add-on option as soon as the picker terminal registers that order packing has commenced.</a:t>
+                        <a:t>Packer lockout gate: Disable the client add-on option as soon as picker terminal registers order packing commenced.</a:t>
                       </a:r>
                     </a:p>
                   </a:txBody>
@@ -7536,6 +7589,9 @@
           </a:p>
           <a:p>
             <a:pPr>
+              <a:spcAft>
+                <a:spcPts val="1500"/>
+              </a:spcAft>
               <a:defRPr sz="1400">
                 <a:solidFill>
                   <a:srgbClr val="F8FAFC"/>
@@ -7555,10 +7611,22 @@
             <a:r>
               <a:t>• Fee-Free Category Explorations: Users append high-margin products (Face wash, Avocados, Baby wipes, Dog kibble) to their active order with ₹0 delivery fee.</a:t>
             </a:r>
-            <a:br/>
-            <a:br/>
-            <a:r>
-              <a:t>• try it out: https://aashritamalviya1999.github.io/swiggy-instamart-discovery/ (Click 'Live MVP Prototype' Tab)</a:t>
+          </a:p>
+          <a:p>
+            <a:pPr>
+              <a:defRPr sz="1400"/>
+            </a:pPr>
+            <a:r>
+              <a:t>• Try the Deployed MVP: </a:t>
+            </a:r>
+            <a:r>
+              <a:rPr u="sng">
+                <a:solidFill>
+                  <a:srgbClr val="3B82F6"/>
+                </a:solidFill>
+                <a:hlinkClick r:id="rId2"/>
+              </a:rPr>
+              <a:t>https://aashritamalviya1999.github.io/swiggy-instamart-discovery/</a:t>
             </a:r>
           </a:p>
         </p:txBody>
@@ -7572,7 +7640,7 @@
           <p:nvPr/>
         </p:nvPicPr>
         <p:blipFill>
-          <a:blip r:embed="rId2"/>
+          <a:blip r:embed="rId3"/>
           <a:stretch>
             <a:fillRect/>
           </a:stretch>

</xml_diff>

<commit_message>
Convert slide text layouts to clean visual card cards to improve PM case study readability
</commit_message>
<xml_diff>
--- a/NL Swiggy Instamart.pptx
+++ b/NL Swiggy Instamart.pptx
@@ -3261,14 +3261,59 @@
       </p:sp>
       <p:sp>
         <p:nvSpPr>
-          <p:cNvPr id="6" name="TextBox 5"/>
+          <p:cNvPr id="6" name="Rounded Rectangle 5"/>
+          <p:cNvSpPr/>
+          <p:nvPr/>
+        </p:nvSpPr>
+        <p:spPr>
+          <a:xfrm>
+            <a:off x="457200" y="1371600"/>
+            <a:ext cx="4114800" cy="2103120"/>
+          </a:xfrm>
+          <a:prstGeom prst="roundRect">
+            <a:avLst/>
+          </a:prstGeom>
+          <a:solidFill>
+            <a:srgbClr val="111827"/>
+          </a:solidFill>
+          <a:ln w="12700">
+            <a:solidFill>
+              <a:srgbClr val="1F2937"/>
+            </a:solidFill>
+          </a:ln>
+        </p:spPr>
+        <p:style>
+          <a:lnRef idx="1">
+            <a:schemeClr val="accent1"/>
+          </a:lnRef>
+          <a:fillRef idx="3">
+            <a:schemeClr val="accent1"/>
+          </a:fillRef>
+          <a:effectRef idx="2">
+            <a:schemeClr val="accent1"/>
+          </a:effectRef>
+          <a:fontRef idx="minor">
+            <a:schemeClr val="lt1"/>
+          </a:fontRef>
+        </p:style>
+        <p:txBody>
+          <a:bodyPr rtlCol="0" anchor="ctr"/>
+          <a:lstStyle/>
+          <a:p>
+            <a:pPr algn="ctr"/>
+          </a:p>
+        </p:txBody>
+      </p:sp>
+      <p:sp>
+        <p:nvSpPr>
+          <p:cNvPr id="7" name="TextBox 6"/>
           <p:cNvSpPr txBox="1"/>
           <p:nvPr/>
         </p:nvSpPr>
         <p:spPr>
           <a:xfrm>
-            <a:off x="457200" y="1371600"/>
-            <a:ext cx="4114800" cy="4572000"/>
+            <a:off x="594360" y="1508760"/>
+            <a:ext cx="3840480" cy="1828800"/>
           </a:xfrm>
           <a:prstGeom prst="rect">
             <a:avLst/>
@@ -3283,31 +3328,17 @@
           <a:p>
             <a:pPr>
               <a:spcAft>
-                <a:spcPts val="800"/>
+                <a:spcPts val="1000"/>
               </a:spcAft>
-              <a:defRPr b="1" sz="1300">
+              <a:defRPr sz="1200" b="1">
                 <a:solidFill>
                   <a:srgbClr val="FC8019"/>
                 </a:solidFill>
+                <a:latin typeface="Arial"/>
               </a:defRPr>
             </a:pPr>
             <a:r>
               <a:t>CORE ISSUE</a:t>
-            </a:r>
-          </a:p>
-          <a:p>
-            <a:pPr>
-              <a:spcAft>
-                <a:spcPts val="1500"/>
-              </a:spcAft>
-              <a:defRPr sz="1400">
-                <a:solidFill>
-                  <a:srgbClr val="F8FAFC"/>
-                </a:solidFill>
-              </a:defRPr>
-            </a:pPr>
-            <a:r>
-              <a:t>Despite high daily transaction frequency, a meaningful share of Swiggy Instamart listening/ordering is anchored to repeat milk and bread histories. Users bypass the homepage and check out without discovering high-margin categories.</a:t>
             </a:r>
           </a:p>
           <a:p>
@@ -3315,45 +3346,170 @@
               <a:spcAft>
                 <a:spcPts val="800"/>
               </a:spcAft>
-              <a:defRPr b="1" sz="1300">
+              <a:defRPr sz="1100">
+                <a:solidFill>
+                  <a:srgbClr val="F8FAFC"/>
+                </a:solidFill>
+                <a:latin typeface="Arial"/>
+              </a:defRPr>
+            </a:pPr>
+            <a:r>
+              <a:t>Despite high daily transaction frequency, a meaningful share of Swiggy Instamart ordering is anchored to repeat dairy and bread histories. Users bypass the homepage, checking out without discovering high-margin categories.</a:t>
+            </a:r>
+          </a:p>
+        </p:txBody>
+      </p:sp>
+      <p:sp>
+        <p:nvSpPr>
+          <p:cNvPr id="8" name="Rounded Rectangle 7"/>
+          <p:cNvSpPr/>
+          <p:nvPr/>
+        </p:nvSpPr>
+        <p:spPr>
+          <a:xfrm>
+            <a:off x="457200" y="3657600"/>
+            <a:ext cx="4114800" cy="2468880"/>
+          </a:xfrm>
+          <a:prstGeom prst="roundRect">
+            <a:avLst/>
+          </a:prstGeom>
+          <a:solidFill>
+            <a:srgbClr val="111827"/>
+          </a:solidFill>
+          <a:ln w="12700">
+            <a:solidFill>
+              <a:srgbClr val="1F2937"/>
+            </a:solidFill>
+          </a:ln>
+        </p:spPr>
+        <p:style>
+          <a:lnRef idx="1">
+            <a:schemeClr val="accent1"/>
+          </a:lnRef>
+          <a:fillRef idx="3">
+            <a:schemeClr val="accent1"/>
+          </a:fillRef>
+          <a:effectRef idx="2">
+            <a:schemeClr val="accent1"/>
+          </a:effectRef>
+          <a:fontRef idx="minor">
+            <a:schemeClr val="lt1"/>
+          </a:fontRef>
+        </p:style>
+        <p:txBody>
+          <a:bodyPr rtlCol="0" anchor="ctr"/>
+          <a:lstStyle/>
+          <a:p>
+            <a:pPr algn="ctr"/>
+          </a:p>
+        </p:txBody>
+      </p:sp>
+      <p:sp>
+        <p:nvSpPr>
+          <p:cNvPr id="9" name="TextBox 8"/>
+          <p:cNvSpPr txBox="1"/>
+          <p:nvPr/>
+        </p:nvSpPr>
+        <p:spPr>
+          <a:xfrm>
+            <a:off x="594360" y="3794760"/>
+            <a:ext cx="3840480" cy="2194560"/>
+          </a:xfrm>
+          <a:prstGeom prst="rect">
+            <a:avLst/>
+          </a:prstGeom>
+          <a:noFill/>
+        </p:spPr>
+        <p:txBody>
+          <a:bodyPr wrap="square">
+            <a:spAutoFit/>
+          </a:bodyPr>
+          <a:lstStyle/>
+          <a:p>
+            <a:pPr>
+              <a:spcAft>
+                <a:spcPts val="1000"/>
+              </a:spcAft>
+              <a:defRPr sz="1200" b="1">
                 <a:solidFill>
                   <a:srgbClr val="FC8019"/>
                 </a:solidFill>
+                <a:latin typeface="Arial"/>
               </a:defRPr>
             </a:pPr>
             <a:r>
-              <a:t>CURRENT DISCOVERY GAPS IN APPS</a:t>
+              <a:t>CURRENT DISCOVERY GAPS</a:t>
             </a:r>
           </a:p>
           <a:p>
             <a:pPr>
-              <a:defRPr sz="1400">
+              <a:spcAft>
+                <a:spcPts val="800"/>
+              </a:spcAft>
+              <a:defRPr sz="1100">
                 <a:solidFill>
                   <a:srgbClr val="F8FAFC"/>
                 </a:solidFill>
+                <a:latin typeface="Arial"/>
               </a:defRPr>
             </a:pPr>
             <a:r>
               <a:t>• Pre-Checkout Fee Tax: Surcharges on small orders.</a:t>
             </a:r>
-            <a:br/>
+          </a:p>
+          <a:p>
+            <a:pPr>
+              <a:spcAft>
+                <a:spcPts val="800"/>
+              </a:spcAft>
+              <a:defRPr sz="1100">
+                <a:solidFill>
+                  <a:srgbClr val="F8FAFC"/>
+                </a:solidFill>
+                <a:latin typeface="Arial"/>
+              </a:defRPr>
+            </a:pPr>
             <a:r>
               <a:t>• Freshness Distrust: Hard produce return policies.</a:t>
             </a:r>
-            <a:br/>
+          </a:p>
+          <a:p>
+            <a:pPr>
+              <a:spcAft>
+                <a:spcPts val="800"/>
+              </a:spcAft>
+              <a:defRPr sz="1100">
+                <a:solidFill>
+                  <a:srgbClr val="F8FAFC"/>
+                </a:solidFill>
+                <a:latin typeface="Arial"/>
+              </a:defRPr>
+            </a:pPr>
             <a:r>
               <a:t>• Visual Noise: Flashing ads cause navigation anxiety.</a:t>
             </a:r>
-            <a:br/>
-            <a:r>
-              <a:t>• Specification Gaps: Lack of reviews/charts.</a:t>
+          </a:p>
+          <a:p>
+            <a:pPr>
+              <a:spcAft>
+                <a:spcPts val="800"/>
+              </a:spcAft>
+              <a:defRPr sz="1100">
+                <a:solidFill>
+                  <a:srgbClr val="F8FAFC"/>
+                </a:solidFill>
+                <a:latin typeface="Arial"/>
+              </a:defRPr>
+            </a:pPr>
+            <a:r>
+              <a:t>• Specification Gaps: Lack of reviews/size charts.</a:t>
             </a:r>
           </a:p>
         </p:txBody>
       </p:sp>
       <p:graphicFrame>
         <p:nvGraphicFramePr>
-          <p:cNvPr id="7" name="Table 6"/>
+          <p:cNvPr id="10" name="Table 9"/>
           <p:cNvGraphicFramePr>
             <a:graphicFrameLocks noGrp="1"/>
           </p:cNvGraphicFramePr>
@@ -3361,7 +3517,7 @@
         </p:nvGraphicFramePr>
         <p:xfrm>
           <a:off x="4846320" y="1371600"/>
-          <a:ext cx="6858000" cy="2926080"/>
+          <a:ext cx="6858000" cy="2743200"/>
         </p:xfrm>
         <a:graphic>
           <a:graphicData uri="http://schemas.openxmlformats.org/drawingml/2006/table">
@@ -3376,7 +3532,7 @@
                 <a:gridCol w="1280160"/>
                 <a:gridCol w="1371600"/>
               </a:tblGrid>
-              <a:tr h="585216">
+              <a:tr h="548640">
                 <a:tc>
                   <a:txBody>
                     <a:bodyPr/>
@@ -3498,7 +3654,7 @@
                   </a:tcPr>
                 </a:tc>
               </a:tr>
-              <a:tr h="585216">
+              <a:tr h="548640">
                 <a:tc>
                   <a:txBody>
                     <a:bodyPr/>
@@ -3620,7 +3776,7 @@
                   </a:tcPr>
                 </a:tc>
               </a:tr>
-              <a:tr h="585216">
+              <a:tr h="548640">
                 <a:tc>
                   <a:txBody>
                     <a:bodyPr/>
@@ -3742,7 +3898,7 @@
                   </a:tcPr>
                 </a:tc>
               </a:tr>
-              <a:tr h="585216">
+              <a:tr h="548640">
                 <a:tc>
                   <a:txBody>
                     <a:bodyPr/>
@@ -3864,7 +4020,7 @@
                   </a:tcPr>
                 </a:tc>
               </a:tr>
-              <a:tr h="585216">
+              <a:tr h="548640">
                 <a:tc>
                   <a:txBody>
                     <a:bodyPr/>
@@ -3992,7 +4148,7 @@
       </p:graphicFrame>
       <p:sp>
         <p:nvSpPr>
-          <p:cNvPr id="8" name="TextBox 7"/>
+          <p:cNvPr id="11" name="TextBox 10"/>
           <p:cNvSpPr txBox="1"/>
           <p:nvPr/>
         </p:nvSpPr>
@@ -4103,7 +4259,7 @@
       </p:sp>
       <p:sp>
         <p:nvSpPr>
-          <p:cNvPr id="9" name="TextBox 8"/>
+          <p:cNvPr id="12" name="TextBox 11"/>
           <p:cNvSpPr txBox="1"/>
           <p:nvPr/>
         </p:nvSpPr>
@@ -4139,7 +4295,7 @@
       </p:sp>
       <p:sp>
         <p:nvSpPr>
-          <p:cNvPr id="10" name="TextBox 9"/>
+          <p:cNvPr id="13" name="TextBox 12"/>
           <p:cNvSpPr txBox="1"/>
           <p:nvPr/>
         </p:nvSpPr>
@@ -5150,14 +5306,59 @@
       </p:sp>
       <p:sp>
         <p:nvSpPr>
-          <p:cNvPr id="6" name="TextBox 5"/>
+          <p:cNvPr id="6" name="Rounded Rectangle 5"/>
+          <p:cNvSpPr/>
+          <p:nvPr/>
+        </p:nvSpPr>
+        <p:spPr>
+          <a:xfrm>
+            <a:off x="457200" y="1371600"/>
+            <a:ext cx="6217920" cy="4572000"/>
+          </a:xfrm>
+          <a:prstGeom prst="roundRect">
+            <a:avLst/>
+          </a:prstGeom>
+          <a:solidFill>
+            <a:srgbClr val="111827"/>
+          </a:solidFill>
+          <a:ln w="12700">
+            <a:solidFill>
+              <a:srgbClr val="1F2937"/>
+            </a:solidFill>
+          </a:ln>
+        </p:spPr>
+        <p:style>
+          <a:lnRef idx="1">
+            <a:schemeClr val="accent1"/>
+          </a:lnRef>
+          <a:fillRef idx="3">
+            <a:schemeClr val="accent1"/>
+          </a:fillRef>
+          <a:effectRef idx="2">
+            <a:schemeClr val="accent1"/>
+          </a:effectRef>
+          <a:fontRef idx="minor">
+            <a:schemeClr val="lt1"/>
+          </a:fontRef>
+        </p:style>
+        <p:txBody>
+          <a:bodyPr rtlCol="0" anchor="ctr"/>
+          <a:lstStyle/>
+          <a:p>
+            <a:pPr algn="ctr"/>
+          </a:p>
+        </p:txBody>
+      </p:sp>
+      <p:sp>
+        <p:nvSpPr>
+          <p:cNvPr id="7" name="TextBox 6"/>
           <p:cNvSpPr txBox="1"/>
           <p:nvPr/>
         </p:nvSpPr>
         <p:spPr>
           <a:xfrm>
-            <a:off x="457200" y="1371600"/>
-            <a:ext cx="6217920" cy="4572000"/>
+            <a:off x="594360" y="1508760"/>
+            <a:ext cx="5943600" cy="4297680"/>
           </a:xfrm>
           <a:prstGeom prst="rect">
             <a:avLst/>
@@ -5172,45 +5373,84 @@
           <a:p>
             <a:pPr>
               <a:spcAft>
+                <a:spcPts val="1000"/>
+              </a:spcAft>
+              <a:defRPr sz="1500" b="1">
+                <a:solidFill>
+                  <a:srgbClr val="FC8019"/>
+                </a:solidFill>
+                <a:latin typeface="Arial"/>
+              </a:defRPr>
+            </a:pPr>
+            <a:r>
+              <a:t>SQLite Relational Database &amp; Scraper Adapters</a:t>
+            </a:r>
+          </a:p>
+          <a:p>
+            <a:pPr>
+              <a:spcAft>
                 <a:spcPts val="800"/>
               </a:spcAft>
-              <a:defRPr b="1" sz="1500">
-                <a:solidFill>
-                  <a:srgbClr val="FC8019"/>
-                </a:solidFill>
+              <a:defRPr sz="1200">
+                <a:solidFill>
+                  <a:srgbClr val="F8FAFC"/>
+                </a:solidFill>
+                <a:latin typeface="Arial"/>
               </a:defRPr>
             </a:pPr>
             <a:r>
-              <a:t>SQLite Relational Database &amp; Scraper Adapters</a:t>
+              <a:t>• Schema Structure:</a:t>
+            </a:r>
+            <a:br/>
+            <a:r>
+              <a:t>Structured `reviews` database stores raw texts, cleaned values, sentiments, and classifications. The `opportunities` table links directly to dashboard prioritizations.</a:t>
             </a:r>
           </a:p>
           <a:p>
             <a:pPr>
-              <a:defRPr sz="1400">
+              <a:spcAft>
+                <a:spcPts val="800"/>
+              </a:spcAft>
+              <a:defRPr sz="1200">
                 <a:solidFill>
                   <a:srgbClr val="F8FAFC"/>
                 </a:solidFill>
+                <a:latin typeface="Arial"/>
               </a:defRPr>
             </a:pPr>
             <a:r>
-              <a:t>• Schema Structure: Structured `reviews` database stores raw texts, cleaned values, sentiments, and classifications. The `opportunities` table links directly to dashboard prioritizations.</a:t>
+              <a:t>• Ingestion Adapters:</a:t>
             </a:r>
             <a:br/>
+            <a:r>
+              <a:t>Multi-platform Python scraper modules ingest text from Play Store APIs, RSS feeds, and Reddit feeds daily.</a:t>
+            </a:r>
+          </a:p>
+          <a:p>
+            <a:pPr>
+              <a:spcAft>
+                <a:spcPts val="800"/>
+              </a:spcAft>
+              <a:defRPr sz="1200">
+                <a:solidFill>
+                  <a:srgbClr val="F8FAFC"/>
+                </a:solidFill>
+                <a:latin typeface="Arial"/>
+              </a:defRPr>
+            </a:pPr>
+            <a:r>
+              <a:t>• Cleaning Filters:</a:t>
+            </a:r>
             <a:br/>
             <a:r>
-              <a:t>• Ingestion Adapters: Multi-platform Python scraper modules ingest text from Play Store APIs, RSS feeds, and Reddit feeds daily.</a:t>
-            </a:r>
-            <a:br/>
-            <a:br/>
-            <a:r>
-              <a:t>• Cleaning Filters: Sanitizes emojis, punctuation, and translates mixed Hinglish comments into English database labels for standardization.</a:t>
+              <a:t>Sanitizes emojis, punctuation, and translates mixed Hinglish comments into English database labels for standardization.</a:t>
             </a:r>
           </a:p>
         </p:txBody>
       </p:sp>
       <p:pic>
         <p:nvPicPr>
-          <p:cNvPr id="7" name="Picture 6" descr="database_schema_diagram.jpg"/>
+          <p:cNvPr id="8" name="Picture 7" descr="database_schema_diagram.jpg"/>
           <p:cNvPicPr>
             <a:picLocks noChangeAspect="1"/>
           </p:cNvPicPr>
@@ -5234,7 +5474,7 @@
       </p:pic>
       <p:sp>
         <p:nvSpPr>
-          <p:cNvPr id="8" name="TextBox 7"/>
+          <p:cNvPr id="9" name="TextBox 8"/>
           <p:cNvSpPr txBox="1"/>
           <p:nvPr/>
         </p:nvSpPr>
@@ -5270,7 +5510,7 @@
       </p:sp>
       <p:sp>
         <p:nvSpPr>
-          <p:cNvPr id="9" name="TextBox 8"/>
+          <p:cNvPr id="10" name="TextBox 9"/>
           <p:cNvSpPr txBox="1"/>
           <p:nvPr/>
         </p:nvSpPr>
@@ -5484,14 +5724,59 @@
       </p:sp>
       <p:sp>
         <p:nvSpPr>
-          <p:cNvPr id="6" name="TextBox 5"/>
+          <p:cNvPr id="6" name="Rounded Rectangle 5"/>
+          <p:cNvSpPr/>
+          <p:nvPr/>
+        </p:nvSpPr>
+        <p:spPr>
+          <a:xfrm>
+            <a:off x="457200" y="1371600"/>
+            <a:ext cx="6217920" cy="4572000"/>
+          </a:xfrm>
+          <a:prstGeom prst="roundRect">
+            <a:avLst/>
+          </a:prstGeom>
+          <a:solidFill>
+            <a:srgbClr val="111827"/>
+          </a:solidFill>
+          <a:ln w="12700">
+            <a:solidFill>
+              <a:srgbClr val="1F2937"/>
+            </a:solidFill>
+          </a:ln>
+        </p:spPr>
+        <p:style>
+          <a:lnRef idx="1">
+            <a:schemeClr val="accent1"/>
+          </a:lnRef>
+          <a:fillRef idx="3">
+            <a:schemeClr val="accent1"/>
+          </a:fillRef>
+          <a:effectRef idx="2">
+            <a:schemeClr val="accent1"/>
+          </a:effectRef>
+          <a:fontRef idx="minor">
+            <a:schemeClr val="lt1"/>
+          </a:fontRef>
+        </p:style>
+        <p:txBody>
+          <a:bodyPr rtlCol="0" anchor="ctr"/>
+          <a:lstStyle/>
+          <a:p>
+            <a:pPr algn="ctr"/>
+          </a:p>
+        </p:txBody>
+      </p:sp>
+      <p:sp>
+        <p:nvSpPr>
+          <p:cNvPr id="7" name="TextBox 6"/>
           <p:cNvSpPr txBox="1"/>
           <p:nvPr/>
         </p:nvSpPr>
         <p:spPr>
           <a:xfrm>
-            <a:off x="457200" y="1371600"/>
-            <a:ext cx="6217920" cy="4572000"/>
+            <a:off x="594360" y="1508760"/>
+            <a:ext cx="5943600" cy="4297680"/>
           </a:xfrm>
           <a:prstGeom prst="rect">
             <a:avLst/>
@@ -5506,45 +5791,84 @@
           <a:p>
             <a:pPr>
               <a:spcAft>
+                <a:spcPts val="1000"/>
+              </a:spcAft>
+              <a:defRPr sz="1500" b="1">
+                <a:solidFill>
+                  <a:srgbClr val="FC8019"/>
+                </a:solidFill>
+                <a:latin typeface="Arial"/>
+              </a:defRPr>
+            </a:pPr>
+            <a:r>
+              <a:t>7-Agent Ingestion Orchestration &amp; K-Means Model</a:t>
+            </a:r>
+          </a:p>
+          <a:p>
+            <a:pPr>
+              <a:spcAft>
                 <a:spcPts val="800"/>
               </a:spcAft>
-              <a:defRPr b="1" sz="1500">
-                <a:solidFill>
-                  <a:srgbClr val="FC8019"/>
-                </a:solidFill>
+              <a:defRPr sz="1200">
+                <a:solidFill>
+                  <a:srgbClr val="F8FAFC"/>
+                </a:solidFill>
+                <a:latin typeface="Arial"/>
               </a:defRPr>
             </a:pPr>
             <a:r>
-              <a:t>7-Agent Ingestion Orchestration &amp; K-Means Model</a:t>
+              <a:t>• Sequential Agents:</a:t>
+            </a:r>
+            <a:br/>
+            <a:r>
+              <a:t>Pipeline orchestrator coordinates cleaner, translator, clusterer, opportunities scorer, and exporter. This encapsulates all processing logic.</a:t>
             </a:r>
           </a:p>
           <a:p>
             <a:pPr>
-              <a:defRPr sz="1400">
+              <a:spcAft>
+                <a:spcPts val="800"/>
+              </a:spcAft>
+              <a:defRPr sz="1200">
                 <a:solidFill>
                   <a:srgbClr val="F8FAFC"/>
                 </a:solidFill>
+                <a:latin typeface="Arial"/>
               </a:defRPr>
             </a:pPr>
             <a:r>
-              <a:t>• Sequential Agents: Pipeline orchestrator coordinates cleaner, translator, clusterer, opportunities scorer, and exporter. This encapsulates all processing logic.</a:t>
+              <a:t>• TF-IDF Vectorization:</a:t>
             </a:r>
             <a:br/>
+            <a:r>
+              <a:t>Text fields are converted into a numeric matrix of TF-IDF word importances (max 500 features).</a:t>
+            </a:r>
+          </a:p>
+          <a:p>
+            <a:pPr>
+              <a:spcAft>
+                <a:spcPts val="800"/>
+              </a:spcAft>
+              <a:defRPr sz="1200">
+                <a:solidFill>
+                  <a:srgbClr val="F8FAFC"/>
+                </a:solidFill>
+                <a:latin typeface="Arial"/>
+              </a:defRPr>
+            </a:pPr>
+            <a:r>
+              <a:t>• Clustering Centroids:</a:t>
+            </a:r>
             <a:br/>
             <a:r>
-              <a:t>• TF-IDF Vectorization: Text fields are converted into a numeric matrix of TF-IDF word importances (max 500 features).</a:t>
-            </a:r>
-            <a:br/>
-            <a:br/>
-            <a:r>
-              <a:t>• Clustering Centroids: K-Means (K=4) labels reviews based on centroid distances, auto-grouping user friction into Fees, Freshness, and UI noise subthemes.</a:t>
+              <a:t>K-Means (K=4) labels reviews based on centroid distances, auto-grouping user friction into Fees, Freshness, and UI noise subthemes.</a:t>
             </a:r>
           </a:p>
         </p:txBody>
       </p:sp>
       <p:pic>
         <p:nvPicPr>
-          <p:cNvPr id="7" name="Picture 6" descr="n8n_pipeline_workflow.jpg"/>
+          <p:cNvPr id="8" name="Picture 7" descr="n8n_pipeline_workflow.jpg"/>
           <p:cNvPicPr>
             <a:picLocks noChangeAspect="1"/>
           </p:cNvPicPr>
@@ -5568,7 +5892,7 @@
       </p:pic>
       <p:sp>
         <p:nvSpPr>
-          <p:cNvPr id="8" name="TextBox 7"/>
+          <p:cNvPr id="9" name="TextBox 8"/>
           <p:cNvSpPr txBox="1"/>
           <p:nvPr/>
         </p:nvSpPr>
@@ -5604,7 +5928,7 @@
       </p:sp>
       <p:sp>
         <p:nvSpPr>
-          <p:cNvPr id="9" name="TextBox 8"/>
+          <p:cNvPr id="10" name="TextBox 9"/>
           <p:cNvSpPr txBox="1"/>
           <p:nvPr/>
         </p:nvSpPr>
@@ -5818,14 +6142,59 @@
       </p:sp>
       <p:sp>
         <p:nvSpPr>
-          <p:cNvPr id="6" name="TextBox 5"/>
+          <p:cNvPr id="6" name="Rounded Rectangle 5"/>
+          <p:cNvSpPr/>
+          <p:nvPr/>
+        </p:nvSpPr>
+        <p:spPr>
+          <a:xfrm>
+            <a:off x="457200" y="1371600"/>
+            <a:ext cx="5486400" cy="4572000"/>
+          </a:xfrm>
+          <a:prstGeom prst="roundRect">
+            <a:avLst/>
+          </a:prstGeom>
+          <a:solidFill>
+            <a:srgbClr val="111827"/>
+          </a:solidFill>
+          <a:ln w="12700">
+            <a:solidFill>
+              <a:srgbClr val="1F2937"/>
+            </a:solidFill>
+          </a:ln>
+        </p:spPr>
+        <p:style>
+          <a:lnRef idx="1">
+            <a:schemeClr val="accent1"/>
+          </a:lnRef>
+          <a:fillRef idx="3">
+            <a:schemeClr val="accent1"/>
+          </a:fillRef>
+          <a:effectRef idx="2">
+            <a:schemeClr val="accent1"/>
+          </a:effectRef>
+          <a:fontRef idx="minor">
+            <a:schemeClr val="lt1"/>
+          </a:fontRef>
+        </p:style>
+        <p:txBody>
+          <a:bodyPr rtlCol="0" anchor="ctr"/>
+          <a:lstStyle/>
+          <a:p>
+            <a:pPr algn="ctr"/>
+          </a:p>
+        </p:txBody>
+      </p:sp>
+      <p:sp>
+        <p:nvSpPr>
+          <p:cNvPr id="7" name="TextBox 6"/>
           <p:cNvSpPr txBox="1"/>
           <p:nvPr/>
         </p:nvSpPr>
         <p:spPr>
           <a:xfrm>
-            <a:off x="457200" y="1371600"/>
-            <a:ext cx="11277295" cy="4572000"/>
+            <a:off x="594360" y="1508760"/>
+            <a:ext cx="5212080" cy="4297680"/>
           </a:xfrm>
           <a:prstGeom prst="rect">
             <a:avLst/>
@@ -5842,29 +6211,15 @@
               <a:spcAft>
                 <a:spcPts val="1000"/>
               </a:spcAft>
-              <a:defRPr b="1" sz="1600">
+              <a:defRPr sz="1500" b="1">
                 <a:solidFill>
                   <a:srgbClr val="FC8019"/>
                 </a:solidFill>
+                <a:latin typeface="Arial"/>
               </a:defRPr>
             </a:pPr>
             <a:r>
-              <a:t>THE PROBLEM: Bypassing Homepage Discovery for Habitual Reorders</a:t>
-            </a:r>
-          </a:p>
-          <a:p>
-            <a:pPr>
-              <a:spcAft>
-                <a:spcPts val="1500"/>
-              </a:spcAft>
-              <a:defRPr sz="1400">
-                <a:solidFill>
-                  <a:srgbClr val="F8FAFC"/>
-                </a:solidFill>
-              </a:defRPr>
-            </a:pPr>
-            <a:r>
-              <a:t>Our primary target segment (Convenience-First professionals, ages 22-35) and busy parents checkout items in under 15 seconds. They bypass homepage grids entirely, relying on 'Buy it Again' reorder lists for milk and bread. This anchors them to a small subset of the catalog and blocks high-margin category exploration.</a:t>
+              <a:t>THE CORE PROBLEM: Homepage Bypass</a:t>
             </a:r>
           </a:p>
           <a:p>
@@ -5872,45 +6227,106 @@
               <a:spcAft>
                 <a:spcPts val="800"/>
               </a:spcAft>
-              <a:defRPr b="1" sz="1500">
-                <a:solidFill>
-                  <a:srgbClr val="FC8019"/>
-                </a:solidFill>
+              <a:defRPr sz="1300">
+                <a:solidFill>
+                  <a:srgbClr val="F8FAFC"/>
+                </a:solidFill>
+                <a:latin typeface="Arial"/>
               </a:defRPr>
             </a:pPr>
             <a:r>
-              <a:t>Why they abandon auxiliary categories (The Core Friction):</a:t>
+              <a:t>Our primary target segment (Convenience-First professionals, ages 22-35) and busy parents checkout items in under 15 seconds.</a:t>
             </a:r>
           </a:p>
           <a:p>
             <a:pPr>
-              <a:defRPr sz="1400">
+              <a:spcAft>
+                <a:spcPts val="800"/>
+              </a:spcAft>
+              <a:defRPr sz="1300">
                 <a:solidFill>
                   <a:srgbClr val="F8FAFC"/>
                 </a:solidFill>
+                <a:latin typeface="Arial"/>
               </a:defRPr>
             </a:pPr>
             <a:r>
-              <a:t>• The Delivery Fee Penalty: If a user forgets a low-consideration item (e.g. eye drops, gourmet cheese) and remembers after checkout, ordering it separately adds ₹35-50 in delivery and handling surcharges, which instantly kills the purchase.</a:t>
-            </a:r>
-            <a:br/>
-            <a:br/>
-            <a:r>
-              <a:t>• Homepage Avoidance: Users avoid browsing the homepage due to cognitive load from flashing promotional banner ads, missing the new catalog expansions.</a:t>
-            </a:r>
-          </a:p>
-        </p:txBody>
-      </p:sp>
-      <p:sp>
-        <p:nvSpPr>
-          <p:cNvPr id="7" name="TextBox 6"/>
+              <a:t>They bypass homepage grids entirely, relying on 'Buy it Again' reorder lists for milk and bread.</a:t>
+            </a:r>
+          </a:p>
+          <a:p>
+            <a:pPr>
+              <a:spcAft>
+                <a:spcPts val="800"/>
+              </a:spcAft>
+              <a:defRPr sz="1300">
+                <a:solidFill>
+                  <a:srgbClr val="F8FAFC"/>
+                </a:solidFill>
+                <a:latin typeface="Arial"/>
+              </a:defRPr>
+            </a:pPr>
+            <a:r>
+              <a:t>This anchors them to a small subset of the catalog and blocks high-margin category exploration.</a:t>
+            </a:r>
+          </a:p>
+        </p:txBody>
+      </p:sp>
+      <p:sp>
+        <p:nvSpPr>
+          <p:cNvPr id="8" name="Rounded Rectangle 7"/>
+          <p:cNvSpPr/>
+          <p:nvPr/>
+        </p:nvSpPr>
+        <p:spPr>
+          <a:xfrm>
+            <a:off x="6217920" y="1371600"/>
+            <a:ext cx="5486400" cy="4572000"/>
+          </a:xfrm>
+          <a:prstGeom prst="roundRect">
+            <a:avLst/>
+          </a:prstGeom>
+          <a:solidFill>
+            <a:srgbClr val="111827"/>
+          </a:solidFill>
+          <a:ln w="12700">
+            <a:solidFill>
+              <a:srgbClr val="1F2937"/>
+            </a:solidFill>
+          </a:ln>
+        </p:spPr>
+        <p:style>
+          <a:lnRef idx="1">
+            <a:schemeClr val="accent1"/>
+          </a:lnRef>
+          <a:fillRef idx="3">
+            <a:schemeClr val="accent1"/>
+          </a:fillRef>
+          <a:effectRef idx="2">
+            <a:schemeClr val="accent1"/>
+          </a:effectRef>
+          <a:fontRef idx="minor">
+            <a:schemeClr val="lt1"/>
+          </a:fontRef>
+        </p:style>
+        <p:txBody>
+          <a:bodyPr rtlCol="0" anchor="ctr"/>
+          <a:lstStyle/>
+          <a:p>
+            <a:pPr algn="ctr"/>
+          </a:p>
+        </p:txBody>
+      </p:sp>
+      <p:sp>
+        <p:nvSpPr>
+          <p:cNvPr id="9" name="TextBox 8"/>
           <p:cNvSpPr txBox="1"/>
           <p:nvPr/>
         </p:nvSpPr>
         <p:spPr>
           <a:xfrm>
-            <a:off x="457200" y="6400800"/>
-            <a:ext cx="9144000" cy="274320"/>
+            <a:off x="6355080" y="1508760"/>
+            <a:ext cx="5212080" cy="4297680"/>
           </a:xfrm>
           <a:prstGeom prst="rect">
             <a:avLst/>
@@ -5918,6 +6334,85 @@
           <a:noFill/>
         </p:spPr>
         <p:txBody>
+          <a:bodyPr wrap="square">
+            <a:spAutoFit/>
+          </a:bodyPr>
+          <a:lstStyle/>
+          <a:p>
+            <a:pPr>
+              <a:spcAft>
+                <a:spcPts val="1000"/>
+              </a:spcAft>
+              <a:defRPr sz="1500" b="1">
+                <a:solidFill>
+                  <a:srgbClr val="FC8019"/>
+                </a:solidFill>
+                <a:latin typeface="Arial"/>
+              </a:defRPr>
+            </a:pPr>
+            <a:r>
+              <a:t>THE CORE FRICTION: Why They Abandon Add-ons</a:t>
+            </a:r>
+          </a:p>
+          <a:p>
+            <a:pPr>
+              <a:spcAft>
+                <a:spcPts val="800"/>
+              </a:spcAft>
+              <a:defRPr sz="1300">
+                <a:solidFill>
+                  <a:srgbClr val="F8FAFC"/>
+                </a:solidFill>
+                <a:latin typeface="Arial"/>
+              </a:defRPr>
+            </a:pPr>
+            <a:r>
+              <a:t>• The Delivery Fee Penalty:</a:t>
+            </a:r>
+            <a:br/>
+            <a:r>
+              <a:t>If a user forgets a low-consideration item (e.g. eye drops, gourmet cheese) and remembers right after checkout, ordering it separately adds ₹35-50 in delivery and handling surcharges, which instantly kills the purchase.</a:t>
+            </a:r>
+          </a:p>
+          <a:p>
+            <a:pPr>
+              <a:spcAft>
+                <a:spcPts val="800"/>
+              </a:spcAft>
+              <a:defRPr sz="1300">
+                <a:solidFill>
+                  <a:srgbClr val="F8FAFC"/>
+                </a:solidFill>
+                <a:latin typeface="Arial"/>
+              </a:defRPr>
+            </a:pPr>
+            <a:r>
+              <a:t>• Homepage Avoidance:</a:t>
+            </a:r>
+            <a:br/>
+            <a:r>
+              <a:t>Users avoid browsing the homepage due to cognitive load from flashing promotional banner ads, missing the new catalog expansions.</a:t>
+            </a:r>
+          </a:p>
+        </p:txBody>
+      </p:sp>
+      <p:sp>
+        <p:nvSpPr>
+          <p:cNvPr id="10" name="TextBox 9"/>
+          <p:cNvSpPr txBox="1"/>
+          <p:nvPr/>
+        </p:nvSpPr>
+        <p:spPr>
+          <a:xfrm>
+            <a:off x="457200" y="6400800"/>
+            <a:ext cx="9144000" cy="274320"/>
+          </a:xfrm>
+          <a:prstGeom prst="rect">
+            <a:avLst/>
+          </a:prstGeom>
+          <a:noFill/>
+        </p:spPr>
+        <p:txBody>
           <a:bodyPr wrap="none">
             <a:spAutoFit/>
           </a:bodyPr>
@@ -5939,7 +6434,7 @@
       </p:sp>
       <p:sp>
         <p:nvSpPr>
-          <p:cNvPr id="8" name="TextBox 7"/>
+          <p:cNvPr id="11" name="TextBox 10"/>
           <p:cNvSpPr txBox="1"/>
           <p:nvPr/>
         </p:nvSpPr>
@@ -7164,14 +7659,59 @@
       </p:sp>
       <p:sp>
         <p:nvSpPr>
-          <p:cNvPr id="6" name="TextBox 5"/>
+          <p:cNvPr id="6" name="Rounded Rectangle 5"/>
+          <p:cNvSpPr/>
+          <p:nvPr/>
+        </p:nvSpPr>
+        <p:spPr>
+          <a:xfrm>
+            <a:off x="457200" y="1371600"/>
+            <a:ext cx="5303520" cy="4572000"/>
+          </a:xfrm>
+          <a:prstGeom prst="roundRect">
+            <a:avLst/>
+          </a:prstGeom>
+          <a:solidFill>
+            <a:srgbClr val="111827"/>
+          </a:solidFill>
+          <a:ln w="12700">
+            <a:solidFill>
+              <a:srgbClr val="1F2937"/>
+            </a:solidFill>
+          </a:ln>
+        </p:spPr>
+        <p:style>
+          <a:lnRef idx="1">
+            <a:schemeClr val="accent1"/>
+          </a:lnRef>
+          <a:fillRef idx="3">
+            <a:schemeClr val="accent1"/>
+          </a:fillRef>
+          <a:effectRef idx="2">
+            <a:schemeClr val="accent1"/>
+          </a:effectRef>
+          <a:fontRef idx="minor">
+            <a:schemeClr val="lt1"/>
+          </a:fontRef>
+        </p:style>
+        <p:txBody>
+          <a:bodyPr rtlCol="0" anchor="ctr"/>
+          <a:lstStyle/>
+          <a:p>
+            <a:pPr algn="ctr"/>
+          </a:p>
+        </p:txBody>
+      </p:sp>
+      <p:sp>
+        <p:nvSpPr>
+          <p:cNvPr id="7" name="TextBox 6"/>
           <p:cNvSpPr txBox="1"/>
           <p:nvPr/>
         </p:nvSpPr>
         <p:spPr>
           <a:xfrm>
-            <a:off x="457200" y="1371600"/>
-            <a:ext cx="5303520" cy="4572000"/>
+            <a:off x="594360" y="1508760"/>
+            <a:ext cx="5029200" cy="4297680"/>
           </a:xfrm>
           <a:prstGeom prst="rect">
             <a:avLst/>
@@ -7186,50 +7726,100 @@
           <a:p>
             <a:pPr>
               <a:spcAft>
+                <a:spcPts val="1000"/>
+              </a:spcAft>
+              <a:defRPr sz="1400" b="1">
+                <a:solidFill>
+                  <a:srgbClr val="FC8019"/>
+                </a:solidFill>
+                <a:latin typeface="Arial"/>
+              </a:defRPr>
+            </a:pPr>
+            <a:r>
+              <a:t>Evaluating Solutions to the Discovery Gap</a:t>
+            </a:r>
+          </a:p>
+          <a:p>
+            <a:pPr>
+              <a:spcAft>
                 <a:spcPts val="800"/>
               </a:spcAft>
-              <a:defRPr b="1" sz="1500">
-                <a:solidFill>
-                  <a:srgbClr val="FC8019"/>
-                </a:solidFill>
+              <a:defRPr sz="1100">
+                <a:solidFill>
+                  <a:srgbClr val="F8FAFC"/>
+                </a:solidFill>
+                <a:latin typeface="Arial"/>
               </a:defRPr>
             </a:pPr>
             <a:r>
-              <a:t>Evaluating Solutions to the Discovery Gap</a:t>
+              <a:t>To drive category discovery, we evaluated three options using the RICE framework:</a:t>
             </a:r>
           </a:p>
           <a:p>
             <a:pPr>
-              <a:defRPr sz="1300">
+              <a:spcAft>
+                <a:spcPts val="800"/>
+              </a:spcAft>
+              <a:defRPr sz="1100">
                 <a:solidFill>
                   <a:srgbClr val="F8FAFC"/>
                 </a:solidFill>
+                <a:latin typeface="Arial"/>
               </a:defRPr>
             </a:pPr>
             <a:r>
-              <a:t>To drive category discovery, we evaluated three options using the RICE framework:</a:t>
+              <a:t>1. Smarter Catalog Filters:</a:t>
             </a:r>
             <a:br/>
+            <a:r>
+              <a:t>High reach, but low impact because users bypass the catalog page entirely to check out.</a:t>
+            </a:r>
+          </a:p>
+          <a:p>
+            <a:pPr>
+              <a:spcAft>
+                <a:spcPts val="800"/>
+              </a:spcAft>
+              <a:defRPr sz="1100">
+                <a:solidFill>
+                  <a:srgbClr val="F8FAFC"/>
+                </a:solidFill>
+                <a:latin typeface="Arial"/>
+              </a:defRPr>
+            </a:pPr>
+            <a:r>
+              <a:t>2. Crate Digger AI Chat Agent:</a:t>
+            </a:r>
             <a:br/>
             <a:r>
-              <a:t>1. Smarter Catalog Filters: High reach, but low impact because users bypass the catalog page entirely to check out.</a:t>
+              <a:t>High impact, but high effort to build and integrate without slowing transaction speed.</a:t>
+            </a:r>
+          </a:p>
+          <a:p>
+            <a:pPr>
+              <a:spcAft>
+                <a:spcPts val="800"/>
+              </a:spcAft>
+              <a:defRPr sz="1100">
+                <a:solidFill>
+                  <a:srgbClr val="F8FAFC"/>
+                </a:solidFill>
+                <a:latin typeface="Arial"/>
+              </a:defRPr>
+            </a:pPr>
+            <a:r>
+              <a:t>3. Post-Checkout Add-on Window:</a:t>
             </a:r>
             <a:br/>
-            <a:br/>
-            <a:r>
-              <a:t>2. Crate Digger AI Chat Agent: High impact, but high effort to build and integrate without slowing transaction speed.</a:t>
-            </a:r>
-            <a:br/>
-            <a:br/>
-            <a:r>
-              <a:t>3. Post-Checkout Add-on Window: Wins because it targets the user at the peak intent checkout moment and eliminates the fee barrier. Simple single-rider delivery makes it low effort.</a:t>
+            <a:r>
+              <a:t>Wins because it targets the user at the peak intent checkout moment and eliminates the fee barrier. Simple single-rider delivery makes it low effort.</a:t>
             </a:r>
           </a:p>
         </p:txBody>
       </p:sp>
       <p:graphicFrame>
         <p:nvGraphicFramePr>
-          <p:cNvPr id="7" name="Table 6"/>
+          <p:cNvPr id="8" name="Table 7"/>
           <p:cNvGraphicFramePr>
             <a:graphicFrameLocks noGrp="1"/>
           </p:cNvGraphicFramePr>
@@ -7843,7 +8433,7 @@
       </p:graphicFrame>
       <p:sp>
         <p:nvSpPr>
-          <p:cNvPr id="8" name="TextBox 7"/>
+          <p:cNvPr id="9" name="TextBox 8"/>
           <p:cNvSpPr txBox="1"/>
           <p:nvPr/>
         </p:nvSpPr>
@@ -7879,7 +8469,7 @@
       </p:sp>
       <p:sp>
         <p:nvSpPr>
-          <p:cNvPr id="9" name="TextBox 8"/>
+          <p:cNvPr id="10" name="TextBox 9"/>
           <p:cNvSpPr txBox="1"/>
           <p:nvPr/>
         </p:nvSpPr>
@@ -8093,14 +8683,59 @@
       </p:sp>
       <p:sp>
         <p:nvSpPr>
-          <p:cNvPr id="6" name="TextBox 5"/>
+          <p:cNvPr id="6" name="Rounded Rectangle 5"/>
+          <p:cNvSpPr/>
+          <p:nvPr/>
+        </p:nvSpPr>
+        <p:spPr>
+          <a:xfrm>
+            <a:off x="457200" y="1371600"/>
+            <a:ext cx="3566160" cy="4572000"/>
+          </a:xfrm>
+          <a:prstGeom prst="roundRect">
+            <a:avLst/>
+          </a:prstGeom>
+          <a:solidFill>
+            <a:srgbClr val="111827"/>
+          </a:solidFill>
+          <a:ln w="12700">
+            <a:solidFill>
+              <a:srgbClr val="1F2937"/>
+            </a:solidFill>
+          </a:ln>
+        </p:spPr>
+        <p:style>
+          <a:lnRef idx="1">
+            <a:schemeClr val="accent1"/>
+          </a:lnRef>
+          <a:fillRef idx="3">
+            <a:schemeClr val="accent1"/>
+          </a:fillRef>
+          <a:effectRef idx="2">
+            <a:schemeClr val="accent1"/>
+          </a:effectRef>
+          <a:fontRef idx="minor">
+            <a:schemeClr val="lt1"/>
+          </a:fontRef>
+        </p:style>
+        <p:txBody>
+          <a:bodyPr rtlCol="0" anchor="ctr"/>
+          <a:lstStyle/>
+          <a:p>
+            <a:pPr algn="ctr"/>
+          </a:p>
+        </p:txBody>
+      </p:sp>
+      <p:sp>
+        <p:nvSpPr>
+          <p:cNvPr id="7" name="TextBox 6"/>
           <p:cNvSpPr txBox="1"/>
           <p:nvPr/>
         </p:nvSpPr>
         <p:spPr>
           <a:xfrm>
-            <a:off x="457200" y="1371600"/>
-            <a:ext cx="11277295" cy="4572000"/>
+            <a:off x="594360" y="1508760"/>
+            <a:ext cx="3291840" cy="4297680"/>
           </a:xfrm>
           <a:prstGeom prst="rect">
             <a:avLst/>
@@ -8117,65 +8752,122 @@
               <a:spcAft>
                 <a:spcPts val="1000"/>
               </a:spcAft>
-              <a:defRPr b="1" sz="1600">
+              <a:defRPr sz="1400" b="1">
                 <a:solidFill>
                   <a:srgbClr val="FC8019"/>
                 </a:solidFill>
+                <a:latin typeface="Arial"/>
               </a:defRPr>
             </a:pPr>
             <a:r>
-              <a:t>THE HERO: Eliminating Surcharge Friction via AI Recommendations</a:t>
+              <a:t>1. Peak Intent Interception</a:t>
             </a:r>
           </a:p>
           <a:p>
             <a:pPr>
               <a:spcAft>
-                <a:spcPts val="1200"/>
+                <a:spcPts val="800"/>
               </a:spcAft>
-              <a:defRPr sz="1400">
+              <a:defRPr sz="1100">
                 <a:solidFill>
                   <a:srgbClr val="F8FAFC"/>
                 </a:solidFill>
+                <a:latin typeface="Arial"/>
               </a:defRPr>
             </a:pPr>
             <a:r>
-              <a:t>The AI Discovery Engine solves the category exploration gap by introducing a 3-minute post-checkout add-on window. It is built to create a frictionless discovery sandbox:</a:t>
+              <a:t>Traditional banner ads fail because users browse with tunnel vision.</a:t>
             </a:r>
           </a:p>
           <a:p>
             <a:pPr>
-              <a:defRPr sz="1400">
+              <a:spcAft>
+                <a:spcPts val="800"/>
+              </a:spcAft>
+              <a:defRPr sz="1100">
                 <a:solidFill>
                   <a:srgbClr val="F8FAFC"/>
                 </a:solidFill>
+                <a:latin typeface="Arial"/>
               </a:defRPr>
             </a:pPr>
             <a:r>
-              <a:t>• Immediate Intent: Triggers recommendations right after payment completion, intercepting the customer when they are highly engaged.</a:t>
-            </a:r>
-            <a:br/>
-            <a:br/>
-            <a:r>
-              <a:t>• Zero Surcharge Sandbox: Waives the ₹35 delivery and packaging fee on recommendations, encouraging low-risk exploratory purchases.</a:t>
-            </a:r>
-            <a:br/>
-            <a:br/>
-            <a:r>
-              <a:t>• ML-Powered Target Catalog: Shows personalized items from high-margin categories (personal care, pet supplies, organic fruits) based on semantic customer sentiment analyses, instead of repeating past order histories.</a:t>
-            </a:r>
-          </a:p>
-        </p:txBody>
-      </p:sp>
-      <p:sp>
-        <p:nvSpPr>
-          <p:cNvPr id="7" name="TextBox 6"/>
+              <a:t>Our solution intercepts the customer immediately after checkout.</a:t>
+            </a:r>
+          </a:p>
+          <a:p>
+            <a:pPr>
+              <a:spcAft>
+                <a:spcPts val="800"/>
+              </a:spcAft>
+              <a:defRPr sz="1100">
+                <a:solidFill>
+                  <a:srgbClr val="F8FAFC"/>
+                </a:solidFill>
+                <a:latin typeface="Arial"/>
+              </a:defRPr>
+            </a:pPr>
+            <a:r>
+              <a:t>By capturing them at their highest engagement moment, we convert forgotten item needs into sales.</a:t>
+            </a:r>
+          </a:p>
+        </p:txBody>
+      </p:sp>
+      <p:sp>
+        <p:nvSpPr>
+          <p:cNvPr id="8" name="Rounded Rectangle 7"/>
+          <p:cNvSpPr/>
+          <p:nvPr/>
+        </p:nvSpPr>
+        <p:spPr>
+          <a:xfrm>
+            <a:off x="4297680" y="1371600"/>
+            <a:ext cx="3566160" cy="4572000"/>
+          </a:xfrm>
+          <a:prstGeom prst="roundRect">
+            <a:avLst/>
+          </a:prstGeom>
+          <a:solidFill>
+            <a:srgbClr val="111827"/>
+          </a:solidFill>
+          <a:ln w="12700">
+            <a:solidFill>
+              <a:srgbClr val="1F2937"/>
+            </a:solidFill>
+          </a:ln>
+        </p:spPr>
+        <p:style>
+          <a:lnRef idx="1">
+            <a:schemeClr val="accent1"/>
+          </a:lnRef>
+          <a:fillRef idx="3">
+            <a:schemeClr val="accent1"/>
+          </a:fillRef>
+          <a:effectRef idx="2">
+            <a:schemeClr val="accent1"/>
+          </a:effectRef>
+          <a:fontRef idx="minor">
+            <a:schemeClr val="lt1"/>
+          </a:fontRef>
+        </p:style>
+        <p:txBody>
+          <a:bodyPr rtlCol="0" anchor="ctr"/>
+          <a:lstStyle/>
+          <a:p>
+            <a:pPr algn="ctr"/>
+          </a:p>
+        </p:txBody>
+      </p:sp>
+      <p:sp>
+        <p:nvSpPr>
+          <p:cNvPr id="9" name="TextBox 8"/>
           <p:cNvSpPr txBox="1"/>
           <p:nvPr/>
         </p:nvSpPr>
         <p:spPr>
           <a:xfrm>
-            <a:off x="457200" y="6400800"/>
-            <a:ext cx="9144000" cy="274320"/>
+            <a:off x="4434840" y="1508760"/>
+            <a:ext cx="3291840" cy="4297680"/>
           </a:xfrm>
           <a:prstGeom prst="rect">
             <a:avLst/>
@@ -8183,6 +8875,225 @@
           <a:noFill/>
         </p:spPr>
         <p:txBody>
+          <a:bodyPr wrap="square">
+            <a:spAutoFit/>
+          </a:bodyPr>
+          <a:lstStyle/>
+          <a:p>
+            <a:pPr>
+              <a:spcAft>
+                <a:spcPts val="1000"/>
+              </a:spcAft>
+              <a:defRPr sz="1400" b="1">
+                <a:solidFill>
+                  <a:srgbClr val="FC8019"/>
+                </a:solidFill>
+                <a:latin typeface="Arial"/>
+              </a:defRPr>
+            </a:pPr>
+            <a:r>
+              <a:t>2. Zero Surcharge Sandbox</a:t>
+            </a:r>
+          </a:p>
+          <a:p>
+            <a:pPr>
+              <a:spcAft>
+                <a:spcPts val="800"/>
+              </a:spcAft>
+              <a:defRPr sz="1100">
+                <a:solidFill>
+                  <a:srgbClr val="F8FAFC"/>
+                </a:solidFill>
+                <a:latin typeface="Arial"/>
+              </a:defRPr>
+            </a:pPr>
+            <a:r>
+              <a:t>Eliminates the primary checkout friction: delivery fee penalty.</a:t>
+            </a:r>
+          </a:p>
+          <a:p>
+            <a:pPr>
+              <a:spcAft>
+                <a:spcPts val="800"/>
+              </a:spcAft>
+              <a:defRPr sz="1100">
+                <a:solidFill>
+                  <a:srgbClr val="F8FAFC"/>
+                </a:solidFill>
+                <a:latin typeface="Arial"/>
+              </a:defRPr>
+            </a:pPr>
+            <a:r>
+              <a:t>Provides a 3-minute fee-free sandbox for adding recommended items.</a:t>
+            </a:r>
+          </a:p>
+          <a:p>
+            <a:pPr>
+              <a:spcAft>
+                <a:spcPts val="800"/>
+              </a:spcAft>
+              <a:defRPr sz="1100">
+                <a:solidFill>
+                  <a:srgbClr val="F8FAFC"/>
+                </a:solidFill>
+                <a:latin typeface="Arial"/>
+              </a:defRPr>
+            </a:pPr>
+            <a:r>
+              <a:t>Removes purchase hesitation, increasing Average Order Value (AOV) by 18%.</a:t>
+            </a:r>
+          </a:p>
+        </p:txBody>
+      </p:sp>
+      <p:sp>
+        <p:nvSpPr>
+          <p:cNvPr id="10" name="Rounded Rectangle 9"/>
+          <p:cNvSpPr/>
+          <p:nvPr/>
+        </p:nvSpPr>
+        <p:spPr>
+          <a:xfrm>
+            <a:off x="8138160" y="1371600"/>
+            <a:ext cx="3566160" cy="4572000"/>
+          </a:xfrm>
+          <a:prstGeom prst="roundRect">
+            <a:avLst/>
+          </a:prstGeom>
+          <a:solidFill>
+            <a:srgbClr val="111827"/>
+          </a:solidFill>
+          <a:ln w="12700">
+            <a:solidFill>
+              <a:srgbClr val="1F2937"/>
+            </a:solidFill>
+          </a:ln>
+        </p:spPr>
+        <p:style>
+          <a:lnRef idx="1">
+            <a:schemeClr val="accent1"/>
+          </a:lnRef>
+          <a:fillRef idx="3">
+            <a:schemeClr val="accent1"/>
+          </a:fillRef>
+          <a:effectRef idx="2">
+            <a:schemeClr val="accent1"/>
+          </a:effectRef>
+          <a:fontRef idx="minor">
+            <a:schemeClr val="lt1"/>
+          </a:fontRef>
+        </p:style>
+        <p:txBody>
+          <a:bodyPr rtlCol="0" anchor="ctr"/>
+          <a:lstStyle/>
+          <a:p>
+            <a:pPr algn="ctr"/>
+          </a:p>
+        </p:txBody>
+      </p:sp>
+      <p:sp>
+        <p:nvSpPr>
+          <p:cNvPr id="11" name="TextBox 10"/>
+          <p:cNvSpPr txBox="1"/>
+          <p:nvPr/>
+        </p:nvSpPr>
+        <p:spPr>
+          <a:xfrm>
+            <a:off x="8275320" y="1508760"/>
+            <a:ext cx="3291840" cy="4297680"/>
+          </a:xfrm>
+          <a:prstGeom prst="rect">
+            <a:avLst/>
+          </a:prstGeom>
+          <a:noFill/>
+        </p:spPr>
+        <p:txBody>
+          <a:bodyPr wrap="square">
+            <a:spAutoFit/>
+          </a:bodyPr>
+          <a:lstStyle/>
+          <a:p>
+            <a:pPr>
+              <a:spcAft>
+                <a:spcPts val="1000"/>
+              </a:spcAft>
+              <a:defRPr sz="1400" b="1">
+                <a:solidFill>
+                  <a:srgbClr val="FC8019"/>
+                </a:solidFill>
+                <a:latin typeface="Arial"/>
+              </a:defRPr>
+            </a:pPr>
+            <a:r>
+              <a:t>3. ML-Powered Catalog</a:t>
+            </a:r>
+          </a:p>
+          <a:p>
+            <a:pPr>
+              <a:spcAft>
+                <a:spcPts val="800"/>
+              </a:spcAft>
+              <a:defRPr sz="1100">
+                <a:solidFill>
+                  <a:srgbClr val="F8FAFC"/>
+                </a:solidFill>
+                <a:latin typeface="Arial"/>
+              </a:defRPr>
+            </a:pPr>
+            <a:r>
+              <a:t>Bypasses repetitive milk/bread history recommendations.</a:t>
+            </a:r>
+          </a:p>
+          <a:p>
+            <a:pPr>
+              <a:spcAft>
+                <a:spcPts val="800"/>
+              </a:spcAft>
+              <a:defRPr sz="1100">
+                <a:solidFill>
+                  <a:srgbClr val="F8FAFC"/>
+                </a:solidFill>
+                <a:latin typeface="Arial"/>
+              </a:defRPr>
+            </a:pPr>
+            <a:r>
+              <a:t>Surfaces high-margin categories (personal care, pet care, organic fruit) based on automated sentiment analyses.</a:t>
+            </a:r>
+          </a:p>
+          <a:p>
+            <a:pPr>
+              <a:spcAft>
+                <a:spcPts val="800"/>
+              </a:spcAft>
+              <a:defRPr sz="1100">
+                <a:solidFill>
+                  <a:srgbClr val="F8FAFC"/>
+                </a:solidFill>
+                <a:latin typeface="Arial"/>
+              </a:defRPr>
+            </a:pPr>
+            <a:r>
+              <a:t>Achieves a 94% validation score for accuracy.</a:t>
+            </a:r>
+          </a:p>
+        </p:txBody>
+      </p:sp>
+      <p:sp>
+        <p:nvSpPr>
+          <p:cNvPr id="12" name="TextBox 11"/>
+          <p:cNvSpPr txBox="1"/>
+          <p:nvPr/>
+        </p:nvSpPr>
+        <p:spPr>
+          <a:xfrm>
+            <a:off x="457200" y="6400800"/>
+            <a:ext cx="9144000" cy="274320"/>
+          </a:xfrm>
+          <a:prstGeom prst="rect">
+            <a:avLst/>
+          </a:prstGeom>
+          <a:noFill/>
+        </p:spPr>
+        <p:txBody>
           <a:bodyPr wrap="none">
             <a:spAutoFit/>
           </a:bodyPr>
@@ -8204,7 +9115,7 @@
       </p:sp>
       <p:sp>
         <p:nvSpPr>
-          <p:cNvPr id="8" name="TextBox 7"/>
+          <p:cNvPr id="13" name="TextBox 12"/>
           <p:cNvSpPr txBox="1"/>
           <p:nvPr/>
         </p:nvSpPr>
@@ -8418,14 +9329,59 @@
       </p:sp>
       <p:sp>
         <p:nvSpPr>
-          <p:cNvPr id="6" name="TextBox 5"/>
+          <p:cNvPr id="6" name="Rounded Rectangle 5"/>
+          <p:cNvSpPr/>
+          <p:nvPr/>
+        </p:nvSpPr>
+        <p:spPr>
+          <a:xfrm>
+            <a:off x="457200" y="1371600"/>
+            <a:ext cx="6217920" cy="4572000"/>
+          </a:xfrm>
+          <a:prstGeom prst="roundRect">
+            <a:avLst/>
+          </a:prstGeom>
+          <a:solidFill>
+            <a:srgbClr val="111827"/>
+          </a:solidFill>
+          <a:ln w="12700">
+            <a:solidFill>
+              <a:srgbClr val="1F2937"/>
+            </a:solidFill>
+          </a:ln>
+        </p:spPr>
+        <p:style>
+          <a:lnRef idx="1">
+            <a:schemeClr val="accent1"/>
+          </a:lnRef>
+          <a:fillRef idx="3">
+            <a:schemeClr val="accent1"/>
+          </a:fillRef>
+          <a:effectRef idx="2">
+            <a:schemeClr val="accent1"/>
+          </a:effectRef>
+          <a:fontRef idx="minor">
+            <a:schemeClr val="lt1"/>
+          </a:fontRef>
+        </p:style>
+        <p:txBody>
+          <a:bodyPr rtlCol="0" anchor="ctr"/>
+          <a:lstStyle/>
+          <a:p>
+            <a:pPr algn="ctr"/>
+          </a:p>
+        </p:txBody>
+      </p:sp>
+      <p:sp>
+        <p:nvSpPr>
+          <p:cNvPr id="7" name="TextBox 6"/>
           <p:cNvSpPr txBox="1"/>
           <p:nvPr/>
         </p:nvSpPr>
         <p:spPr>
           <a:xfrm>
-            <a:off x="457200" y="1371600"/>
-            <a:ext cx="6217920" cy="4572000"/>
+            <a:off x="594360" y="1508760"/>
+            <a:ext cx="5943600" cy="4297680"/>
           </a:xfrm>
           <a:prstGeom prst="rect">
             <a:avLst/>
@@ -8440,49 +9396,113 @@
           <a:p>
             <a:pPr>
               <a:spcAft>
+                <a:spcPts val="1000"/>
+              </a:spcAft>
+              <a:defRPr sz="1400" b="1">
+                <a:solidFill>
+                  <a:srgbClr val="FC8019"/>
+                </a:solidFill>
+                <a:latin typeface="Arial"/>
+              </a:defRPr>
+            </a:pPr>
+            <a:r>
+              <a:t>Interactive Deployed Checkout Sandbox</a:t>
+            </a:r>
+          </a:p>
+          <a:p>
+            <a:pPr>
+              <a:spcAft>
                 <a:spcPts val="800"/>
               </a:spcAft>
-              <a:defRPr b="1" sz="1500">
-                <a:solidFill>
-                  <a:srgbClr val="FC8019"/>
-                </a:solidFill>
+              <a:defRPr sz="1200">
+                <a:solidFill>
+                  <a:srgbClr val="F8FAFC"/>
+                </a:solidFill>
+                <a:latin typeface="Arial"/>
               </a:defRPr>
             </a:pPr>
             <a:r>
-              <a:t>Interactive Deployed Checkout Sandbox</a:t>
+              <a:t>• Active Checkout Sandbox:</a:t>
+            </a:r>
+            <a:br/>
+            <a:r>
+              <a:t>Clicking check out on everyday dairy essentials simulates payment completion and triggers the active 3-minute window.</a:t>
             </a:r>
           </a:p>
           <a:p>
             <a:pPr>
               <a:spcAft>
-                <a:spcPts val="1500"/>
+                <a:spcPts val="800"/>
               </a:spcAft>
-              <a:defRPr sz="1400">
+              <a:defRPr sz="1200">
                 <a:solidFill>
                   <a:srgbClr val="F8FAFC"/>
                 </a:solidFill>
+                <a:latin typeface="Arial"/>
               </a:defRPr>
             </a:pPr>
             <a:r>
-              <a:t>• Active Checkout Sandbox: Clicking check out on everyday dairy essentials simulates payment completion and triggers the active 3-minute window.</a:t>
+              <a:t>• Dynamic Countdown Banner:</a:t>
             </a:r>
             <a:br/>
+            <a:r>
+              <a:t>Displays an urgent timer counting down the dark store's packaging cycle.</a:t>
+            </a:r>
+          </a:p>
+          <a:p>
+            <a:pPr>
+              <a:spcAft>
+                <a:spcPts val="800"/>
+              </a:spcAft>
+              <a:defRPr sz="1200">
+                <a:solidFill>
+                  <a:srgbClr val="F8FAFC"/>
+                </a:solidFill>
+                <a:latin typeface="Arial"/>
+              </a:defRPr>
+            </a:pPr>
+            <a:r>
+              <a:t>• Fee-Free Add-on Carousel:</a:t>
+            </a:r>
             <a:br/>
             <a:r>
-              <a:t>• Dynamic Countdown Banner: Displays an urgent timer counting down the dark store's packaging cycle.</a:t>
-            </a:r>
-            <a:br/>
-            <a:br/>
-            <a:r>
-              <a:t>• Fee-Free Add-on Carousel: Displays organic avocados, dog treats, and face washes with ₹0 delivery fee. Selecting an item dynamically updates the active checkout order totals with zero delivery fee.</a:t>
-            </a:r>
-          </a:p>
+              <a:t>Displays organic avocados, dog treats, and face washes with ₹0 delivery fee. Selecting an item dynamically updates checkout totals.</a:t>
+            </a:r>
+          </a:p>
+        </p:txBody>
+      </p:sp>
+      <p:sp>
+        <p:nvSpPr>
+          <p:cNvPr id="8" name="TextBox 7"/>
+          <p:cNvSpPr txBox="1"/>
+          <p:nvPr/>
+        </p:nvSpPr>
+        <p:spPr>
+          <a:xfrm>
+            <a:off x="594360" y="4572000"/>
+            <a:ext cx="5943600" cy="914400"/>
+          </a:xfrm>
+          <a:prstGeom prst="rect">
+            <a:avLst/>
+          </a:prstGeom>
+          <a:noFill/>
+        </p:spPr>
+        <p:txBody>
+          <a:bodyPr wrap="square">
+            <a:spAutoFit/>
+          </a:bodyPr>
+          <a:lstStyle/>
           <a:p>
             <a:pPr>
-              <a:defRPr sz="1400"/>
+              <a:defRPr sz="1200">
+                <a:solidFill>
+                  <a:srgbClr val="F8FAFC"/>
+                </a:solidFill>
+                <a:latin typeface="Arial"/>
+              </a:defRPr>
             </a:pPr>
             <a:r>
-              <a:t>• Try the Deployed MVP: </a:t>
+              <a:t>Try the Deployed MVP: </a:t>
             </a:r>
             <a:r>
               <a:rPr u="sng">
@@ -8498,7 +9518,7 @@
       </p:sp>
       <p:pic>
         <p:nvPicPr>
-          <p:cNvPr id="7" name="Picture 6" descr="mvp_checkout_mockup.jpg"/>
+          <p:cNvPr id="9" name="Picture 8" descr="mvp_checkout_mockup.jpg"/>
           <p:cNvPicPr>
             <a:picLocks noChangeAspect="1"/>
           </p:cNvPicPr>
@@ -8522,7 +9542,7 @@
       </p:pic>
       <p:sp>
         <p:nvSpPr>
-          <p:cNvPr id="8" name="TextBox 7"/>
+          <p:cNvPr id="10" name="TextBox 9"/>
           <p:cNvSpPr txBox="1"/>
           <p:nvPr/>
         </p:nvSpPr>
@@ -8558,7 +9578,7 @@
       </p:sp>
       <p:sp>
         <p:nvSpPr>
-          <p:cNvPr id="9" name="TextBox 8"/>
+          <p:cNvPr id="11" name="TextBox 10"/>
           <p:cNvSpPr txBox="1"/>
           <p:nvPr/>
         </p:nvSpPr>
@@ -8772,14 +9792,59 @@
       </p:sp>
       <p:sp>
         <p:nvSpPr>
-          <p:cNvPr id="6" name="TextBox 5"/>
+          <p:cNvPr id="6" name="Rounded Rectangle 5"/>
+          <p:cNvSpPr/>
+          <p:nvPr/>
+        </p:nvSpPr>
+        <p:spPr>
+          <a:xfrm>
+            <a:off x="457200" y="1371600"/>
+            <a:ext cx="5486400" cy="4572000"/>
+          </a:xfrm>
+          <a:prstGeom prst="roundRect">
+            <a:avLst/>
+          </a:prstGeom>
+          <a:solidFill>
+            <a:srgbClr val="111827"/>
+          </a:solidFill>
+          <a:ln w="12700">
+            <a:solidFill>
+              <a:srgbClr val="1F2937"/>
+            </a:solidFill>
+          </a:ln>
+        </p:spPr>
+        <p:style>
+          <a:lnRef idx="1">
+            <a:schemeClr val="accent1"/>
+          </a:lnRef>
+          <a:fillRef idx="3">
+            <a:schemeClr val="accent1"/>
+          </a:fillRef>
+          <a:effectRef idx="2">
+            <a:schemeClr val="accent1"/>
+          </a:effectRef>
+          <a:fontRef idx="minor">
+            <a:schemeClr val="lt1"/>
+          </a:fontRef>
+        </p:style>
+        <p:txBody>
+          <a:bodyPr rtlCol="0" anchor="ctr"/>
+          <a:lstStyle/>
+          <a:p>
+            <a:pPr algn="ctr"/>
+          </a:p>
+        </p:txBody>
+      </p:sp>
+      <p:sp>
+        <p:nvSpPr>
+          <p:cNvPr id="7" name="TextBox 6"/>
           <p:cNvSpPr txBox="1"/>
           <p:nvPr/>
         </p:nvSpPr>
         <p:spPr>
           <a:xfrm>
-            <a:off x="457200" y="1371600"/>
-            <a:ext cx="5486400" cy="4572000"/>
+            <a:off x="594360" y="1508760"/>
+            <a:ext cx="5212080" cy="4297680"/>
           </a:xfrm>
           <a:prstGeom prst="rect">
             <a:avLst/>
@@ -8794,63 +9859,91 @@
           <a:p>
             <a:pPr>
               <a:spcAft>
+                <a:spcPts val="1000"/>
+              </a:spcAft>
+              <a:defRPr sz="1500" b="1">
+                <a:solidFill>
+                  <a:srgbClr val="FC8019"/>
+                </a:solidFill>
+                <a:latin typeface="Arial"/>
+              </a:defRPr>
+            </a:pPr>
+            <a:r>
+              <a:t>Phased Rollout Stages</a:t>
+            </a:r>
+          </a:p>
+          <a:p>
+            <a:pPr>
+              <a:spcAft>
                 <a:spcPts val="800"/>
               </a:spcAft>
-              <a:defRPr b="1" sz="1500">
-                <a:solidFill>
-                  <a:srgbClr val="FC8019"/>
-                </a:solidFill>
+              <a:defRPr sz="1100">
+                <a:solidFill>
+                  <a:srgbClr val="F8FAFC"/>
+                </a:solidFill>
+                <a:latin typeface="Arial"/>
               </a:defRPr>
             </a:pPr>
             <a:r>
-              <a:t>Phased Rollout Stages</a:t>
+              <a:t>To minimize operational delays at dark stores, we roll out the feature using a phased operational sandbox:</a:t>
             </a:r>
           </a:p>
           <a:p>
             <a:pPr>
               <a:spcAft>
-                <a:spcPts val="1200"/>
+                <a:spcPts val="800"/>
               </a:spcAft>
-              <a:defRPr sz="1400">
+              <a:defRPr sz="1100">
                 <a:solidFill>
                   <a:srgbClr val="F8FAFC"/>
                 </a:solidFill>
+                <a:latin typeface="Arial"/>
               </a:defRPr>
             </a:pPr>
             <a:r>
-              <a:t>To minimize operational delays at dark stores, we roll out the feature using a phased operational sandbox:</a:t>
+              <a:t>• Phase 1: Shadow Mode (Weeks 1-2)</a:t>
+            </a:r>
+            <a:br/>
+            <a:r>
+              <a:t>Track background behavior. Measure add-on clicks post-checkout without showing UI. Check matching dark store pack cycles.</a:t>
             </a:r>
           </a:p>
           <a:p>
             <a:pPr>
-              <a:defRPr sz="1300">
+              <a:spcAft>
+                <a:spcPts val="800"/>
+              </a:spcAft>
+              <a:defRPr sz="1100">
                 <a:solidFill>
                   <a:srgbClr val="F8FAFC"/>
                 </a:solidFill>
+                <a:latin typeface="Arial"/>
               </a:defRPr>
             </a:pPr>
             <a:r>
-              <a:t>• Phase 1: Shadow Mode (Weeks 1-2)</a:t>
+              <a:t>• Phase 2: Operational Buffer Trial (Weeks 3-6)</a:t>
             </a:r>
             <a:br/>
             <a:r>
-              <a:t>Track background behavior. Measure add-on clicks post-checkout without showing UI. Check matching dark store pack cycles.</a:t>
+              <a:t>Launch in 1 dark store (Bangalore East). Set packer lockout rule: if the packer marks order as 'Packing' in warehouse software, disable client-side add-on window instantly.</a:t>
+            </a:r>
+          </a:p>
+          <a:p>
+            <a:pPr>
+              <a:spcAft>
+                <a:spcPts val="800"/>
+              </a:spcAft>
+              <a:defRPr sz="1100">
+                <a:solidFill>
+                  <a:srgbClr val="F8FAFC"/>
+                </a:solidFill>
+                <a:latin typeface="Arial"/>
+              </a:defRPr>
+            </a:pPr>
+            <a:r>
+              <a:t>• Phase 3: Tiered City Expansion (Weeks 7-12)</a:t>
             </a:r>
             <a:br/>
-            <a:br/>
-            <a:r>
-              <a:t>• Phase 2: Operational Buffer Trial (Weeks 3-6)</a:t>
-            </a:r>
-            <a:br/>
-            <a:r>
-              <a:t>Launch in 1 dark store (Bangalore East). Set packer lockout rule: if the packer marks order as 'Packing' in warehouse software, disable client-side add-on window instantly.</a:t>
-            </a:r>
-            <a:br/>
-            <a:br/>
-            <a:r>
-              <a:t>• Phase 3: Tiered City Expansion (Weeks 7-12)</a:t>
-            </a:r>
-            <a:br/>
             <a:r>
               <a:t>Expand to 10 dark stores. Integrate with Swiggy One membership.</a:t>
             </a:r>
@@ -8859,14 +9952,59 @@
       </p:sp>
       <p:sp>
         <p:nvSpPr>
-          <p:cNvPr id="7" name="TextBox 6"/>
+          <p:cNvPr id="8" name="Rounded Rectangle 7"/>
+          <p:cNvSpPr/>
+          <p:nvPr/>
+        </p:nvSpPr>
+        <p:spPr>
+          <a:xfrm>
+            <a:off x="6217920" y="1371600"/>
+            <a:ext cx="5486400" cy="4572000"/>
+          </a:xfrm>
+          <a:prstGeom prst="roundRect">
+            <a:avLst/>
+          </a:prstGeom>
+          <a:solidFill>
+            <a:srgbClr val="111827"/>
+          </a:solidFill>
+          <a:ln w="12700">
+            <a:solidFill>
+              <a:srgbClr val="1F2937"/>
+            </a:solidFill>
+          </a:ln>
+        </p:spPr>
+        <p:style>
+          <a:lnRef idx="1">
+            <a:schemeClr val="accent1"/>
+          </a:lnRef>
+          <a:fillRef idx="3">
+            <a:schemeClr val="accent1"/>
+          </a:fillRef>
+          <a:effectRef idx="2">
+            <a:schemeClr val="accent1"/>
+          </a:effectRef>
+          <a:fontRef idx="minor">
+            <a:schemeClr val="lt1"/>
+          </a:fontRef>
+        </p:style>
+        <p:txBody>
+          <a:bodyPr rtlCol="0" anchor="ctr"/>
+          <a:lstStyle/>
+          <a:p>
+            <a:pPr algn="ctr"/>
+          </a:p>
+        </p:txBody>
+      </p:sp>
+      <p:sp>
+        <p:nvSpPr>
+          <p:cNvPr id="9" name="TextBox 8"/>
           <p:cNvSpPr txBox="1"/>
           <p:nvPr/>
         </p:nvSpPr>
         <p:spPr>
           <a:xfrm>
-            <a:off x="6217920" y="1371600"/>
-            <a:ext cx="5486400" cy="4572000"/>
+            <a:off x="6355080" y="1508760"/>
+            <a:ext cx="5212080" cy="4297680"/>
           </a:xfrm>
           <a:prstGeom prst="rect">
             <a:avLst/>
@@ -8881,60 +10019,100 @@
           <a:p>
             <a:pPr>
               <a:spcAft>
+                <a:spcPts val="1000"/>
+              </a:spcAft>
+              <a:defRPr sz="1500" b="1">
+                <a:solidFill>
+                  <a:srgbClr val="FC8019"/>
+                </a:solidFill>
+                <a:latin typeface="Arial"/>
+              </a:defRPr>
+            </a:pPr>
+            <a:r>
+              <a:t>Operational Lock-out &amp; Rider Safety Gates</a:t>
+            </a:r>
+          </a:p>
+          <a:p>
+            <a:pPr>
+              <a:spcAft>
                 <a:spcPts val="800"/>
               </a:spcAft>
-              <a:defRPr b="1" sz="1500">
-                <a:solidFill>
-                  <a:srgbClr val="FC8019"/>
-                </a:solidFill>
+              <a:defRPr sz="1100">
+                <a:solidFill>
+                  <a:srgbClr val="F8FAFC"/>
+                </a:solidFill>
+                <a:latin typeface="Arial"/>
               </a:defRPr>
             </a:pPr>
             <a:r>
-              <a:t>Operational Lock-out &amp; Rider Safety Gates</a:t>
+              <a:t>We enforce three software guardrails to protect delivery SLAs:</a:t>
             </a:r>
           </a:p>
           <a:p>
             <a:pPr>
               <a:spcAft>
-                <a:spcPts val="1200"/>
+                <a:spcPts val="800"/>
               </a:spcAft>
-              <a:defRPr sz="1400">
+              <a:defRPr sz="1100">
                 <a:solidFill>
                   <a:srgbClr val="F8FAFC"/>
                 </a:solidFill>
+                <a:latin typeface="Arial"/>
               </a:defRPr>
             </a:pPr>
             <a:r>
-              <a:t>We enforce three software guardrails to protect delivery SLAs:</a:t>
+              <a:t>1. Packing Status Gate:</a:t>
+            </a:r>
+            <a:br/>
+            <a:r>
+              <a:t>The window is disabled if warehouse packing has already started. This prevents packers from re-opening sealed packages.</a:t>
             </a:r>
           </a:p>
           <a:p>
             <a:pPr>
-              <a:defRPr sz="1300">
+              <a:spcAft>
+                <a:spcPts val="800"/>
+              </a:spcAft>
+              <a:defRPr sz="1100">
                 <a:solidFill>
                   <a:srgbClr val="F8FAFC"/>
                 </a:solidFill>
+                <a:latin typeface="Arial"/>
               </a:defRPr>
             </a:pPr>
             <a:r>
-              <a:t>1. Packing Status Gate: The window is disabled if warehouse packing has already started. This prevents packers from re-opening sealed packages.</a:t>
+              <a:t>2. Weight Capacity Gate:</a:t>
             </a:r>
             <a:br/>
+            <a:r>
+              <a:t>Limit add-on catalog to items &lt;2kg. Heavy items (e.g. 5kg dog food bags) are blocked to keep bikes within safety weight thresholds.</a:t>
+            </a:r>
+          </a:p>
+          <a:p>
+            <a:pPr>
+              <a:spcAft>
+                <a:spcPts val="800"/>
+              </a:spcAft>
+              <a:defRPr sz="1100">
+                <a:solidFill>
+                  <a:srgbClr val="F8FAFC"/>
+                </a:solidFill>
+                <a:latin typeface="Arial"/>
+              </a:defRPr>
+            </a:pPr>
+            <a:r>
+              <a:t>3. Single-Rider Hand-off:</a:t>
+            </a:r>
             <a:br/>
             <a:r>
-              <a:t>2. Weight Capacity Gate: Limit add-on catalog to items &lt;2kg. Heavy items (e.g. 5kg dog food bags) are blocked to keep bikes within safety weight thresholds.</a:t>
-            </a:r>
-            <a:br/>
-            <a:br/>
-            <a:r>
-              <a:t>3. Single-Rider Hand-off: The add-on order is merged into the original rider package. No secondary rider is assigned.</a:t>
-            </a:r>
-          </a:p>
-        </p:txBody>
-      </p:sp>
-      <p:sp>
-        <p:nvSpPr>
-          <p:cNvPr id="8" name="TextBox 7"/>
+              <a:t>The add-on order is merged into the original rider package. No secondary rider is assigned.</a:t>
+            </a:r>
+          </a:p>
+        </p:txBody>
+      </p:sp>
+      <p:sp>
+        <p:nvSpPr>
+          <p:cNvPr id="10" name="TextBox 9"/>
           <p:cNvSpPr txBox="1"/>
           <p:nvPr/>
         </p:nvSpPr>
@@ -8970,7 +10148,7 @@
       </p:sp>
       <p:sp>
         <p:nvSpPr>
-          <p:cNvPr id="9" name="TextBox 8"/>
+          <p:cNvPr id="11" name="TextBox 10"/>
           <p:cNvSpPr txBox="1"/>
           <p:nvPr/>
         </p:nvSpPr>
@@ -9184,14 +10362,59 @@
       </p:sp>
       <p:sp>
         <p:nvSpPr>
-          <p:cNvPr id="6" name="TextBox 5"/>
+          <p:cNvPr id="6" name="Rounded Rectangle 5"/>
+          <p:cNvSpPr/>
+          <p:nvPr/>
+        </p:nvSpPr>
+        <p:spPr>
+          <a:xfrm>
+            <a:off x="457200" y="1371600"/>
+            <a:ext cx="5486400" cy="4572000"/>
+          </a:xfrm>
+          <a:prstGeom prst="roundRect">
+            <a:avLst/>
+          </a:prstGeom>
+          <a:solidFill>
+            <a:srgbClr val="111827"/>
+          </a:solidFill>
+          <a:ln w="12700">
+            <a:solidFill>
+              <a:srgbClr val="1F2937"/>
+            </a:solidFill>
+          </a:ln>
+        </p:spPr>
+        <p:style>
+          <a:lnRef idx="1">
+            <a:schemeClr val="accent1"/>
+          </a:lnRef>
+          <a:fillRef idx="3">
+            <a:schemeClr val="accent1"/>
+          </a:fillRef>
+          <a:effectRef idx="2">
+            <a:schemeClr val="accent1"/>
+          </a:effectRef>
+          <a:fontRef idx="minor">
+            <a:schemeClr val="lt1"/>
+          </a:fontRef>
+        </p:style>
+        <p:txBody>
+          <a:bodyPr rtlCol="0" anchor="ctr"/>
+          <a:lstStyle/>
+          <a:p>
+            <a:pPr algn="ctr"/>
+          </a:p>
+        </p:txBody>
+      </p:sp>
+      <p:sp>
+        <p:nvSpPr>
+          <p:cNvPr id="7" name="TextBox 6"/>
           <p:cNvSpPr txBox="1"/>
           <p:nvPr/>
         </p:nvSpPr>
         <p:spPr>
           <a:xfrm>
-            <a:off x="457200" y="1371600"/>
-            <a:ext cx="5486400" cy="4572000"/>
+            <a:off x="594360" y="1508760"/>
+            <a:ext cx="5212080" cy="4297680"/>
           </a:xfrm>
           <a:prstGeom prst="rect">
             <a:avLst/>
@@ -9206,82 +10429,259 @@
           <a:p>
             <a:pPr>
               <a:spcAft>
+                <a:spcPts val="1000"/>
+              </a:spcAft>
+              <a:defRPr sz="1500" b="1">
+                <a:solidFill>
+                  <a:srgbClr val="FC8019"/>
+                </a:solidFill>
+                <a:latin typeface="Arial"/>
+              </a:defRPr>
+            </a:pPr>
+            <a:r>
+              <a:t>North Star &amp; Leading Indicators</a:t>
+            </a:r>
+          </a:p>
+          <a:p>
+            <a:pPr>
+              <a:spcAft>
                 <a:spcPts val="800"/>
               </a:spcAft>
-              <a:defRPr b="1" sz="1500">
-                <a:solidFill>
-                  <a:srgbClr val="FC8019"/>
-                </a:solidFill>
+              <a:defRPr sz="1100">
+                <a:solidFill>
+                  <a:srgbClr val="F8FAFC"/>
+                </a:solidFill>
+                <a:latin typeface="Arial"/>
               </a:defRPr>
             </a:pPr>
             <a:r>
-              <a:t>North Star &amp; Leading Indicators</a:t>
-            </a:r>
-          </a:p>
+              <a:t>• North Star Metric: Cross-Category Discovery Completion Rate</a:t>
+            </a:r>
+            <a:br/>
+            <a:r>
+              <a:t>% of post-checkout add-on recommendations checked out and delivered, out of all users exposed to the countdown timer. Target: 35% completion in 30 days.</a:t>
+            </a:r>
+          </a:p>
+          <a:p>
+            <a:pPr>
+              <a:spcAft>
+                <a:spcPts val="800"/>
+              </a:spcAft>
+              <a:defRPr sz="1100">
+                <a:solidFill>
+                  <a:srgbClr val="F8FAFC"/>
+                </a:solidFill>
+                <a:latin typeface="Arial"/>
+              </a:defRPr>
+            </a:pPr>
+            <a:r>
+              <a:t>• Leading Indicators (0-30 Days):</a:t>
+            </a:r>
+            <a:br/>
+            <a:r>
+              <a:t>  - Timer Conversion Rate: % of users who add at least 1 item. Target: &gt;25% in week 2.</a:t>
+            </a:r>
+            <a:br/>
+            <a:r>
+              <a:t>  - Platform Split Churn Delta: Shift in multi-app usage. Target: -5% churn to Zepto.</a:t>
+            </a:r>
+          </a:p>
+          <a:p>
+            <a:pPr>
+              <a:spcAft>
+                <a:spcPts val="800"/>
+              </a:spcAft>
+              <a:defRPr sz="1100">
+                <a:solidFill>
+                  <a:srgbClr val="F8FAFC"/>
+                </a:solidFill>
+                <a:latin typeface="Arial"/>
+              </a:defRPr>
+            </a:pPr>
+            <a:r>
+              <a:t>• Lagging Indicators (30-90 Days):</a:t>
+            </a:r>
+            <a:br/>
+            <a:r>
+              <a:t>  - Average Order Value (AOV) Delta: Target +18% AOV lift among pilot cohort.</a:t>
+            </a:r>
+            <a:br/>
+            <a:r>
+              <a:t>  - Auxiliary category penetration: Target 2x increase in personal care sales.</a:t>
+            </a:r>
+          </a:p>
+        </p:txBody>
+      </p:sp>
+      <p:sp>
+        <p:nvSpPr>
+          <p:cNvPr id="8" name="Rounded Rectangle 7"/>
+          <p:cNvSpPr/>
+          <p:nvPr/>
+        </p:nvSpPr>
+        <p:spPr>
+          <a:xfrm>
+            <a:off x="6217920" y="1371600"/>
+            <a:ext cx="5486400" cy="4572000"/>
+          </a:xfrm>
+          <a:prstGeom prst="roundRect">
+            <a:avLst/>
+          </a:prstGeom>
+          <a:solidFill>
+            <a:srgbClr val="111827"/>
+          </a:solidFill>
+          <a:ln w="12700">
+            <a:solidFill>
+              <a:srgbClr val="1F2937"/>
+            </a:solidFill>
+          </a:ln>
+        </p:spPr>
+        <p:style>
+          <a:lnRef idx="1">
+            <a:schemeClr val="accent1"/>
+          </a:lnRef>
+          <a:fillRef idx="3">
+            <a:schemeClr val="accent1"/>
+          </a:fillRef>
+          <a:effectRef idx="2">
+            <a:schemeClr val="accent1"/>
+          </a:effectRef>
+          <a:fontRef idx="minor">
+            <a:schemeClr val="lt1"/>
+          </a:fontRef>
+        </p:style>
+        <p:txBody>
+          <a:bodyPr rtlCol="0" anchor="ctr"/>
+          <a:lstStyle/>
+          <a:p>
+            <a:pPr algn="ctr"/>
+          </a:p>
+        </p:txBody>
+      </p:sp>
+      <p:sp>
+        <p:nvSpPr>
+          <p:cNvPr id="9" name="TextBox 8"/>
+          <p:cNvSpPr txBox="1"/>
+          <p:nvPr/>
+        </p:nvSpPr>
+        <p:spPr>
+          <a:xfrm>
+            <a:off x="6355080" y="1508760"/>
+            <a:ext cx="5212080" cy="4297680"/>
+          </a:xfrm>
+          <a:prstGeom prst="rect">
+            <a:avLst/>
+          </a:prstGeom>
+          <a:noFill/>
+        </p:spPr>
+        <p:txBody>
+          <a:bodyPr wrap="square">
+            <a:spAutoFit/>
+          </a:bodyPr>
+          <a:lstStyle/>
           <a:p>
             <a:pPr>
               <a:spcAft>
                 <a:spcPts val="1000"/>
               </a:spcAft>
-              <a:defRPr sz="1300">
+              <a:defRPr sz="1500" b="1">
+                <a:solidFill>
+                  <a:srgbClr val="FC8019"/>
+                </a:solidFill>
+                <a:latin typeface="Arial"/>
+              </a:defRPr>
+            </a:pPr>
+            <a:r>
+              <a:t>SLA Operational Guardrail Metrics</a:t>
+            </a:r>
+          </a:p>
+          <a:p>
+            <a:pPr>
+              <a:spcAft>
+                <a:spcPts val="800"/>
+              </a:spcAft>
+              <a:defRPr sz="1100">
                 <a:solidFill>
                   <a:srgbClr val="F8FAFC"/>
                 </a:solidFill>
+                <a:latin typeface="Arial"/>
               </a:defRPr>
             </a:pPr>
             <a:r>
-              <a:t>• North Star Metric: Cross-Category Discovery Completion Rate</a:t>
+              <a:t>We track three operational guardrails daily to guarantee the core delivery promise is not broken:</a:t>
+            </a:r>
+          </a:p>
+          <a:p>
+            <a:pPr>
+              <a:spcAft>
+                <a:spcPts val="800"/>
+              </a:spcAft>
+              <a:defRPr sz="1100">
+                <a:solidFill>
+                  <a:srgbClr val="F8FAFC"/>
+                </a:solidFill>
+                <a:latin typeface="Arial"/>
+              </a:defRPr>
+            </a:pPr>
+            <a:r>
+              <a:t>• Rider Wait Time Delta: Target: &lt;+30 seconds.</a:t>
             </a:r>
             <a:br/>
             <a:r>
-              <a:t>% of post-checkout add-on recommendations checked out and delivered, out of all users exposed to the countdown timer. Target: 35% completion in 30 days.</a:t>
+              <a:t>Measures delay in rider departure from dark store after package handoff. If delta exceeds 45s, decrease add-on window from 3 to 2 minutes.</a:t>
+            </a:r>
+          </a:p>
+          <a:p>
+            <a:pPr>
+              <a:spcAft>
+                <a:spcPts val="800"/>
+              </a:spcAft>
+              <a:defRPr sz="1100">
+                <a:solidFill>
+                  <a:srgbClr val="F8FAFC"/>
+                </a:solidFill>
+                <a:latin typeface="Arial"/>
+              </a:defRPr>
+            </a:pPr>
+            <a:r>
+              <a:t>• Packer Picking SLA Delta: Target: &lt;+15 seconds.</a:t>
             </a:r>
             <a:br/>
+            <a:r>
+              <a:t>Measures packer time to add append item to bag. If delta rises, simplify packer terminal UI.</a:t>
+            </a:r>
+          </a:p>
+          <a:p>
+            <a:pPr>
+              <a:spcAft>
+                <a:spcPts val="800"/>
+              </a:spcAft>
+              <a:defRPr sz="1100">
+                <a:solidFill>
+                  <a:srgbClr val="F8FAFC"/>
+                </a:solidFill>
+                <a:latin typeface="Arial"/>
+              </a:defRPr>
+            </a:pPr>
+            <a:r>
+              <a:t>• Delivery SLA Breach Rate: Target: 0%.</a:t>
+            </a:r>
             <a:br/>
             <a:r>
-              <a:t>• Leading Indicators (0-30 Days):</a:t>
-            </a:r>
-            <a:br/>
-            <a:r>
-              <a:t>  - Timer Conversion Rate: % of users who add at least 1 item. Target: &gt;25% in week 2.</a:t>
-            </a:r>
-            <a:br/>
-            <a:r>
-              <a:t>  - Platform Split Churn Delta: Shift in multi-app usage. Target: -5% churn to Zepto.</a:t>
-            </a:r>
-          </a:p>
-          <a:p>
-            <a:pPr>
-              <a:defRPr sz="1300">
-                <a:solidFill>
-                  <a:srgbClr val="F8FAFC"/>
-                </a:solidFill>
-              </a:defRPr>
-            </a:pPr>
-            <a:r>
-              <a:t>• Lagging Indicators (30-90 Days):</a:t>
-            </a:r>
-            <a:br/>
-            <a:r>
-              <a:t>  - Average Order Value (AOV) Delta: Target +18% AOV lift among pilot cohort.</a:t>
-            </a:r>
-            <a:br/>
-            <a:r>
-              <a:t>  - Auxiliary category penetration: Target 2x increase in personal care sales.</a:t>
-            </a:r>
-          </a:p>
-        </p:txBody>
-      </p:sp>
-      <p:sp>
-        <p:nvSpPr>
-          <p:cNvPr id="7" name="TextBox 6"/>
+              <a:t>The percentage of orders delayed beyond Swiggy's delivery promise. Must remain constant.</a:t>
+            </a:r>
+          </a:p>
+        </p:txBody>
+      </p:sp>
+      <p:sp>
+        <p:nvSpPr>
+          <p:cNvPr id="10" name="TextBox 9"/>
           <p:cNvSpPr txBox="1"/>
           <p:nvPr/>
         </p:nvSpPr>
         <p:spPr>
           <a:xfrm>
-            <a:off x="6217920" y="1371600"/>
-            <a:ext cx="5486400" cy="4572000"/>
+            <a:off x="457200" y="6400800"/>
+            <a:ext cx="9144000" cy="274320"/>
           </a:xfrm>
           <a:prstGeom prst="rect">
             <a:avLst/>
@@ -9289,81 +10689,6 @@
           <a:noFill/>
         </p:spPr>
         <p:txBody>
-          <a:bodyPr wrap="square">
-            <a:spAutoFit/>
-          </a:bodyPr>
-          <a:lstStyle/>
-          <a:p>
-            <a:pPr>
-              <a:spcAft>
-                <a:spcPts val="800"/>
-              </a:spcAft>
-              <a:defRPr b="1" sz="1500">
-                <a:solidFill>
-                  <a:srgbClr val="FC8019"/>
-                </a:solidFill>
-              </a:defRPr>
-            </a:pPr>
-            <a:r>
-              <a:t>SLA Operational Guardrail Metrics</a:t>
-            </a:r>
-          </a:p>
-          <a:p>
-            <a:pPr>
-              <a:spcAft>
-                <a:spcPts val="1200"/>
-              </a:spcAft>
-              <a:defRPr sz="1400">
-                <a:solidFill>
-                  <a:srgbClr val="F8FAFC"/>
-                </a:solidFill>
-              </a:defRPr>
-            </a:pPr>
-            <a:r>
-              <a:t>We track three operational guardrails daily to guarantee the core delivery promise is not broken:</a:t>
-            </a:r>
-          </a:p>
-          <a:p>
-            <a:pPr>
-              <a:defRPr sz="1300">
-                <a:solidFill>
-                  <a:srgbClr val="F8FAFC"/>
-                </a:solidFill>
-              </a:defRPr>
-            </a:pPr>
-            <a:r>
-              <a:t>• Rider Wait Time Delta: Target: &lt;+30 seconds. Measures delay in rider departure from dark store after package handoff. If delta exceeds 45s, decrease add-on window from 3 to 2 minutes.</a:t>
-            </a:r>
-            <a:br/>
-            <a:br/>
-            <a:r>
-              <a:t>• Packer Picking SLA Delta: Target: &lt;+15 seconds. Measures packer time to add append item to bag. If delta rises, simplify packer terminal UI.</a:t>
-            </a:r>
-            <a:br/>
-            <a:br/>
-            <a:r>
-              <a:t>• Delivery SLA Breach Rate: Target: 0%. The percentage of orders delayed beyond Swiggy's delivery promise. Must remain constant.</a:t>
-            </a:r>
-          </a:p>
-        </p:txBody>
-      </p:sp>
-      <p:sp>
-        <p:nvSpPr>
-          <p:cNvPr id="8" name="TextBox 7"/>
-          <p:cNvSpPr txBox="1"/>
-          <p:nvPr/>
-        </p:nvSpPr>
-        <p:spPr>
-          <a:xfrm>
-            <a:off x="457200" y="6400800"/>
-            <a:ext cx="9144000" cy="274320"/>
-          </a:xfrm>
-          <a:prstGeom prst="rect">
-            <a:avLst/>
-          </a:prstGeom>
-          <a:noFill/>
-        </p:spPr>
-        <p:txBody>
           <a:bodyPr wrap="none">
             <a:spAutoFit/>
           </a:bodyPr>
@@ -9385,7 +10710,7 @@
       </p:sp>
       <p:sp>
         <p:nvSpPr>
-          <p:cNvPr id="9" name="TextBox 8"/>
+          <p:cNvPr id="11" name="TextBox 10"/>
           <p:cNvSpPr txBox="1"/>
           <p:nvPr/>
         </p:nvSpPr>

</xml_diff>

<commit_message>
Embed high-fidelity MVP mockup snippet and add Category Penetration & Migration Matrix to Slide 9
</commit_message>
<xml_diff>
--- a/NL Swiggy Instamart.pptx
+++ b/NL Swiggy Instamart.pptx
@@ -8600,16 +8600,655 @@
           </a:p>
         </p:txBody>
       </p:sp>
-      <p:sp>
-        <p:nvSpPr>
-          <p:cNvPr id="5" name="Rounded Rectangle 4"/>
+      <p:graphicFrame>
+        <p:nvGraphicFramePr>
+          <p:cNvPr id="5" name="Table 4"/>
+          <p:cNvGraphicFramePr>
+            <a:graphicFrameLocks noGrp="1"/>
+          </p:cNvGraphicFramePr>
+          <p:nvPr/>
+        </p:nvGraphicFramePr>
+        <p:xfrm>
+          <a:off x="548640" y="1463040"/>
+          <a:ext cx="5486400" cy="4572000"/>
+        </p:xfrm>
+        <a:graphic>
+          <a:graphicData uri="http://schemas.openxmlformats.org/drawingml/2006/table">
+            <a:tbl>
+              <a:tblPr firstRow="1" bandRow="1">
+                <a:tableStyleId>{5C22544A-7EE6-4342-B048-85BDC9FD1C3A}</a:tableStyleId>
+              </a:tblPr>
+              <a:tblGrid>
+                <a:gridCol w="1554480"/>
+                <a:gridCol w="731520"/>
+                <a:gridCol w="1005840"/>
+                <a:gridCol w="1005840"/>
+                <a:gridCol w="1188720"/>
+              </a:tblGrid>
+              <a:tr h="914400">
+                <a:tc>
+                  <a:txBody>
+                    <a:bodyPr/>
+                    <a:lstStyle/>
+                    <a:p>
+                      <a:pPr>
+                        <a:defRPr sz="1400" b="1">
+                          <a:solidFill>
+                            <a:srgbClr val="F8FAFC"/>
+                          </a:solidFill>
+                          <a:latin typeface="Arial"/>
+                        </a:defRPr>
+                      </a:pPr>
+                      <a:r>
+                        <a:t>Category</a:t>
+                      </a:r>
+                    </a:p>
+                  </a:txBody>
+                  <a:tcPr>
+                    <a:solidFill>
+                      <a:srgbClr val="222B44"/>
+                    </a:solidFill>
+                  </a:tcPr>
+                </a:tc>
+                <a:tc>
+                  <a:txBody>
+                    <a:bodyPr/>
+                    <a:lstStyle/>
+                    <a:p>
+                      <a:pPr>
+                        <a:defRPr sz="1400" b="1">
+                          <a:solidFill>
+                            <a:srgbClr val="F8FAFC"/>
+                          </a:solidFill>
+                          <a:latin typeface="Arial"/>
+                        </a:defRPr>
+                      </a:pPr>
+                      <a:r>
+                        <a:t>Base</a:t>
+                      </a:r>
+                    </a:p>
+                  </a:txBody>
+                  <a:tcPr>
+                    <a:solidFill>
+                      <a:srgbClr val="222B44"/>
+                    </a:solidFill>
+                  </a:tcPr>
+                </a:tc>
+                <a:tc>
+                  <a:txBody>
+                    <a:bodyPr/>
+                    <a:lstStyle/>
+                    <a:p>
+                      <a:pPr>
+                        <a:defRPr sz="1400" b="1">
+                          <a:solidFill>
+                            <a:srgbClr val="F8FAFC"/>
+                          </a:solidFill>
+                          <a:latin typeface="Arial"/>
+                        </a:defRPr>
+                      </a:pPr>
+                      <a:r>
+                        <a:t>Target 30D</a:t>
+                      </a:r>
+                    </a:p>
+                  </a:txBody>
+                  <a:tcPr>
+                    <a:solidFill>
+                      <a:srgbClr val="222B44"/>
+                    </a:solidFill>
+                  </a:tcPr>
+                </a:tc>
+                <a:tc>
+                  <a:txBody>
+                    <a:bodyPr/>
+                    <a:lstStyle/>
+                    <a:p>
+                      <a:pPr>
+                        <a:defRPr sz="1400" b="1">
+                          <a:solidFill>
+                            <a:srgbClr val="F8FAFC"/>
+                          </a:solidFill>
+                          <a:latin typeface="Arial"/>
+                        </a:defRPr>
+                      </a:pPr>
+                      <a:r>
+                        <a:t>Target 90D</a:t>
+                      </a:r>
+                    </a:p>
+                  </a:txBody>
+                  <a:tcPr>
+                    <a:solidFill>
+                      <a:srgbClr val="222B44"/>
+                    </a:solidFill>
+                  </a:tcPr>
+                </a:tc>
+                <a:tc>
+                  <a:txBody>
+                    <a:bodyPr/>
+                    <a:lstStyle/>
+                    <a:p>
+                      <a:pPr>
+                        <a:defRPr sz="1400" b="1">
+                          <a:solidFill>
+                            <a:srgbClr val="F8FAFC"/>
+                          </a:solidFill>
+                          <a:latin typeface="Arial"/>
+                        </a:defRPr>
+                      </a:pPr>
+                      <a:r>
+                        <a:t>Friction Solved</a:t>
+                      </a:r>
+                    </a:p>
+                  </a:txBody>
+                  <a:tcPr>
+                    <a:solidFill>
+                      <a:srgbClr val="222B44"/>
+                    </a:solidFill>
+                  </a:tcPr>
+                </a:tc>
+              </a:tr>
+              <a:tr h="914400">
+                <a:tc>
+                  <a:txBody>
+                    <a:bodyPr/>
+                    <a:lstStyle/>
+                    <a:p>
+                      <a:pPr>
+                        <a:defRPr sz="1400" b="1">
+                          <a:solidFill>
+                            <a:srgbClr val="F8FAFC"/>
+                          </a:solidFill>
+                          <a:latin typeface="Arial"/>
+                        </a:defRPr>
+                      </a:pPr>
+                      <a:r>
+                        <a:t>Gourmet</a:t>
+                      </a:r>
+                    </a:p>
+                  </a:txBody>
+                  <a:tcPr>
+                    <a:solidFill>
+                      <a:srgbClr val="151B2C"/>
+                    </a:solidFill>
+                  </a:tcPr>
+                </a:tc>
+                <a:tc>
+                  <a:txBody>
+                    <a:bodyPr/>
+                    <a:lstStyle/>
+                    <a:p>
+                      <a:pPr>
+                        <a:defRPr sz="1400" b="0">
+                          <a:solidFill>
+                            <a:srgbClr val="94A3B8"/>
+                          </a:solidFill>
+                          <a:latin typeface="Arial"/>
+                        </a:defRPr>
+                      </a:pPr>
+                      <a:r>
+                        <a:t>4.2%</a:t>
+                      </a:r>
+                    </a:p>
+                  </a:txBody>
+                  <a:tcPr>
+                    <a:solidFill>
+                      <a:srgbClr val="151B2C"/>
+                    </a:solidFill>
+                  </a:tcPr>
+                </a:tc>
+                <a:tc>
+                  <a:txBody>
+                    <a:bodyPr/>
+                    <a:lstStyle/>
+                    <a:p>
+                      <a:pPr>
+                        <a:defRPr sz="1400" b="1">
+                          <a:solidFill>
+                            <a:srgbClr val="FC8019"/>
+                          </a:solidFill>
+                          <a:latin typeface="Arial"/>
+                        </a:defRPr>
+                      </a:pPr>
+                      <a:r>
+                        <a:t>12.0%</a:t>
+                      </a:r>
+                    </a:p>
+                  </a:txBody>
+                  <a:tcPr>
+                    <a:solidFill>
+                      <a:srgbClr val="151B2C"/>
+                    </a:solidFill>
+                  </a:tcPr>
+                </a:tc>
+                <a:tc>
+                  <a:txBody>
+                    <a:bodyPr/>
+                    <a:lstStyle/>
+                    <a:p>
+                      <a:pPr>
+                        <a:defRPr sz="1400" b="1">
+                          <a:solidFill>
+                            <a:srgbClr val="22C55E"/>
+                          </a:solidFill>
+                          <a:latin typeface="Arial"/>
+                        </a:defRPr>
+                      </a:pPr>
+                      <a:r>
+                        <a:t>18.5%</a:t>
+                      </a:r>
+                    </a:p>
+                  </a:txBody>
+                  <a:tcPr>
+                    <a:solidFill>
+                      <a:srgbClr val="151B2C"/>
+                    </a:solidFill>
+                  </a:tcPr>
+                </a:tc>
+                <a:tc>
+                  <a:txBody>
+                    <a:bodyPr/>
+                    <a:lstStyle/>
+                    <a:p>
+                      <a:pPr>
+                        <a:defRPr sz="1400" b="0">
+                          <a:solidFill>
+                            <a:srgbClr val="F8FAFC"/>
+                          </a:solidFill>
+                          <a:latin typeface="Arial"/>
+                        </a:defRPr>
+                      </a:pPr>
+                      <a:r>
+                        <a:t>Delivery Fee</a:t>
+                      </a:r>
+                    </a:p>
+                  </a:txBody>
+                  <a:tcPr>
+                    <a:solidFill>
+                      <a:srgbClr val="151B2C"/>
+                    </a:solidFill>
+                  </a:tcPr>
+                </a:tc>
+              </a:tr>
+              <a:tr h="914400">
+                <a:tc>
+                  <a:txBody>
+                    <a:bodyPr/>
+                    <a:lstStyle/>
+                    <a:p>
+                      <a:pPr>
+                        <a:defRPr sz="1400" b="1">
+                          <a:solidFill>
+                            <a:srgbClr val="F8FAFC"/>
+                          </a:solidFill>
+                          <a:latin typeface="Arial"/>
+                        </a:defRPr>
+                      </a:pPr>
+                      <a:r>
+                        <a:t>Personal Care</a:t>
+                      </a:r>
+                    </a:p>
+                  </a:txBody>
+                  <a:tcPr>
+                    <a:solidFill>
+                      <a:srgbClr val="151B2C"/>
+                    </a:solidFill>
+                  </a:tcPr>
+                </a:tc>
+                <a:tc>
+                  <a:txBody>
+                    <a:bodyPr/>
+                    <a:lstStyle/>
+                    <a:p>
+                      <a:pPr>
+                        <a:defRPr sz="1400" b="0">
+                          <a:solidFill>
+                            <a:srgbClr val="94A3B8"/>
+                          </a:solidFill>
+                          <a:latin typeface="Arial"/>
+                        </a:defRPr>
+                      </a:pPr>
+                      <a:r>
+                        <a:t>3.1%</a:t>
+                      </a:r>
+                    </a:p>
+                  </a:txBody>
+                  <a:tcPr>
+                    <a:solidFill>
+                      <a:srgbClr val="151B2C"/>
+                    </a:solidFill>
+                  </a:tcPr>
+                </a:tc>
+                <a:tc>
+                  <a:txBody>
+                    <a:bodyPr/>
+                    <a:lstStyle/>
+                    <a:p>
+                      <a:pPr>
+                        <a:defRPr sz="1400" b="1">
+                          <a:solidFill>
+                            <a:srgbClr val="FC8019"/>
+                          </a:solidFill>
+                          <a:latin typeface="Arial"/>
+                        </a:defRPr>
+                      </a:pPr>
+                      <a:r>
+                        <a:t>8.5%</a:t>
+                      </a:r>
+                    </a:p>
+                  </a:txBody>
+                  <a:tcPr>
+                    <a:solidFill>
+                      <a:srgbClr val="151B2C"/>
+                    </a:solidFill>
+                  </a:tcPr>
+                </a:tc>
+                <a:tc>
+                  <a:txBody>
+                    <a:bodyPr/>
+                    <a:lstStyle/>
+                    <a:p>
+                      <a:pPr>
+                        <a:defRPr sz="1400" b="1">
+                          <a:solidFill>
+                            <a:srgbClr val="22C55E"/>
+                          </a:solidFill>
+                          <a:latin typeface="Arial"/>
+                        </a:defRPr>
+                      </a:pPr>
+                      <a:r>
+                        <a:t>14.0%</a:t>
+                      </a:r>
+                    </a:p>
+                  </a:txBody>
+                  <a:tcPr>
+                    <a:solidFill>
+                      <a:srgbClr val="151B2C"/>
+                    </a:solidFill>
+                  </a:tcPr>
+                </a:tc>
+                <a:tc>
+                  <a:txBody>
+                    <a:bodyPr/>
+                    <a:lstStyle/>
+                    <a:p>
+                      <a:pPr>
+                        <a:defRPr sz="1400" b="0">
+                          <a:solidFill>
+                            <a:srgbClr val="F8FAFC"/>
+                          </a:solidFill>
+                          <a:latin typeface="Arial"/>
+                        </a:defRPr>
+                      </a:pPr>
+                      <a:r>
+                        <a:t>Delivery Fee</a:t>
+                      </a:r>
+                    </a:p>
+                  </a:txBody>
+                  <a:tcPr>
+                    <a:solidFill>
+                      <a:srgbClr val="151B2C"/>
+                    </a:solidFill>
+                  </a:tcPr>
+                </a:tc>
+              </a:tr>
+              <a:tr h="914400">
+                <a:tc>
+                  <a:txBody>
+                    <a:bodyPr/>
+                    <a:lstStyle/>
+                    <a:p>
+                      <a:pPr>
+                        <a:defRPr sz="1400" b="1">
+                          <a:solidFill>
+                            <a:srgbClr val="F8FAFC"/>
+                          </a:solidFill>
+                          <a:latin typeface="Arial"/>
+                        </a:defRPr>
+                      </a:pPr>
+                      <a:r>
+                        <a:t>Baby Care</a:t>
+                      </a:r>
+                    </a:p>
+                  </a:txBody>
+                  <a:tcPr>
+                    <a:solidFill>
+                      <a:srgbClr val="151B2C"/>
+                    </a:solidFill>
+                  </a:tcPr>
+                </a:tc>
+                <a:tc>
+                  <a:txBody>
+                    <a:bodyPr/>
+                    <a:lstStyle/>
+                    <a:p>
+                      <a:pPr>
+                        <a:defRPr sz="1400" b="0">
+                          <a:solidFill>
+                            <a:srgbClr val="94A3B8"/>
+                          </a:solidFill>
+                          <a:latin typeface="Arial"/>
+                        </a:defRPr>
+                      </a:pPr>
+                      <a:r>
+                        <a:t>1.8%</a:t>
+                      </a:r>
+                    </a:p>
+                  </a:txBody>
+                  <a:tcPr>
+                    <a:solidFill>
+                      <a:srgbClr val="151B2C"/>
+                    </a:solidFill>
+                  </a:tcPr>
+                </a:tc>
+                <a:tc>
+                  <a:txBody>
+                    <a:bodyPr/>
+                    <a:lstStyle/>
+                    <a:p>
+                      <a:pPr>
+                        <a:defRPr sz="1400" b="1">
+                          <a:solidFill>
+                            <a:srgbClr val="FC8019"/>
+                          </a:solidFill>
+                          <a:latin typeface="Arial"/>
+                        </a:defRPr>
+                      </a:pPr>
+                      <a:r>
+                        <a:t>5.0%</a:t>
+                      </a:r>
+                    </a:p>
+                  </a:txBody>
+                  <a:tcPr>
+                    <a:solidFill>
+                      <a:srgbClr val="151B2C"/>
+                    </a:solidFill>
+                  </a:tcPr>
+                </a:tc>
+                <a:tc>
+                  <a:txBody>
+                    <a:bodyPr/>
+                    <a:lstStyle/>
+                    <a:p>
+                      <a:pPr>
+                        <a:defRPr sz="1400" b="1">
+                          <a:solidFill>
+                            <a:srgbClr val="22C55E"/>
+                          </a:solidFill>
+                          <a:latin typeface="Arial"/>
+                        </a:defRPr>
+                      </a:pPr>
+                      <a:r>
+                        <a:t>9.5%</a:t>
+                      </a:r>
+                    </a:p>
+                  </a:txBody>
+                  <a:tcPr>
+                    <a:solidFill>
+                      <a:srgbClr val="151B2C"/>
+                    </a:solidFill>
+                  </a:tcPr>
+                </a:tc>
+                <a:tc>
+                  <a:txBody>
+                    <a:bodyPr/>
+                    <a:lstStyle/>
+                    <a:p>
+                      <a:pPr>
+                        <a:defRPr sz="1400" b="0">
+                          <a:solidFill>
+                            <a:srgbClr val="F8FAFC"/>
+                          </a:solidFill>
+                          <a:latin typeface="Arial"/>
+                        </a:defRPr>
+                      </a:pPr>
+                      <a:r>
+                        <a:t>Size Charts</a:t>
+                      </a:r>
+                    </a:p>
+                  </a:txBody>
+                  <a:tcPr>
+                    <a:solidFill>
+                      <a:srgbClr val="151B2C"/>
+                    </a:solidFill>
+                  </a:tcPr>
+                </a:tc>
+              </a:tr>
+              <a:tr h="914400">
+                <a:tc>
+                  <a:txBody>
+                    <a:bodyPr/>
+                    <a:lstStyle/>
+                    <a:p>
+                      <a:pPr>
+                        <a:defRPr sz="1400" b="1">
+                          <a:solidFill>
+                            <a:srgbClr val="F8FAFC"/>
+                          </a:solidFill>
+                          <a:latin typeface="Arial"/>
+                        </a:defRPr>
+                      </a:pPr>
+                      <a:r>
+                        <a:t>Pet Care</a:t>
+                      </a:r>
+                    </a:p>
+                  </a:txBody>
+                  <a:tcPr>
+                    <a:solidFill>
+                      <a:srgbClr val="151B2C"/>
+                    </a:solidFill>
+                  </a:tcPr>
+                </a:tc>
+                <a:tc>
+                  <a:txBody>
+                    <a:bodyPr/>
+                    <a:lstStyle/>
+                    <a:p>
+                      <a:pPr>
+                        <a:defRPr sz="1400" b="0">
+                          <a:solidFill>
+                            <a:srgbClr val="94A3B8"/>
+                          </a:solidFill>
+                          <a:latin typeface="Arial"/>
+                        </a:defRPr>
+                      </a:pPr>
+                      <a:r>
+                        <a:t>2.5%</a:t>
+                      </a:r>
+                    </a:p>
+                  </a:txBody>
+                  <a:tcPr>
+                    <a:solidFill>
+                      <a:srgbClr val="151B2C"/>
+                    </a:solidFill>
+                  </a:tcPr>
+                </a:tc>
+                <a:tc>
+                  <a:txBody>
+                    <a:bodyPr/>
+                    <a:lstStyle/>
+                    <a:p>
+                      <a:pPr>
+                        <a:defRPr sz="1400" b="1">
+                          <a:solidFill>
+                            <a:srgbClr val="FC8019"/>
+                          </a:solidFill>
+                          <a:latin typeface="Arial"/>
+                        </a:defRPr>
+                      </a:pPr>
+                      <a:r>
+                        <a:t>7.0%</a:t>
+                      </a:r>
+                    </a:p>
+                  </a:txBody>
+                  <a:tcPr>
+                    <a:solidFill>
+                      <a:srgbClr val="151B2C"/>
+                    </a:solidFill>
+                  </a:tcPr>
+                </a:tc>
+                <a:tc>
+                  <a:txBody>
+                    <a:bodyPr/>
+                    <a:lstStyle/>
+                    <a:p>
+                      <a:pPr>
+                        <a:defRPr sz="1400" b="1">
+                          <a:solidFill>
+                            <a:srgbClr val="22C55E"/>
+                          </a:solidFill>
+                          <a:latin typeface="Arial"/>
+                        </a:defRPr>
+                      </a:pPr>
+                      <a:r>
+                        <a:t>12.0%</a:t>
+                      </a:r>
+                    </a:p>
+                  </a:txBody>
+                  <a:tcPr>
+                    <a:solidFill>
+                      <a:srgbClr val="151B2C"/>
+                    </a:solidFill>
+                  </a:tcPr>
+                </a:tc>
+                <a:tc>
+                  <a:txBody>
+                    <a:bodyPr/>
+                    <a:lstStyle/>
+                    <a:p>
+                      <a:pPr>
+                        <a:defRPr sz="1400" b="0">
+                          <a:solidFill>
+                            <a:srgbClr val="F8FAFC"/>
+                          </a:solidFill>
+                          <a:latin typeface="Arial"/>
+                        </a:defRPr>
+                      </a:pPr>
+                      <a:r>
+                        <a:t>10m Dispatch</a:t>
+                      </a:r>
+                    </a:p>
+                  </a:txBody>
+                  <a:tcPr>
+                    <a:solidFill>
+                      <a:srgbClr val="151B2C"/>
+                    </a:solidFill>
+                  </a:tcPr>
+                </a:tc>
+              </a:tr>
+            </a:tbl>
+          </a:graphicData>
+        </a:graphic>
+      </p:graphicFrame>
+      <p:sp>
+        <p:nvSpPr>
+          <p:cNvPr id="6" name="Rounded Rectangle 5"/>
           <p:cNvSpPr/>
           <p:nvPr/>
         </p:nvSpPr>
         <p:spPr>
           <a:xfrm>
-            <a:off x="548640" y="1463040"/>
-            <a:ext cx="5303520" cy="4572000"/>
+            <a:off x="6217920" y="1463040"/>
+            <a:ext cx="5394960" cy="4572000"/>
           </a:xfrm>
           <a:prstGeom prst="roundRect">
             <a:avLst/>
@@ -8647,14 +9286,14 @@
       </p:sp>
       <p:sp>
         <p:nvSpPr>
-          <p:cNvPr id="6" name="TextBox 5"/>
+          <p:cNvPr id="7" name="TextBox 6"/>
           <p:cNvSpPr txBox="1"/>
           <p:nvPr/>
         </p:nvSpPr>
         <p:spPr>
           <a:xfrm>
-            <a:off x="685800" y="1600200"/>
-            <a:ext cx="5029200" cy="4297680"/>
+            <a:off x="6355080" y="1600200"/>
+            <a:ext cx="5120640" cy="4297680"/>
           </a:xfrm>
           <a:prstGeom prst="rect">
             <a:avLst/>
@@ -8679,7 +9318,7 @@
               </a:defRPr>
             </a:pPr>
             <a:r>
-              <a:t>North Star &amp; Leading Indicators</a:t>
+              <a:t>Metrics &amp; SLA Operational Guardrails</a:t>
             </a:r>
           </a:p>
           <a:p>
@@ -8699,7 +9338,7 @@
             </a:r>
             <a:br/>
             <a:r>
-              <a:t>% of post-checkout add-on recommendations checked out and delivered, out of all users exposed to the countdown timer. Target: 35% completion in 30 days.</a:t>
+              <a:t>Target: 35% completion rate in pilot dark stores within 30 days.</a:t>
             </a:r>
           </a:p>
           <a:p>
@@ -8715,15 +9354,15 @@
               </a:defRPr>
             </a:pPr>
             <a:r>
-              <a:t>• Leading Indicators (0-30 Days):</a:t>
+              <a:t>• Leading Success Indicators (0-30 Days):</a:t>
             </a:r>
             <a:br/>
             <a:r>
-              <a:t>  - Timer Conversion Rate: % of users who add at least 1 item. Target: &gt;25% in week 2.</a:t>
+              <a:t>  - Timer Conversion Rate: &gt;25% in week 2.</a:t>
             </a:r>
             <a:br/>
             <a:r>
-              <a:t>  - Platform Split Churn Delta: Shift in multi-app usage. Target: -5% churn to Zepto.</a:t>
+              <a:t>  - Platform Split Churn Delta: -5% churn to Zepto.</a:t>
             </a:r>
           </a:p>
           <a:p>
@@ -8739,61 +9378,20 @@
               </a:defRPr>
             </a:pPr>
             <a:r>
-              <a:t>• Lagging Indicators (30-90 Days):</a:t>
+              <a:t>• SLA Guardrail Thresholds (Daily Monitoring):</a:t>
             </a:r>
             <a:br/>
             <a:r>
-              <a:t>  - Average Order Value (AOV) Delta: Target +18% AOV lift among pilot cohort.</a:t>
+              <a:t>  - Rider Wait Time Delta: Keep &lt;+30 seconds. (If exceeded, drop timer window to 2 mins).</a:t>
             </a:r>
             <a:br/>
             <a:r>
-              <a:t>  - Auxiliary category penetration: Target 2x increase in personal care sales.</a:t>
-            </a:r>
-          </a:p>
-        </p:txBody>
-      </p:sp>
-      <p:sp>
-        <p:nvSpPr>
-          <p:cNvPr id="7" name="Rounded Rectangle 6"/>
-          <p:cNvSpPr/>
-          <p:nvPr/>
-        </p:nvSpPr>
-        <p:spPr>
-          <a:xfrm>
-            <a:off x="6217920" y="1463040"/>
-            <a:ext cx="5394960" cy="4572000"/>
-          </a:xfrm>
-          <a:prstGeom prst="roundRect">
-            <a:avLst/>
-          </a:prstGeom>
-          <a:solidFill>
-            <a:srgbClr val="151B2C"/>
-          </a:solidFill>
-          <a:ln w="12700">
-            <a:solidFill>
-              <a:srgbClr val="222B44"/>
-            </a:solidFill>
-          </a:ln>
-        </p:spPr>
-        <p:style>
-          <a:lnRef idx="1">
-            <a:schemeClr val="accent1"/>
-          </a:lnRef>
-          <a:fillRef idx="3">
-            <a:schemeClr val="accent1"/>
-          </a:fillRef>
-          <a:effectRef idx="2">
-            <a:schemeClr val="accent1"/>
-          </a:effectRef>
-          <a:fontRef idx="minor">
-            <a:schemeClr val="lt1"/>
-          </a:fontRef>
-        </p:style>
-        <p:txBody>
-          <a:bodyPr rtlCol="0" anchor="ctr"/>
-          <a:lstStyle/>
-          <a:p>
-            <a:pPr algn="ctr"/>
+              <a:t>  - Packer Picking SLA Delta: Keep &lt;+15 seconds.</a:t>
+            </a:r>
+            <a:br/>
+            <a:r>
+              <a:t>  - Recommendation Hide Rate: Keep &lt;5% rejection.</a:t>
+            </a:r>
           </a:p>
         </p:txBody>
       </p:sp>
@@ -8805,8 +9403,8 @@
         </p:nvSpPr>
         <p:spPr>
           <a:xfrm>
-            <a:off x="6355080" y="1600200"/>
-            <a:ext cx="5120640" cy="4297680"/>
+            <a:off x="548640" y="6400800"/>
+            <a:ext cx="9144000" cy="274320"/>
           </a:xfrm>
           <a:prstGeom prst="rect">
             <a:avLst/>
@@ -8814,121 +9412,6 @@
           <a:noFill/>
         </p:spPr>
         <p:txBody>
-          <a:bodyPr wrap="square">
-            <a:spAutoFit/>
-          </a:bodyPr>
-          <a:lstStyle/>
-          <a:p>
-            <a:pPr>
-              <a:spcAft>
-                <a:spcPts val="1000"/>
-              </a:spcAft>
-              <a:defRPr sz="1500" b="1">
-                <a:solidFill>
-                  <a:srgbClr val="FC8019"/>
-                </a:solidFill>
-                <a:latin typeface="Arial"/>
-              </a:defRPr>
-            </a:pPr>
-            <a:r>
-              <a:t>SLA Operational Guardrail Metrics</a:t>
-            </a:r>
-          </a:p>
-          <a:p>
-            <a:pPr>
-              <a:spcAft>
-                <a:spcPts val="800"/>
-              </a:spcAft>
-              <a:defRPr sz="1400">
-                <a:solidFill>
-                  <a:srgbClr val="F8FAFC"/>
-                </a:solidFill>
-                <a:latin typeface="Arial"/>
-              </a:defRPr>
-            </a:pPr>
-            <a:r>
-              <a:t>We track four operational guardrails daily to guarantee the core delivery promise is not broken:</a:t>
-            </a:r>
-          </a:p>
-          <a:p>
-            <a:pPr>
-              <a:spcAft>
-                <a:spcPts val="800"/>
-              </a:spcAft>
-              <a:defRPr sz="1400">
-                <a:solidFill>
-                  <a:srgbClr val="F8FAFC"/>
-                </a:solidFill>
-                <a:latin typeface="Arial"/>
-              </a:defRPr>
-            </a:pPr>
-            <a:r>
-              <a:t>• Rider Wait Time Delta: Target: &lt;+30 seconds.</a:t>
-            </a:r>
-            <a:br/>
-            <a:r>
-              <a:t>Measures delay in rider departure from dark store after package handoff. If delta exceeds 45s, decrease add-on window from 3 to 2 minutes.</a:t>
-            </a:r>
-          </a:p>
-          <a:p>
-            <a:pPr>
-              <a:spcAft>
-                <a:spcPts val="800"/>
-              </a:spcAft>
-              <a:defRPr sz="1400">
-                <a:solidFill>
-                  <a:srgbClr val="F8FAFC"/>
-                </a:solidFill>
-                <a:latin typeface="Arial"/>
-              </a:defRPr>
-            </a:pPr>
-            <a:r>
-              <a:t>• Packer Picking SLA Delta: Target: &lt;+15 seconds.</a:t>
-            </a:r>
-            <a:br/>
-            <a:r>
-              <a:t>Measures packer time to add append item to bag.</a:t>
-            </a:r>
-          </a:p>
-          <a:p>
-            <a:pPr>
-              <a:spcAft>
-                <a:spcPts val="800"/>
-              </a:spcAft>
-              <a:defRPr sz="1400">
-                <a:solidFill>
-                  <a:srgbClr val="F8FAFC"/>
-                </a:solidFill>
-                <a:latin typeface="Arial"/>
-              </a:defRPr>
-            </a:pPr>
-            <a:r>
-              <a:t>• Delivery SLA Breach Rate: Target: 0% change.</a:t>
-            </a:r>
-            <a:br/>
-            <a:r>
-              <a:t>• Recommendation Hide Rate: Target: &lt;5% rejection.</a:t>
-            </a:r>
-          </a:p>
-        </p:txBody>
-      </p:sp>
-      <p:sp>
-        <p:nvSpPr>
-          <p:cNvPr id="9" name="TextBox 8"/>
-          <p:cNvSpPr txBox="1"/>
-          <p:nvPr/>
-        </p:nvSpPr>
-        <p:spPr>
-          <a:xfrm>
-            <a:off x="548640" y="6400800"/>
-            <a:ext cx="9144000" cy="274320"/>
-          </a:xfrm>
-          <a:prstGeom prst="rect">
-            <a:avLst/>
-          </a:prstGeom>
-          <a:noFill/>
-        </p:spPr>
-        <p:txBody>
           <a:bodyPr wrap="none">
             <a:spAutoFit/>
           </a:bodyPr>
@@ -8950,7 +9433,7 @@
       </p:sp>
       <p:sp>
         <p:nvSpPr>
-          <p:cNvPr id="10" name="TextBox 9"/>
+          <p:cNvPr id="9" name="TextBox 8"/>
           <p:cNvSpPr txBox="1"/>
           <p:nvPr/>
         </p:nvSpPr>

</xml_diff>

<commit_message>
Optimize slide decks: compile exactly 10 slides max and integrate all 14 mentor evaluation requirements
</commit_message>
<xml_diff>
--- a/NL Swiggy Instamart.pptx
+++ b/NL Swiggy Instamart.pptx
@@ -3221,7 +3221,7 @@
         <p:spPr>
           <a:xfrm>
             <a:off x="548640" y="1463040"/>
-            <a:ext cx="5303520" cy="2103120"/>
+            <a:ext cx="5303520" cy="2011680"/>
           </a:xfrm>
           <a:prstGeom prst="roundRect">
             <a:avLst/>
@@ -3266,7 +3266,7 @@
         <p:spPr>
           <a:xfrm>
             <a:off x="685800" y="1600200"/>
-            <a:ext cx="5029200" cy="1828800"/>
+            <a:ext cx="5029200" cy="1737360"/>
           </a:xfrm>
           <a:prstGeom prst="rect">
             <a:avLst/>
@@ -3291,7 +3291,7 @@
               </a:defRPr>
             </a:pPr>
             <a:r>
-              <a:t>CORE ISSUE</a:t>
+              <a:t>WHY NOW? (Strategic Context)</a:t>
             </a:r>
           </a:p>
           <a:p>
@@ -3307,7 +3307,7 @@
               </a:defRPr>
             </a:pPr>
             <a:r>
-              <a:t>Despite high daily transaction frequency, a meaningful share of Swiggy Instamart ordering is anchored to repeat dairy and bread histories. Users bypass the homepage, checking out without discovering high-margin categories.</a:t>
+              <a:t>Instamart already owns high-frequency grocery behavior. Increasing category breadth improves Customer Lifetime Value (LTV) without increasing user acquisition costs (CAC).</a:t>
             </a:r>
           </a:p>
         </p:txBody>
@@ -3320,8 +3320,8 @@
         </p:nvSpPr>
         <p:spPr>
           <a:xfrm>
-            <a:off x="548640" y="3749039"/>
-            <a:ext cx="5303520" cy="2377440"/>
+            <a:off x="548640" y="3657600"/>
+            <a:ext cx="5303520" cy="2468880"/>
           </a:xfrm>
           <a:prstGeom prst="roundRect">
             <a:avLst/>
@@ -3365,8 +3365,8 @@
         </p:nvSpPr>
         <p:spPr>
           <a:xfrm>
-            <a:off x="685800" y="3886199"/>
-            <a:ext cx="5029200" cy="2103120"/>
+            <a:off x="685800" y="3794760"/>
+            <a:ext cx="5029200" cy="2194560"/>
           </a:xfrm>
           <a:prstGeom prst="rect">
             <a:avLst/>
@@ -3707,7 +3707,7 @@
               </a:defRPr>
             </a:pPr>
             <a:r>
-              <a:t>Swiggy Instamart Growth Team Portfolio | Category Expansion Initiative</a:t>
+              <a:t>Swiggy Instamart Growth Portfolio | AI Product Discovery Engine</a:t>
             </a:r>
           </a:p>
         </p:txBody>
@@ -3840,7 +3840,7 @@
               </a:defRPr>
             </a:pPr>
             <a:r>
-              <a:t>PART 4 · RISKS &amp; TECH SUMMARY</a:t>
+              <a:t>PART 4 · SUCCESS &amp; RISKS</a:t>
             </a:r>
           </a:p>
         </p:txBody>
@@ -3876,21 +3876,660 @@
               </a:defRPr>
             </a:pPr>
             <a:r>
-              <a:t>GTM Risk Matrix &amp; Technical Appendix A/B Summary</a:t>
-            </a:r>
-          </a:p>
-        </p:txBody>
-      </p:sp>
-      <p:sp>
-        <p:nvSpPr>
-          <p:cNvPr id="5" name="Rounded Rectangle 4"/>
+              <a:t>Success Metrics, Formula &amp; GTM Risks</a:t>
+            </a:r>
+          </a:p>
+        </p:txBody>
+      </p:sp>
+      <p:graphicFrame>
+        <p:nvGraphicFramePr>
+          <p:cNvPr id="5" name="Table 4"/>
+          <p:cNvGraphicFramePr>
+            <a:graphicFrameLocks noGrp="1"/>
+          </p:cNvGraphicFramePr>
+          <p:nvPr/>
+        </p:nvGraphicFramePr>
+        <p:xfrm>
+          <a:off x="548640" y="1463040"/>
+          <a:ext cx="5486400" cy="2743200"/>
+        </p:xfrm>
+        <a:graphic>
+          <a:graphicData uri="http://schemas.openxmlformats.org/drawingml/2006/table">
+            <a:tbl>
+              <a:tblPr firstRow="1" bandRow="1">
+                <a:tableStyleId>{5C22544A-7EE6-4342-B048-85BDC9FD1C3A}</a:tableStyleId>
+              </a:tblPr>
+              <a:tblGrid>
+                <a:gridCol w="1554480"/>
+                <a:gridCol w="731520"/>
+                <a:gridCol w="1005840"/>
+                <a:gridCol w="1005840"/>
+                <a:gridCol w="1188720"/>
+              </a:tblGrid>
+              <a:tr h="548640">
+                <a:tc>
+                  <a:txBody>
+                    <a:bodyPr/>
+                    <a:lstStyle/>
+                    <a:p>
+                      <a:pPr>
+                        <a:defRPr sz="1400" b="1">
+                          <a:solidFill>
+                            <a:srgbClr val="F8FAFC"/>
+                          </a:solidFill>
+                          <a:latin typeface="Arial"/>
+                        </a:defRPr>
+                      </a:pPr>
+                      <a:r>
+                        <a:t>Category</a:t>
+                      </a:r>
+                    </a:p>
+                  </a:txBody>
+                  <a:tcPr>
+                    <a:solidFill>
+                      <a:srgbClr val="222B44"/>
+                    </a:solidFill>
+                  </a:tcPr>
+                </a:tc>
+                <a:tc>
+                  <a:txBody>
+                    <a:bodyPr/>
+                    <a:lstStyle/>
+                    <a:p>
+                      <a:pPr>
+                        <a:defRPr sz="1400" b="1">
+                          <a:solidFill>
+                            <a:srgbClr val="F8FAFC"/>
+                          </a:solidFill>
+                          <a:latin typeface="Arial"/>
+                        </a:defRPr>
+                      </a:pPr>
+                      <a:r>
+                        <a:t>Base</a:t>
+                      </a:r>
+                    </a:p>
+                  </a:txBody>
+                  <a:tcPr>
+                    <a:solidFill>
+                      <a:srgbClr val="222B44"/>
+                    </a:solidFill>
+                  </a:tcPr>
+                </a:tc>
+                <a:tc>
+                  <a:txBody>
+                    <a:bodyPr/>
+                    <a:lstStyle/>
+                    <a:p>
+                      <a:pPr>
+                        <a:defRPr sz="1400" b="1">
+                          <a:solidFill>
+                            <a:srgbClr val="F8FAFC"/>
+                          </a:solidFill>
+                          <a:latin typeface="Arial"/>
+                        </a:defRPr>
+                      </a:pPr>
+                      <a:r>
+                        <a:t>Target 30D</a:t>
+                      </a:r>
+                    </a:p>
+                  </a:txBody>
+                  <a:tcPr>
+                    <a:solidFill>
+                      <a:srgbClr val="222B44"/>
+                    </a:solidFill>
+                  </a:tcPr>
+                </a:tc>
+                <a:tc>
+                  <a:txBody>
+                    <a:bodyPr/>
+                    <a:lstStyle/>
+                    <a:p>
+                      <a:pPr>
+                        <a:defRPr sz="1400" b="1">
+                          <a:solidFill>
+                            <a:srgbClr val="F8FAFC"/>
+                          </a:solidFill>
+                          <a:latin typeface="Arial"/>
+                        </a:defRPr>
+                      </a:pPr>
+                      <a:r>
+                        <a:t>Target 90D</a:t>
+                      </a:r>
+                    </a:p>
+                  </a:txBody>
+                  <a:tcPr>
+                    <a:solidFill>
+                      <a:srgbClr val="222B44"/>
+                    </a:solidFill>
+                  </a:tcPr>
+                </a:tc>
+                <a:tc>
+                  <a:txBody>
+                    <a:bodyPr/>
+                    <a:lstStyle/>
+                    <a:p>
+                      <a:pPr>
+                        <a:defRPr sz="1400" b="1">
+                          <a:solidFill>
+                            <a:srgbClr val="F8FAFC"/>
+                          </a:solidFill>
+                          <a:latin typeface="Arial"/>
+                        </a:defRPr>
+                      </a:pPr>
+                      <a:r>
+                        <a:t>Friction Solved</a:t>
+                      </a:r>
+                    </a:p>
+                  </a:txBody>
+                  <a:tcPr>
+                    <a:solidFill>
+                      <a:srgbClr val="222B44"/>
+                    </a:solidFill>
+                  </a:tcPr>
+                </a:tc>
+              </a:tr>
+              <a:tr h="548640">
+                <a:tc>
+                  <a:txBody>
+                    <a:bodyPr/>
+                    <a:lstStyle/>
+                    <a:p>
+                      <a:pPr>
+                        <a:defRPr sz="1400" b="1">
+                          <a:solidFill>
+                            <a:srgbClr val="F8FAFC"/>
+                          </a:solidFill>
+                          <a:latin typeface="Arial"/>
+                        </a:defRPr>
+                      </a:pPr>
+                      <a:r>
+                        <a:t>Gourmet</a:t>
+                      </a:r>
+                    </a:p>
+                  </a:txBody>
+                  <a:tcPr>
+                    <a:solidFill>
+                      <a:srgbClr val="151B2C"/>
+                    </a:solidFill>
+                  </a:tcPr>
+                </a:tc>
+                <a:tc>
+                  <a:txBody>
+                    <a:bodyPr/>
+                    <a:lstStyle/>
+                    <a:p>
+                      <a:pPr>
+                        <a:defRPr sz="1400" b="0">
+                          <a:solidFill>
+                            <a:srgbClr val="94A3B8"/>
+                          </a:solidFill>
+                          <a:latin typeface="Arial"/>
+                        </a:defRPr>
+                      </a:pPr>
+                      <a:r>
+                        <a:t>4.2%</a:t>
+                      </a:r>
+                    </a:p>
+                  </a:txBody>
+                  <a:tcPr>
+                    <a:solidFill>
+                      <a:srgbClr val="151B2C"/>
+                    </a:solidFill>
+                  </a:tcPr>
+                </a:tc>
+                <a:tc>
+                  <a:txBody>
+                    <a:bodyPr/>
+                    <a:lstStyle/>
+                    <a:p>
+                      <a:pPr>
+                        <a:defRPr sz="1400" b="1">
+                          <a:solidFill>
+                            <a:srgbClr val="FC8019"/>
+                          </a:solidFill>
+                          <a:latin typeface="Arial"/>
+                        </a:defRPr>
+                      </a:pPr>
+                      <a:r>
+                        <a:t>12.0%</a:t>
+                      </a:r>
+                    </a:p>
+                  </a:txBody>
+                  <a:tcPr>
+                    <a:solidFill>
+                      <a:srgbClr val="151B2C"/>
+                    </a:solidFill>
+                  </a:tcPr>
+                </a:tc>
+                <a:tc>
+                  <a:txBody>
+                    <a:bodyPr/>
+                    <a:lstStyle/>
+                    <a:p>
+                      <a:pPr>
+                        <a:defRPr sz="1400" b="1">
+                          <a:solidFill>
+                            <a:srgbClr val="22C55E"/>
+                          </a:solidFill>
+                          <a:latin typeface="Arial"/>
+                        </a:defRPr>
+                      </a:pPr>
+                      <a:r>
+                        <a:t>18.5%</a:t>
+                      </a:r>
+                    </a:p>
+                  </a:txBody>
+                  <a:tcPr>
+                    <a:solidFill>
+                      <a:srgbClr val="151B2C"/>
+                    </a:solidFill>
+                  </a:tcPr>
+                </a:tc>
+                <a:tc>
+                  <a:txBody>
+                    <a:bodyPr/>
+                    <a:lstStyle/>
+                    <a:p>
+                      <a:pPr>
+                        <a:defRPr sz="1400" b="0">
+                          <a:solidFill>
+                            <a:srgbClr val="F8FAFC"/>
+                          </a:solidFill>
+                          <a:latin typeface="Arial"/>
+                        </a:defRPr>
+                      </a:pPr>
+                      <a:r>
+                        <a:t>Delivery Fee</a:t>
+                      </a:r>
+                    </a:p>
+                  </a:txBody>
+                  <a:tcPr>
+                    <a:solidFill>
+                      <a:srgbClr val="151B2C"/>
+                    </a:solidFill>
+                  </a:tcPr>
+                </a:tc>
+              </a:tr>
+              <a:tr h="548640">
+                <a:tc>
+                  <a:txBody>
+                    <a:bodyPr/>
+                    <a:lstStyle/>
+                    <a:p>
+                      <a:pPr>
+                        <a:defRPr sz="1400" b="1">
+                          <a:solidFill>
+                            <a:srgbClr val="F8FAFC"/>
+                          </a:solidFill>
+                          <a:latin typeface="Arial"/>
+                        </a:defRPr>
+                      </a:pPr>
+                      <a:r>
+                        <a:t>Personal Care</a:t>
+                      </a:r>
+                    </a:p>
+                  </a:txBody>
+                  <a:tcPr>
+                    <a:solidFill>
+                      <a:srgbClr val="151B2C"/>
+                    </a:solidFill>
+                  </a:tcPr>
+                </a:tc>
+                <a:tc>
+                  <a:txBody>
+                    <a:bodyPr/>
+                    <a:lstStyle/>
+                    <a:p>
+                      <a:pPr>
+                        <a:defRPr sz="1400" b="0">
+                          <a:solidFill>
+                            <a:srgbClr val="94A3B8"/>
+                          </a:solidFill>
+                          <a:latin typeface="Arial"/>
+                        </a:defRPr>
+                      </a:pPr>
+                      <a:r>
+                        <a:t>3.1%</a:t>
+                      </a:r>
+                    </a:p>
+                  </a:txBody>
+                  <a:tcPr>
+                    <a:solidFill>
+                      <a:srgbClr val="151B2C"/>
+                    </a:solidFill>
+                  </a:tcPr>
+                </a:tc>
+                <a:tc>
+                  <a:txBody>
+                    <a:bodyPr/>
+                    <a:lstStyle/>
+                    <a:p>
+                      <a:pPr>
+                        <a:defRPr sz="1400" b="1">
+                          <a:solidFill>
+                            <a:srgbClr val="FC8019"/>
+                          </a:solidFill>
+                          <a:latin typeface="Arial"/>
+                        </a:defRPr>
+                      </a:pPr>
+                      <a:r>
+                        <a:t>8.5%</a:t>
+                      </a:r>
+                    </a:p>
+                  </a:txBody>
+                  <a:tcPr>
+                    <a:solidFill>
+                      <a:srgbClr val="151B2C"/>
+                    </a:solidFill>
+                  </a:tcPr>
+                </a:tc>
+                <a:tc>
+                  <a:txBody>
+                    <a:bodyPr/>
+                    <a:lstStyle/>
+                    <a:p>
+                      <a:pPr>
+                        <a:defRPr sz="1400" b="1">
+                          <a:solidFill>
+                            <a:srgbClr val="22C55E"/>
+                          </a:solidFill>
+                          <a:latin typeface="Arial"/>
+                        </a:defRPr>
+                      </a:pPr>
+                      <a:r>
+                        <a:t>14.0%</a:t>
+                      </a:r>
+                    </a:p>
+                  </a:txBody>
+                  <a:tcPr>
+                    <a:solidFill>
+                      <a:srgbClr val="151B2C"/>
+                    </a:solidFill>
+                  </a:tcPr>
+                </a:tc>
+                <a:tc>
+                  <a:txBody>
+                    <a:bodyPr/>
+                    <a:lstStyle/>
+                    <a:p>
+                      <a:pPr>
+                        <a:defRPr sz="1400" b="0">
+                          <a:solidFill>
+                            <a:srgbClr val="F8FAFC"/>
+                          </a:solidFill>
+                          <a:latin typeface="Arial"/>
+                        </a:defRPr>
+                      </a:pPr>
+                      <a:r>
+                        <a:t>Delivery Fee</a:t>
+                      </a:r>
+                    </a:p>
+                  </a:txBody>
+                  <a:tcPr>
+                    <a:solidFill>
+                      <a:srgbClr val="151B2C"/>
+                    </a:solidFill>
+                  </a:tcPr>
+                </a:tc>
+              </a:tr>
+              <a:tr h="548640">
+                <a:tc>
+                  <a:txBody>
+                    <a:bodyPr/>
+                    <a:lstStyle/>
+                    <a:p>
+                      <a:pPr>
+                        <a:defRPr sz="1400" b="1">
+                          <a:solidFill>
+                            <a:srgbClr val="F8FAFC"/>
+                          </a:solidFill>
+                          <a:latin typeface="Arial"/>
+                        </a:defRPr>
+                      </a:pPr>
+                      <a:r>
+                        <a:t>Baby Care</a:t>
+                      </a:r>
+                    </a:p>
+                  </a:txBody>
+                  <a:tcPr>
+                    <a:solidFill>
+                      <a:srgbClr val="151B2C"/>
+                    </a:solidFill>
+                  </a:tcPr>
+                </a:tc>
+                <a:tc>
+                  <a:txBody>
+                    <a:bodyPr/>
+                    <a:lstStyle/>
+                    <a:p>
+                      <a:pPr>
+                        <a:defRPr sz="1400" b="0">
+                          <a:solidFill>
+                            <a:srgbClr val="94A3B8"/>
+                          </a:solidFill>
+                          <a:latin typeface="Arial"/>
+                        </a:defRPr>
+                      </a:pPr>
+                      <a:r>
+                        <a:t>1.8%</a:t>
+                      </a:r>
+                    </a:p>
+                  </a:txBody>
+                  <a:tcPr>
+                    <a:solidFill>
+                      <a:srgbClr val="151B2C"/>
+                    </a:solidFill>
+                  </a:tcPr>
+                </a:tc>
+                <a:tc>
+                  <a:txBody>
+                    <a:bodyPr/>
+                    <a:lstStyle/>
+                    <a:p>
+                      <a:pPr>
+                        <a:defRPr sz="1400" b="1">
+                          <a:solidFill>
+                            <a:srgbClr val="FC8019"/>
+                          </a:solidFill>
+                          <a:latin typeface="Arial"/>
+                        </a:defRPr>
+                      </a:pPr>
+                      <a:r>
+                        <a:t>5.0%</a:t>
+                      </a:r>
+                    </a:p>
+                  </a:txBody>
+                  <a:tcPr>
+                    <a:solidFill>
+                      <a:srgbClr val="151B2C"/>
+                    </a:solidFill>
+                  </a:tcPr>
+                </a:tc>
+                <a:tc>
+                  <a:txBody>
+                    <a:bodyPr/>
+                    <a:lstStyle/>
+                    <a:p>
+                      <a:pPr>
+                        <a:defRPr sz="1400" b="1">
+                          <a:solidFill>
+                            <a:srgbClr val="22C55E"/>
+                          </a:solidFill>
+                          <a:latin typeface="Arial"/>
+                        </a:defRPr>
+                      </a:pPr>
+                      <a:r>
+                        <a:t>9.5%</a:t>
+                      </a:r>
+                    </a:p>
+                  </a:txBody>
+                  <a:tcPr>
+                    <a:solidFill>
+                      <a:srgbClr val="151B2C"/>
+                    </a:solidFill>
+                  </a:tcPr>
+                </a:tc>
+                <a:tc>
+                  <a:txBody>
+                    <a:bodyPr/>
+                    <a:lstStyle/>
+                    <a:p>
+                      <a:pPr>
+                        <a:defRPr sz="1400" b="0">
+                          <a:solidFill>
+                            <a:srgbClr val="F8FAFC"/>
+                          </a:solidFill>
+                          <a:latin typeface="Arial"/>
+                        </a:defRPr>
+                      </a:pPr>
+                      <a:r>
+                        <a:t>Size Charts</a:t>
+                      </a:r>
+                    </a:p>
+                  </a:txBody>
+                  <a:tcPr>
+                    <a:solidFill>
+                      <a:srgbClr val="151B2C"/>
+                    </a:solidFill>
+                  </a:tcPr>
+                </a:tc>
+              </a:tr>
+              <a:tr h="548640">
+                <a:tc>
+                  <a:txBody>
+                    <a:bodyPr/>
+                    <a:lstStyle/>
+                    <a:p>
+                      <a:pPr>
+                        <a:defRPr sz="1400" b="1">
+                          <a:solidFill>
+                            <a:srgbClr val="F8FAFC"/>
+                          </a:solidFill>
+                          <a:latin typeface="Arial"/>
+                        </a:defRPr>
+                      </a:pPr>
+                      <a:r>
+                        <a:t>Pet Care</a:t>
+                      </a:r>
+                    </a:p>
+                  </a:txBody>
+                  <a:tcPr>
+                    <a:solidFill>
+                      <a:srgbClr val="151B2C"/>
+                    </a:solidFill>
+                  </a:tcPr>
+                </a:tc>
+                <a:tc>
+                  <a:txBody>
+                    <a:bodyPr/>
+                    <a:lstStyle/>
+                    <a:p>
+                      <a:pPr>
+                        <a:defRPr sz="1400" b="0">
+                          <a:solidFill>
+                            <a:srgbClr val="94A3B8"/>
+                          </a:solidFill>
+                          <a:latin typeface="Arial"/>
+                        </a:defRPr>
+                      </a:pPr>
+                      <a:r>
+                        <a:t>2.5%</a:t>
+                      </a:r>
+                    </a:p>
+                  </a:txBody>
+                  <a:tcPr>
+                    <a:solidFill>
+                      <a:srgbClr val="151B2C"/>
+                    </a:solidFill>
+                  </a:tcPr>
+                </a:tc>
+                <a:tc>
+                  <a:txBody>
+                    <a:bodyPr/>
+                    <a:lstStyle/>
+                    <a:p>
+                      <a:pPr>
+                        <a:defRPr sz="1400" b="1">
+                          <a:solidFill>
+                            <a:srgbClr val="FC8019"/>
+                          </a:solidFill>
+                          <a:latin typeface="Arial"/>
+                        </a:defRPr>
+                      </a:pPr>
+                      <a:r>
+                        <a:t>7.0%</a:t>
+                      </a:r>
+                    </a:p>
+                  </a:txBody>
+                  <a:tcPr>
+                    <a:solidFill>
+                      <a:srgbClr val="151B2C"/>
+                    </a:solidFill>
+                  </a:tcPr>
+                </a:tc>
+                <a:tc>
+                  <a:txBody>
+                    <a:bodyPr/>
+                    <a:lstStyle/>
+                    <a:p>
+                      <a:pPr>
+                        <a:defRPr sz="1400" b="1">
+                          <a:solidFill>
+                            <a:srgbClr val="22C55E"/>
+                          </a:solidFill>
+                          <a:latin typeface="Arial"/>
+                        </a:defRPr>
+                      </a:pPr>
+                      <a:r>
+                        <a:t>12.0%</a:t>
+                      </a:r>
+                    </a:p>
+                  </a:txBody>
+                  <a:tcPr>
+                    <a:solidFill>
+                      <a:srgbClr val="151B2C"/>
+                    </a:solidFill>
+                  </a:tcPr>
+                </a:tc>
+                <a:tc>
+                  <a:txBody>
+                    <a:bodyPr/>
+                    <a:lstStyle/>
+                    <a:p>
+                      <a:pPr>
+                        <a:defRPr sz="1400" b="0">
+                          <a:solidFill>
+                            <a:srgbClr val="F8FAFC"/>
+                          </a:solidFill>
+                          <a:latin typeface="Arial"/>
+                        </a:defRPr>
+                      </a:pPr>
+                      <a:r>
+                        <a:t>10m Dispatch</a:t>
+                      </a:r>
+                    </a:p>
+                  </a:txBody>
+                  <a:tcPr>
+                    <a:solidFill>
+                      <a:srgbClr val="151B2C"/>
+                    </a:solidFill>
+                  </a:tcPr>
+                </a:tc>
+              </a:tr>
+            </a:tbl>
+          </a:graphicData>
+        </a:graphic>
+      </p:graphicFrame>
+      <p:sp>
+        <p:nvSpPr>
+          <p:cNvPr id="6" name="Rounded Rectangle 5"/>
           <p:cNvSpPr/>
           <p:nvPr/>
         </p:nvSpPr>
         <p:spPr>
           <a:xfrm>
-            <a:off x="548640" y="1463040"/>
-            <a:ext cx="5303520" cy="4572000"/>
+            <a:off x="548640" y="4297680"/>
+            <a:ext cx="5486400" cy="1737360"/>
           </a:xfrm>
           <a:prstGeom prst="roundRect">
             <a:avLst/>
@@ -3928,14 +4567,14 @@
       </p:sp>
       <p:sp>
         <p:nvSpPr>
-          <p:cNvPr id="6" name="TextBox 5"/>
+          <p:cNvPr id="7" name="TextBox 6"/>
           <p:cNvSpPr txBox="1"/>
           <p:nvPr/>
         </p:nvSpPr>
         <p:spPr>
           <a:xfrm>
-            <a:off x="685800" y="1600200"/>
-            <a:ext cx="5029200" cy="4297680"/>
+            <a:off x="685800" y="4434840"/>
+            <a:ext cx="5212080" cy="1463040"/>
           </a:xfrm>
           <a:prstGeom prst="rect">
             <a:avLst/>
@@ -3960,7 +4599,7 @@
               </a:defRPr>
             </a:pPr>
             <a:r>
-              <a:t>GTM Risk Mitigation Matrix</a:t>
+              <a:t>SUCCESS FORMULA DEFINITION</a:t>
             </a:r>
           </a:p>
           <a:p>
@@ -3976,78 +4615,18 @@
               </a:defRPr>
             </a:pPr>
             <a:r>
-              <a:t>• Recommendation Fatigue:</a:t>
+              <a:t>Cross-Category Purchase Rate =</a:t>
             </a:r>
             <a:br/>
             <a:r>
-              <a:t>Mitigation: Enforce daily frequency caps (max 2 displays/user).</a:t>
-            </a:r>
-          </a:p>
-          <a:p>
-            <a:pPr>
-              <a:spcAft>
-                <a:spcPts val="800"/>
-              </a:spcAft>
-              <a:defRPr sz="1400">
-                <a:solidFill>
-                  <a:srgbClr val="F8FAFC"/>
-                </a:solidFill>
-                <a:latin typeface="Arial"/>
-              </a:defRPr>
-            </a:pPr>
-            <a:r>
-              <a:t>• Wrong Recommendations:</a:t>
-            </a:r>
-            <a:br/>
-            <a:r>
-              <a:t>Mitigation: Continuous AI feedback training loops from hides.</a:t>
-            </a:r>
-          </a:p>
-          <a:p>
-            <a:pPr>
-              <a:spcAft>
-                <a:spcPts val="800"/>
-              </a:spcAft>
-              <a:defRPr sz="1400">
-                <a:solidFill>
-                  <a:srgbClr val="F8FAFC"/>
-                </a:solidFill>
-                <a:latin typeface="Arial"/>
-              </a:defRPr>
-            </a:pPr>
-            <a:r>
-              <a:t>• Slower Checkout / Slower Delivery:</a:t>
-            </a:r>
-            <a:br/>
-            <a:r>
-              <a:t>Mitigation: One-click append checkout button.</a:t>
-            </a:r>
-          </a:p>
-          <a:p>
-            <a:pPr>
-              <a:spcAft>
-                <a:spcPts val="800"/>
-              </a:spcAft>
-              <a:defRPr sz="1400">
-                <a:solidFill>
-                  <a:srgbClr val="F8FAFC"/>
-                </a:solidFill>
-                <a:latin typeface="Arial"/>
-              </a:defRPr>
-            </a:pPr>
-            <a:r>
-              <a:t>• Delivery Delay at Dark Store:</a:t>
-            </a:r>
-            <a:br/>
-            <a:r>
-              <a:t>Mitigation: Automatic packer lockout gate once picking begins.</a:t>
-            </a:r>
-          </a:p>
-        </p:txBody>
-      </p:sp>
-      <p:sp>
-        <p:nvSpPr>
-          <p:cNvPr id="7" name="Rounded Rectangle 6"/>
+              <a:t>[Users purchasing ≥1 new category] ÷ [Monthly Active Customers]</a:t>
+            </a:r>
+          </a:p>
+        </p:txBody>
+      </p:sp>
+      <p:sp>
+        <p:nvSpPr>
+          <p:cNvPr id="8" name="Rounded Rectangle 7"/>
           <p:cNvSpPr/>
           <p:nvPr/>
         </p:nvSpPr>
@@ -4092,7 +4671,7 @@
       </p:sp>
       <p:sp>
         <p:nvSpPr>
-          <p:cNvPr id="8" name="TextBox 7"/>
+          <p:cNvPr id="9" name="TextBox 8"/>
           <p:cNvSpPr txBox="1"/>
           <p:nvPr/>
         </p:nvSpPr>
@@ -4124,7 +4703,7 @@
               </a:defRPr>
             </a:pPr>
             <a:r>
-              <a:t>Technical Appendix A &amp; B Summary</a:t>
+              <a:t>Success Metrics &amp; SLA Operational Guardrails</a:t>
             </a:r>
           </a:p>
           <a:p>
@@ -4140,11 +4719,7 @@
               </a:defRPr>
             </a:pPr>
             <a:r>
-              <a:t>• SQLite Relational Database (reviews.db):</a:t>
-            </a:r>
-            <a:br/>
-            <a:r>
-              <a:t>Relational storage holds scraper inputs, sentiments, and ICE priorities. Columns are dynamically synced with FastAPI REST routes.</a:t>
+              <a:t>• North Star Metric: Cross-Category Discovery Completion Rate (Target: 35% in 30 days).</a:t>
             </a:r>
           </a:p>
           <a:p>
@@ -4160,11 +4735,23 @@
               </a:defRPr>
             </a:pPr>
             <a:r>
-              <a:t>• 7-Agent Ingestion Pipeline:</a:t>
+              <a:t>• SLA Guardrails (Daily Monitoring):</a:t>
             </a:r>
             <a:br/>
             <a:r>
-              <a:t>Orchestrates translation dictionaries (converting Hinglish to standard English), cleaning parameters, and K-Means text clustering.</a:t>
+              <a:t>  - Customer Retention SLA Delta: Keep &gt;98%.</a:t>
+            </a:r>
+            <a:br/>
+            <a:r>
+              <a:t>  - Delivery SLA Breach Rate: Keep 0% change.</a:t>
+            </a:r>
+            <a:br/>
+            <a:r>
+              <a:t>  - Packing Time Delta: Keep &lt;+15s.</a:t>
+            </a:r>
+            <a:br/>
+            <a:r>
+              <a:t>  - Order Cancellation Rate: Keep &lt;1% change.</a:t>
             </a:r>
           </a:p>
           <a:p>
@@ -4180,14 +4767,22 @@
               </a:defRPr>
             </a:pPr>
             <a:r>
-              <a:t>• Visual layout maps (schema, n8n flow) are committed in docs/user_research/ directory.</a:t>
-            </a:r>
-          </a:p>
-        </p:txBody>
-      </p:sp>
-      <p:sp>
-        <p:nvSpPr>
-          <p:cNvPr id="9" name="TextBox 8"/>
+              <a:t>• Business Indicators (30-90 Days):</a:t>
+            </a:r>
+            <a:br/>
+            <a:r>
+              <a:t>  - Average Order Value (AOV) Delta: Target +18%.</a:t>
+            </a:r>
+            <a:br/>
+            <a:r>
+              <a:t>  - Revenue Per User / Contribution Margin Delta: Target +12% lift.</a:t>
+            </a:r>
+          </a:p>
+        </p:txBody>
+      </p:sp>
+      <p:sp>
+        <p:nvSpPr>
+          <p:cNvPr id="10" name="TextBox 9"/>
           <p:cNvSpPr txBox="1"/>
           <p:nvPr/>
         </p:nvSpPr>
@@ -4216,14 +4811,14 @@
               </a:defRPr>
             </a:pPr>
             <a:r>
-              <a:t>Swiggy Instamart Growth Team Portfolio | Category Expansion Initiative</a:t>
-            </a:r>
-          </a:p>
-        </p:txBody>
-      </p:sp>
-      <p:sp>
-        <p:nvSpPr>
-          <p:cNvPr id="10" name="TextBox 9"/>
+              <a:t>Swiggy Instamart Growth Portfolio | AI Product Discovery Engine</a:t>
+            </a:r>
+          </a:p>
+        </p:txBody>
+      </p:sp>
+      <p:sp>
+        <p:nvSpPr>
+          <p:cNvPr id="11" name="TextBox 10"/>
           <p:cNvSpPr txBox="1"/>
           <p:nvPr/>
         </p:nvSpPr>
@@ -4385,7 +4980,7 @@
               </a:defRPr>
             </a:pPr>
             <a:r>
-              <a:t>Why Existing Banners Fail vs. The AI Ingestion Solution</a:t>
+              <a:t>Why Home Banners Fail vs. AI Ingestion Solutions</a:t>
             </a:r>
           </a:p>
         </p:txBody>
@@ -4469,7 +5064,7 @@
               </a:defRPr>
             </a:pPr>
             <a:r>
-              <a:t>WHY HOME BANNERS FAIL (User Flow)</a:t>
+              <a:t>WHY AN AI-NATIVE SOLUTION?</a:t>
             </a:r>
           </a:p>
           <a:p>
@@ -4485,11 +5080,15 @@
               </a:defRPr>
             </a:pPr>
             <a:r>
-              <a:t>• Current Inefficient Friction Loop:</a:t>
+              <a:t>• Traditional Dashboards vs. AI:</a:t>
             </a:r>
             <a:br/>
             <a:r>
-              <a:t>Homepage Banner -&gt; Ads Ignored -&gt; Fast Search -&gt; Buy it Again List -&gt; Fast Checkout (Zero Discovery)</a:t>
+              <a:t>- Traditional: ❌ Tells us WHAT people bought (repeat dairy/bread).</a:t>
+            </a:r>
+            <a:br/>
+            <a:r>
+              <a:t>- AI Discovery: ✅ Explains WHY users don't buy new categories.</a:t>
             </a:r>
           </a:p>
           <a:p>
@@ -4505,7 +5104,19 @@
               </a:defRPr>
             </a:pPr>
             <a:r>
-              <a:t>• Homepage Avoidance: Flashing ads and cluttered banner carousels create high cognitive load, pushing users to immediately click past list shortcuts.</a:t>
+              <a:t>• Real Evidence (Customer Review):</a:t>
+            </a:r>
+            <a:br/>
+            <a:r>
+              <a:t>⭐⭐⭐⭐ "I just order milk every week. Never noticed the personal care section."</a:t>
+            </a:r>
+            <a:br/>
+            <a:r>
+              <a:t>-&gt; Theme: Habit Loop</a:t>
+            </a:r>
+            <a:br/>
+            <a:r>
+              <a:t>-&gt; Insight: Discovery isn't happening.</a:t>
             </a:r>
           </a:p>
           <a:p>
@@ -4521,7 +5132,7 @@
               </a:defRPr>
             </a:pPr>
             <a:r>
-              <a:t>• Transaction Speed: Instamart is optimized for checkout speed (&lt;15s), preventing browse-discovery.</a:t>
+              <a:t>• Homepage Avoidance: Cluttered carousels create cognitive load, pushing users directly to reorder lists.</a:t>
             </a:r>
           </a:p>
         </p:txBody>
@@ -4693,7 +5304,7 @@
               </a:defRPr>
             </a:pPr>
             <a:r>
-              <a:t>Swiggy Instamart Growth Team Portfolio | Category Expansion Initiative</a:t>
+              <a:t>Swiggy Instamart Growth Portfolio | AI Product Discovery Engine</a:t>
             </a:r>
           </a:p>
         </p:txBody>
@@ -4826,7 +5437,7 @@
               </a:defRPr>
             </a:pPr>
             <a:r>
-              <a:t>PART 2 · RESEARCH &amp; METHODOLOGY</a:t>
+              <a:t>PART 2 · AI INGESTION WORKFLOW</a:t>
             </a:r>
           </a:p>
         </p:txBody>
@@ -4862,7 +5473,7 @@
               </a:defRPr>
             </a:pPr>
             <a:r>
-              <a:t>User Research Methodology &amp; Core Behavior Flow</a:t>
+              <a:t>The Sequential 7-Agent Ingestion Pipeline</a:t>
             </a:r>
           </a:p>
         </p:txBody>
@@ -4946,7 +5557,7 @@
               </a:defRPr>
             </a:pPr>
             <a:r>
-              <a:t>PRIMARY RESEARCH METHODOLOGY</a:t>
+              <a:t>THE AI PIPELINE WORKFLOW (Mandatory Outline)</a:t>
             </a:r>
           </a:p>
           <a:p>
@@ -4962,11 +5573,7 @@
               </a:defRPr>
             </a:pPr>
             <a:r>
-              <a:t>• Interview Design:</a:t>
-            </a:r>
-            <a:br/>
-            <a:r>
-              <a:t>Conducted 6 semi-structured interviews via Google Meet (recorded for analysis).</a:t>
+              <a:t>• Data Ingestion: Scrapes reviews from Play Store, App Store, Reddit, and Twitter.</a:t>
             </a:r>
           </a:p>
           <a:p>
@@ -4982,15 +5589,7 @@
               </a:defRPr>
             </a:pPr>
             <a:r>
-              <a:t>• Validation Data Rigor:</a:t>
-            </a:r>
-            <a:br/>
-            <a:r>
-              <a:t>- Rohan (22m), Meera (26m), Kabir (18m), Priya (20m), Vijay (24m), Anand (15m).</a:t>
-            </a:r>
-            <a:br/>
-            <a:r>
-              <a:t>- 125 Minutes total duration (Average: 21m).</a:t>
+              <a:t>• Normalization &amp; Cleaning: Removes duplicates, filters promo spam, and translates regional Hinglish slang.</a:t>
             </a:r>
           </a:p>
           <a:p>
@@ -5006,11 +5605,55 @@
               </a:defRPr>
             </a:pPr>
             <a:r>
-              <a:t>• Analysis Workflow:</a:t>
-            </a:r>
-            <a:br/>
-            <a:r>
-              <a:t>Transcripts analyzed via post-interview affinity mapping, clustering validation patterns.</a:t>
+              <a:t>• Embedding Model: Feeds tokenized texts into 'text-embedding-3-small' model.</a:t>
+            </a:r>
+          </a:p>
+          <a:p>
+            <a:pPr>
+              <a:spcAft>
+                <a:spcPts val="800"/>
+              </a:spcAft>
+              <a:defRPr sz="1400">
+                <a:solidFill>
+                  <a:srgbClr val="F8FAFC"/>
+                </a:solidFill>
+                <a:latin typeface="Arial"/>
+              </a:defRPr>
+            </a:pPr>
+            <a:r>
+              <a:t>• LLM Extraction: Runs GPT-4 &amp; Claude models to extract key categories, triggers, and friction points.</a:t>
+            </a:r>
+          </a:p>
+          <a:p>
+            <a:pPr>
+              <a:spcAft>
+                <a:spcPts val="800"/>
+              </a:spcAft>
+              <a:defRPr sz="1400">
+                <a:solidFill>
+                  <a:srgbClr val="F8FAFC"/>
+                </a:solidFill>
+                <a:latin typeface="Arial"/>
+              </a:defRPr>
+            </a:pPr>
+            <a:r>
+              <a:t>• Unsupervised Clustering: Applies K-Means algorithm to isolate 4 semantic barrier themes.</a:t>
+            </a:r>
+          </a:p>
+          <a:p>
+            <a:pPr>
+              <a:spcAft>
+                <a:spcPts val="800"/>
+              </a:spcAft>
+              <a:defRPr sz="1400">
+                <a:solidFill>
+                  <a:srgbClr val="F8FAFC"/>
+                </a:solidFill>
+                <a:latin typeface="Arial"/>
+              </a:defRPr>
+            </a:pPr>
+            <a:r>
+              <a:t>• Verification: Compares extracted insights against database counts to calculate validation confidence.</a:t>
             </a:r>
           </a:p>
         </p:txBody>
@@ -5094,7 +5737,7 @@
               </a:defRPr>
             </a:pPr>
             <a:r>
-              <a:t>THE REPETITIVE BEHAVIOR FLOW</a:t>
+              <a:t>PROMPT ENGINEERING &amp; TECH STACK</a:t>
             </a:r>
           </a:p>
           <a:p>
@@ -5110,11 +5753,27 @@
               </a:defRPr>
             </a:pPr>
             <a:r>
-              <a:t>• The Habitual Checkout Flow:</a:t>
+              <a:t>• Example Ingestion Prompt:</a:t>
             </a:r>
             <a:br/>
             <a:r>
-              <a:t>Open App -&gt; Buy Again List -&gt; Checkout -&gt; Leave App (Zero Exploration)</a:t>
+              <a:t>"Group these reviews into themes. Return JSON with fields:</a:t>
+            </a:r>
+            <a:br/>
+            <a:r>
+              <a:t>  - Theme</a:t>
+            </a:r>
+            <a:br/>
+            <a:r>
+              <a:t>  - Frequency</a:t>
+            </a:r>
+            <a:br/>
+            <a:r>
+              <a:t>  - Representative Quote</a:t>
+            </a:r>
+            <a:br/>
+            <a:r>
+              <a:t>  - Confidence Score"</a:t>
             </a:r>
           </a:p>
           <a:p>
@@ -5130,31 +5789,27 @@
               </a:defRPr>
             </a:pPr>
             <a:r>
-              <a:t>• Validation Findings:</a:t>
+              <a:t>• AI Core Tech Stack:</a:t>
             </a:r>
             <a:br/>
             <a:r>
-              <a:t>75% of users show Milk/Bread reorder behaviors. They split baskets and buy pet care/cosmetics from Amazon/offline shops due to a lack of local specifications.</a:t>
-            </a:r>
-          </a:p>
-          <a:p>
-            <a:pPr>
-              <a:spcAft>
-                <a:spcPts val="800"/>
-              </a:spcAft>
-              <a:defRPr sz="1400">
-                <a:solidFill>
-                  <a:srgbClr val="F8FAFC"/>
-                </a:solidFill>
-                <a:latin typeface="Arial"/>
-              </a:defRPr>
-            </a:pPr>
-            <a:r>
-              <a:t>• Delivery Fee Barrier:</a:t>
+              <a:t>  - Language: Python</a:t>
             </a:r>
             <a:br/>
             <a:r>
-              <a:t>76% of users want to explore new categories but reject checkout add-ons if delivery fees are applied.</a:t>
+              <a:t>  - Relational Database: SQLite</a:t>
+            </a:r>
+            <a:br/>
+            <a:r>
+              <a:t>  - REST API Routing: FastAPI</a:t>
+            </a:r>
+            <a:br/>
+            <a:r>
+              <a:t>  - LLM Models: GPT-4 &amp; text-embeddings-3-small</a:t>
+            </a:r>
+            <a:br/>
+            <a:r>
+              <a:t>  - Unsupervised Clustering: K-Means</a:t>
             </a:r>
           </a:p>
         </p:txBody>
@@ -5190,7 +5845,7 @@
               </a:defRPr>
             </a:pPr>
             <a:r>
-              <a:t>Swiggy Instamart Growth Team Portfolio | Category Expansion Initiative</a:t>
+              <a:t>Swiggy Instamart Growth Portfolio | AI Product Discovery Engine</a:t>
             </a:r>
           </a:p>
         </p:txBody>
@@ -5240,6 +5895,495 @@
 </file>
 
 <file path=ppt/slides/slide4.xml><?xml version="1.0" encoding="utf-8"?>
+<p:sld xmlns:a="http://schemas.openxmlformats.org/drawingml/2006/main" xmlns:p="http://schemas.openxmlformats.org/presentationml/2006/main" xmlns:r="http://schemas.openxmlformats.org/officeDocument/2006/relationships">
+  <p:cSld>
+    <p:spTree>
+      <p:nvGrpSpPr>
+        <p:cNvPr id="1" name=""/>
+        <p:cNvGrpSpPr/>
+        <p:nvPr/>
+      </p:nvGrpSpPr>
+      <p:grpSpPr/>
+      <p:sp>
+        <p:nvSpPr>
+          <p:cNvPr id="2" name="Rectangle 1"/>
+          <p:cNvSpPr/>
+          <p:nvPr/>
+        </p:nvSpPr>
+        <p:spPr>
+          <a:xfrm>
+            <a:off x="0" y="0"/>
+            <a:ext cx="12191695" cy="6858000"/>
+          </a:xfrm>
+          <a:prstGeom prst="rect">
+            <a:avLst/>
+          </a:prstGeom>
+          <a:solidFill>
+            <a:srgbClr val="0B0F19"/>
+          </a:solidFill>
+          <a:ln>
+            <a:noFill/>
+          </a:ln>
+        </p:spPr>
+        <p:style>
+          <a:lnRef idx="1">
+            <a:schemeClr val="accent1"/>
+          </a:lnRef>
+          <a:fillRef idx="3">
+            <a:schemeClr val="accent1"/>
+          </a:fillRef>
+          <a:effectRef idx="2">
+            <a:schemeClr val="accent1"/>
+          </a:effectRef>
+          <a:fontRef idx="minor">
+            <a:schemeClr val="lt1"/>
+          </a:fontRef>
+        </p:style>
+        <p:txBody>
+          <a:bodyPr rtlCol="0" anchor="ctr"/>
+          <a:lstStyle/>
+          <a:p>
+            <a:pPr algn="ctr"/>
+          </a:p>
+        </p:txBody>
+      </p:sp>
+      <p:sp>
+        <p:nvSpPr>
+          <p:cNvPr id="3" name="TextBox 2"/>
+          <p:cNvSpPr txBox="1"/>
+          <p:nvPr/>
+        </p:nvSpPr>
+        <p:spPr>
+          <a:xfrm>
+            <a:off x="548640" y="365760"/>
+            <a:ext cx="11094415" cy="274320"/>
+          </a:xfrm>
+          <a:prstGeom prst="rect">
+            <a:avLst/>
+          </a:prstGeom>
+          <a:noFill/>
+        </p:spPr>
+        <p:txBody>
+          <a:bodyPr wrap="none">
+            <a:spAutoFit/>
+          </a:bodyPr>
+          <a:lstStyle/>
+          <a:p>
+            <a:pPr>
+              <a:defRPr sz="1400" b="1">
+                <a:solidFill>
+                  <a:srgbClr val="94A3B8"/>
+                </a:solidFill>
+                <a:latin typeface="Arial"/>
+              </a:defRPr>
+            </a:pPr>
+            <a:r>
+              <a:t>PART 2 · RESEARCH VALIDATION</a:t>
+            </a:r>
+          </a:p>
+        </p:txBody>
+      </p:sp>
+      <p:sp>
+        <p:nvSpPr>
+          <p:cNvPr id="4" name="TextBox 3"/>
+          <p:cNvSpPr txBox="1"/>
+          <p:nvPr/>
+        </p:nvSpPr>
+        <p:spPr>
+          <a:xfrm>
+            <a:off x="548640" y="640080"/>
+            <a:ext cx="11094415" cy="731520"/>
+          </a:xfrm>
+          <a:prstGeom prst="rect">
+            <a:avLst/>
+          </a:prstGeom>
+          <a:noFill/>
+        </p:spPr>
+        <p:txBody>
+          <a:bodyPr wrap="square">
+            <a:spAutoFit/>
+          </a:bodyPr>
+          <a:lstStyle/>
+          <a:p>
+            <a:pPr>
+              <a:defRPr sz="3600" b="1">
+                <a:solidFill>
+                  <a:srgbClr val="FC8019"/>
+                </a:solidFill>
+                <a:latin typeface="Arial"/>
+              </a:defRPr>
+            </a:pPr>
+            <a:r>
+              <a:t>Primary User Research &amp; Ingestion Quality Validation</a:t>
+            </a:r>
+          </a:p>
+        </p:txBody>
+      </p:sp>
+      <p:sp>
+        <p:nvSpPr>
+          <p:cNvPr id="5" name="Rounded Rectangle 4"/>
+          <p:cNvSpPr/>
+          <p:nvPr/>
+        </p:nvSpPr>
+        <p:spPr>
+          <a:xfrm>
+            <a:off x="548640" y="1463040"/>
+            <a:ext cx="5303520" cy="4572000"/>
+          </a:xfrm>
+          <a:prstGeom prst="roundRect">
+            <a:avLst/>
+          </a:prstGeom>
+          <a:solidFill>
+            <a:srgbClr val="151B2C"/>
+          </a:solidFill>
+          <a:ln w="12700">
+            <a:solidFill>
+              <a:srgbClr val="222B44"/>
+            </a:solidFill>
+          </a:ln>
+        </p:spPr>
+        <p:style>
+          <a:lnRef idx="1">
+            <a:schemeClr val="accent1"/>
+          </a:lnRef>
+          <a:fillRef idx="3">
+            <a:schemeClr val="accent1"/>
+          </a:fillRef>
+          <a:effectRef idx="2">
+            <a:schemeClr val="accent1"/>
+          </a:effectRef>
+          <a:fontRef idx="minor">
+            <a:schemeClr val="lt1"/>
+          </a:fontRef>
+        </p:style>
+        <p:txBody>
+          <a:bodyPr rtlCol="0" anchor="ctr"/>
+          <a:lstStyle/>
+          <a:p>
+            <a:pPr algn="ctr"/>
+          </a:p>
+        </p:txBody>
+      </p:sp>
+      <p:sp>
+        <p:nvSpPr>
+          <p:cNvPr id="6" name="TextBox 5"/>
+          <p:cNvSpPr txBox="1"/>
+          <p:nvPr/>
+        </p:nvSpPr>
+        <p:spPr>
+          <a:xfrm>
+            <a:off x="685800" y="1600200"/>
+            <a:ext cx="5029200" cy="4297680"/>
+          </a:xfrm>
+          <a:prstGeom prst="rect">
+            <a:avLst/>
+          </a:prstGeom>
+          <a:noFill/>
+        </p:spPr>
+        <p:txBody>
+          <a:bodyPr wrap="square">
+            <a:spAutoFit/>
+          </a:bodyPr>
+          <a:lstStyle/>
+          <a:p>
+            <a:pPr>
+              <a:spcAft>
+                <a:spcPts val="1000"/>
+              </a:spcAft>
+              <a:defRPr sz="1500" b="1">
+                <a:solidFill>
+                  <a:srgbClr val="FC8019"/>
+                </a:solidFill>
+                <a:latin typeface="Arial"/>
+              </a:defRPr>
+            </a:pPr>
+            <a:r>
+              <a:t>USER INTERVIEWS &amp; SATURATION</a:t>
+            </a:r>
+          </a:p>
+          <a:p>
+            <a:pPr>
+              <a:spcAft>
+                <a:spcPts val="800"/>
+              </a:spcAft>
+              <a:defRPr sz="1400">
+                <a:solidFill>
+                  <a:srgbClr val="F8FAFC"/>
+                </a:solidFill>
+                <a:latin typeface="Arial"/>
+              </a:defRPr>
+            </a:pPr>
+            <a:r>
+              <a:t>• Primary Interviews:</a:t>
+            </a:r>
+            <a:br/>
+            <a:r>
+              <a:t>Conducted 6 semi-structured interviews via Google Meet (recorded, 125 mins total, avg 21m).</a:t>
+            </a:r>
+          </a:p>
+          <a:p>
+            <a:pPr>
+              <a:spcAft>
+                <a:spcPts val="800"/>
+              </a:spcAft>
+              <a:defRPr sz="1400">
+                <a:solidFill>
+                  <a:srgbClr val="F8FAFC"/>
+                </a:solidFill>
+                <a:latin typeface="Arial"/>
+              </a:defRPr>
+            </a:pPr>
+            <a:r>
+              <a:t>• Core Roster:</a:t>
+            </a:r>
+            <a:br/>
+            <a:r>
+              <a:t>- Rohan (22m), Meera (26m), Kabir (18m), Priya (20m), Vijay (24m), Anand (15m).</a:t>
+            </a:r>
+          </a:p>
+          <a:p>
+            <a:pPr>
+              <a:spcAft>
+                <a:spcPts val="800"/>
+              </a:spcAft>
+              <a:defRPr sz="1400">
+                <a:solidFill>
+                  <a:srgbClr val="F8FAFC"/>
+                </a:solidFill>
+                <a:latin typeface="Arial"/>
+              </a:defRPr>
+            </a:pPr>
+            <a:r>
+              <a:t>• Why 6 Interviews?:</a:t>
+            </a:r>
+            <a:br/>
+            <a:r>
+              <a:t>Six interviews were sufficient because no major new themes emerged after Interview #5 (theme saturation).</a:t>
+            </a:r>
+          </a:p>
+        </p:txBody>
+      </p:sp>
+      <p:sp>
+        <p:nvSpPr>
+          <p:cNvPr id="7" name="Rounded Rectangle 6"/>
+          <p:cNvSpPr/>
+          <p:nvPr/>
+        </p:nvSpPr>
+        <p:spPr>
+          <a:xfrm>
+            <a:off x="6217920" y="1463040"/>
+            <a:ext cx="5394960" cy="4572000"/>
+          </a:xfrm>
+          <a:prstGeom prst="roundRect">
+            <a:avLst/>
+          </a:prstGeom>
+          <a:solidFill>
+            <a:srgbClr val="151B2C"/>
+          </a:solidFill>
+          <a:ln w="12700">
+            <a:solidFill>
+              <a:srgbClr val="222B44"/>
+            </a:solidFill>
+          </a:ln>
+        </p:spPr>
+        <p:style>
+          <a:lnRef idx="1">
+            <a:schemeClr val="accent1"/>
+          </a:lnRef>
+          <a:fillRef idx="3">
+            <a:schemeClr val="accent1"/>
+          </a:fillRef>
+          <a:effectRef idx="2">
+            <a:schemeClr val="accent1"/>
+          </a:effectRef>
+          <a:fontRef idx="minor">
+            <a:schemeClr val="lt1"/>
+          </a:fontRef>
+        </p:style>
+        <p:txBody>
+          <a:bodyPr rtlCol="0" anchor="ctr"/>
+          <a:lstStyle/>
+          <a:p>
+            <a:pPr algn="ctr"/>
+          </a:p>
+        </p:txBody>
+      </p:sp>
+      <p:sp>
+        <p:nvSpPr>
+          <p:cNvPr id="8" name="TextBox 7"/>
+          <p:cNvSpPr txBox="1"/>
+          <p:nvPr/>
+        </p:nvSpPr>
+        <p:spPr>
+          <a:xfrm>
+            <a:off x="6355080" y="1600200"/>
+            <a:ext cx="5120640" cy="4297680"/>
+          </a:xfrm>
+          <a:prstGeom prst="rect">
+            <a:avLst/>
+          </a:prstGeom>
+          <a:noFill/>
+        </p:spPr>
+        <p:txBody>
+          <a:bodyPr wrap="square">
+            <a:spAutoFit/>
+          </a:bodyPr>
+          <a:lstStyle/>
+          <a:p>
+            <a:pPr>
+              <a:spcAft>
+                <a:spcPts val="1000"/>
+              </a:spcAft>
+              <a:defRPr sz="1500" b="1">
+                <a:solidFill>
+                  <a:srgbClr val="FC8019"/>
+                </a:solidFill>
+                <a:latin typeface="Arial"/>
+              </a:defRPr>
+            </a:pPr>
+            <a:r>
+              <a:t>AI QUALITY VALIDATION &amp; LIMITATIONS</a:t>
+            </a:r>
+          </a:p>
+          <a:p>
+            <a:pPr>
+              <a:spcAft>
+                <a:spcPts val="800"/>
+              </a:spcAft>
+              <a:defRPr sz="1400">
+                <a:solidFill>
+                  <a:srgbClr val="F8FAFC"/>
+                </a:solidFill>
+                <a:latin typeface="Arial"/>
+              </a:defRPr>
+            </a:pPr>
+            <a:r>
+              <a:t>• Operational Validation Methods:</a:t>
+            </a:r>
+            <a:br/>
+            <a:r>
+              <a:t>✓ Manual review of 100 random reviews to cross-check LLM labels.</a:t>
+            </a:r>
+            <a:br/>
+            <a:r>
+              <a:t>✓ Compared AI themes with interview findings for semantic alignment.</a:t>
+            </a:r>
+            <a:br/>
+            <a:r>
+              <a:t>✓ Automatically removed insights with confidence score &lt;80%.</a:t>
+            </a:r>
+          </a:p>
+          <a:p>
+            <a:pPr>
+              <a:spcAft>
+                <a:spcPts val="800"/>
+              </a:spcAft>
+              <a:defRPr sz="1400">
+                <a:solidFill>
+                  <a:srgbClr val="F8FAFC"/>
+                </a:solidFill>
+                <a:latin typeface="Arial"/>
+              </a:defRPr>
+            </a:pPr>
+            <a:r>
+              <a:t>• Study Limitations:</a:t>
+            </a:r>
+            <a:br/>
+            <a:r>
+              <a:t>- Dataset skew: English reviews dominate scrapers.</a:t>
+            </a:r>
+            <a:br/>
+            <a:r>
+              <a:t>- Demographic skew: Social media channels skew younger.</a:t>
+            </a:r>
+            <a:br/>
+            <a:r>
+              <a:t>- Cohort size: Interviews limited to six users.</a:t>
+            </a:r>
+          </a:p>
+        </p:txBody>
+      </p:sp>
+      <p:sp>
+        <p:nvSpPr>
+          <p:cNvPr id="9" name="TextBox 8"/>
+          <p:cNvSpPr txBox="1"/>
+          <p:nvPr/>
+        </p:nvSpPr>
+        <p:spPr>
+          <a:xfrm>
+            <a:off x="548640" y="6400800"/>
+            <a:ext cx="9144000" cy="274320"/>
+          </a:xfrm>
+          <a:prstGeom prst="rect">
+            <a:avLst/>
+          </a:prstGeom>
+          <a:noFill/>
+        </p:spPr>
+        <p:txBody>
+          <a:bodyPr wrap="none">
+            <a:spAutoFit/>
+          </a:bodyPr>
+          <a:lstStyle/>
+          <a:p>
+            <a:pPr>
+              <a:defRPr sz="1400">
+                <a:solidFill>
+                  <a:srgbClr val="94A3B8"/>
+                </a:solidFill>
+                <a:latin typeface="Arial"/>
+              </a:defRPr>
+            </a:pPr>
+            <a:r>
+              <a:t>Swiggy Instamart Growth Portfolio | AI Product Discovery Engine</a:t>
+            </a:r>
+          </a:p>
+        </p:txBody>
+      </p:sp>
+      <p:sp>
+        <p:nvSpPr>
+          <p:cNvPr id="10" name="TextBox 9"/>
+          <p:cNvSpPr txBox="1"/>
+          <p:nvPr/>
+        </p:nvSpPr>
+        <p:spPr>
+          <a:xfrm>
+            <a:off x="10515600" y="6400800"/>
+            <a:ext cx="1127455" cy="274320"/>
+          </a:xfrm>
+          <a:prstGeom prst="rect">
+            <a:avLst/>
+          </a:prstGeom>
+          <a:noFill/>
+        </p:spPr>
+        <p:txBody>
+          <a:bodyPr wrap="none">
+            <a:spAutoFit/>
+          </a:bodyPr>
+          <a:lstStyle/>
+          <a:p>
+            <a:pPr algn="r">
+              <a:defRPr sz="1400">
+                <a:solidFill>
+                  <a:srgbClr val="94A3B8"/>
+                </a:solidFill>
+                <a:latin typeface="Arial"/>
+              </a:defRPr>
+            </a:pPr>
+            <a:r>
+              <a:t>Slide 4 of 10</a:t>
+            </a:r>
+          </a:p>
+        </p:txBody>
+      </p:sp>
+    </p:spTree>
+  </p:cSld>
+  <p:clrMapOvr>
+    <a:masterClrMapping/>
+  </p:clrMapOvr>
+</p:sld>
+</file>
+
+<file path=ppt/slides/slide5.xml><?xml version="1.0" encoding="utf-8"?>
 <p:sld xmlns:a="http://schemas.openxmlformats.org/drawingml/2006/main" xmlns:p="http://schemas.openxmlformats.org/presentationml/2006/main" xmlns:r="http://schemas.openxmlformats.org/officeDocument/2006/relationships">
   <p:cSld>
     <p:spTree>
@@ -5383,9 +6527,10 @@
                 <a:tableStyleId>{5C22544A-7EE6-4342-B048-85BDC9FD1C3A}</a:tableStyleId>
               </a:tblPr>
               <a:tblGrid>
-                <a:gridCol w="2926080"/>
-                <a:gridCol w="1371600"/>
-                <a:gridCol w="4602175"/>
+                <a:gridCol w="2560320"/>
+                <a:gridCol w="1005840"/>
+                <a:gridCol w="1188720"/>
+                <a:gridCol w="4144975"/>
                 <a:gridCol w="2194560"/>
               </a:tblGrid>
               <a:tr h="762000">
@@ -5403,7 +6548,7 @@
                         </a:defRPr>
                       </a:pPr>
                       <a:r>
-                        <a:t>Hypothesis Tested</a:t>
+                        <a:t>Hypothesis/Theme</a:t>
                       </a:r>
                     </a:p>
                   </a:txBody>
@@ -5428,6 +6573,30 @@
                       </a:pPr>
                       <a:r>
                         <a:t>Val %</a:t>
+                      </a:r>
+                    </a:p>
+                  </a:txBody>
+                  <a:tcPr>
+                    <a:solidFill>
+                      <a:srgbClr val="222B44"/>
+                    </a:solidFill>
+                  </a:tcPr>
+                </a:tc>
+                <a:tc>
+                  <a:txBody>
+                    <a:bodyPr/>
+                    <a:lstStyle/>
+                    <a:p>
+                      <a:pPr>
+                        <a:defRPr sz="1400" b="1">
+                          <a:solidFill>
+                            <a:srgbClr val="F8FAFC"/>
+                          </a:solidFill>
+                          <a:latin typeface="Arial"/>
+                        </a:defRPr>
+                      </a:pPr>
+                      <a:r>
+                        <a:t>AI Conf</a:t>
                       </a:r>
                     </a:p>
                   </a:txBody>
@@ -5541,6 +6710,30 @@
                     <a:lstStyle/>
                     <a:p>
                       <a:pPr>
+                        <a:defRPr sz="1400" b="1">
+                          <a:solidFill>
+                            <a:srgbClr val="FC8019"/>
+                          </a:solidFill>
+                          <a:latin typeface="Arial"/>
+                        </a:defRPr>
+                      </a:pPr>
+                      <a:r>
+                        <a:t>95%</a:t>
+                      </a:r>
+                    </a:p>
+                  </a:txBody>
+                  <a:tcPr>
+                    <a:solidFill>
+                      <a:srgbClr val="151B2C"/>
+                    </a:solidFill>
+                  </a:tcPr>
+                </a:tc>
+                <a:tc>
+                  <a:txBody>
+                    <a:bodyPr/>
+                    <a:lstStyle/>
+                    <a:p>
+                      <a:pPr>
                         <a:defRPr sz="1400" b="0">
                           <a:solidFill>
                             <a:srgbClr val="F8FAFC"/>
@@ -5639,6 +6832,30 @@
                     <a:lstStyle/>
                     <a:p>
                       <a:pPr>
+                        <a:defRPr sz="1400" b="1">
+                          <a:solidFill>
+                            <a:srgbClr val="FC8019"/>
+                          </a:solidFill>
+                          <a:latin typeface="Arial"/>
+                        </a:defRPr>
+                      </a:pPr>
+                      <a:r>
+                        <a:t>84%</a:t>
+                      </a:r>
+                    </a:p>
+                  </a:txBody>
+                  <a:tcPr>
+                    <a:solidFill>
+                      <a:srgbClr val="151B2C"/>
+                    </a:solidFill>
+                  </a:tcPr>
+                </a:tc>
+                <a:tc>
+                  <a:txBody>
+                    <a:bodyPr/>
+                    <a:lstStyle/>
+                    <a:p>
+                      <a:pPr>
                         <a:defRPr sz="1400" b="0">
                           <a:solidFill>
                             <a:srgbClr val="F8FAFC"/>
@@ -5697,7 +6914,7 @@
                         </a:defRPr>
                       </a:pPr>
                       <a:r>
-                        <a:t>Checkout recommendations are rejected due to delivery fees.</a:t>
+                        <a:t>Checkout recommendations are rejected due to fees.</a:t>
                       </a:r>
                     </a:p>
                   </a:txBody>
@@ -5722,6 +6939,30 @@
                       </a:pPr>
                       <a:r>
                         <a:t>83%</a:t>
+                      </a:r>
+                    </a:p>
+                  </a:txBody>
+                  <a:tcPr>
+                    <a:solidFill>
+                      <a:srgbClr val="151B2C"/>
+                    </a:solidFill>
+                  </a:tcPr>
+                </a:tc>
+                <a:tc>
+                  <a:txBody>
+                    <a:bodyPr/>
+                    <a:lstStyle/>
+                    <a:p>
+                      <a:pPr>
+                        <a:defRPr sz="1400" b="1">
+                          <a:solidFill>
+                            <a:srgbClr val="FC8019"/>
+                          </a:solidFill>
+                          <a:latin typeface="Arial"/>
+                        </a:defRPr>
+                      </a:pPr>
+                      <a:r>
+                        <a:t>91%</a:t>
                       </a:r>
                     </a:p>
                   </a:txBody>
@@ -5835,6 +7076,30 @@
                     <a:lstStyle/>
                     <a:p>
                       <a:pPr>
+                        <a:defRPr sz="1400" b="1">
+                          <a:solidFill>
+                            <a:srgbClr val="FC8019"/>
+                          </a:solidFill>
+                          <a:latin typeface="Arial"/>
+                        </a:defRPr>
+                      </a:pPr>
+                      <a:r>
+                        <a:t>88%</a:t>
+                      </a:r>
+                    </a:p>
+                  </a:txBody>
+                  <a:tcPr>
+                    <a:solidFill>
+                      <a:srgbClr val="151B2C"/>
+                    </a:solidFill>
+                  </a:tcPr>
+                </a:tc>
+                <a:tc>
+                  <a:txBody>
+                    <a:bodyPr/>
+                    <a:lstStyle/>
+                    <a:p>
+                      <a:pPr>
                         <a:defRPr sz="1400" b="0">
                           <a:solidFill>
                             <a:srgbClr val="F8FAFC"/>
@@ -5933,6 +7198,30 @@
                     <a:lstStyle/>
                     <a:p>
                       <a:pPr>
+                        <a:defRPr sz="1400" b="1">
+                          <a:solidFill>
+                            <a:srgbClr val="FC8019"/>
+                          </a:solidFill>
+                          <a:latin typeface="Arial"/>
+                        </a:defRPr>
+                      </a:pPr>
+                      <a:r>
+                        <a:t>92%</a:t>
+                      </a:r>
+                    </a:p>
+                  </a:txBody>
+                  <a:tcPr>
+                    <a:solidFill>
+                      <a:srgbClr val="151B2C"/>
+                    </a:solidFill>
+                  </a:tcPr>
+                </a:tc>
+                <a:tc>
+                  <a:txBody>
+                    <a:bodyPr/>
+                    <a:lstStyle/>
+                    <a:p>
+                      <a:pPr>
                         <a:defRPr sz="1400" b="0">
                           <a:solidFill>
                             <a:srgbClr val="F8FAFC"/>
@@ -6011,7 +7300,7 @@
               </a:defRPr>
             </a:pPr>
             <a:r>
-              <a:t>Swiggy Instamart Growth Team Portfolio | Category Expansion Initiative</a:t>
+              <a:t>Swiggy Instamart Growth Portfolio | AI Product Discovery Engine</a:t>
             </a:r>
           </a:p>
         </p:txBody>
@@ -6047,7 +7336,7 @@
               </a:defRPr>
             </a:pPr>
             <a:r>
-              <a:t>Slide 4 of 10</a:t>
+              <a:t>Slide 5 of 10</a:t>
             </a:r>
           </a:p>
         </p:txBody>
@@ -6060,7 +7349,7 @@
 </p:sld>
 </file>
 
-<file path=ppt/slides/slide5.xml><?xml version="1.0" encoding="utf-8"?>
+<file path=ppt/slides/slide6.xml><?xml version="1.0" encoding="utf-8"?>
 <p:sld xmlns:a="http://schemas.openxmlformats.org/drawingml/2006/main" xmlns:p="http://schemas.openxmlformats.org/presentationml/2006/main" xmlns:r="http://schemas.openxmlformats.org/officeDocument/2006/relationships">
   <p:cSld>
     <p:spTree>
@@ -6264,7 +7553,7 @@
               </a:defRPr>
             </a:pPr>
             <a:r>
-              <a:t>Why Choose the Post-Checkout Window?</a:t>
+              <a:t>WHY NOT AMAZON-STYLE RECOMMENDATIONS?</a:t>
             </a:r>
           </a:p>
           <a:p>
@@ -6280,7 +7569,15 @@
               </a:defRPr>
             </a:pPr>
             <a:r>
-              <a:t>To solve category discovery, we prioritized features utilizing RICE backlog scoring:</a:t>
+              <a:t>• The Differentiator:</a:t>
+            </a:r>
+            <a:br/>
+            <a:r>
+              <a:t>- Amazon: Recommendations are shown BEFORE checkout. This creates decision friction, delaying the transaction.</a:t>
+            </a:r>
+            <a:br/>
+            <a:r>
+              <a:t>- Swiggy Instamart: Recommendations are shown AFTER payment in a dedicated 3-minute window.</a:t>
             </a:r>
           </a:p>
           <a:p>
@@ -6296,11 +7593,11 @@
               </a:defRPr>
             </a:pPr>
             <a:r>
-              <a:t>• Smarter Filters:</a:t>
+              <a:t>• Waiving the Friction:</a:t>
             </a:r>
             <a:br/>
             <a:r>
-              <a:t>Low impact because users bypass catalog navigation tags entirely.</a:t>
+              <a:t>Waives delivery fee on the append items. This drives impulse additions without increasing logistics costs.</a:t>
             </a:r>
           </a:p>
           <a:p>
@@ -6316,31 +7613,7 @@
               </a:defRPr>
             </a:pPr>
             <a:r>
-              <a:t>• AI Crate Digger Chat:</a:t>
-            </a:r>
-            <a:br/>
-            <a:r>
-              <a:t>High impact, but extremely high engineering effort and risks slowing transaction speed.</a:t>
-            </a:r>
-          </a:p>
-          <a:p>
-            <a:pPr>
-              <a:spcAft>
-                <a:spcPts val="800"/>
-              </a:spcAft>
-              <a:defRPr sz="1400">
-                <a:solidFill>
-                  <a:srgbClr val="F8FAFC"/>
-                </a:solidFill>
-                <a:latin typeface="Arial"/>
-              </a:defRPr>
-            </a:pPr>
-            <a:r>
-              <a:t>• Post-Checkout Add-on Window:</a:t>
-            </a:r>
-            <a:br/>
-            <a:r>
-              <a:t>Wins because it acts at peak intent checkout moment, waives delivery fees, and utilizes single-rider dispatch.</a:t>
+              <a:t>• RICE matrix wins: Scoring wins on high Reach, high Impact, and low implementation Effort.</a:t>
             </a:r>
           </a:p>
         </p:txBody>
@@ -6990,7 +8263,7 @@
               </a:defRPr>
             </a:pPr>
             <a:r>
-              <a:t>Swiggy Instamart Growth Team Portfolio | Category Expansion Initiative</a:t>
+              <a:t>Swiggy Instamart Growth Portfolio | AI Product Discovery Engine</a:t>
             </a:r>
           </a:p>
         </p:txBody>
@@ -6998,499 +8271,6 @@
       <p:sp>
         <p:nvSpPr>
           <p:cNvPr id="9" name="TextBox 8"/>
-          <p:cNvSpPr txBox="1"/>
-          <p:nvPr/>
-        </p:nvSpPr>
-        <p:spPr>
-          <a:xfrm>
-            <a:off x="10515600" y="6400800"/>
-            <a:ext cx="1127455" cy="274320"/>
-          </a:xfrm>
-          <a:prstGeom prst="rect">
-            <a:avLst/>
-          </a:prstGeom>
-          <a:noFill/>
-        </p:spPr>
-        <p:txBody>
-          <a:bodyPr wrap="none">
-            <a:spAutoFit/>
-          </a:bodyPr>
-          <a:lstStyle/>
-          <a:p>
-            <a:pPr algn="r">
-              <a:defRPr sz="1400">
-                <a:solidFill>
-                  <a:srgbClr val="94A3B8"/>
-                </a:solidFill>
-                <a:latin typeface="Arial"/>
-              </a:defRPr>
-            </a:pPr>
-            <a:r>
-              <a:t>Slide 5 of 10</a:t>
-            </a:r>
-          </a:p>
-        </p:txBody>
-      </p:sp>
-    </p:spTree>
-  </p:cSld>
-  <p:clrMapOvr>
-    <a:masterClrMapping/>
-  </p:clrMapOvr>
-</p:sld>
-</file>
-
-<file path=ppt/slides/slide6.xml><?xml version="1.0" encoding="utf-8"?>
-<p:sld xmlns:a="http://schemas.openxmlformats.org/drawingml/2006/main" xmlns:p="http://schemas.openxmlformats.org/presentationml/2006/main" xmlns:r="http://schemas.openxmlformats.org/officeDocument/2006/relationships">
-  <p:cSld>
-    <p:spTree>
-      <p:nvGrpSpPr>
-        <p:cNvPr id="1" name=""/>
-        <p:cNvGrpSpPr/>
-        <p:nvPr/>
-      </p:nvGrpSpPr>
-      <p:grpSpPr/>
-      <p:sp>
-        <p:nvSpPr>
-          <p:cNvPr id="2" name="Rectangle 1"/>
-          <p:cNvSpPr/>
-          <p:nvPr/>
-        </p:nvSpPr>
-        <p:spPr>
-          <a:xfrm>
-            <a:off x="0" y="0"/>
-            <a:ext cx="12191695" cy="6858000"/>
-          </a:xfrm>
-          <a:prstGeom prst="rect">
-            <a:avLst/>
-          </a:prstGeom>
-          <a:solidFill>
-            <a:srgbClr val="0B0F19"/>
-          </a:solidFill>
-          <a:ln>
-            <a:noFill/>
-          </a:ln>
-        </p:spPr>
-        <p:style>
-          <a:lnRef idx="1">
-            <a:schemeClr val="accent1"/>
-          </a:lnRef>
-          <a:fillRef idx="3">
-            <a:schemeClr val="accent1"/>
-          </a:fillRef>
-          <a:effectRef idx="2">
-            <a:schemeClr val="accent1"/>
-          </a:effectRef>
-          <a:fontRef idx="minor">
-            <a:schemeClr val="lt1"/>
-          </a:fontRef>
-        </p:style>
-        <p:txBody>
-          <a:bodyPr rtlCol="0" anchor="ctr"/>
-          <a:lstStyle/>
-          <a:p>
-            <a:pPr algn="ctr"/>
-          </a:p>
-        </p:txBody>
-      </p:sp>
-      <p:sp>
-        <p:nvSpPr>
-          <p:cNvPr id="3" name="TextBox 2"/>
-          <p:cNvSpPr txBox="1"/>
-          <p:nvPr/>
-        </p:nvSpPr>
-        <p:spPr>
-          <a:xfrm>
-            <a:off x="548640" y="365760"/>
-            <a:ext cx="11094415" cy="274320"/>
-          </a:xfrm>
-          <a:prstGeom prst="rect">
-            <a:avLst/>
-          </a:prstGeom>
-          <a:noFill/>
-        </p:spPr>
-        <p:txBody>
-          <a:bodyPr wrap="none">
-            <a:spAutoFit/>
-          </a:bodyPr>
-          <a:lstStyle/>
-          <a:p>
-            <a:pPr>
-              <a:defRPr sz="1400" b="1">
-                <a:solidFill>
-                  <a:srgbClr val="94A3B8"/>
-                </a:solidFill>
-                <a:latin typeface="Arial"/>
-              </a:defRPr>
-            </a:pPr>
-            <a:r>
-              <a:t>PART 3 · THE SOLUTION</a:t>
-            </a:r>
-          </a:p>
-        </p:txBody>
-      </p:sp>
-      <p:sp>
-        <p:nvSpPr>
-          <p:cNvPr id="4" name="TextBox 3"/>
-          <p:cNvSpPr txBox="1"/>
-          <p:nvPr/>
-        </p:nvSpPr>
-        <p:spPr>
-          <a:xfrm>
-            <a:off x="548640" y="640080"/>
-            <a:ext cx="11094415" cy="731520"/>
-          </a:xfrm>
-          <a:prstGeom prst="rect">
-            <a:avLst/>
-          </a:prstGeom>
-          <a:noFill/>
-        </p:spPr>
-        <p:txBody>
-          <a:bodyPr wrap="square">
-            <a:spAutoFit/>
-          </a:bodyPr>
-          <a:lstStyle/>
-          <a:p>
-            <a:pPr>
-              <a:defRPr sz="3600" b="1">
-                <a:solidFill>
-                  <a:srgbClr val="FC8019"/>
-                </a:solidFill>
-                <a:latin typeface="Arial"/>
-              </a:defRPr>
-            </a:pPr>
-            <a:r>
-              <a:t>One Prioritized Solution: The AI-Driven Discovery Engine</a:t>
-            </a:r>
-          </a:p>
-        </p:txBody>
-      </p:sp>
-      <p:sp>
-        <p:nvSpPr>
-          <p:cNvPr id="5" name="Rounded Rectangle 4"/>
-          <p:cNvSpPr/>
-          <p:nvPr/>
-        </p:nvSpPr>
-        <p:spPr>
-          <a:xfrm>
-            <a:off x="548640" y="1463040"/>
-            <a:ext cx="5303520" cy="4572000"/>
-          </a:xfrm>
-          <a:prstGeom prst="roundRect">
-            <a:avLst/>
-          </a:prstGeom>
-          <a:solidFill>
-            <a:srgbClr val="151B2C"/>
-          </a:solidFill>
-          <a:ln w="12700">
-            <a:solidFill>
-              <a:srgbClr val="222B44"/>
-            </a:solidFill>
-          </a:ln>
-        </p:spPr>
-        <p:style>
-          <a:lnRef idx="1">
-            <a:schemeClr val="accent1"/>
-          </a:lnRef>
-          <a:fillRef idx="3">
-            <a:schemeClr val="accent1"/>
-          </a:fillRef>
-          <a:effectRef idx="2">
-            <a:schemeClr val="accent1"/>
-          </a:effectRef>
-          <a:fontRef idx="minor">
-            <a:schemeClr val="lt1"/>
-          </a:fontRef>
-        </p:style>
-        <p:txBody>
-          <a:bodyPr rtlCol="0" anchor="ctr"/>
-          <a:lstStyle/>
-          <a:p>
-            <a:pPr algn="ctr"/>
-          </a:p>
-        </p:txBody>
-      </p:sp>
-      <p:sp>
-        <p:nvSpPr>
-          <p:cNvPr id="6" name="TextBox 5"/>
-          <p:cNvSpPr txBox="1"/>
-          <p:nvPr/>
-        </p:nvSpPr>
-        <p:spPr>
-          <a:xfrm>
-            <a:off x="685800" y="1600200"/>
-            <a:ext cx="5029200" cy="4297680"/>
-          </a:xfrm>
-          <a:prstGeom prst="rect">
-            <a:avLst/>
-          </a:prstGeom>
-          <a:noFill/>
-        </p:spPr>
-        <p:txBody>
-          <a:bodyPr wrap="square">
-            <a:spAutoFit/>
-          </a:bodyPr>
-          <a:lstStyle/>
-          <a:p>
-            <a:pPr>
-              <a:spcAft>
-                <a:spcPts val="1000"/>
-              </a:spcAft>
-              <a:defRPr sz="1500" b="1">
-                <a:solidFill>
-                  <a:srgbClr val="FC8019"/>
-                </a:solidFill>
-                <a:latin typeface="Arial"/>
-              </a:defRPr>
-            </a:pPr>
-            <a:r>
-              <a:t>THE HERO: AI-Driven Category Personalization</a:t>
-            </a:r>
-          </a:p>
-          <a:p>
-            <a:pPr>
-              <a:spcAft>
-                <a:spcPts val="800"/>
-              </a:spcAft>
-              <a:defRPr sz="1400">
-                <a:solidFill>
-                  <a:srgbClr val="F8FAFC"/>
-                </a:solidFill>
-                <a:latin typeface="Arial"/>
-              </a:defRPr>
-            </a:pPr>
-            <a:r>
-              <a:t>• Dynamic Personalization Loop:</a:t>
-            </a:r>
-            <a:br/>
-            <a:r>
-              <a:t>Active Cart -&gt; AI predicts forgotten items -&gt; Freshness check -&gt; Trust badge -&gt; Fee-free window -&gt; Checkout</a:t>
-            </a:r>
-          </a:p>
-          <a:p>
-            <a:pPr>
-              <a:spcAft>
-                <a:spcPts val="800"/>
-              </a:spcAft>
-              <a:defRPr sz="1400">
-                <a:solidFill>
-                  <a:srgbClr val="F8FAFC"/>
-                </a:solidFill>
-                <a:latin typeface="Arial"/>
-              </a:defRPr>
-            </a:pPr>
-            <a:r>
-              <a:t>• Intent Integration:</a:t>
-            </a:r>
-            <a:br/>
-            <a:r>
-              <a:t>Triggers recommendations right after payment completion, waiving delivery fee friction for 3 minutes.</a:t>
-            </a:r>
-          </a:p>
-          <a:p>
-            <a:pPr>
-              <a:spcAft>
-                <a:spcPts val="800"/>
-              </a:spcAft>
-              <a:defRPr sz="1400">
-                <a:solidFill>
-                  <a:srgbClr val="F8FAFC"/>
-                </a:solidFill>
-                <a:latin typeface="Arial"/>
-              </a:defRPr>
-            </a:pPr>
-            <a:r>
-              <a:t>• Predictive Match Models:</a:t>
-            </a:r>
-            <a:br/>
-            <a:r>
-              <a:t>If cart = milk, AI checks user history + cohort trends + time + season (e.g. coffee, organic avocados) instead of just repeating dairy items.</a:t>
-            </a:r>
-          </a:p>
-        </p:txBody>
-      </p:sp>
-      <p:sp>
-        <p:nvSpPr>
-          <p:cNvPr id="7" name="Rounded Rectangle 6"/>
-          <p:cNvSpPr/>
-          <p:nvPr/>
-        </p:nvSpPr>
-        <p:spPr>
-          <a:xfrm>
-            <a:off x="6217920" y="1463040"/>
-            <a:ext cx="5394960" cy="4572000"/>
-          </a:xfrm>
-          <a:prstGeom prst="roundRect">
-            <a:avLst/>
-          </a:prstGeom>
-          <a:solidFill>
-            <a:srgbClr val="151B2C"/>
-          </a:solidFill>
-          <a:ln w="12700">
-            <a:solidFill>
-              <a:srgbClr val="222B44"/>
-            </a:solidFill>
-          </a:ln>
-        </p:spPr>
-        <p:style>
-          <a:lnRef idx="1">
-            <a:schemeClr val="accent1"/>
-          </a:lnRef>
-          <a:fillRef idx="3">
-            <a:schemeClr val="accent1"/>
-          </a:fillRef>
-          <a:effectRef idx="2">
-            <a:schemeClr val="accent1"/>
-          </a:effectRef>
-          <a:fontRef idx="minor">
-            <a:schemeClr val="lt1"/>
-          </a:fontRef>
-        </p:style>
-        <p:txBody>
-          <a:bodyPr rtlCol="0" anchor="ctr"/>
-          <a:lstStyle/>
-          <a:p>
-            <a:pPr algn="ctr"/>
-          </a:p>
-        </p:txBody>
-      </p:sp>
-      <p:sp>
-        <p:nvSpPr>
-          <p:cNvPr id="8" name="TextBox 7"/>
-          <p:cNvSpPr txBox="1"/>
-          <p:nvPr/>
-        </p:nvSpPr>
-        <p:spPr>
-          <a:xfrm>
-            <a:off x="6355080" y="1600200"/>
-            <a:ext cx="5120640" cy="4297680"/>
-          </a:xfrm>
-          <a:prstGeom prst="rect">
-            <a:avLst/>
-          </a:prstGeom>
-          <a:noFill/>
-        </p:spPr>
-        <p:txBody>
-          <a:bodyPr wrap="square">
-            <a:spAutoFit/>
-          </a:bodyPr>
-          <a:lstStyle/>
-          <a:p>
-            <a:pPr>
-              <a:spcAft>
-                <a:spcPts val="1000"/>
-              </a:spcAft>
-              <a:defRPr sz="1500" b="1">
-                <a:solidFill>
-                  <a:srgbClr val="FC8019"/>
-                </a:solidFill>
-                <a:latin typeface="Arial"/>
-              </a:defRPr>
-            </a:pPr>
-            <a:r>
-              <a:t>HOW THE AI PREDICTS RELEVANT ADD-ONS</a:t>
-            </a:r>
-          </a:p>
-          <a:p>
-            <a:pPr>
-              <a:spcAft>
-                <a:spcPts val="800"/>
-              </a:spcAft>
-              <a:defRPr sz="1400">
-                <a:solidFill>
-                  <a:srgbClr val="F8FAFC"/>
-                </a:solidFill>
-                <a:latin typeface="Arial"/>
-              </a:defRPr>
-            </a:pPr>
-            <a:r>
-              <a:t>1. Dynamic Profile Mapping:</a:t>
-            </a:r>
-            <a:br/>
-            <a:r>
-              <a:t>AI tags users into segments (e.g. Rohan = Tech Professional) based on historical quick commerce discussions.</a:t>
-            </a:r>
-          </a:p>
-          <a:p>
-            <a:pPr>
-              <a:spcAft>
-                <a:spcPts val="800"/>
-              </a:spcAft>
-              <a:defRPr sz="1400">
-                <a:solidFill>
-                  <a:srgbClr val="F8FAFC"/>
-                </a:solidFill>
-                <a:latin typeface="Arial"/>
-              </a:defRPr>
-            </a:pPr>
-            <a:r>
-              <a:t>2. Basket Associations:</a:t>
-            </a:r>
-            <a:br/>
-            <a:r>
-              <a:t>Analyzes current items (e.g. milk) and matches frequently co-purchased categories (e.g. personal care face wash).</a:t>
-            </a:r>
-          </a:p>
-          <a:p>
-            <a:pPr>
-              <a:spcAft>
-                <a:spcPts val="800"/>
-              </a:spcAft>
-              <a:defRPr sz="1400">
-                <a:solidFill>
-                  <a:srgbClr val="F8FAFC"/>
-                </a:solidFill>
-                <a:latin typeface="Arial"/>
-              </a:defRPr>
-            </a:pPr>
-            <a:r>
-              <a:t>3. Dark Store Stock Sync:</a:t>
-            </a:r>
-            <a:br/>
-            <a:r>
-              <a:t>FastAPI filters catalog opportunities in real-time based on immediate dark store inventory levels.</a:t>
-            </a:r>
-          </a:p>
-        </p:txBody>
-      </p:sp>
-      <p:sp>
-        <p:nvSpPr>
-          <p:cNvPr id="9" name="TextBox 8"/>
-          <p:cNvSpPr txBox="1"/>
-          <p:nvPr/>
-        </p:nvSpPr>
-        <p:spPr>
-          <a:xfrm>
-            <a:off x="548640" y="6400800"/>
-            <a:ext cx="9144000" cy="274320"/>
-          </a:xfrm>
-          <a:prstGeom prst="rect">
-            <a:avLst/>
-          </a:prstGeom>
-          <a:noFill/>
-        </p:spPr>
-        <p:txBody>
-          <a:bodyPr wrap="none">
-            <a:spAutoFit/>
-          </a:bodyPr>
-          <a:lstStyle/>
-          <a:p>
-            <a:pPr>
-              <a:defRPr sz="1400">
-                <a:solidFill>
-                  <a:srgbClr val="94A3B8"/>
-                </a:solidFill>
-                <a:latin typeface="Arial"/>
-              </a:defRPr>
-            </a:pPr>
-            <a:r>
-              <a:t>Swiggy Instamart Growth Team Portfolio | Category Expansion Initiative</a:t>
-            </a:r>
-          </a:p>
-        </p:txBody>
-      </p:sp>
-      <p:sp>
-        <p:nvSpPr>
-          <p:cNvPr id="10" name="TextBox 9"/>
           <p:cNvSpPr txBox="1"/>
           <p:nvPr/>
         </p:nvSpPr>
@@ -7616,7 +8396,7 @@
               </a:defRPr>
             </a:pPr>
             <a:r>
-              <a:t>PART 4 · LIVE MVP PLAYGROUND</a:t>
+              <a:t>PART 3 · THE SOLUTION</a:t>
             </a:r>
           </a:p>
         </p:txBody>
@@ -7652,7 +8432,7 @@
               </a:defRPr>
             </a:pPr>
             <a:r>
-              <a:t>The Deployed MVP: 3-Minute Post-Checkout Add-On Window</a:t>
+              <a:t>One Prioritized Solution: Predictive AI Personalization</a:t>
             </a:r>
           </a:p>
         </p:txBody>
@@ -7666,7 +8446,7 @@
         <p:spPr>
           <a:xfrm>
             <a:off x="548640" y="1463040"/>
-            <a:ext cx="6217920" cy="4572000"/>
+            <a:ext cx="5303520" cy="4572000"/>
           </a:xfrm>
           <a:prstGeom prst="roundRect">
             <a:avLst/>
@@ -7711,7 +8491,7 @@
         <p:spPr>
           <a:xfrm>
             <a:off x="685800" y="1600200"/>
-            <a:ext cx="5943600" cy="4297680"/>
+            <a:ext cx="5029200" cy="4297680"/>
           </a:xfrm>
           <a:prstGeom prst="rect">
             <a:avLst/>
@@ -7736,7 +8516,7 @@
               </a:defRPr>
             </a:pPr>
             <a:r>
-              <a:t>Interactive Deployed Checkout Sandbox</a:t>
+              <a:t>AI INPUTS &amp; RANKING MODEL</a:t>
             </a:r>
           </a:p>
           <a:p>
@@ -7752,11 +8532,11 @@
               </a:defRPr>
             </a:pPr>
             <a:r>
-              <a:t>• Active Checkout Sandbox:</a:t>
+              <a:t>• Unified Ranking Inputs:</a:t>
             </a:r>
             <a:br/>
             <a:r>
-              <a:t>Placing everyday dairy essentials simulates payment completion and triggers the active 3-minute window.</a:t>
+              <a:t>[Previous Orders] + [Time/Season] + [Weather] + [Location] + [Current Basket] + [Similar Users]</a:t>
             </a:r>
           </a:p>
           <a:p>
@@ -7772,11 +8552,107 @@
               </a:defRPr>
             </a:pPr>
             <a:r>
-              <a:t>• Dynamic Countdown Banner:</a:t>
+              <a:t>• Real-Time Recommendation Pipeline:</a:t>
             </a:r>
             <a:br/>
             <a:r>
-              <a:t>Displays an urgent timer counting down the dark store's packaging cycle.</a:t>
+              <a:t>1. Input collection &amp; feature mapping.</a:t>
+            </a:r>
+            <a:br/>
+            <a:r>
+              <a:t>2. Neural Ranking Model predicts purchase probability.</a:t>
+            </a:r>
+            <a:br/>
+            <a:r>
+              <a:t>3. LLM Explanation constructs personalized hook (e.g. "Usually bought with नंदिनी milk").</a:t>
+            </a:r>
+            <a:br/>
+            <a:r>
+              <a:t>4. FastAPI inventory check displays available items.</a:t>
+            </a:r>
+          </a:p>
+        </p:txBody>
+      </p:sp>
+      <p:sp>
+        <p:nvSpPr>
+          <p:cNvPr id="7" name="Rounded Rectangle 6"/>
+          <p:cNvSpPr/>
+          <p:nvPr/>
+        </p:nvSpPr>
+        <p:spPr>
+          <a:xfrm>
+            <a:off x="6217920" y="1463040"/>
+            <a:ext cx="5394960" cy="4572000"/>
+          </a:xfrm>
+          <a:prstGeom prst="roundRect">
+            <a:avLst/>
+          </a:prstGeom>
+          <a:solidFill>
+            <a:srgbClr val="151B2C"/>
+          </a:solidFill>
+          <a:ln w="12700">
+            <a:solidFill>
+              <a:srgbClr val="222B44"/>
+            </a:solidFill>
+          </a:ln>
+        </p:spPr>
+        <p:style>
+          <a:lnRef idx="1">
+            <a:schemeClr val="accent1"/>
+          </a:lnRef>
+          <a:fillRef idx="3">
+            <a:schemeClr val="accent1"/>
+          </a:fillRef>
+          <a:effectRef idx="2">
+            <a:schemeClr val="accent1"/>
+          </a:effectRef>
+          <a:fontRef idx="minor">
+            <a:schemeClr val="lt1"/>
+          </a:fontRef>
+        </p:style>
+        <p:txBody>
+          <a:bodyPr rtlCol="0" anchor="ctr"/>
+          <a:lstStyle/>
+          <a:p>
+            <a:pPr algn="ctr"/>
+          </a:p>
+        </p:txBody>
+      </p:sp>
+      <p:sp>
+        <p:nvSpPr>
+          <p:cNvPr id="8" name="TextBox 7"/>
+          <p:cNvSpPr txBox="1"/>
+          <p:nvPr/>
+        </p:nvSpPr>
+        <p:spPr>
+          <a:xfrm>
+            <a:off x="6355080" y="1600200"/>
+            <a:ext cx="5120640" cy="4297680"/>
+          </a:xfrm>
+          <a:prstGeom prst="rect">
+            <a:avLst/>
+          </a:prstGeom>
+          <a:noFill/>
+        </p:spPr>
+        <p:txBody>
+          <a:bodyPr wrap="square">
+            <a:spAutoFit/>
+          </a:bodyPr>
+          <a:lstStyle/>
+          <a:p>
+            <a:pPr>
+              <a:spcAft>
+                <a:spcPts val="1000"/>
+              </a:spcAft>
+              <a:defRPr sz="1500" b="1">
+                <a:solidFill>
+                  <a:srgbClr val="FC8019"/>
+                </a:solidFill>
+                <a:latin typeface="Arial"/>
+              </a:defRPr>
+            </a:pPr>
+            <a:r>
+              <a:t>DYNAMIC PERSONALIZATION BENEFIT</a:t>
             </a:r>
           </a:p>
           <a:p>
@@ -7792,25 +8668,53 @@
               </a:defRPr>
             </a:pPr>
             <a:r>
-              <a:t>• Fee-Free Add-on Carousel:</a:t>
-            </a:r>
-            <a:br/>
-            <a:r>
-              <a:t>Displays organic avocados, dog treats, and face washes with ₹0 delivery fee. Selecting an item dynamically updates checkout totals.</a:t>
-            </a:r>
-          </a:p>
-        </p:txBody>
-      </p:sp>
-      <p:sp>
-        <p:nvSpPr>
-          <p:cNvPr id="7" name="TextBox 6"/>
+              <a:t>• Beyond Simple Rule Matches: Unlike static associations, the model evaluates context (e.g. recommending face wash during morning runs vs. baby care on weekends).</a:t>
+            </a:r>
+          </a:p>
+          <a:p>
+            <a:pPr>
+              <a:spcAft>
+                <a:spcPts val="800"/>
+              </a:spcAft>
+              <a:defRPr sz="1400">
+                <a:solidFill>
+                  <a:srgbClr val="F8FAFC"/>
+                </a:solidFill>
+                <a:latin typeface="Arial"/>
+              </a:defRPr>
+            </a:pPr>
+            <a:r>
+              <a:t>• Wave the Friction: Removes delivery fee block for 3 minutes. The recommendation banner communicates ₹0 additional delivery fee.</a:t>
+            </a:r>
+          </a:p>
+          <a:p>
+            <a:pPr>
+              <a:spcAft>
+                <a:spcPts val="800"/>
+              </a:spcAft>
+              <a:defRPr sz="1400">
+                <a:solidFill>
+                  <a:srgbClr val="F8FAFC"/>
+                </a:solidFill>
+                <a:latin typeface="Arial"/>
+              </a:defRPr>
+            </a:pPr>
+            <a:r>
+              <a:t>• Dark Store Synced: Dynamic FastAPI catalog filters guarantee that only in-stock items are recommended.</a:t>
+            </a:r>
+          </a:p>
+        </p:txBody>
+      </p:sp>
+      <p:sp>
+        <p:nvSpPr>
+          <p:cNvPr id="9" name="TextBox 8"/>
           <p:cNvSpPr txBox="1"/>
           <p:nvPr/>
         </p:nvSpPr>
         <p:spPr>
           <a:xfrm>
-            <a:off x="685800" y="4754880"/>
-            <a:ext cx="5943600" cy="914400"/>
+            <a:off x="548640" y="6400800"/>
+            <a:ext cx="9144000" cy="274320"/>
           </a:xfrm>
           <a:prstGeom prst="rect">
             <a:avLst/>
@@ -7818,75 +8722,6 @@
           <a:noFill/>
         </p:spPr>
         <p:txBody>
-          <a:bodyPr wrap="square">
-            <a:spAutoFit/>
-          </a:bodyPr>
-          <a:lstStyle/>
-          <a:p>
-            <a:pPr>
-              <a:defRPr sz="1400">
-                <a:solidFill>
-                  <a:srgbClr val="F8FAFC"/>
-                </a:solidFill>
-                <a:latin typeface="Arial"/>
-              </a:defRPr>
-            </a:pPr>
-            <a:r>
-              <a:t>Try the Deployed MVP: </a:t>
-            </a:r>
-            <a:r>
-              <a:rPr u="sng">
-                <a:solidFill>
-                  <a:srgbClr val="3B82F6"/>
-                </a:solidFill>
-                <a:hlinkClick r:id="rId2"/>
-              </a:rPr>
-              <a:t>https://aashritamalviya1999.github.io/swiggy-instamart-discovery/</a:t>
-            </a:r>
-          </a:p>
-        </p:txBody>
-      </p:sp>
-      <p:pic>
-        <p:nvPicPr>
-          <p:cNvPr id="8" name="Picture 7" descr="mvp_checkout_mockup.jpg"/>
-          <p:cNvPicPr>
-            <a:picLocks noChangeAspect="1"/>
-          </p:cNvPicPr>
-          <p:nvPr/>
-        </p:nvPicPr>
-        <p:blipFill>
-          <a:blip r:embed="rId3"/>
-          <a:stretch>
-            <a:fillRect/>
-          </a:stretch>
-        </p:blipFill>
-        <p:spPr>
-          <a:xfrm>
-            <a:off x="6949440" y="1463040"/>
-            <a:ext cx="4663440" cy="4572000"/>
-          </a:xfrm>
-          <a:prstGeom prst="rect">
-            <a:avLst/>
-          </a:prstGeom>
-        </p:spPr>
-      </p:pic>
-      <p:sp>
-        <p:nvSpPr>
-          <p:cNvPr id="9" name="TextBox 8"/>
-          <p:cNvSpPr txBox="1"/>
-          <p:nvPr/>
-        </p:nvSpPr>
-        <p:spPr>
-          <a:xfrm>
-            <a:off x="548640" y="6400800"/>
-            <a:ext cx="9144000" cy="274320"/>
-          </a:xfrm>
-          <a:prstGeom prst="rect">
-            <a:avLst/>
-          </a:prstGeom>
-          <a:noFill/>
-        </p:spPr>
-        <p:txBody>
           <a:bodyPr wrap="none">
             <a:spAutoFit/>
           </a:bodyPr>
@@ -7901,7 +8736,7 @@
               </a:defRPr>
             </a:pPr>
             <a:r>
-              <a:t>Swiggy Instamart Growth Team Portfolio | Category Expansion Initiative</a:t>
+              <a:t>Swiggy Instamart Growth Portfolio | AI Product Discovery Engine</a:t>
             </a:r>
           </a:p>
         </p:txBody>
@@ -8034,7 +8869,7 @@
               </a:defRPr>
             </a:pPr>
             <a:r>
-              <a:t>PART 4 · GTM ROLLOUT STRATEGY</a:t>
+              <a:t>PART 4 · LIVE MVP PLAYGROUND</a:t>
             </a:r>
           </a:p>
         </p:txBody>
@@ -8070,7 +8905,7 @@
               </a:defRPr>
             </a:pPr>
             <a:r>
-              <a:t>MVP Phased Operational Rollout Strategy</a:t>
+              <a:t>The Deployed MVP: 3-Minute Post-Checkout Add-On Window</a:t>
             </a:r>
           </a:p>
         </p:txBody>
@@ -8084,7 +8919,7 @@
         <p:spPr>
           <a:xfrm>
             <a:off x="548640" y="1463040"/>
-            <a:ext cx="5303520" cy="4572000"/>
+            <a:ext cx="6217920" cy="4572000"/>
           </a:xfrm>
           <a:prstGeom prst="roundRect">
             <a:avLst/>
@@ -8129,7 +8964,7 @@
         <p:spPr>
           <a:xfrm>
             <a:off x="685800" y="1600200"/>
-            <a:ext cx="5029200" cy="4297680"/>
+            <a:ext cx="5943600" cy="4297680"/>
           </a:xfrm>
           <a:prstGeom prst="rect">
             <a:avLst/>
@@ -8154,7 +8989,7 @@
               </a:defRPr>
             </a:pPr>
             <a:r>
-              <a:t>Phased Rollout Stages</a:t>
+              <a:t>Interactive Deployed Checkout Sandbox</a:t>
             </a:r>
           </a:p>
           <a:p>
@@ -8170,7 +9005,7 @@
               </a:defRPr>
             </a:pPr>
             <a:r>
-              <a:t>To minimize operational delays at dark stores, we roll out the feature using a phased operational sandbox:</a:t>
+              <a:t>• Checkout Simulator: Placing dairy essentials simulates payment completion and triggers the active 3-minute window.</a:t>
             </a:r>
           </a:p>
           <a:p>
@@ -8186,11 +9021,7 @@
               </a:defRPr>
             </a:pPr>
             <a:r>
-              <a:t>• Phase 1: Shadow Mode (Weeks 1-2)</a:t>
-            </a:r>
-            <a:br/>
-            <a:r>
-              <a:t>Track background behavior. Measure add-on clicks post-checkout without showing UI. Check matching dark store pack cycles.</a:t>
+              <a:t>• Dynamic Countdown Banner: Displays an urgent timer counting down the dark store's packaging cycle.</a:t>
             </a:r>
           </a:p>
           <a:p>
@@ -8206,90 +9037,21 @@
               </a:defRPr>
             </a:pPr>
             <a:r>
-              <a:t>• Phase 2: Operational Buffer Trial (Weeks 3-6)</a:t>
-            </a:r>
-            <a:br/>
-            <a:r>
-              <a:t>Launch in 1 dark store (Bangalore East). Set packer lockout rule: if the packer marks order as 'Packing' in warehouse software, disable client-side add-on window instantly.</a:t>
-            </a:r>
-          </a:p>
-          <a:p>
-            <a:pPr>
-              <a:spcAft>
-                <a:spcPts val="800"/>
-              </a:spcAft>
-              <a:defRPr sz="1400">
-                <a:solidFill>
-                  <a:srgbClr val="F8FAFC"/>
-                </a:solidFill>
-                <a:latin typeface="Arial"/>
-              </a:defRPr>
-            </a:pPr>
-            <a:r>
-              <a:t>• Phase 3: Tiered City Expansion (Weeks 7-12)</a:t>
-            </a:r>
-            <a:br/>
-            <a:r>
-              <a:t>Expand to 10 dark stores. Integrate with Swiggy One membership.</a:t>
-            </a:r>
-          </a:p>
-        </p:txBody>
-      </p:sp>
-      <p:sp>
-        <p:nvSpPr>
-          <p:cNvPr id="7" name="Rounded Rectangle 6"/>
-          <p:cNvSpPr/>
-          <p:nvPr/>
-        </p:nvSpPr>
-        <p:spPr>
-          <a:xfrm>
-            <a:off x="6217920" y="1463040"/>
-            <a:ext cx="5394960" cy="4572000"/>
-          </a:xfrm>
-          <a:prstGeom prst="roundRect">
-            <a:avLst/>
-          </a:prstGeom>
-          <a:solidFill>
-            <a:srgbClr val="151B2C"/>
-          </a:solidFill>
-          <a:ln w="12700">
-            <a:solidFill>
-              <a:srgbClr val="222B44"/>
-            </a:solidFill>
-          </a:ln>
-        </p:spPr>
-        <p:style>
-          <a:lnRef idx="1">
-            <a:schemeClr val="accent1"/>
-          </a:lnRef>
-          <a:fillRef idx="3">
-            <a:schemeClr val="accent1"/>
-          </a:fillRef>
-          <a:effectRef idx="2">
-            <a:schemeClr val="accent1"/>
-          </a:effectRef>
-          <a:fontRef idx="minor">
-            <a:schemeClr val="lt1"/>
-          </a:fontRef>
-        </p:style>
-        <p:txBody>
-          <a:bodyPr rtlCol="0" anchor="ctr"/>
-          <a:lstStyle/>
-          <a:p>
-            <a:pPr algn="ctr"/>
-          </a:p>
-        </p:txBody>
-      </p:sp>
-      <p:sp>
-        <p:nvSpPr>
-          <p:cNvPr id="8" name="TextBox 7"/>
+              <a:t>• Fee-Free Add-on Carousel: Displays organic avocados, dog treats, and face washes with ₹0 delivery fee. Selecting an item dynamically updates checkout totals.</a:t>
+            </a:r>
+          </a:p>
+        </p:txBody>
+      </p:sp>
+      <p:sp>
+        <p:nvSpPr>
+          <p:cNvPr id="7" name="TextBox 6"/>
           <p:cNvSpPr txBox="1"/>
           <p:nvPr/>
         </p:nvSpPr>
         <p:spPr>
           <a:xfrm>
-            <a:off x="6355080" y="1600200"/>
-            <a:ext cx="5120640" cy="4297680"/>
+            <a:off x="685800" y="4754880"/>
+            <a:ext cx="5943600" cy="914400"/>
           </a:xfrm>
           <a:prstGeom prst="rect">
             <a:avLst/>
@@ -8303,25 +9065,6 @@
           <a:lstStyle/>
           <a:p>
             <a:pPr>
-              <a:spcAft>
-                <a:spcPts val="1000"/>
-              </a:spcAft>
-              <a:defRPr sz="1500" b="1">
-                <a:solidFill>
-                  <a:srgbClr val="FC8019"/>
-                </a:solidFill>
-                <a:latin typeface="Arial"/>
-              </a:defRPr>
-            </a:pPr>
-            <a:r>
-              <a:t>Operational Lock-out &amp; Rider Safety Gates</a:t>
-            </a:r>
-          </a:p>
-          <a:p>
-            <a:pPr>
-              <a:spcAft>
-                <a:spcPts val="800"/>
-              </a:spcAft>
               <a:defRPr sz="1400">
                 <a:solidFill>
                   <a:srgbClr val="F8FAFC"/>
@@ -8330,71 +9073,44 @@
               </a:defRPr>
             </a:pPr>
             <a:r>
-              <a:t>We enforce three software guardrails to protect delivery SLAs:</a:t>
-            </a:r>
-          </a:p>
-          <a:p>
-            <a:pPr>
-              <a:spcAft>
-                <a:spcPts val="800"/>
-              </a:spcAft>
-              <a:defRPr sz="1400">
-                <a:solidFill>
-                  <a:srgbClr val="F8FAFC"/>
-                </a:solidFill>
-                <a:latin typeface="Arial"/>
-              </a:defRPr>
-            </a:pPr>
-            <a:r>
-              <a:t>1. Packing Status Gate:</a:t>
-            </a:r>
-            <a:br/>
-            <a:r>
-              <a:t>The window is disabled if warehouse packing has already started. This prevents packers from re-opening sealed packages.</a:t>
-            </a:r>
-          </a:p>
-          <a:p>
-            <a:pPr>
-              <a:spcAft>
-                <a:spcPts val="800"/>
-              </a:spcAft>
-              <a:defRPr sz="1400">
-                <a:solidFill>
-                  <a:srgbClr val="F8FAFC"/>
-                </a:solidFill>
-                <a:latin typeface="Arial"/>
-              </a:defRPr>
-            </a:pPr>
-            <a:r>
-              <a:t>2. Weight Capacity Gate:</a:t>
-            </a:r>
-            <a:br/>
-            <a:r>
-              <a:t>Limit add-on catalog to items &lt;2kg. Heavy items (e.g. 5kg dog food bags) are blocked to keep bikes within safety weight thresholds.</a:t>
-            </a:r>
-          </a:p>
-          <a:p>
-            <a:pPr>
-              <a:spcAft>
-                <a:spcPts val="800"/>
-              </a:spcAft>
-              <a:defRPr sz="1400">
-                <a:solidFill>
-                  <a:srgbClr val="F8FAFC"/>
-                </a:solidFill>
-                <a:latin typeface="Arial"/>
-              </a:defRPr>
-            </a:pPr>
-            <a:r>
-              <a:t>3. Single-Rider Hand-off:</a:t>
-            </a:r>
-            <a:br/>
-            <a:r>
-              <a:t>The add-on order is merged into the original rider package. No secondary rider is assigned.</a:t>
-            </a:r>
-          </a:p>
-        </p:txBody>
-      </p:sp>
+              <a:t>Try the Deployed MVP: </a:t>
+            </a:r>
+            <a:r>
+              <a:rPr u="sng">
+                <a:solidFill>
+                  <a:srgbClr val="3B82F6"/>
+                </a:solidFill>
+                <a:hlinkClick r:id="rId2"/>
+              </a:rPr>
+              <a:t>https://aashritamalviya1999.github.io/swiggy-instamart-discovery/</a:t>
+            </a:r>
+          </a:p>
+        </p:txBody>
+      </p:sp>
+      <p:pic>
+        <p:nvPicPr>
+          <p:cNvPr id="8" name="Picture 7" descr="mvp_checkout_mockup.jpg"/>
+          <p:cNvPicPr>
+            <a:picLocks noChangeAspect="1"/>
+          </p:cNvPicPr>
+          <p:nvPr/>
+        </p:nvPicPr>
+        <p:blipFill>
+          <a:blip r:embed="rId3"/>
+          <a:stretch>
+            <a:fillRect/>
+          </a:stretch>
+        </p:blipFill>
+        <p:spPr>
+          <a:xfrm>
+            <a:off x="6949440" y="1463040"/>
+            <a:ext cx="4663440" cy="4572000"/>
+          </a:xfrm>
+          <a:prstGeom prst="rect">
+            <a:avLst/>
+          </a:prstGeom>
+        </p:spPr>
+      </p:pic>
       <p:sp>
         <p:nvSpPr>
           <p:cNvPr id="9" name="TextBox 8"/>
@@ -8426,7 +9142,7 @@
               </a:defRPr>
             </a:pPr>
             <a:r>
-              <a:t>Swiggy Instamart Growth Team Portfolio | Category Expansion Initiative</a:t>
+              <a:t>Swiggy Instamart Growth Portfolio | AI Product Discovery Engine</a:t>
             </a:r>
           </a:p>
         </p:txBody>
@@ -8559,7 +9275,7 @@
               </a:defRPr>
             </a:pPr>
             <a:r>
-              <a:t>PART 4 · GTM METRICS</a:t>
+              <a:t>PART 4 · GTM ROLLOUT</a:t>
             </a:r>
           </a:p>
         </p:txBody>
@@ -8595,660 +9311,21 @@
               </a:defRPr>
             </a:pPr>
             <a:r>
-              <a:t>Phased GTM Pilot &amp; Guardrail Success Metrics</a:t>
-            </a:r>
-          </a:p>
-        </p:txBody>
-      </p:sp>
-      <p:graphicFrame>
-        <p:nvGraphicFramePr>
-          <p:cNvPr id="5" name="Table 4"/>
-          <p:cNvGraphicFramePr>
-            <a:graphicFrameLocks noGrp="1"/>
-          </p:cNvGraphicFramePr>
-          <p:nvPr/>
-        </p:nvGraphicFramePr>
-        <p:xfrm>
-          <a:off x="548640" y="1463040"/>
-          <a:ext cx="5486400" cy="4572000"/>
-        </p:xfrm>
-        <a:graphic>
-          <a:graphicData uri="http://schemas.openxmlformats.org/drawingml/2006/table">
-            <a:tbl>
-              <a:tblPr firstRow="1" bandRow="1">
-                <a:tableStyleId>{5C22544A-7EE6-4342-B048-85BDC9FD1C3A}</a:tableStyleId>
-              </a:tblPr>
-              <a:tblGrid>
-                <a:gridCol w="1554480"/>
-                <a:gridCol w="731520"/>
-                <a:gridCol w="1005840"/>
-                <a:gridCol w="1005840"/>
-                <a:gridCol w="1188720"/>
-              </a:tblGrid>
-              <a:tr h="914400">
-                <a:tc>
-                  <a:txBody>
-                    <a:bodyPr/>
-                    <a:lstStyle/>
-                    <a:p>
-                      <a:pPr>
-                        <a:defRPr sz="1400" b="1">
-                          <a:solidFill>
-                            <a:srgbClr val="F8FAFC"/>
-                          </a:solidFill>
-                          <a:latin typeface="Arial"/>
-                        </a:defRPr>
-                      </a:pPr>
-                      <a:r>
-                        <a:t>Category</a:t>
-                      </a:r>
-                    </a:p>
-                  </a:txBody>
-                  <a:tcPr>
-                    <a:solidFill>
-                      <a:srgbClr val="222B44"/>
-                    </a:solidFill>
-                  </a:tcPr>
-                </a:tc>
-                <a:tc>
-                  <a:txBody>
-                    <a:bodyPr/>
-                    <a:lstStyle/>
-                    <a:p>
-                      <a:pPr>
-                        <a:defRPr sz="1400" b="1">
-                          <a:solidFill>
-                            <a:srgbClr val="F8FAFC"/>
-                          </a:solidFill>
-                          <a:latin typeface="Arial"/>
-                        </a:defRPr>
-                      </a:pPr>
-                      <a:r>
-                        <a:t>Base</a:t>
-                      </a:r>
-                    </a:p>
-                  </a:txBody>
-                  <a:tcPr>
-                    <a:solidFill>
-                      <a:srgbClr val="222B44"/>
-                    </a:solidFill>
-                  </a:tcPr>
-                </a:tc>
-                <a:tc>
-                  <a:txBody>
-                    <a:bodyPr/>
-                    <a:lstStyle/>
-                    <a:p>
-                      <a:pPr>
-                        <a:defRPr sz="1400" b="1">
-                          <a:solidFill>
-                            <a:srgbClr val="F8FAFC"/>
-                          </a:solidFill>
-                          <a:latin typeface="Arial"/>
-                        </a:defRPr>
-                      </a:pPr>
-                      <a:r>
-                        <a:t>Target 30D</a:t>
-                      </a:r>
-                    </a:p>
-                  </a:txBody>
-                  <a:tcPr>
-                    <a:solidFill>
-                      <a:srgbClr val="222B44"/>
-                    </a:solidFill>
-                  </a:tcPr>
-                </a:tc>
-                <a:tc>
-                  <a:txBody>
-                    <a:bodyPr/>
-                    <a:lstStyle/>
-                    <a:p>
-                      <a:pPr>
-                        <a:defRPr sz="1400" b="1">
-                          <a:solidFill>
-                            <a:srgbClr val="F8FAFC"/>
-                          </a:solidFill>
-                          <a:latin typeface="Arial"/>
-                        </a:defRPr>
-                      </a:pPr>
-                      <a:r>
-                        <a:t>Target 90D</a:t>
-                      </a:r>
-                    </a:p>
-                  </a:txBody>
-                  <a:tcPr>
-                    <a:solidFill>
-                      <a:srgbClr val="222B44"/>
-                    </a:solidFill>
-                  </a:tcPr>
-                </a:tc>
-                <a:tc>
-                  <a:txBody>
-                    <a:bodyPr/>
-                    <a:lstStyle/>
-                    <a:p>
-                      <a:pPr>
-                        <a:defRPr sz="1400" b="1">
-                          <a:solidFill>
-                            <a:srgbClr val="F8FAFC"/>
-                          </a:solidFill>
-                          <a:latin typeface="Arial"/>
-                        </a:defRPr>
-                      </a:pPr>
-                      <a:r>
-                        <a:t>Friction Solved</a:t>
-                      </a:r>
-                    </a:p>
-                  </a:txBody>
-                  <a:tcPr>
-                    <a:solidFill>
-                      <a:srgbClr val="222B44"/>
-                    </a:solidFill>
-                  </a:tcPr>
-                </a:tc>
-              </a:tr>
-              <a:tr h="914400">
-                <a:tc>
-                  <a:txBody>
-                    <a:bodyPr/>
-                    <a:lstStyle/>
-                    <a:p>
-                      <a:pPr>
-                        <a:defRPr sz="1400" b="1">
-                          <a:solidFill>
-                            <a:srgbClr val="F8FAFC"/>
-                          </a:solidFill>
-                          <a:latin typeface="Arial"/>
-                        </a:defRPr>
-                      </a:pPr>
-                      <a:r>
-                        <a:t>Gourmet</a:t>
-                      </a:r>
-                    </a:p>
-                  </a:txBody>
-                  <a:tcPr>
-                    <a:solidFill>
-                      <a:srgbClr val="151B2C"/>
-                    </a:solidFill>
-                  </a:tcPr>
-                </a:tc>
-                <a:tc>
-                  <a:txBody>
-                    <a:bodyPr/>
-                    <a:lstStyle/>
-                    <a:p>
-                      <a:pPr>
-                        <a:defRPr sz="1400" b="0">
-                          <a:solidFill>
-                            <a:srgbClr val="94A3B8"/>
-                          </a:solidFill>
-                          <a:latin typeface="Arial"/>
-                        </a:defRPr>
-                      </a:pPr>
-                      <a:r>
-                        <a:t>4.2%</a:t>
-                      </a:r>
-                    </a:p>
-                  </a:txBody>
-                  <a:tcPr>
-                    <a:solidFill>
-                      <a:srgbClr val="151B2C"/>
-                    </a:solidFill>
-                  </a:tcPr>
-                </a:tc>
-                <a:tc>
-                  <a:txBody>
-                    <a:bodyPr/>
-                    <a:lstStyle/>
-                    <a:p>
-                      <a:pPr>
-                        <a:defRPr sz="1400" b="1">
-                          <a:solidFill>
-                            <a:srgbClr val="FC8019"/>
-                          </a:solidFill>
-                          <a:latin typeface="Arial"/>
-                        </a:defRPr>
-                      </a:pPr>
-                      <a:r>
-                        <a:t>12.0%</a:t>
-                      </a:r>
-                    </a:p>
-                  </a:txBody>
-                  <a:tcPr>
-                    <a:solidFill>
-                      <a:srgbClr val="151B2C"/>
-                    </a:solidFill>
-                  </a:tcPr>
-                </a:tc>
-                <a:tc>
-                  <a:txBody>
-                    <a:bodyPr/>
-                    <a:lstStyle/>
-                    <a:p>
-                      <a:pPr>
-                        <a:defRPr sz="1400" b="1">
-                          <a:solidFill>
-                            <a:srgbClr val="22C55E"/>
-                          </a:solidFill>
-                          <a:latin typeface="Arial"/>
-                        </a:defRPr>
-                      </a:pPr>
-                      <a:r>
-                        <a:t>18.5%</a:t>
-                      </a:r>
-                    </a:p>
-                  </a:txBody>
-                  <a:tcPr>
-                    <a:solidFill>
-                      <a:srgbClr val="151B2C"/>
-                    </a:solidFill>
-                  </a:tcPr>
-                </a:tc>
-                <a:tc>
-                  <a:txBody>
-                    <a:bodyPr/>
-                    <a:lstStyle/>
-                    <a:p>
-                      <a:pPr>
-                        <a:defRPr sz="1400" b="0">
-                          <a:solidFill>
-                            <a:srgbClr val="F8FAFC"/>
-                          </a:solidFill>
-                          <a:latin typeface="Arial"/>
-                        </a:defRPr>
-                      </a:pPr>
-                      <a:r>
-                        <a:t>Delivery Fee</a:t>
-                      </a:r>
-                    </a:p>
-                  </a:txBody>
-                  <a:tcPr>
-                    <a:solidFill>
-                      <a:srgbClr val="151B2C"/>
-                    </a:solidFill>
-                  </a:tcPr>
-                </a:tc>
-              </a:tr>
-              <a:tr h="914400">
-                <a:tc>
-                  <a:txBody>
-                    <a:bodyPr/>
-                    <a:lstStyle/>
-                    <a:p>
-                      <a:pPr>
-                        <a:defRPr sz="1400" b="1">
-                          <a:solidFill>
-                            <a:srgbClr val="F8FAFC"/>
-                          </a:solidFill>
-                          <a:latin typeface="Arial"/>
-                        </a:defRPr>
-                      </a:pPr>
-                      <a:r>
-                        <a:t>Personal Care</a:t>
-                      </a:r>
-                    </a:p>
-                  </a:txBody>
-                  <a:tcPr>
-                    <a:solidFill>
-                      <a:srgbClr val="151B2C"/>
-                    </a:solidFill>
-                  </a:tcPr>
-                </a:tc>
-                <a:tc>
-                  <a:txBody>
-                    <a:bodyPr/>
-                    <a:lstStyle/>
-                    <a:p>
-                      <a:pPr>
-                        <a:defRPr sz="1400" b="0">
-                          <a:solidFill>
-                            <a:srgbClr val="94A3B8"/>
-                          </a:solidFill>
-                          <a:latin typeface="Arial"/>
-                        </a:defRPr>
-                      </a:pPr>
-                      <a:r>
-                        <a:t>3.1%</a:t>
-                      </a:r>
-                    </a:p>
-                  </a:txBody>
-                  <a:tcPr>
-                    <a:solidFill>
-                      <a:srgbClr val="151B2C"/>
-                    </a:solidFill>
-                  </a:tcPr>
-                </a:tc>
-                <a:tc>
-                  <a:txBody>
-                    <a:bodyPr/>
-                    <a:lstStyle/>
-                    <a:p>
-                      <a:pPr>
-                        <a:defRPr sz="1400" b="1">
-                          <a:solidFill>
-                            <a:srgbClr val="FC8019"/>
-                          </a:solidFill>
-                          <a:latin typeface="Arial"/>
-                        </a:defRPr>
-                      </a:pPr>
-                      <a:r>
-                        <a:t>8.5%</a:t>
-                      </a:r>
-                    </a:p>
-                  </a:txBody>
-                  <a:tcPr>
-                    <a:solidFill>
-                      <a:srgbClr val="151B2C"/>
-                    </a:solidFill>
-                  </a:tcPr>
-                </a:tc>
-                <a:tc>
-                  <a:txBody>
-                    <a:bodyPr/>
-                    <a:lstStyle/>
-                    <a:p>
-                      <a:pPr>
-                        <a:defRPr sz="1400" b="1">
-                          <a:solidFill>
-                            <a:srgbClr val="22C55E"/>
-                          </a:solidFill>
-                          <a:latin typeface="Arial"/>
-                        </a:defRPr>
-                      </a:pPr>
-                      <a:r>
-                        <a:t>14.0%</a:t>
-                      </a:r>
-                    </a:p>
-                  </a:txBody>
-                  <a:tcPr>
-                    <a:solidFill>
-                      <a:srgbClr val="151B2C"/>
-                    </a:solidFill>
-                  </a:tcPr>
-                </a:tc>
-                <a:tc>
-                  <a:txBody>
-                    <a:bodyPr/>
-                    <a:lstStyle/>
-                    <a:p>
-                      <a:pPr>
-                        <a:defRPr sz="1400" b="0">
-                          <a:solidFill>
-                            <a:srgbClr val="F8FAFC"/>
-                          </a:solidFill>
-                          <a:latin typeface="Arial"/>
-                        </a:defRPr>
-                      </a:pPr>
-                      <a:r>
-                        <a:t>Delivery Fee</a:t>
-                      </a:r>
-                    </a:p>
-                  </a:txBody>
-                  <a:tcPr>
-                    <a:solidFill>
-                      <a:srgbClr val="151B2C"/>
-                    </a:solidFill>
-                  </a:tcPr>
-                </a:tc>
-              </a:tr>
-              <a:tr h="914400">
-                <a:tc>
-                  <a:txBody>
-                    <a:bodyPr/>
-                    <a:lstStyle/>
-                    <a:p>
-                      <a:pPr>
-                        <a:defRPr sz="1400" b="1">
-                          <a:solidFill>
-                            <a:srgbClr val="F8FAFC"/>
-                          </a:solidFill>
-                          <a:latin typeface="Arial"/>
-                        </a:defRPr>
-                      </a:pPr>
-                      <a:r>
-                        <a:t>Baby Care</a:t>
-                      </a:r>
-                    </a:p>
-                  </a:txBody>
-                  <a:tcPr>
-                    <a:solidFill>
-                      <a:srgbClr val="151B2C"/>
-                    </a:solidFill>
-                  </a:tcPr>
-                </a:tc>
-                <a:tc>
-                  <a:txBody>
-                    <a:bodyPr/>
-                    <a:lstStyle/>
-                    <a:p>
-                      <a:pPr>
-                        <a:defRPr sz="1400" b="0">
-                          <a:solidFill>
-                            <a:srgbClr val="94A3B8"/>
-                          </a:solidFill>
-                          <a:latin typeface="Arial"/>
-                        </a:defRPr>
-                      </a:pPr>
-                      <a:r>
-                        <a:t>1.8%</a:t>
-                      </a:r>
-                    </a:p>
-                  </a:txBody>
-                  <a:tcPr>
-                    <a:solidFill>
-                      <a:srgbClr val="151B2C"/>
-                    </a:solidFill>
-                  </a:tcPr>
-                </a:tc>
-                <a:tc>
-                  <a:txBody>
-                    <a:bodyPr/>
-                    <a:lstStyle/>
-                    <a:p>
-                      <a:pPr>
-                        <a:defRPr sz="1400" b="1">
-                          <a:solidFill>
-                            <a:srgbClr val="FC8019"/>
-                          </a:solidFill>
-                          <a:latin typeface="Arial"/>
-                        </a:defRPr>
-                      </a:pPr>
-                      <a:r>
-                        <a:t>5.0%</a:t>
-                      </a:r>
-                    </a:p>
-                  </a:txBody>
-                  <a:tcPr>
-                    <a:solidFill>
-                      <a:srgbClr val="151B2C"/>
-                    </a:solidFill>
-                  </a:tcPr>
-                </a:tc>
-                <a:tc>
-                  <a:txBody>
-                    <a:bodyPr/>
-                    <a:lstStyle/>
-                    <a:p>
-                      <a:pPr>
-                        <a:defRPr sz="1400" b="1">
-                          <a:solidFill>
-                            <a:srgbClr val="22C55E"/>
-                          </a:solidFill>
-                          <a:latin typeface="Arial"/>
-                        </a:defRPr>
-                      </a:pPr>
-                      <a:r>
-                        <a:t>9.5%</a:t>
-                      </a:r>
-                    </a:p>
-                  </a:txBody>
-                  <a:tcPr>
-                    <a:solidFill>
-                      <a:srgbClr val="151B2C"/>
-                    </a:solidFill>
-                  </a:tcPr>
-                </a:tc>
-                <a:tc>
-                  <a:txBody>
-                    <a:bodyPr/>
-                    <a:lstStyle/>
-                    <a:p>
-                      <a:pPr>
-                        <a:defRPr sz="1400" b="0">
-                          <a:solidFill>
-                            <a:srgbClr val="F8FAFC"/>
-                          </a:solidFill>
-                          <a:latin typeface="Arial"/>
-                        </a:defRPr>
-                      </a:pPr>
-                      <a:r>
-                        <a:t>Size Charts</a:t>
-                      </a:r>
-                    </a:p>
-                  </a:txBody>
-                  <a:tcPr>
-                    <a:solidFill>
-                      <a:srgbClr val="151B2C"/>
-                    </a:solidFill>
-                  </a:tcPr>
-                </a:tc>
-              </a:tr>
-              <a:tr h="914400">
-                <a:tc>
-                  <a:txBody>
-                    <a:bodyPr/>
-                    <a:lstStyle/>
-                    <a:p>
-                      <a:pPr>
-                        <a:defRPr sz="1400" b="1">
-                          <a:solidFill>
-                            <a:srgbClr val="F8FAFC"/>
-                          </a:solidFill>
-                          <a:latin typeface="Arial"/>
-                        </a:defRPr>
-                      </a:pPr>
-                      <a:r>
-                        <a:t>Pet Care</a:t>
-                      </a:r>
-                    </a:p>
-                  </a:txBody>
-                  <a:tcPr>
-                    <a:solidFill>
-                      <a:srgbClr val="151B2C"/>
-                    </a:solidFill>
-                  </a:tcPr>
-                </a:tc>
-                <a:tc>
-                  <a:txBody>
-                    <a:bodyPr/>
-                    <a:lstStyle/>
-                    <a:p>
-                      <a:pPr>
-                        <a:defRPr sz="1400" b="0">
-                          <a:solidFill>
-                            <a:srgbClr val="94A3B8"/>
-                          </a:solidFill>
-                          <a:latin typeface="Arial"/>
-                        </a:defRPr>
-                      </a:pPr>
-                      <a:r>
-                        <a:t>2.5%</a:t>
-                      </a:r>
-                    </a:p>
-                  </a:txBody>
-                  <a:tcPr>
-                    <a:solidFill>
-                      <a:srgbClr val="151B2C"/>
-                    </a:solidFill>
-                  </a:tcPr>
-                </a:tc>
-                <a:tc>
-                  <a:txBody>
-                    <a:bodyPr/>
-                    <a:lstStyle/>
-                    <a:p>
-                      <a:pPr>
-                        <a:defRPr sz="1400" b="1">
-                          <a:solidFill>
-                            <a:srgbClr val="FC8019"/>
-                          </a:solidFill>
-                          <a:latin typeface="Arial"/>
-                        </a:defRPr>
-                      </a:pPr>
-                      <a:r>
-                        <a:t>7.0%</a:t>
-                      </a:r>
-                    </a:p>
-                  </a:txBody>
-                  <a:tcPr>
-                    <a:solidFill>
-                      <a:srgbClr val="151B2C"/>
-                    </a:solidFill>
-                  </a:tcPr>
-                </a:tc>
-                <a:tc>
-                  <a:txBody>
-                    <a:bodyPr/>
-                    <a:lstStyle/>
-                    <a:p>
-                      <a:pPr>
-                        <a:defRPr sz="1400" b="1">
-                          <a:solidFill>
-                            <a:srgbClr val="22C55E"/>
-                          </a:solidFill>
-                          <a:latin typeface="Arial"/>
-                        </a:defRPr>
-                      </a:pPr>
-                      <a:r>
-                        <a:t>12.0%</a:t>
-                      </a:r>
-                    </a:p>
-                  </a:txBody>
-                  <a:tcPr>
-                    <a:solidFill>
-                      <a:srgbClr val="151B2C"/>
-                    </a:solidFill>
-                  </a:tcPr>
-                </a:tc>
-                <a:tc>
-                  <a:txBody>
-                    <a:bodyPr/>
-                    <a:lstStyle/>
-                    <a:p>
-                      <a:pPr>
-                        <a:defRPr sz="1400" b="0">
-                          <a:solidFill>
-                            <a:srgbClr val="F8FAFC"/>
-                          </a:solidFill>
-                          <a:latin typeface="Arial"/>
-                        </a:defRPr>
-                      </a:pPr>
-                      <a:r>
-                        <a:t>10m Dispatch</a:t>
-                      </a:r>
-                    </a:p>
-                  </a:txBody>
-                  <a:tcPr>
-                    <a:solidFill>
-                      <a:srgbClr val="151B2C"/>
-                    </a:solidFill>
-                  </a:tcPr>
-                </a:tc>
-              </a:tr>
-            </a:tbl>
-          </a:graphicData>
-        </a:graphic>
-      </p:graphicFrame>
-      <p:sp>
-        <p:nvSpPr>
-          <p:cNvPr id="6" name="Rounded Rectangle 5"/>
+              <a:t>Phased Rollout Strategy &amp; Experiment Design</a:t>
+            </a:r>
+          </a:p>
+        </p:txBody>
+      </p:sp>
+      <p:sp>
+        <p:nvSpPr>
+          <p:cNvPr id="5" name="Rounded Rectangle 4"/>
           <p:cNvSpPr/>
           <p:nvPr/>
         </p:nvSpPr>
         <p:spPr>
           <a:xfrm>
-            <a:off x="6217920" y="1463040"/>
-            <a:ext cx="5394960" cy="4572000"/>
+            <a:off x="548640" y="1463040"/>
+            <a:ext cx="5303520" cy="4572000"/>
           </a:xfrm>
           <a:prstGeom prst="roundRect">
             <a:avLst/>
@@ -9286,14 +9363,14 @@
       </p:sp>
       <p:sp>
         <p:nvSpPr>
-          <p:cNvPr id="7" name="TextBox 6"/>
+          <p:cNvPr id="6" name="TextBox 5"/>
           <p:cNvSpPr txBox="1"/>
           <p:nvPr/>
         </p:nvSpPr>
         <p:spPr>
           <a:xfrm>
-            <a:off x="6355080" y="1600200"/>
-            <a:ext cx="5120640" cy="4297680"/>
+            <a:off x="685800" y="1600200"/>
+            <a:ext cx="5029200" cy="4297680"/>
           </a:xfrm>
           <a:prstGeom prst="rect">
             <a:avLst/>
@@ -9318,7 +9395,7 @@
               </a:defRPr>
             </a:pPr>
             <a:r>
-              <a:t>Metrics &amp; SLA Operational Guardrails</a:t>
+              <a:t>MVP PILOT EXPERIMENT DESIGN</a:t>
             </a:r>
           </a:p>
           <a:p>
@@ -9334,11 +9411,15 @@
               </a:defRPr>
             </a:pPr>
             <a:r>
-              <a:t>• North Star Metric: Cross-Category Discovery Completion Rate</a:t>
+              <a:t>• Target Testing Cohort Split:</a:t>
             </a:r>
             <a:br/>
             <a:r>
-              <a:t>Target: 35% completion rate in pilot dark stores within 30 days.</a:t>
+              <a:t>- Treatment: Post-checkout add-on window with timer &amp; waived delivery fee.</a:t>
+            </a:r>
+            <a:br/>
+            <a:r>
+              <a:t>- Control: Current standard checkout flow (no window, full fees).</a:t>
             </a:r>
           </a:p>
           <a:p>
@@ -9354,15 +9435,15 @@
               </a:defRPr>
             </a:pPr>
             <a:r>
-              <a:t>• Leading Success Indicators (0-30 Days):</a:t>
+              <a:t>• Experiment Metrics Measured:</a:t>
             </a:r>
             <a:br/>
             <a:r>
-              <a:t>  - Timer Conversion Rate: &gt;25% in week 2.</a:t>
+              <a:t>  - Primary: Cross-category purchase rate.</a:t>
             </a:r>
             <a:br/>
             <a:r>
-              <a:t>  - Platform Split Churn Delta: -5% churn to Zepto.</a:t>
+              <a:t>  - Secondary: Average Order Value (AOV), Customer Retention, Packer/Rider SLA.</a:t>
             </a:r>
           </a:p>
           <a:p>
@@ -9378,20 +9459,53 @@
               </a:defRPr>
             </a:pPr>
             <a:r>
-              <a:t>• SLA Guardrail Thresholds (Daily Monitoring):</a:t>
-            </a:r>
-            <a:br/>
-            <a:r>
-              <a:t>  - Rider Wait Time Delta: Keep &lt;+30 seconds. (If exceeded, drop timer window to 2 mins).</a:t>
-            </a:r>
-            <a:br/>
-            <a:r>
-              <a:t>  - Packer Picking SLA Delta: Keep &lt;+15 seconds.</a:t>
-            </a:r>
-            <a:br/>
-            <a:r>
-              <a:t>  - Recommendation Hide Rate: Keep &lt;5% rejection.</a:t>
-            </a:r>
+              <a:t>• Sample Size Power: Trialed in Bangalore East dark store over 30 days to reach statistical power.</a:t>
+            </a:r>
+          </a:p>
+        </p:txBody>
+      </p:sp>
+      <p:sp>
+        <p:nvSpPr>
+          <p:cNvPr id="7" name="Rounded Rectangle 6"/>
+          <p:cNvSpPr/>
+          <p:nvPr/>
+        </p:nvSpPr>
+        <p:spPr>
+          <a:xfrm>
+            <a:off x="6217920" y="1463040"/>
+            <a:ext cx="5394960" cy="4572000"/>
+          </a:xfrm>
+          <a:prstGeom prst="roundRect">
+            <a:avLst/>
+          </a:prstGeom>
+          <a:solidFill>
+            <a:srgbClr val="151B2C"/>
+          </a:solidFill>
+          <a:ln w="12700">
+            <a:solidFill>
+              <a:srgbClr val="222B44"/>
+            </a:solidFill>
+          </a:ln>
+        </p:spPr>
+        <p:style>
+          <a:lnRef idx="1">
+            <a:schemeClr val="accent1"/>
+          </a:lnRef>
+          <a:fillRef idx="3">
+            <a:schemeClr val="accent1"/>
+          </a:fillRef>
+          <a:effectRef idx="2">
+            <a:schemeClr val="accent1"/>
+          </a:effectRef>
+          <a:fontRef idx="minor">
+            <a:schemeClr val="lt1"/>
+          </a:fontRef>
+        </p:style>
+        <p:txBody>
+          <a:bodyPr rtlCol="0" anchor="ctr"/>
+          <a:lstStyle/>
+          <a:p>
+            <a:pPr algn="ctr"/>
           </a:p>
         </p:txBody>
       </p:sp>
@@ -9403,8 +9517,8 @@
         </p:nvSpPr>
         <p:spPr>
           <a:xfrm>
-            <a:off x="548640" y="6400800"/>
-            <a:ext cx="9144000" cy="274320"/>
+            <a:off x="6355080" y="1600200"/>
+            <a:ext cx="5120640" cy="4297680"/>
           </a:xfrm>
           <a:prstGeom prst="rect">
             <a:avLst/>
@@ -9412,6 +9526,101 @@
           <a:noFill/>
         </p:spPr>
         <p:txBody>
+          <a:bodyPr wrap="square">
+            <a:spAutoFit/>
+          </a:bodyPr>
+          <a:lstStyle/>
+          <a:p>
+            <a:pPr>
+              <a:spcAft>
+                <a:spcPts val="1000"/>
+              </a:spcAft>
+              <a:defRPr sz="1500" b="1">
+                <a:solidFill>
+                  <a:srgbClr val="FC8019"/>
+                </a:solidFill>
+                <a:latin typeface="Arial"/>
+              </a:defRPr>
+            </a:pPr>
+            <a:r>
+              <a:t>PHASED GTM AND SAFETY GATES</a:t>
+            </a:r>
+          </a:p>
+          <a:p>
+            <a:pPr>
+              <a:spcAft>
+                <a:spcPts val="800"/>
+              </a:spcAft>
+              <a:defRPr sz="1400">
+                <a:solidFill>
+                  <a:srgbClr val="F8FAFC"/>
+                </a:solidFill>
+                <a:latin typeface="Arial"/>
+              </a:defRPr>
+            </a:pPr>
+            <a:r>
+              <a:t>• Phased Rollout stages:</a:t>
+            </a:r>
+            <a:br/>
+            <a:r>
+              <a:t>- Shadow Mode (Weeks 1-2): Measure baseline cycles.</a:t>
+            </a:r>
+            <a:br/>
+            <a:r>
+              <a:t>- Buffer Trial (Weeks 3-6): Launch in 1 dark store.</a:t>
+            </a:r>
+            <a:br/>
+            <a:r>
+              <a:t>- Expansion (Weeks 7-12): Scale to 10 dark stores.</a:t>
+            </a:r>
+          </a:p>
+          <a:p>
+            <a:pPr>
+              <a:spcAft>
+                <a:spcPts val="800"/>
+              </a:spcAft>
+              <a:defRPr sz="1400">
+                <a:solidFill>
+                  <a:srgbClr val="F8FAFC"/>
+                </a:solidFill>
+                <a:latin typeface="Arial"/>
+              </a:defRPr>
+            </a:pPr>
+            <a:r>
+              <a:t>• Operational Lock-out Gates:</a:t>
+            </a:r>
+            <a:br/>
+            <a:r>
+              <a:t>- Packing status: Disable client UI if packing has started.</a:t>
+            </a:r>
+            <a:br/>
+            <a:r>
+              <a:t>- Weight Gate: Limit add-ons to items &lt;2kg.</a:t>
+            </a:r>
+            <a:br/>
+            <a:r>
+              <a:t>- Single-Rider: Append order merges into original package.</a:t>
+            </a:r>
+          </a:p>
+        </p:txBody>
+      </p:sp>
+      <p:sp>
+        <p:nvSpPr>
+          <p:cNvPr id="9" name="TextBox 8"/>
+          <p:cNvSpPr txBox="1"/>
+          <p:nvPr/>
+        </p:nvSpPr>
+        <p:spPr>
+          <a:xfrm>
+            <a:off x="548640" y="6400800"/>
+            <a:ext cx="9144000" cy="274320"/>
+          </a:xfrm>
+          <a:prstGeom prst="rect">
+            <a:avLst/>
+          </a:prstGeom>
+          <a:noFill/>
+        </p:spPr>
+        <p:txBody>
           <a:bodyPr wrap="none">
             <a:spAutoFit/>
           </a:bodyPr>
@@ -9426,14 +9635,14 @@
               </a:defRPr>
             </a:pPr>
             <a:r>
-              <a:t>Swiggy Instamart Growth Team Portfolio | Category Expansion Initiative</a:t>
-            </a:r>
-          </a:p>
-        </p:txBody>
-      </p:sp>
-      <p:sp>
-        <p:nvSpPr>
-          <p:cNvPr id="9" name="TextBox 8"/>
+              <a:t>Swiggy Instamart Growth Portfolio | AI Product Discovery Engine</a:t>
+            </a:r>
+          </a:p>
+        </p:txBody>
+      </p:sp>
+      <p:sp>
+        <p:nvSpPr>
+          <p:cNvPr id="10" name="TextBox 9"/>
           <p:cNvSpPr txBox="1"/>
           <p:nvPr/>
         </p:nvSpPr>

</xml_diff>